<commit_message>
discover: modality ablation (linguistic vs audio vs multimodal) + slides
Add feature_modality selector to _prepare_xy (multimodal / paralinguistic / audio)
and run all three through the classifier panel (D/T/All, both targets, segment +
60s window). paralinguistic = transcript text + speaking/turn-taking; audio =
group affect v/a/d; multimodal = both. Panel outputs gain a feature_modality column.

Finding: DOUBLE DISSOCIATION. Group task engagement is carried by audio affect
(audio-only ~= multimodal; text adds nothing); individual engagement by
(para)linguistic (paralinguistic-only >= multimodal; audio collapses to baseline).
No multimodal synergy. Answers slide-9 linguistic-only + multimodal RQs.

Refresh comparison_summary.md (ablation table + RQ answers). Slides: add Feature
Modalities + Modality Ablation slides, rewrite RQ slide with concrete answers.
Save presentation_scripts 04/05.
</commit_message>
<xml_diff>
--- a/discover/2026_March_ViLearn_Planning.pptx
+++ b/discover/2026_March_ViLearn_Planning.pptx
@@ -15,6 +15,8 @@
     <p:sldId id="263" r:id="rId10"/>
     <p:sldId id="264" r:id="rId11"/>
     <p:sldId id="265" r:id="rId12"/>
+    <p:sldId id="271" r:id="rId19"/>
+    <p:sldId id="272" r:id="rId20"/>
     <p:sldId id="266" r:id="rId13"/>
     <p:sldId id="267" r:id="rId14"/>
     <p:sldId id="268" r:id="rId15"/>
@@ -8705,6 +8707,274 @@
 </file>
 
 <file path=ppt/slides/slide11.xml><?xml version="1.0" encoding="utf-8"?>
+<p:sld xmlns:a="http://schemas.openxmlformats.org/drawingml/2006/main" xmlns:p="http://schemas.openxmlformats.org/presentationml/2006/main" xmlns:r="http://schemas.openxmlformats.org/officeDocument/2006/relationships">
+  <p:cSld>
+    <p:spTree>
+      <p:nvGrpSpPr>
+        <p:cNvPr id="1" name=""/>
+        <p:cNvGrpSpPr/>
+        <p:nvPr/>
+      </p:nvGrpSpPr>
+      <p:grpSpPr/>
+      <p:sp>
+        <p:nvSpPr>
+          <p:cNvPr id="2" name="Title 1"/>
+          <p:cNvSpPr>
+            <a:spLocks noGrp="1"/>
+          </p:cNvSpPr>
+          <p:nvPr>
+            <p:ph type="title"/>
+          </p:nvPr>
+        </p:nvSpPr>
+        <p:spPr/>
+        <p:txBody>
+          <a:bodyPr/>
+          <a:lstStyle/>
+          <a:p>
+            <a:r>
+              <a:t>Feature Modalities (ablation buckets)</a:t>
+            </a:r>
+          </a:p>
+        </p:txBody>
+      </p:sp>
+      <p:sp>
+        <p:nvSpPr>
+          <p:cNvPr id="3" name="Text Placeholder 2"/>
+          <p:cNvSpPr>
+            <a:spLocks noGrp="1"/>
+          </p:cNvSpPr>
+          <p:nvPr>
+            <p:ph type="body"/>
+          </p:nvPr>
+        </p:nvSpPr>
+        <p:spPr/>
+        <p:txBody>
+          <a:bodyPr/>
+          <a:lstStyle/>
+          <a:p/>
+        </p:txBody>
+      </p:sp>
+      <p:sp>
+        <p:nvSpPr>
+          <p:cNvPr id="4" name="Text Placeholder 3"/>
+          <p:cNvSpPr>
+            <a:spLocks noGrp="1"/>
+          </p:cNvSpPr>
+          <p:nvPr>
+            <p:ph type="body"/>
+          </p:nvPr>
+        </p:nvSpPr>
+        <p:spPr/>
+        <p:txBody>
+          <a:bodyPr/>
+          <a:lstStyle/>
+          <a:p/>
+        </p:txBody>
+      </p:sp>
+      <p:graphicFrame>
+        <p:nvGraphicFramePr>
+          <p:cNvPr id="5" name="Table 4"/>
+          <p:cNvGraphicFramePr>
+            <a:graphicFrameLocks noGrp="1"/>
+          </p:cNvGraphicFramePr>
+          <p:nvPr/>
+        </p:nvGraphicFramePr>
+        <p:xfrm>
+          <a:off x="457200" y="1463040"/>
+          <a:ext cx="11155680" cy="1828800"/>
+        </p:xfrm>
+        <a:graphic>
+          <a:graphicData uri="http://schemas.openxmlformats.org/drawingml/2006/table">
+            <a:tbl>
+              <a:tblPr firstRow="1" bandRow="1">
+                <a:tableStyleId>{5C22544A-7EE6-4342-B048-85BDC9FD1C3A}</a:tableStyleId>
+              </a:tblPr>
+              <a:tblGrid>
+                <a:gridCol w="2377440"/>
+                <a:gridCol w="8778240"/>
+              </a:tblGrid>
+              <a:tr h="365760">
+                <a:tc>
+                  <a:txBody>
+                    <a:bodyPr/>
+                    <a:lstStyle/>
+                    <a:p>
+                      <a:r>
+                        <a:rPr sz="1300" b="1"/>
+                        <a:t>Modality</a:t>
+                      </a:r>
+                    </a:p>
+                  </a:txBody>
+                  <a:tcPr/>
+                </a:tc>
+                <a:tc>
+                  <a:txBody>
+                    <a:bodyPr/>
+                    <a:lstStyle/>
+                    <a:p>
+                      <a:r>
+                        <a:rPr sz="1300" b="1"/>
+                        <a:t>Features</a:t>
+                      </a:r>
+                    </a:p>
+                  </a:txBody>
+                  <a:tcPr/>
+                </a:tc>
+              </a:tr>
+              <a:tr h="365760">
+                <a:tc>
+                  <a:txBody>
+                    <a:bodyPr wrap="square"/>
+                    <a:lstStyle/>
+                    <a:p>
+                      <a:r>
+                        <a:rPr sz="1200"/>
+                        <a:t>(Para)linguistic</a:t>
+                      </a:r>
+                    </a:p>
+                  </a:txBody>
+                  <a:tcPr/>
+                </a:tc>
+                <a:tc>
+                  <a:txBody>
+                    <a:bodyPr wrap="square"/>
+                    <a:lstStyle/>
+                    <a:p>
+                      <a:r>
+                        <a:rPr sz="1200"/>
+                        <a:t>text: word_count, words/sec, avg_word_length, question/statement_rate, sentiment;  speaking: speaking_role, speaking_seconds, segment_count</a:t>
+                      </a:r>
+                    </a:p>
+                  </a:txBody>
+                  <a:tcPr/>
+                </a:tc>
+              </a:tr>
+              <a:tr h="365760">
+                <a:tc>
+                  <a:txBody>
+                    <a:bodyPr wrap="square"/>
+                    <a:lstStyle/>
+                    <a:p>
+                      <a:r>
+                        <a:rPr sz="1200"/>
+                        <a:t>Audio (affect)</a:t>
+                      </a:r>
+                    </a:p>
+                  </a:txBody>
+                  <a:tcPr/>
+                </a:tc>
+                <a:tc>
+                  <a:txBody>
+                    <a:bodyPr wrap="square"/>
+                    <a:lstStyle/>
+                    <a:p>
+                      <a:r>
+                        <a:rPr sz="1200"/>
+                        <a:t>arousal, dominance, valence  (group-level audio emotion)</a:t>
+                      </a:r>
+                    </a:p>
+                  </a:txBody>
+                  <a:tcPr/>
+                </a:tc>
+              </a:tr>
+              <a:tr h="365760">
+                <a:tc>
+                  <a:txBody>
+                    <a:bodyPr wrap="square"/>
+                    <a:lstStyle/>
+                    <a:p>
+                      <a:r>
+                        <a:rPr sz="1200"/>
+                        <a:t>Multimodal</a:t>
+                      </a:r>
+                    </a:p>
+                  </a:txBody>
+                  <a:tcPr/>
+                </a:tc>
+                <a:tc>
+                  <a:txBody>
+                    <a:bodyPr wrap="square"/>
+                    <a:lstStyle/>
+                    <a:p>
+                      <a:r>
+                        <a:rPr sz="1200"/>
+                        <a:t>(para)linguistic + audio  (= our main detector)</a:t>
+                      </a:r>
+                    </a:p>
+                  </a:txBody>
+                  <a:tcPr/>
+                </a:tc>
+              </a:tr>
+              <a:tr h="365760">
+                <a:tc>
+                  <a:txBody>
+                    <a:bodyPr wrap="square"/>
+                    <a:lstStyle/>
+                    <a:p>
+                      <a:r>
+                        <a:rPr sz="1200"/>
+                        <a:t>(+ embeddings)</a:t>
+                      </a:r>
+                    </a:p>
+                  </a:txBody>
+                  <a:tcPr/>
+                </a:tc>
+                <a:tc>
+                  <a:txBody>
+                    <a:bodyPr wrap="square"/>
+                    <a:lstStyle/>
+                    <a:p>
+                      <a:r>
+                        <a:rPr sz="1200"/>
+                        <a:t>optional: openSMILE + emoW2V + sentiment embeddings, PCA (degrade slightly)</a:t>
+                      </a:r>
+                    </a:p>
+                  </a:txBody>
+                  <a:tcPr/>
+                </a:tc>
+              </a:tr>
+            </a:tbl>
+          </a:graphicData>
+        </a:graphic>
+      </p:graphicFrame>
+      <p:sp>
+        <p:nvSpPr>
+          <p:cNvPr id="6" name="TextBox 5"/>
+          <p:cNvSpPr txBox="1"/>
+          <p:nvPr/>
+        </p:nvSpPr>
+        <p:spPr>
+          <a:xfrm>
+            <a:off x="457200" y="3474720"/>
+            <a:ext cx="11155680" cy="914400"/>
+          </a:xfrm>
+          <a:prstGeom prst="rect">
+            <a:avLst/>
+          </a:prstGeom>
+          <a:noFill/>
+        </p:spPr>
+        <p:txBody>
+          <a:bodyPr wrap="square">
+            <a:spAutoFit/>
+          </a:bodyPr>
+          <a:lstStyle/>
+          <a:p>
+            <a:r>
+              <a:rPr sz="1100" i="1"/>
+              <a:t>Audio is group-shared (one group.audio.wav); the transcript is diarized from it. Speaking attributes the shared signal to each role -&gt; folded into (para)linguistic. v/a/d derived from audio -&gt; audio. Ablation: (para)linguistic-only vs audio-only vs both.</a:t>
+            </a:r>
+          </a:p>
+        </p:txBody>
+      </p:sp>
+    </p:spTree>
+  </p:cSld>
+  <p:clrMapOvr>
+    <a:masterClrMapping/>
+  </p:clrMapOvr>
+</p:sld>
+</file>
+
+<file path=ppt/slides/slide12.xml><?xml version="1.0" encoding="utf-8"?>
 <p:sld xmlns:a="http://schemas.openxmlformats.org/drawingml/2006/main" xmlns:p="http://schemas.openxmlformats.org/presentationml/2006/main" xmlns:r="http://schemas.openxmlformats.org/officeDocument/2006/relationships" xmlns:p14="http://schemas.microsoft.com/office/powerpoint/2010/main" xmlns:p15="http://schemas.microsoft.com/office/powerpoint/2012/main" xmlns:mc="http://schemas.openxmlformats.org/markup-compatibility/2006">
   <p:cSld>
     <p:spTree>
@@ -10406,7 +10676,7 @@
 </p:sld>
 </file>
 
-<file path=ppt/slides/slide12.xml><?xml version="1.0" encoding="utf-8"?>
+<file path=ppt/slides/slide13.xml><?xml version="1.0" encoding="utf-8"?>
 <p:sld xmlns:a="http://schemas.openxmlformats.org/drawingml/2006/main" xmlns:p="http://schemas.openxmlformats.org/presentationml/2006/main" xmlns:r="http://schemas.openxmlformats.org/officeDocument/2006/relationships" xmlns:p14="http://schemas.microsoft.com/office/powerpoint/2010/main" xmlns:p15="http://schemas.microsoft.com/office/powerpoint/2012/main" xmlns:mc="http://schemas.openxmlformats.org/markup-compatibility/2006">
   <p:cSld>
     <p:spTree>
@@ -10769,7 +11039,7 @@
 </p:sld>
 </file>
 
-<file path=ppt/slides/slide13.xml><?xml version="1.0" encoding="utf-8"?>
+<file path=ppt/slides/slide14.xml><?xml version="1.0" encoding="utf-8"?>
 <p:sld xmlns:a="http://schemas.openxmlformats.org/drawingml/2006/main" xmlns:p="http://schemas.openxmlformats.org/presentationml/2006/main" xmlns:r="http://schemas.openxmlformats.org/officeDocument/2006/relationships" xmlns:p14="http://schemas.microsoft.com/office/powerpoint/2010/main" xmlns:p15="http://schemas.microsoft.com/office/powerpoint/2012/main" xmlns:mc="http://schemas.openxmlformats.org/markup-compatibility/2006">
   <p:cSld>
     <p:spTree>
@@ -11349,7 +11619,7 @@
 </p:sld>
 </file>
 
-<file path=ppt/slides/slide14.xml><?xml version="1.0" encoding="utf-8"?>
+<file path=ppt/slides/slide15.xml><?xml version="1.0" encoding="utf-8"?>
 <p:sld xmlns:a="http://schemas.openxmlformats.org/drawingml/2006/main" xmlns:p="http://schemas.openxmlformats.org/presentationml/2006/main" xmlns:r="http://schemas.openxmlformats.org/officeDocument/2006/relationships" xmlns:p14="http://schemas.microsoft.com/office/powerpoint/2010/main" xmlns:p15="http://schemas.microsoft.com/office/powerpoint/2012/main" xmlns:mc="http://schemas.openxmlformats.org/markup-compatibility/2006">
   <p:cSld>
     <p:spTree>
@@ -11873,7 +12143,7 @@
 </p:sld>
 </file>
 
-<file path=ppt/slides/slide15.xml><?xml version="1.0" encoding="utf-8"?>
+<file path=ppt/slides/slide16.xml><?xml version="1.0" encoding="utf-8"?>
 <p:sld xmlns:a="http://schemas.openxmlformats.org/drawingml/2006/main" xmlns:p="http://schemas.openxmlformats.org/presentationml/2006/main" xmlns:r="http://schemas.openxmlformats.org/officeDocument/2006/relationships" xmlns:p14="http://schemas.microsoft.com/office/powerpoint/2010/main" xmlns:p15="http://schemas.microsoft.com/office/powerpoint/2012/main" xmlns:mc="http://schemas.openxmlformats.org/markup-compatibility/2006">
   <p:cSld>
     <p:spTree>
@@ -11988,8 +12258,8 @@
               <a:buChar char="•"/>
             </a:pPr>
             <a:r>
-              <a:rPr sz="1500"/>
-              <a:t>Our features = linguistic (text) + audio-derived affect (valence/arousal/dominance) + speaking (VAD) -&gt; MULTIMODAL, not linguistic-only</a:t>
+              <a:rPr sz="1400"/>
+              <a:t>Double dissociation: group TE &lt;- audio affect (valence/dominance); individual engagement &lt;- (para)linguistic (speaking + text)</a:t>
             </a:r>
             <a:endParaRPr lang="en-US" sz="1800" b="0" u="none" strike="noStrike">
               <a:solidFill>
@@ -12002,37 +12272,37 @@
           </a:p>
           <a:p>
             <a:r>
-              <a:rPr sz="1500"/>
-              <a:t>Multimodal (text + audio affect): group TE acc 0.83 / F1 0.76 (All); significantly beats prior gaze x speaking QDA (d = 0.9-1.35)</a:t>
-            </a:r>
-          </a:p>
-          <a:p>
-            <a:r>
-              <a:rPr sz="1500"/>
-              <a:t>Strongest signal: audio affect (valence +, dominance -) for group TE; speaking + word-rate for individual</a:t>
-            </a:r>
-          </a:p>
-          <a:p>
-            <a:r>
-              <a:rPr sz="1500"/>
-              <a:t>Linguistic-only RQ NOT yet isolated - needs text-only ablation (word counts, rates, sentiment), dropping audio affect + speaking (future work)</a:t>
-            </a:r>
-          </a:p>
-          <a:p>
-            <a:r>
-              <a:rPr sz="1500"/>
-              <a:t>Embeddings (openSMILE/emoW2V/sentiment) on top: no gain, slight degradation</a:t>
-            </a:r>
-          </a:p>
-          <a:p>
-            <a:r>
-              <a:rPr sz="1500"/>
-              <a:t>Open: individual engagement still ~0.70; dyads underpowered (n=8); class imbalance (74% high)</a:t>
-            </a:r>
-          </a:p>
-          <a:p>
-            <a:r>
-              <a:rPr sz="1500"/>
+              <a:rPr sz="1400"/>
+              <a:t>Linguistic-only detects TE? Modest for group TE (acc ~0.72, below audio); but the BEST channel for individual engagement (acc ~0.71)</a:t>
+            </a:r>
+          </a:p>
+          <a:p>
+            <a:r>
+              <a:rPr sz="1400"/>
+              <a:t>Strongest linguistic features? speaking_role, word_count, words_per_second + sentiment (individual). Group TE driven by audio valence (+) / dominance (-), not text</a:t>
+            </a:r>
+          </a:p>
+          <a:p>
+            <a:r>
+              <a:rPr sz="1400"/>
+              <a:t>Multimodal (both)? group TE 0.82-0.88, individual 0.69-0.73 = matches the dominant single modality; no synergy; embeddings on top degrade slightly</a:t>
+            </a:r>
+          </a:p>
+          <a:p>
+            <a:r>
+              <a:rPr sz="1400"/>
+              <a:t>Multimodal significantly beats prior gaze x speaking QDA on All + Triads (d = 0.9-1.35); dyads trend same but n=8 underpowered</a:t>
+            </a:r>
+          </a:p>
+          <a:p>
+            <a:r>
+              <a:rPr sz="1400"/>
+              <a:t>Open: individual engagement ~0.70; class imbalance (74% high); 60 s windows best granularity</a:t>
+            </a:r>
+          </a:p>
+          <a:p>
+            <a:r>
+              <a:rPr sz="1400"/>
               <a:t>1-year: real-time multimodal per-window TE detector feeding adaptive VR feedback</a:t>
             </a:r>
           </a:p>
@@ -12048,6 +12318,406 @@
       <p:transition spd="slow"/>
     </mc:Fallback>
   </mc:AlternateContent>
+</p:sld>
+</file>
+
+<file path=ppt/slides/slide17.xml><?xml version="1.0" encoding="utf-8"?>
+<p:sld xmlns:a="http://schemas.openxmlformats.org/drawingml/2006/main" xmlns:p="http://schemas.openxmlformats.org/presentationml/2006/main" xmlns:r="http://schemas.openxmlformats.org/officeDocument/2006/relationships">
+  <p:cSld>
+    <p:spTree>
+      <p:nvGrpSpPr>
+        <p:cNvPr id="1" name=""/>
+        <p:cNvGrpSpPr/>
+        <p:nvPr/>
+      </p:nvGrpSpPr>
+      <p:grpSpPr/>
+      <p:sp>
+        <p:nvSpPr>
+          <p:cNvPr id="2" name="Title 1"/>
+          <p:cNvSpPr>
+            <a:spLocks noGrp="1"/>
+          </p:cNvSpPr>
+          <p:nvPr>
+            <p:ph type="title"/>
+          </p:nvPr>
+        </p:nvSpPr>
+        <p:spPr/>
+        <p:txBody>
+          <a:bodyPr/>
+          <a:lstStyle/>
+          <a:p>
+            <a:r>
+              <a:t>Modality Ablation — what each modality detects (60 s, LOSO)</a:t>
+            </a:r>
+          </a:p>
+        </p:txBody>
+      </p:sp>
+      <p:sp>
+        <p:nvSpPr>
+          <p:cNvPr id="3" name="Text Placeholder 2"/>
+          <p:cNvSpPr>
+            <a:spLocks noGrp="1"/>
+          </p:cNvSpPr>
+          <p:nvPr>
+            <p:ph type="body"/>
+          </p:nvPr>
+        </p:nvSpPr>
+        <p:spPr/>
+        <p:txBody>
+          <a:bodyPr/>
+          <a:lstStyle/>
+          <a:p/>
+        </p:txBody>
+      </p:sp>
+      <p:sp>
+        <p:nvSpPr>
+          <p:cNvPr id="4" name="Text Placeholder 3"/>
+          <p:cNvSpPr>
+            <a:spLocks noGrp="1"/>
+          </p:cNvSpPr>
+          <p:nvPr>
+            <p:ph type="body"/>
+          </p:nvPr>
+        </p:nvSpPr>
+        <p:spPr/>
+        <p:txBody>
+          <a:bodyPr/>
+          <a:lstStyle/>
+          <a:p/>
+        </p:txBody>
+      </p:sp>
+      <p:graphicFrame>
+        <p:nvGraphicFramePr>
+          <p:cNvPr id="5" name="Table 4"/>
+          <p:cNvGraphicFramePr>
+            <a:graphicFrameLocks noGrp="1"/>
+          </p:cNvGraphicFramePr>
+          <p:nvPr/>
+        </p:nvGraphicFramePr>
+        <p:xfrm>
+          <a:off x="457200" y="1463040"/>
+          <a:ext cx="9144000" cy="1828800"/>
+        </p:xfrm>
+        <a:graphic>
+          <a:graphicData uri="http://schemas.openxmlformats.org/drawingml/2006/table">
+            <a:tbl>
+              <a:tblPr firstRow="1" bandRow="1">
+                <a:tableStyleId>{5C22544A-7EE6-4342-B048-85BDC9FD1C3A}</a:tableStyleId>
+              </a:tblPr>
+              <a:tblGrid>
+                <a:gridCol w="3108960"/>
+                <a:gridCol w="2011680"/>
+                <a:gridCol w="2011680"/>
+                <a:gridCol w="2011680"/>
+              </a:tblGrid>
+              <a:tr h="365760">
+                <a:tc>
+                  <a:txBody>
+                    <a:bodyPr/>
+                    <a:lstStyle/>
+                    <a:p>
+                      <a:r>
+                        <a:rPr sz="1300" b="1"/>
+                        <a:t>Target (split)</a:t>
+                      </a:r>
+                    </a:p>
+                  </a:txBody>
+                  <a:tcPr/>
+                </a:tc>
+                <a:tc>
+                  <a:txBody>
+                    <a:bodyPr/>
+                    <a:lstStyle/>
+                    <a:p>
+                      <a:r>
+                        <a:rPr sz="1300" b="1"/>
+                        <a:t>Multimodal</a:t>
+                      </a:r>
+                    </a:p>
+                  </a:txBody>
+                  <a:tcPr/>
+                </a:tc>
+                <a:tc>
+                  <a:txBody>
+                    <a:bodyPr/>
+                    <a:lstStyle/>
+                    <a:p>
+                      <a:r>
+                        <a:rPr sz="1300" b="1"/>
+                        <a:t>Audio-only</a:t>
+                      </a:r>
+                    </a:p>
+                  </a:txBody>
+                  <a:tcPr/>
+                </a:tc>
+                <a:tc>
+                  <a:txBody>
+                    <a:bodyPr/>
+                    <a:lstStyle/>
+                    <a:p>
+                      <a:r>
+                        <a:rPr sz="1300" b="1"/>
+                        <a:t>(Para)ling-only</a:t>
+                      </a:r>
+                    </a:p>
+                  </a:txBody>
+                  <a:tcPr/>
+                </a:tc>
+              </a:tr>
+              <a:tr h="365760">
+                <a:tc>
+                  <a:txBody>
+                    <a:bodyPr/>
+                    <a:lstStyle/>
+                    <a:p>
+                      <a:r>
+                        <a:rPr sz="1200"/>
+                        <a:t>Group TE (All)</a:t>
+                      </a:r>
+                    </a:p>
+                  </a:txBody>
+                  <a:tcPr/>
+                </a:tc>
+                <a:tc>
+                  <a:txBody>
+                    <a:bodyPr/>
+                    <a:lstStyle/>
+                    <a:p>
+                      <a:r>
+                        <a:rPr sz="1200"/>
+                        <a:t>0.82</a:t>
+                      </a:r>
+                    </a:p>
+                  </a:txBody>
+                  <a:tcPr/>
+                </a:tc>
+                <a:tc>
+                  <a:txBody>
+                    <a:bodyPr/>
+                    <a:lstStyle/>
+                    <a:p>
+                      <a:r>
+                        <a:rPr sz="1200"/>
+                        <a:t>0.82</a:t>
+                      </a:r>
+                    </a:p>
+                  </a:txBody>
+                  <a:tcPr/>
+                </a:tc>
+                <a:tc>
+                  <a:txBody>
+                    <a:bodyPr/>
+                    <a:lstStyle/>
+                    <a:p>
+                      <a:r>
+                        <a:rPr sz="1200"/>
+                        <a:t>0.72</a:t>
+                      </a:r>
+                    </a:p>
+                  </a:txBody>
+                  <a:tcPr/>
+                </a:tc>
+              </a:tr>
+              <a:tr h="365760">
+                <a:tc>
+                  <a:txBody>
+                    <a:bodyPr/>
+                    <a:lstStyle/>
+                    <a:p>
+                      <a:r>
+                        <a:rPr sz="1200"/>
+                        <a:t>Group TE (Triads)</a:t>
+                      </a:r>
+                    </a:p>
+                  </a:txBody>
+                  <a:tcPr/>
+                </a:tc>
+                <a:tc>
+                  <a:txBody>
+                    <a:bodyPr/>
+                    <a:lstStyle/>
+                    <a:p>
+                      <a:r>
+                        <a:rPr sz="1200"/>
+                        <a:t>0.88</a:t>
+                      </a:r>
+                    </a:p>
+                  </a:txBody>
+                  <a:tcPr/>
+                </a:tc>
+                <a:tc>
+                  <a:txBody>
+                    <a:bodyPr/>
+                    <a:lstStyle/>
+                    <a:p>
+                      <a:r>
+                        <a:rPr sz="1200"/>
+                        <a:t>0.86</a:t>
+                      </a:r>
+                    </a:p>
+                  </a:txBody>
+                  <a:tcPr/>
+                </a:tc>
+                <a:tc>
+                  <a:txBody>
+                    <a:bodyPr/>
+                    <a:lstStyle/>
+                    <a:p>
+                      <a:r>
+                        <a:rPr sz="1200"/>
+                        <a:t>0.72</a:t>
+                      </a:r>
+                    </a:p>
+                  </a:txBody>
+                  <a:tcPr/>
+                </a:tc>
+              </a:tr>
+              <a:tr h="365760">
+                <a:tc>
+                  <a:txBody>
+                    <a:bodyPr/>
+                    <a:lstStyle/>
+                    <a:p>
+                      <a:r>
+                        <a:rPr sz="1200"/>
+                        <a:t>Individual (All)</a:t>
+                      </a:r>
+                    </a:p>
+                  </a:txBody>
+                  <a:tcPr/>
+                </a:tc>
+                <a:tc>
+                  <a:txBody>
+                    <a:bodyPr/>
+                    <a:lstStyle/>
+                    <a:p>
+                      <a:r>
+                        <a:rPr sz="1200"/>
+                        <a:t>0.69</a:t>
+                      </a:r>
+                    </a:p>
+                  </a:txBody>
+                  <a:tcPr/>
+                </a:tc>
+                <a:tc>
+                  <a:txBody>
+                    <a:bodyPr/>
+                    <a:lstStyle/>
+                    <a:p>
+                      <a:r>
+                        <a:rPr sz="1200"/>
+                        <a:t>0.66</a:t>
+                      </a:r>
+                    </a:p>
+                  </a:txBody>
+                  <a:tcPr/>
+                </a:tc>
+                <a:tc>
+                  <a:txBody>
+                    <a:bodyPr/>
+                    <a:lstStyle/>
+                    <a:p>
+                      <a:r>
+                        <a:rPr sz="1200"/>
+                        <a:t>0.71</a:t>
+                      </a:r>
+                    </a:p>
+                  </a:txBody>
+                  <a:tcPr/>
+                </a:tc>
+              </a:tr>
+              <a:tr h="365760">
+                <a:tc>
+                  <a:txBody>
+                    <a:bodyPr/>
+                    <a:lstStyle/>
+                    <a:p>
+                      <a:r>
+                        <a:rPr sz="1200"/>
+                        <a:t>Individual (Triads)</a:t>
+                      </a:r>
+                    </a:p>
+                  </a:txBody>
+                  <a:tcPr/>
+                </a:tc>
+                <a:tc>
+                  <a:txBody>
+                    <a:bodyPr/>
+                    <a:lstStyle/>
+                    <a:p>
+                      <a:r>
+                        <a:rPr sz="1200"/>
+                        <a:t>0.73</a:t>
+                      </a:r>
+                    </a:p>
+                  </a:txBody>
+                  <a:tcPr/>
+                </a:tc>
+                <a:tc>
+                  <a:txBody>
+                    <a:bodyPr/>
+                    <a:lstStyle/>
+                    <a:p>
+                      <a:r>
+                        <a:rPr sz="1200"/>
+                        <a:t>0.64</a:t>
+                      </a:r>
+                    </a:p>
+                  </a:txBody>
+                  <a:tcPr/>
+                </a:tc>
+                <a:tc>
+                  <a:txBody>
+                    <a:bodyPr/>
+                    <a:lstStyle/>
+                    <a:p>
+                      <a:r>
+                        <a:rPr sz="1200"/>
+                        <a:t>0.72</a:t>
+                      </a:r>
+                    </a:p>
+                  </a:txBody>
+                  <a:tcPr/>
+                </a:tc>
+              </a:tr>
+            </a:tbl>
+          </a:graphicData>
+        </a:graphic>
+      </p:graphicFrame>
+      <p:sp>
+        <p:nvSpPr>
+          <p:cNvPr id="6" name="TextBox 5"/>
+          <p:cNvSpPr txBox="1"/>
+          <p:nvPr/>
+        </p:nvSpPr>
+        <p:spPr>
+          <a:xfrm>
+            <a:off x="457200" y="3474720"/>
+            <a:ext cx="10515600" cy="1280160"/>
+          </a:xfrm>
+          <a:prstGeom prst="rect">
+            <a:avLst/>
+          </a:prstGeom>
+          <a:noFill/>
+        </p:spPr>
+        <p:txBody>
+          <a:bodyPr wrap="square">
+            <a:spAutoFit/>
+          </a:bodyPr>
+          <a:lstStyle/>
+          <a:p>
+            <a:r>
+              <a:rPr sz="1200" i="1"/>
+              <a:t>Best model per cell, accuracy. DOUBLE DISSOCIATION: group task engagement is carried by audio affect (valence/dominance) - text adds nothing; individual engagement is carried by (para)linguistic (speaking + word rate) - group-shared audio gives no per-role signal. Combining modalities = the dominant one, no synergy.</a:t>
+            </a:r>
+          </a:p>
+        </p:txBody>
+      </p:sp>
+    </p:spTree>
+  </p:cSld>
+  <p:clrMapOvr>
+    <a:masterClrMapping/>
+  </p:clrMapOvr>
 </p:sld>
 </file>
 

</xml_diff>

<commit_message>
discover(deck): add 'What Changed Since Last Week' opener slide
Pre-empts the why-did-numbers-drop question before the results slide: separates the two independent causes (label-balance correction 0.82->0.68; prior recomputed off time-stretch-bugged labels). Idempotent; inserts before the results slide. Run AFTER 06 (06 uses fixed indices).
</commit_message>
<xml_diff>
--- a/discover/2026_March_ViLearn_Planning.pptx
+++ b/discover/2026_March_ViLearn_Planning.pptx
@@ -17,6 +17,7 @@
     <p:sldId id="265" r:id="rId12"/>
     <p:sldId id="271" r:id="rId19"/>
     <p:sldId id="272" r:id="rId20"/>
+    <p:sldId id="273" r:id="rId21"/>
     <p:sldId id="266" r:id="rId13"/>
     <p:sldId id="267" r:id="rId14"/>
     <p:sldId id="268" r:id="rId15"/>
@@ -12428,6 +12429,381 @@
 </p:sld>
 </file>
 
+<file path=ppt/slides/slide18.xml><?xml version="1.0" encoding="utf-8"?>
+<p:sld xmlns:a="http://schemas.openxmlformats.org/drawingml/2006/main" xmlns:p="http://schemas.openxmlformats.org/presentationml/2006/main" xmlns:r="http://schemas.openxmlformats.org/officeDocument/2006/relationships">
+  <p:cSld>
+    <p:spTree>
+      <p:nvGrpSpPr>
+        <p:cNvPr id="1" name=""/>
+        <p:cNvGrpSpPr/>
+        <p:nvPr/>
+      </p:nvGrpSpPr>
+      <p:grpSpPr/>
+      <p:sp>
+        <p:nvSpPr>
+          <p:cNvPr id="2" name="Title 1"/>
+          <p:cNvSpPr>
+            <a:spLocks noGrp="1"/>
+          </p:cNvSpPr>
+          <p:nvPr>
+            <p:ph type="title"/>
+          </p:nvPr>
+        </p:nvSpPr>
+        <p:spPr/>
+        <p:txBody>
+          <a:bodyPr/>
+          <a:lstStyle/>
+          <a:p>
+            <a:r>
+              <a:t>What Changed Since Last Week</a:t>
+            </a:r>
+          </a:p>
+        </p:txBody>
+      </p:sp>
+      <p:sp>
+        <p:nvSpPr>
+          <p:cNvPr id="3" name="Text Placeholder 2"/>
+          <p:cNvSpPr>
+            <a:spLocks noGrp="1"/>
+          </p:cNvSpPr>
+          <p:nvPr>
+            <p:ph type="body"/>
+          </p:nvPr>
+        </p:nvSpPr>
+        <p:spPr/>
+        <p:txBody>
+          <a:bodyPr/>
+          <a:lstStyle/>
+          <a:p/>
+        </p:txBody>
+      </p:sp>
+      <p:graphicFrame>
+        <p:nvGraphicFramePr>
+          <p:cNvPr id="4" name="Table 3"/>
+          <p:cNvGraphicFramePr>
+            <a:graphicFrameLocks noGrp="1"/>
+          </p:cNvGraphicFramePr>
+          <p:nvPr/>
+        </p:nvGraphicFramePr>
+        <p:xfrm>
+          <a:off x="457200" y="1371600"/>
+          <a:ext cx="9601200" cy="2194560"/>
+        </p:xfrm>
+        <a:graphic>
+          <a:graphicData uri="http://schemas.openxmlformats.org/drawingml/2006/table">
+            <a:tbl>
+              <a:tblPr firstRow="1" bandRow="1">
+                <a:tableStyleId>{5C22544A-7EE6-4342-B048-85BDC9FD1C3A}</a:tableStyleId>
+              </a:tblPr>
+              <a:tblGrid>
+                <a:gridCol w="2377440"/>
+                <a:gridCol w="3383280"/>
+                <a:gridCol w="3840480"/>
+              </a:tblGrid>
+              <a:tr h="365760">
+                <a:tc>
+                  <a:txBody>
+                    <a:bodyPr/>
+                    <a:lstStyle/>
+                    <a:p/>
+                  </a:txBody>
+                  <a:tcPr/>
+                </a:tc>
+                <a:tc>
+                  <a:txBody>
+                    <a:bodyPr/>
+                    <a:lstStyle/>
+                    <a:p>
+                      <a:r>
+                        <a:rPr sz="1300" b="1"/>
+                        <a:t>Last week</a:t>
+                      </a:r>
+                    </a:p>
+                  </a:txBody>
+                  <a:tcPr/>
+                </a:tc>
+                <a:tc>
+                  <a:txBody>
+                    <a:bodyPr/>
+                    <a:lstStyle/>
+                    <a:p>
+                      <a:r>
+                        <a:rPr sz="1300" b="1"/>
+                        <a:t>Now (harmonized)</a:t>
+                      </a:r>
+                    </a:p>
+                  </a:txBody>
+                  <a:tcPr/>
+                </a:tc>
+              </a:tr>
+              <a:tr h="365760">
+                <a:tc>
+                  <a:txBody>
+                    <a:bodyPr/>
+                    <a:lstStyle/>
+                    <a:p>
+                      <a:r>
+                        <a:rPr sz="1200" b="1"/>
+                        <a:t>Labels</a:t>
+                      </a:r>
+                    </a:p>
+                  </a:txBody>
+                  <a:tcPr/>
+                </a:tc>
+                <a:tc>
+                  <a:txBody>
+                    <a:bodyPr/>
+                    <a:lstStyle/>
+                    <a:p>
+                      <a:r>
+                        <a:rPr sz="1200"/>
+                        <a:t>helen only · 74% high (skew)</a:t>
+                      </a:r>
+                    </a:p>
+                  </a:txBody>
+                  <a:tcPr/>
+                </a:tc>
+                <a:tc>
+                  <a:txBody>
+                    <a:bodyPr/>
+                    <a:lstStyle/>
+                    <a:p>
+                      <a:r>
+                        <a:rPr sz="1200"/>
+                        <a:t>2-annotator mean · ~49% (balanced)</a:t>
+                      </a:r>
+                    </a:p>
+                  </a:txBody>
+                  <a:tcPr/>
+                </a:tc>
+              </a:tr>
+              <a:tr h="365760">
+                <a:tc>
+                  <a:txBody>
+                    <a:bodyPr/>
+                    <a:lstStyle/>
+                    <a:p>
+                      <a:r>
+                        <a:rPr sz="1200" b="1"/>
+                        <a:t>Group TE — All</a:t>
+                      </a:r>
+                    </a:p>
+                  </a:txBody>
+                  <a:tcPr/>
+                </a:tc>
+                <a:tc>
+                  <a:txBody>
+                    <a:bodyPr/>
+                    <a:lstStyle/>
+                    <a:p>
+                      <a:r>
+                        <a:rPr sz="1200"/>
+                        <a:t>0.82</a:t>
+                      </a:r>
+                    </a:p>
+                  </a:txBody>
+                  <a:tcPr/>
+                </a:tc>
+                <a:tc>
+                  <a:txBody>
+                    <a:bodyPr/>
+                    <a:lstStyle/>
+                    <a:p>
+                      <a:r>
+                        <a:rPr sz="1200"/>
+                        <a:t>0.68</a:t>
+                      </a:r>
+                    </a:p>
+                  </a:txBody>
+                  <a:tcPr/>
+                </a:tc>
+              </a:tr>
+              <a:tr h="365760">
+                <a:tc>
+                  <a:txBody>
+                    <a:bodyPr/>
+                    <a:lstStyle/>
+                    <a:p>
+                      <a:r>
+                        <a:rPr sz="1200" b="1"/>
+                        <a:t>Group TE — Triads</a:t>
+                      </a:r>
+                    </a:p>
+                  </a:txBody>
+                  <a:tcPr/>
+                </a:tc>
+                <a:tc>
+                  <a:txBody>
+                    <a:bodyPr/>
+                    <a:lstStyle/>
+                    <a:p>
+                      <a:r>
+                        <a:rPr sz="1200"/>
+                        <a:t>0.88</a:t>
+                      </a:r>
+                    </a:p>
+                  </a:txBody>
+                  <a:tcPr/>
+                </a:tc>
+                <a:tc>
+                  <a:txBody>
+                    <a:bodyPr/>
+                    <a:lstStyle/>
+                    <a:p>
+                      <a:r>
+                        <a:rPr sz="1200"/>
+                        <a:t>0.70</a:t>
+                      </a:r>
+                    </a:p>
+                  </a:txBody>
+                  <a:tcPr/>
+                </a:tc>
+              </a:tr>
+              <a:tr h="365760">
+                <a:tc>
+                  <a:txBody>
+                    <a:bodyPr/>
+                    <a:lstStyle/>
+                    <a:p>
+                      <a:r>
+                        <a:rPr sz="1200" b="1"/>
+                        <a:t>Group TE — Dyads</a:t>
+                      </a:r>
+                    </a:p>
+                  </a:txBody>
+                  <a:tcPr/>
+                </a:tc>
+                <a:tc>
+                  <a:txBody>
+                    <a:bodyPr/>
+                    <a:lstStyle/>
+                    <a:p>
+                      <a:r>
+                        <a:rPr sz="1200"/>
+                        <a:t>0.74</a:t>
+                      </a:r>
+                    </a:p>
+                  </a:txBody>
+                  <a:tcPr/>
+                </a:tc>
+                <a:tc>
+                  <a:txBody>
+                    <a:bodyPr/>
+                    <a:lstStyle/>
+                    <a:p>
+                      <a:r>
+                        <a:rPr sz="1200"/>
+                        <a:t>0.65</a:t>
+                      </a:r>
+                    </a:p>
+                  </a:txBody>
+                  <a:tcPr/>
+                </a:tc>
+              </a:tr>
+              <a:tr h="365760">
+                <a:tc>
+                  <a:txBody>
+                    <a:bodyPr/>
+                    <a:lstStyle/>
+                    <a:p>
+                      <a:r>
+                        <a:rPr sz="1200" b="1"/>
+                        <a:t>vs prior gaze QDA</a:t>
+                      </a:r>
+                    </a:p>
+                  </a:txBody>
+                  <a:tcPr/>
+                </a:tc>
+                <a:tc>
+                  <a:txBody>
+                    <a:bodyPr/>
+                    <a:lstStyle/>
+                    <a:p>
+                      <a:r>
+                        <a:rPr sz="1200"/>
+                        <a:t>beats ✓ (d=0.92–1.35)</a:t>
+                      </a:r>
+                    </a:p>
+                  </a:txBody>
+                  <a:tcPr/>
+                </a:tc>
+                <a:tc>
+                  <a:txBody>
+                    <a:bodyPr/>
+                    <a:lstStyle/>
+                    <a:p>
+                      <a:r>
+                        <a:rPr sz="1200"/>
+                        <a:t>n.s. — matches prior (0.73)</a:t>
+                      </a:r>
+                    </a:p>
+                  </a:txBody>
+                  <a:tcPr/>
+                </a:tc>
+              </a:tr>
+            </a:tbl>
+          </a:graphicData>
+        </a:graphic>
+      </p:graphicFrame>
+      <p:sp>
+        <p:nvSpPr>
+          <p:cNvPr id="5" name="TextBox 4"/>
+          <p:cNvSpPr txBox="1"/>
+          <p:nvPr/>
+        </p:nvSpPr>
+        <p:spPr>
+          <a:xfrm>
+            <a:off x="457200" y="4114800"/>
+            <a:ext cx="10515600" cy="2377440"/>
+          </a:xfrm>
+          <a:prstGeom prst="rect">
+            <a:avLst/>
+          </a:prstGeom>
+          <a:noFill/>
+        </p:spPr>
+        <p:txBody>
+          <a:bodyPr wrap="square">
+            <a:spAutoFit/>
+          </a:bodyPr>
+          <a:lstStyle/>
+          <a:p>
+            <a:pPr/>
+            <a:r>
+              <a:rPr sz="1400" b="1"/>
+              <a:t>Two artifacts removed — they are independent:</a:t>
+            </a:r>
+          </a:p>
+          <a:p>
+            <a:pPr lvl="1"/>
+            <a:r>
+              <a:rPr sz="1200"/>
+              <a:t>(1) Our labels were single-annotator + 74% high → majority baseline 0.74 inflated last week's accuracy. Adopting the published 2-annotator mean balances to ~49% → honest 0.68.</a:t>
+            </a:r>
+          </a:p>
+          <a:p>
+            <a:pPr lvl="1"/>
+            <a:r>
+              <a:rPr sz="1200"/>
+              <a:t>(2) The prior baseline itself was computed on time-stretch-bugged labels (60 Hz averaging error, 13/20 groups). Re-ran it on clean labels under identical nested CV.</a:t>
+            </a:r>
+          </a:p>
+          <a:p>
+            <a:pPr lvl="1"/>
+            <a:r>
+              <a:rPr sz="1200"/>
+              <a:t>Net: 0.68, statistically tied with the prior (neither wins); double dissociation + gaze-free parity hold. Better surfaced now than at review.</a:t>
+            </a:r>
+          </a:p>
+        </p:txBody>
+      </p:sp>
+    </p:spTree>
+  </p:cSld>
+  <p:clrMapOvr>
+    <a:masterClrMapping/>
+  </p:clrMapOvr>
+</p:sld>
+</file>
+
 <file path=ppt/slides/slide2.xml><?xml version="1.0" encoding="utf-8"?>
 <p:sld xmlns:a="http://schemas.openxmlformats.org/drawingml/2006/main" xmlns:p="http://schemas.openxmlformats.org/presentationml/2006/main" xmlns:r="http://schemas.openxmlformats.org/officeDocument/2006/relationships" xmlns:p14="http://schemas.microsoft.com/office/powerpoint/2010/main" xmlns:p15="http://schemas.microsoft.com/office/powerpoint/2012/main" xmlns:mc="http://schemas.openxmlformats.org/markup-compatibility/2006">
   <p:cSld>

</xml_diff>

<commit_message>
discover(deck): add fair-comparison methods footnote + slides-2/3 numeric note
Results slide footnote: prior gaze features (185 floorlevel windows) re-scored with our harmonized labels under identical nested CV; our windows 197; tail-trim diff; paired by group. RQ slide: replace named-author bug bullet with neutral slides-2/3 reference (QDA All 0.60->0.67). No author names remain in deck.
</commit_message>
<xml_diff>
--- a/discover/2026_March_ViLearn_Planning.pptx
+++ b/discover/2026_March_ViLearn_Planning.pptx
@@ -11187,6 +11187,35 @@
           </a:p>
         </p:txBody>
       </p:sp>
+      <p:sp>
+        <p:nvSpPr>
+          <p:cNvPr id="96" name="TextBox 95"/>
+          <p:cNvSpPr txBox="1"/>
+          <p:nvPr/>
+        </p:nvSpPr>
+        <p:spPr>
+          <a:xfrm>
+            <a:off x="457200" y="6126480"/>
+            <a:ext cx="11155680" cy="731520"/>
+          </a:xfrm>
+          <a:prstGeom prst="rect">
+            <a:avLst/>
+          </a:prstGeom>
+          <a:noFill/>
+        </p:spPr>
+        <p:txBody>
+          <a:bodyPr wrap="square">
+            <a:spAutoFit/>
+          </a:bodyPr>
+          <a:lstStyle/>
+          <a:p>
+            <a:r>
+              <a:rPr sz="1000" i="1"/>
+              <a:t>Fair comparison: prior gaze features (185 floorlevel windows) re-scored with our harmonized 2-annotator labels under identical LOSO nested CV; our detector uses our pipeline windows (197). Counts differ from tail-window trimming; tests paired by group (n = 20 / 8 / 12).</a:t>
+            </a:r>
+          </a:p>
+        </p:txBody>
+      </p:sp>
     </p:spTree>
   </p:cSld>
   <mc:AlternateContent>
@@ -12768,7 +12797,7 @@
           <a:p>
             <a:r>
               <a:rPr sz="1500"/>
-              <a:t>Carlos's published baseline was itself depressed by a label time-stretch bug (clean QDA 0.67 vs published 0.60)</a:t>
+              <a:t>Prior baseline shown on slides 2–3 is depressed by a 60 Hz label time-stretch bug (e.g. QDA All 0.60 published → 0.67 corrected on harmonized labels)</a:t>
             </a:r>
           </a:p>
           <a:p>

</xml_diff>

<commit_message>
discover(deck): add corrected-prior-baseline slide after 'What Changed'
Reconciles prior gaze QDA across three columns: published (slides 2-3, bugged) -> label-fixed same protocol (0.60->0.67) -> our nested CV (0.73, the results-slide comparison). Prevents adjacent slides looking contradictory; isolates the bug's ~0.05-0.08 depression.
</commit_message>
<xml_diff>
--- a/discover/2026_March_ViLearn_Planning.pptx
+++ b/discover/2026_March_ViLearn_Planning.pptx
@@ -18,6 +18,7 @@
     <p:sldId id="271" r:id="rId19"/>
     <p:sldId id="272" r:id="rId20"/>
     <p:sldId id="273" r:id="rId21"/>
+    <p:sldId id="274" r:id="rId22"/>
     <p:sldId id="266" r:id="rId13"/>
     <p:sldId id="267" r:id="rId14"/>
     <p:sldId id="268" r:id="rId15"/>
@@ -12833,6 +12834,353 @@
 </p:sld>
 </file>
 
+<file path=ppt/slides/slide19.xml><?xml version="1.0" encoding="utf-8"?>
+<p:sld xmlns:a="http://schemas.openxmlformats.org/drawingml/2006/main" xmlns:p="http://schemas.openxmlformats.org/presentationml/2006/main" xmlns:r="http://schemas.openxmlformats.org/officeDocument/2006/relationships">
+  <p:cSld>
+    <p:spTree>
+      <p:nvGrpSpPr>
+        <p:cNvPr id="1" name=""/>
+        <p:cNvGrpSpPr/>
+        <p:nvPr/>
+      </p:nvGrpSpPr>
+      <p:grpSpPr/>
+      <p:sp>
+        <p:nvSpPr>
+          <p:cNvPr id="2" name="Title 1"/>
+          <p:cNvSpPr>
+            <a:spLocks noGrp="1"/>
+          </p:cNvSpPr>
+          <p:nvPr>
+            <p:ph type="title"/>
+          </p:nvPr>
+        </p:nvSpPr>
+        <p:spPr/>
+        <p:txBody>
+          <a:bodyPr/>
+          <a:lstStyle/>
+          <a:p>
+            <a:r>
+              <a:t>Prior Baseline — Corrected for the Label Bug</a:t>
+            </a:r>
+          </a:p>
+        </p:txBody>
+      </p:sp>
+      <p:sp>
+        <p:nvSpPr>
+          <p:cNvPr id="3" name="Text Placeholder 2"/>
+          <p:cNvSpPr>
+            <a:spLocks noGrp="1"/>
+          </p:cNvSpPr>
+          <p:nvPr>
+            <p:ph type="body"/>
+          </p:nvPr>
+        </p:nvSpPr>
+        <p:spPr/>
+        <p:txBody>
+          <a:bodyPr/>
+          <a:lstStyle/>
+          <a:p/>
+        </p:txBody>
+      </p:sp>
+      <p:graphicFrame>
+        <p:nvGraphicFramePr>
+          <p:cNvPr id="4" name="Table 3"/>
+          <p:cNvGraphicFramePr>
+            <a:graphicFrameLocks noGrp="1"/>
+          </p:cNvGraphicFramePr>
+          <p:nvPr/>
+        </p:nvGraphicFramePr>
+        <p:xfrm>
+          <a:off x="365760" y="1371600"/>
+          <a:ext cx="10881360" cy="1645920"/>
+        </p:xfrm>
+        <a:graphic>
+          <a:graphicData uri="http://schemas.openxmlformats.org/drawingml/2006/table">
+            <a:tbl>
+              <a:tblPr firstRow="1" bandRow="1">
+                <a:tableStyleId>{5C22544A-7EE6-4342-B048-85BDC9FD1C3A}</a:tableStyleId>
+              </a:tblPr>
+              <a:tblGrid>
+                <a:gridCol w="2377440"/>
+                <a:gridCol w="2651760"/>
+                <a:gridCol w="3108960"/>
+                <a:gridCol w="2743200"/>
+              </a:tblGrid>
+              <a:tr h="411480">
+                <a:tc>
+                  <a:txBody>
+                    <a:bodyPr/>
+                    <a:lstStyle/>
+                    <a:p>
+                      <a:r>
+                        <a:rPr sz="1200" b="1"/>
+                        <a:t>Prior gaze QDA</a:t>
+                      </a:r>
+                    </a:p>
+                  </a:txBody>
+                  <a:tcPr/>
+                </a:tc>
+                <a:tc>
+                  <a:txBody>
+                    <a:bodyPr/>
+                    <a:lstStyle/>
+                    <a:p>
+                      <a:r>
+                        <a:rPr sz="1200" b="1"/>
+                        <a:t>Published (slides 2–3)</a:t>
+                      </a:r>
+                    </a:p>
+                  </a:txBody>
+                  <a:tcPr/>
+                </a:tc>
+                <a:tc>
+                  <a:txBody>
+                    <a:bodyPr/>
+                    <a:lstStyle/>
+                    <a:p>
+                      <a:r>
+                        <a:rPr sz="1200" b="1"/>
+                        <a:t>Label-fixed (same protocol)</a:t>
+                      </a:r>
+                    </a:p>
+                  </a:txBody>
+                  <a:tcPr/>
+                </a:tc>
+                <a:tc>
+                  <a:txBody>
+                    <a:bodyPr/>
+                    <a:lstStyle/>
+                    <a:p>
+                      <a:r>
+                        <a:rPr sz="1200" b="1"/>
+                        <a:t>Our nested CV (results)</a:t>
+                      </a:r>
+                    </a:p>
+                  </a:txBody>
+                  <a:tcPr/>
+                </a:tc>
+              </a:tr>
+              <a:tr h="411480">
+                <a:tc>
+                  <a:txBody>
+                    <a:bodyPr/>
+                    <a:lstStyle/>
+                    <a:p>
+                      <a:r>
+                        <a:rPr sz="1200" b="1"/>
+                        <a:t>All (20)</a:t>
+                      </a:r>
+                    </a:p>
+                  </a:txBody>
+                  <a:tcPr/>
+                </a:tc>
+                <a:tc>
+                  <a:txBody>
+                    <a:bodyPr/>
+                    <a:lstStyle/>
+                    <a:p>
+                      <a:r>
+                        <a:rPr sz="1200"/>
+                        <a:t>0.60</a:t>
+                      </a:r>
+                    </a:p>
+                  </a:txBody>
+                  <a:tcPr/>
+                </a:tc>
+                <a:tc>
+                  <a:txBody>
+                    <a:bodyPr/>
+                    <a:lstStyle/>
+                    <a:p>
+                      <a:r>
+                        <a:rPr sz="1200"/>
+                        <a:t>0.67</a:t>
+                      </a:r>
+                    </a:p>
+                  </a:txBody>
+                  <a:tcPr/>
+                </a:tc>
+                <a:tc>
+                  <a:txBody>
+                    <a:bodyPr/>
+                    <a:lstStyle/>
+                    <a:p>
+                      <a:r>
+                        <a:rPr sz="1200"/>
+                        <a:t>0.73</a:t>
+                      </a:r>
+                    </a:p>
+                  </a:txBody>
+                  <a:tcPr/>
+                </a:tc>
+              </a:tr>
+              <a:tr h="411480">
+                <a:tc>
+                  <a:txBody>
+                    <a:bodyPr/>
+                    <a:lstStyle/>
+                    <a:p>
+                      <a:r>
+                        <a:rPr sz="1200" b="1"/>
+                        <a:t>Dyads (8)</a:t>
+                      </a:r>
+                    </a:p>
+                  </a:txBody>
+                  <a:tcPr/>
+                </a:tc>
+                <a:tc>
+                  <a:txBody>
+                    <a:bodyPr/>
+                    <a:lstStyle/>
+                    <a:p>
+                      <a:r>
+                        <a:rPr sz="1200"/>
+                        <a:t>0.63</a:t>
+                      </a:r>
+                    </a:p>
+                  </a:txBody>
+                  <a:tcPr/>
+                </a:tc>
+                <a:tc>
+                  <a:txBody>
+                    <a:bodyPr/>
+                    <a:lstStyle/>
+                    <a:p>
+                      <a:r>
+                        <a:rPr sz="1200"/>
+                        <a:t>0.69</a:t>
+                      </a:r>
+                    </a:p>
+                  </a:txBody>
+                  <a:tcPr/>
+                </a:tc>
+                <a:tc>
+                  <a:txBody>
+                    <a:bodyPr/>
+                    <a:lstStyle/>
+                    <a:p>
+                      <a:r>
+                        <a:rPr sz="1200"/>
+                        <a:t>0.77</a:t>
+                      </a:r>
+                    </a:p>
+                  </a:txBody>
+                  <a:tcPr/>
+                </a:tc>
+              </a:tr>
+              <a:tr h="411480">
+                <a:tc>
+                  <a:txBody>
+                    <a:bodyPr/>
+                    <a:lstStyle/>
+                    <a:p>
+                      <a:r>
+                        <a:rPr sz="1200" b="1"/>
+                        <a:t>Triads (12)</a:t>
+                      </a:r>
+                    </a:p>
+                  </a:txBody>
+                  <a:tcPr/>
+                </a:tc>
+                <a:tc>
+                  <a:txBody>
+                    <a:bodyPr/>
+                    <a:lstStyle/>
+                    <a:p>
+                      <a:r>
+                        <a:rPr sz="1200"/>
+                        <a:t>0.55</a:t>
+                      </a:r>
+                    </a:p>
+                  </a:txBody>
+                  <a:tcPr/>
+                </a:tc>
+                <a:tc>
+                  <a:txBody>
+                    <a:bodyPr/>
+                    <a:lstStyle/>
+                    <a:p>
+                      <a:r>
+                        <a:rPr sz="1200"/>
+                        <a:t>0.59</a:t>
+                      </a:r>
+                    </a:p>
+                  </a:txBody>
+                  <a:tcPr/>
+                </a:tc>
+                <a:tc>
+                  <a:txBody>
+                    <a:bodyPr/>
+                    <a:lstStyle/>
+                    <a:p>
+                      <a:r>
+                        <a:rPr sz="1200"/>
+                        <a:t>0.65</a:t>
+                      </a:r>
+                    </a:p>
+                  </a:txBody>
+                  <a:tcPr/>
+                </a:tc>
+              </a:tr>
+            </a:tbl>
+          </a:graphicData>
+        </a:graphic>
+      </p:graphicFrame>
+      <p:sp>
+        <p:nvSpPr>
+          <p:cNvPr id="5" name="TextBox 4"/>
+          <p:cNvSpPr txBox="1"/>
+          <p:nvPr/>
+        </p:nvSpPr>
+        <p:spPr>
+          <a:xfrm>
+            <a:off x="365760" y="3749039"/>
+            <a:ext cx="11155680" cy="2560320"/>
+          </a:xfrm>
+          <a:prstGeom prst="rect">
+            <a:avLst/>
+          </a:prstGeom>
+          <a:noFill/>
+        </p:spPr>
+        <p:txBody>
+          <a:bodyPr wrap="square">
+            <a:spAutoFit/>
+          </a:bodyPr>
+          <a:lstStyle/>
+          <a:p>
+            <a:r>
+              <a:rPr sz="1300"/>
+              <a:t>Same QDA, same gaze features — only the labels are harmonized (60 Hz time-stretch removed, 2-annotator mean).</a:t>
+            </a:r>
+          </a:p>
+          <a:p>
+            <a:r>
+              <a:rPr sz="1300"/>
+              <a:t>Label fix alone (col 2): published 0.60 → 0.67 All. The bug depressed published numbers ~0.05–0.08 (13/20 groups at 60 Hz; the 7 pure-90 Hz groups replicate exactly).</a:t>
+            </a:r>
+          </a:p>
+          <a:p>
+            <a:r>
+              <a:rPr sz="1300"/>
+              <a:t>Col 3 = our harmonized nested-CV protocol (scaled) — the column the results slide uses for the fair head-to-head vs our detector.</a:t>
+            </a:r>
+          </a:p>
+          <a:p>
+            <a:r>
+              <a:rPr sz="1300"/>
+              <a:t>None of these reach significance vs chance after Bonferroni (d up to 1.18 but n=8–20 underpowered).</a:t>
+            </a:r>
+          </a:p>
+        </p:txBody>
+      </p:sp>
+    </p:spTree>
+  </p:cSld>
+  <p:clrMapOvr>
+    <a:masterClrMapping/>
+  </p:clrMapOvr>
+</p:sld>
+</file>
+
 <file path=ppt/slides/slide2.xml><?xml version="1.0" encoding="utf-8"?>
 <p:sld xmlns:a="http://schemas.openxmlformats.org/drawingml/2006/main" xmlns:p="http://schemas.openxmlformats.org/presentationml/2006/main" xmlns:r="http://schemas.openxmlformats.org/officeDocument/2006/relationships" xmlns:p14="http://schemas.microsoft.com/office/powerpoint/2010/main" xmlns:p15="http://schemas.microsoft.com/office/powerpoint/2012/main" xmlns:mc="http://schemas.openxmlformats.org/markup-compatibility/2006">
   <p:cSld>

</xml_diff>

<commit_message>
discover(deck): clarify corrected-prior columns differ by scaling, not CV
Both non-published columns use the same nested CV (adopted from the prior); the difference is StandardScaler (published runs unscaled SIMPLE; our pipeline scales). Relabel headers + note to avoid implying the CV changed.
</commit_message>
<xml_diff>
--- a/discover/2026_March_ViLearn_Planning.pptx
+++ b/discover/2026_March_ViLearn_Planning.pptx
@@ -9860,6 +9860,353 @@
 </file>
 
 <file path=ppt/slides/slide14.xml><?xml version="1.0" encoding="utf-8"?>
+<p:sld xmlns:a="http://schemas.openxmlformats.org/drawingml/2006/main" xmlns:p="http://schemas.openxmlformats.org/presentationml/2006/main" xmlns:r="http://schemas.openxmlformats.org/officeDocument/2006/relationships">
+  <p:cSld>
+    <p:spTree>
+      <p:nvGrpSpPr>
+        <p:cNvPr id="1" name=""/>
+        <p:cNvGrpSpPr/>
+        <p:nvPr/>
+      </p:nvGrpSpPr>
+      <p:grpSpPr/>
+      <p:sp>
+        <p:nvSpPr>
+          <p:cNvPr id="2" name="Title 1"/>
+          <p:cNvSpPr>
+            <a:spLocks noGrp="1"/>
+          </p:cNvSpPr>
+          <p:nvPr>
+            <p:ph type="title"/>
+          </p:nvPr>
+        </p:nvSpPr>
+        <p:spPr/>
+        <p:txBody>
+          <a:bodyPr/>
+          <a:lstStyle/>
+          <a:p>
+            <a:r>
+              <a:t>Prior Baseline — Corrected for the Label Bug</a:t>
+            </a:r>
+          </a:p>
+        </p:txBody>
+      </p:sp>
+      <p:sp>
+        <p:nvSpPr>
+          <p:cNvPr id="3" name="Text Placeholder 2"/>
+          <p:cNvSpPr>
+            <a:spLocks noGrp="1"/>
+          </p:cNvSpPr>
+          <p:nvPr>
+            <p:ph type="body"/>
+          </p:nvPr>
+        </p:nvSpPr>
+        <p:spPr/>
+        <p:txBody>
+          <a:bodyPr/>
+          <a:lstStyle/>
+          <a:p/>
+        </p:txBody>
+      </p:sp>
+      <p:graphicFrame>
+        <p:nvGraphicFramePr>
+          <p:cNvPr id="4" name="Table 3"/>
+          <p:cNvGraphicFramePr>
+            <a:graphicFrameLocks noGrp="1"/>
+          </p:cNvGraphicFramePr>
+          <p:nvPr/>
+        </p:nvGraphicFramePr>
+        <p:xfrm>
+          <a:off x="365760" y="1371600"/>
+          <a:ext cx="10881360" cy="1645920"/>
+        </p:xfrm>
+        <a:graphic>
+          <a:graphicData uri="http://schemas.openxmlformats.org/drawingml/2006/table">
+            <a:tbl>
+              <a:tblPr firstRow="1" bandRow="1">
+                <a:tableStyleId>{5C22544A-7EE6-4342-B048-85BDC9FD1C3A}</a:tableStyleId>
+              </a:tblPr>
+              <a:tblGrid>
+                <a:gridCol w="2377440"/>
+                <a:gridCol w="2651760"/>
+                <a:gridCol w="3108960"/>
+                <a:gridCol w="2743200"/>
+              </a:tblGrid>
+              <a:tr h="411480">
+                <a:tc>
+                  <a:txBody>
+                    <a:bodyPr/>
+                    <a:lstStyle/>
+                    <a:p>
+                      <a:r>
+                        <a:rPr sz="1200" b="1"/>
+                        <a:t>Prior gaze QDA</a:t>
+                      </a:r>
+                    </a:p>
+                  </a:txBody>
+                  <a:tcPr/>
+                </a:tc>
+                <a:tc>
+                  <a:txBody>
+                    <a:bodyPr/>
+                    <a:lstStyle/>
+                    <a:p>
+                      <a:r>
+                        <a:rPr sz="1200" b="1"/>
+                        <a:t>Published (slides 2–3)</a:t>
+                      </a:r>
+                    </a:p>
+                  </a:txBody>
+                  <a:tcPr/>
+                </a:tc>
+                <a:tc>
+                  <a:txBody>
+                    <a:bodyPr/>
+                    <a:lstStyle/>
+                    <a:p>
+                      <a:r>
+                        <a:rPr sz="1200" b="1"/>
+                        <a:t>Label-fixed · unscaled (prior setup)</a:t>
+                      </a:r>
+                    </a:p>
+                  </a:txBody>
+                  <a:tcPr/>
+                </a:tc>
+                <a:tc>
+                  <a:txBody>
+                    <a:bodyPr/>
+                    <a:lstStyle/>
+                    <a:p>
+                      <a:r>
+                        <a:rPr sz="1200" b="1"/>
+                        <a:t>Label-fixed · scaled (our pipeline)</a:t>
+                      </a:r>
+                    </a:p>
+                  </a:txBody>
+                  <a:tcPr/>
+                </a:tc>
+              </a:tr>
+              <a:tr h="411480">
+                <a:tc>
+                  <a:txBody>
+                    <a:bodyPr/>
+                    <a:lstStyle/>
+                    <a:p>
+                      <a:r>
+                        <a:rPr sz="1200" b="1"/>
+                        <a:t>All (20)</a:t>
+                      </a:r>
+                    </a:p>
+                  </a:txBody>
+                  <a:tcPr/>
+                </a:tc>
+                <a:tc>
+                  <a:txBody>
+                    <a:bodyPr/>
+                    <a:lstStyle/>
+                    <a:p>
+                      <a:r>
+                        <a:rPr sz="1200"/>
+                        <a:t>0.60</a:t>
+                      </a:r>
+                    </a:p>
+                  </a:txBody>
+                  <a:tcPr/>
+                </a:tc>
+                <a:tc>
+                  <a:txBody>
+                    <a:bodyPr/>
+                    <a:lstStyle/>
+                    <a:p>
+                      <a:r>
+                        <a:rPr sz="1200"/>
+                        <a:t>0.67</a:t>
+                      </a:r>
+                    </a:p>
+                  </a:txBody>
+                  <a:tcPr/>
+                </a:tc>
+                <a:tc>
+                  <a:txBody>
+                    <a:bodyPr/>
+                    <a:lstStyle/>
+                    <a:p>
+                      <a:r>
+                        <a:rPr sz="1200"/>
+                        <a:t>0.73</a:t>
+                      </a:r>
+                    </a:p>
+                  </a:txBody>
+                  <a:tcPr/>
+                </a:tc>
+              </a:tr>
+              <a:tr h="411480">
+                <a:tc>
+                  <a:txBody>
+                    <a:bodyPr/>
+                    <a:lstStyle/>
+                    <a:p>
+                      <a:r>
+                        <a:rPr sz="1200" b="1"/>
+                        <a:t>Dyads (8)</a:t>
+                      </a:r>
+                    </a:p>
+                  </a:txBody>
+                  <a:tcPr/>
+                </a:tc>
+                <a:tc>
+                  <a:txBody>
+                    <a:bodyPr/>
+                    <a:lstStyle/>
+                    <a:p>
+                      <a:r>
+                        <a:rPr sz="1200"/>
+                        <a:t>0.63</a:t>
+                      </a:r>
+                    </a:p>
+                  </a:txBody>
+                  <a:tcPr/>
+                </a:tc>
+                <a:tc>
+                  <a:txBody>
+                    <a:bodyPr/>
+                    <a:lstStyle/>
+                    <a:p>
+                      <a:r>
+                        <a:rPr sz="1200"/>
+                        <a:t>0.69</a:t>
+                      </a:r>
+                    </a:p>
+                  </a:txBody>
+                  <a:tcPr/>
+                </a:tc>
+                <a:tc>
+                  <a:txBody>
+                    <a:bodyPr/>
+                    <a:lstStyle/>
+                    <a:p>
+                      <a:r>
+                        <a:rPr sz="1200"/>
+                        <a:t>0.77</a:t>
+                      </a:r>
+                    </a:p>
+                  </a:txBody>
+                  <a:tcPr/>
+                </a:tc>
+              </a:tr>
+              <a:tr h="411480">
+                <a:tc>
+                  <a:txBody>
+                    <a:bodyPr/>
+                    <a:lstStyle/>
+                    <a:p>
+                      <a:r>
+                        <a:rPr sz="1200" b="1"/>
+                        <a:t>Triads (12)</a:t>
+                      </a:r>
+                    </a:p>
+                  </a:txBody>
+                  <a:tcPr/>
+                </a:tc>
+                <a:tc>
+                  <a:txBody>
+                    <a:bodyPr/>
+                    <a:lstStyle/>
+                    <a:p>
+                      <a:r>
+                        <a:rPr sz="1200"/>
+                        <a:t>0.55</a:t>
+                      </a:r>
+                    </a:p>
+                  </a:txBody>
+                  <a:tcPr/>
+                </a:tc>
+                <a:tc>
+                  <a:txBody>
+                    <a:bodyPr/>
+                    <a:lstStyle/>
+                    <a:p>
+                      <a:r>
+                        <a:rPr sz="1200"/>
+                        <a:t>0.59</a:t>
+                      </a:r>
+                    </a:p>
+                  </a:txBody>
+                  <a:tcPr/>
+                </a:tc>
+                <a:tc>
+                  <a:txBody>
+                    <a:bodyPr/>
+                    <a:lstStyle/>
+                    <a:p>
+                      <a:r>
+                        <a:rPr sz="1200"/>
+                        <a:t>0.65</a:t>
+                      </a:r>
+                    </a:p>
+                  </a:txBody>
+                  <a:tcPr/>
+                </a:tc>
+              </a:tr>
+            </a:tbl>
+          </a:graphicData>
+        </a:graphic>
+      </p:graphicFrame>
+      <p:sp>
+        <p:nvSpPr>
+          <p:cNvPr id="5" name="TextBox 4"/>
+          <p:cNvSpPr txBox="1"/>
+          <p:nvPr/>
+        </p:nvSpPr>
+        <p:spPr>
+          <a:xfrm>
+            <a:off x="365760" y="3749039"/>
+            <a:ext cx="11155680" cy="2560320"/>
+          </a:xfrm>
+          <a:prstGeom prst="rect">
+            <a:avLst/>
+          </a:prstGeom>
+          <a:noFill/>
+        </p:spPr>
+        <p:txBody>
+          <a:bodyPr wrap="square">
+            <a:spAutoFit/>
+          </a:bodyPr>
+          <a:lstStyle/>
+          <a:p>
+            <a:r>
+              <a:rPr sz="1300"/>
+              <a:t>Same QDA, same gaze features, same nested CV (adopted from the prior) in all columns — only the labels and feature scaling change.</a:t>
+            </a:r>
+          </a:p>
+          <a:p>
+            <a:r>
+              <a:rPr sz="1300"/>
+              <a:t>Label fix alone (col 2, unscaled = the prior's published SIMPLE setup): 0.60 → 0.67 All. The 60 Hz time-stretch bug depressed published numbers ~0.05–0.08 (13/20 groups; the 7 pure-90 Hz groups replicate exactly).</a:t>
+            </a:r>
+          </a:p>
+          <a:p>
+            <a:r>
+              <a:rPr sz="1300"/>
+              <a:t>Cols 2 → 3 differ only by feature scaling (StandardScaler): the prior's published runs were unscaled; our detector pipeline scales. Col 3 is what the results slide compares against.</a:t>
+            </a:r>
+          </a:p>
+          <a:p>
+            <a:r>
+              <a:rPr sz="1300"/>
+              <a:t>None reach significance vs chance after Bonferroni (d up to 1.18, but n = 8–20 underpowered).</a:t>
+            </a:r>
+          </a:p>
+        </p:txBody>
+      </p:sp>
+    </p:spTree>
+  </p:cSld>
+  <p:clrMapOvr>
+    <a:masterClrMapping/>
+  </p:clrMapOvr>
+</p:sld>
+</file>
+
+<file path=ppt/slides/slide15.xml><?xml version="1.0" encoding="utf-8"?>
 <p:sld xmlns:a="http://schemas.openxmlformats.org/drawingml/2006/main" xmlns:p="http://schemas.openxmlformats.org/presentationml/2006/main" xmlns:r="http://schemas.openxmlformats.org/officeDocument/2006/relationships" xmlns:p14="http://schemas.microsoft.com/office/powerpoint/2010/main" xmlns:p15="http://schemas.microsoft.com/office/powerpoint/2012/main" xmlns:mc="http://schemas.openxmlformats.org/markup-compatibility/2006">
   <p:cSld>
     <p:spTree>
@@ -11230,7 +11577,7 @@
 </p:sld>
 </file>
 
-<file path=ppt/slides/slide15.xml><?xml version="1.0" encoding="utf-8"?>
+<file path=ppt/slides/slide16.xml><?xml version="1.0" encoding="utf-8"?>
 <p:sld xmlns:a="http://schemas.openxmlformats.org/drawingml/2006/main" xmlns:p="http://schemas.openxmlformats.org/presentationml/2006/main" xmlns:r="http://schemas.openxmlformats.org/officeDocument/2006/relationships" xmlns:p14="http://schemas.microsoft.com/office/powerpoint/2010/main" xmlns:p15="http://schemas.microsoft.com/office/powerpoint/2012/main" xmlns:mc="http://schemas.openxmlformats.org/markup-compatibility/2006">
   <p:cSld>
     <p:spTree>
@@ -11552,7 +11899,7 @@
 </p:sld>
 </file>
 
-<file path=ppt/slides/slide16.xml><?xml version="1.0" encoding="utf-8"?>
+<file path=ppt/slides/slide17.xml><?xml version="1.0" encoding="utf-8"?>
 <p:sld xmlns:a="http://schemas.openxmlformats.org/drawingml/2006/main" xmlns:p="http://schemas.openxmlformats.org/presentationml/2006/main" xmlns:r="http://schemas.openxmlformats.org/officeDocument/2006/relationships" xmlns:p14="http://schemas.microsoft.com/office/powerpoint/2010/main" xmlns:p15="http://schemas.microsoft.com/office/powerpoint/2012/main" xmlns:mc="http://schemas.openxmlformats.org/markup-compatibility/2006">
   <p:cSld>
     <p:spTree>
@@ -12132,7 +12479,7 @@
 </p:sld>
 </file>
 
-<file path=ppt/slides/slide17.xml><?xml version="1.0" encoding="utf-8"?>
+<file path=ppt/slides/slide18.xml><?xml version="1.0" encoding="utf-8"?>
 <p:sld xmlns:a="http://schemas.openxmlformats.org/drawingml/2006/main" xmlns:p="http://schemas.openxmlformats.org/presentationml/2006/main" xmlns:r="http://schemas.openxmlformats.org/officeDocument/2006/relationships" xmlns:p14="http://schemas.microsoft.com/office/powerpoint/2010/main" xmlns:p15="http://schemas.microsoft.com/office/powerpoint/2012/main" xmlns:mc="http://schemas.openxmlformats.org/markup-compatibility/2006">
   <p:cSld>
     <p:spTree>
@@ -12656,7 +13003,7 @@
 </p:sld>
 </file>
 
-<file path=ppt/slides/slide18.xml><?xml version="1.0" encoding="utf-8"?>
+<file path=ppt/slides/slide19.xml><?xml version="1.0" encoding="utf-8"?>
 <p:sld xmlns:a="http://schemas.openxmlformats.org/drawingml/2006/main" xmlns:p="http://schemas.openxmlformats.org/presentationml/2006/main" xmlns:r="http://schemas.openxmlformats.org/officeDocument/2006/relationships" xmlns:p14="http://schemas.microsoft.com/office/powerpoint/2010/main" xmlns:p15="http://schemas.microsoft.com/office/powerpoint/2012/main" xmlns:mc="http://schemas.openxmlformats.org/markup-compatibility/2006">
   <p:cSld>
     <p:spTree>
@@ -12831,353 +13178,6 @@
       <p:transition spd="slow"/>
     </mc:Fallback>
   </mc:AlternateContent>
-</p:sld>
-</file>
-
-<file path=ppt/slides/slide19.xml><?xml version="1.0" encoding="utf-8"?>
-<p:sld xmlns:a="http://schemas.openxmlformats.org/drawingml/2006/main" xmlns:p="http://schemas.openxmlformats.org/presentationml/2006/main" xmlns:r="http://schemas.openxmlformats.org/officeDocument/2006/relationships">
-  <p:cSld>
-    <p:spTree>
-      <p:nvGrpSpPr>
-        <p:cNvPr id="1" name=""/>
-        <p:cNvGrpSpPr/>
-        <p:nvPr/>
-      </p:nvGrpSpPr>
-      <p:grpSpPr/>
-      <p:sp>
-        <p:nvSpPr>
-          <p:cNvPr id="2" name="Title 1"/>
-          <p:cNvSpPr>
-            <a:spLocks noGrp="1"/>
-          </p:cNvSpPr>
-          <p:nvPr>
-            <p:ph type="title"/>
-          </p:nvPr>
-        </p:nvSpPr>
-        <p:spPr/>
-        <p:txBody>
-          <a:bodyPr/>
-          <a:lstStyle/>
-          <a:p>
-            <a:r>
-              <a:t>Prior Baseline — Corrected for the Label Bug</a:t>
-            </a:r>
-          </a:p>
-        </p:txBody>
-      </p:sp>
-      <p:sp>
-        <p:nvSpPr>
-          <p:cNvPr id="3" name="Text Placeholder 2"/>
-          <p:cNvSpPr>
-            <a:spLocks noGrp="1"/>
-          </p:cNvSpPr>
-          <p:nvPr>
-            <p:ph type="body"/>
-          </p:nvPr>
-        </p:nvSpPr>
-        <p:spPr/>
-        <p:txBody>
-          <a:bodyPr/>
-          <a:lstStyle/>
-          <a:p/>
-        </p:txBody>
-      </p:sp>
-      <p:graphicFrame>
-        <p:nvGraphicFramePr>
-          <p:cNvPr id="4" name="Table 3"/>
-          <p:cNvGraphicFramePr>
-            <a:graphicFrameLocks noGrp="1"/>
-          </p:cNvGraphicFramePr>
-          <p:nvPr/>
-        </p:nvGraphicFramePr>
-        <p:xfrm>
-          <a:off x="365760" y="1371600"/>
-          <a:ext cx="10881360" cy="1645920"/>
-        </p:xfrm>
-        <a:graphic>
-          <a:graphicData uri="http://schemas.openxmlformats.org/drawingml/2006/table">
-            <a:tbl>
-              <a:tblPr firstRow="1" bandRow="1">
-                <a:tableStyleId>{5C22544A-7EE6-4342-B048-85BDC9FD1C3A}</a:tableStyleId>
-              </a:tblPr>
-              <a:tblGrid>
-                <a:gridCol w="2377440"/>
-                <a:gridCol w="2651760"/>
-                <a:gridCol w="3108960"/>
-                <a:gridCol w="2743200"/>
-              </a:tblGrid>
-              <a:tr h="411480">
-                <a:tc>
-                  <a:txBody>
-                    <a:bodyPr/>
-                    <a:lstStyle/>
-                    <a:p>
-                      <a:r>
-                        <a:rPr sz="1200" b="1"/>
-                        <a:t>Prior gaze QDA</a:t>
-                      </a:r>
-                    </a:p>
-                  </a:txBody>
-                  <a:tcPr/>
-                </a:tc>
-                <a:tc>
-                  <a:txBody>
-                    <a:bodyPr/>
-                    <a:lstStyle/>
-                    <a:p>
-                      <a:r>
-                        <a:rPr sz="1200" b="1"/>
-                        <a:t>Published (slides 2–3)</a:t>
-                      </a:r>
-                    </a:p>
-                  </a:txBody>
-                  <a:tcPr/>
-                </a:tc>
-                <a:tc>
-                  <a:txBody>
-                    <a:bodyPr/>
-                    <a:lstStyle/>
-                    <a:p>
-                      <a:r>
-                        <a:rPr sz="1200" b="1"/>
-                        <a:t>Label-fixed (same protocol)</a:t>
-                      </a:r>
-                    </a:p>
-                  </a:txBody>
-                  <a:tcPr/>
-                </a:tc>
-                <a:tc>
-                  <a:txBody>
-                    <a:bodyPr/>
-                    <a:lstStyle/>
-                    <a:p>
-                      <a:r>
-                        <a:rPr sz="1200" b="1"/>
-                        <a:t>Our nested CV (results)</a:t>
-                      </a:r>
-                    </a:p>
-                  </a:txBody>
-                  <a:tcPr/>
-                </a:tc>
-              </a:tr>
-              <a:tr h="411480">
-                <a:tc>
-                  <a:txBody>
-                    <a:bodyPr/>
-                    <a:lstStyle/>
-                    <a:p>
-                      <a:r>
-                        <a:rPr sz="1200" b="1"/>
-                        <a:t>All (20)</a:t>
-                      </a:r>
-                    </a:p>
-                  </a:txBody>
-                  <a:tcPr/>
-                </a:tc>
-                <a:tc>
-                  <a:txBody>
-                    <a:bodyPr/>
-                    <a:lstStyle/>
-                    <a:p>
-                      <a:r>
-                        <a:rPr sz="1200"/>
-                        <a:t>0.60</a:t>
-                      </a:r>
-                    </a:p>
-                  </a:txBody>
-                  <a:tcPr/>
-                </a:tc>
-                <a:tc>
-                  <a:txBody>
-                    <a:bodyPr/>
-                    <a:lstStyle/>
-                    <a:p>
-                      <a:r>
-                        <a:rPr sz="1200"/>
-                        <a:t>0.67</a:t>
-                      </a:r>
-                    </a:p>
-                  </a:txBody>
-                  <a:tcPr/>
-                </a:tc>
-                <a:tc>
-                  <a:txBody>
-                    <a:bodyPr/>
-                    <a:lstStyle/>
-                    <a:p>
-                      <a:r>
-                        <a:rPr sz="1200"/>
-                        <a:t>0.73</a:t>
-                      </a:r>
-                    </a:p>
-                  </a:txBody>
-                  <a:tcPr/>
-                </a:tc>
-              </a:tr>
-              <a:tr h="411480">
-                <a:tc>
-                  <a:txBody>
-                    <a:bodyPr/>
-                    <a:lstStyle/>
-                    <a:p>
-                      <a:r>
-                        <a:rPr sz="1200" b="1"/>
-                        <a:t>Dyads (8)</a:t>
-                      </a:r>
-                    </a:p>
-                  </a:txBody>
-                  <a:tcPr/>
-                </a:tc>
-                <a:tc>
-                  <a:txBody>
-                    <a:bodyPr/>
-                    <a:lstStyle/>
-                    <a:p>
-                      <a:r>
-                        <a:rPr sz="1200"/>
-                        <a:t>0.63</a:t>
-                      </a:r>
-                    </a:p>
-                  </a:txBody>
-                  <a:tcPr/>
-                </a:tc>
-                <a:tc>
-                  <a:txBody>
-                    <a:bodyPr/>
-                    <a:lstStyle/>
-                    <a:p>
-                      <a:r>
-                        <a:rPr sz="1200"/>
-                        <a:t>0.69</a:t>
-                      </a:r>
-                    </a:p>
-                  </a:txBody>
-                  <a:tcPr/>
-                </a:tc>
-                <a:tc>
-                  <a:txBody>
-                    <a:bodyPr/>
-                    <a:lstStyle/>
-                    <a:p>
-                      <a:r>
-                        <a:rPr sz="1200"/>
-                        <a:t>0.77</a:t>
-                      </a:r>
-                    </a:p>
-                  </a:txBody>
-                  <a:tcPr/>
-                </a:tc>
-              </a:tr>
-              <a:tr h="411480">
-                <a:tc>
-                  <a:txBody>
-                    <a:bodyPr/>
-                    <a:lstStyle/>
-                    <a:p>
-                      <a:r>
-                        <a:rPr sz="1200" b="1"/>
-                        <a:t>Triads (12)</a:t>
-                      </a:r>
-                    </a:p>
-                  </a:txBody>
-                  <a:tcPr/>
-                </a:tc>
-                <a:tc>
-                  <a:txBody>
-                    <a:bodyPr/>
-                    <a:lstStyle/>
-                    <a:p>
-                      <a:r>
-                        <a:rPr sz="1200"/>
-                        <a:t>0.55</a:t>
-                      </a:r>
-                    </a:p>
-                  </a:txBody>
-                  <a:tcPr/>
-                </a:tc>
-                <a:tc>
-                  <a:txBody>
-                    <a:bodyPr/>
-                    <a:lstStyle/>
-                    <a:p>
-                      <a:r>
-                        <a:rPr sz="1200"/>
-                        <a:t>0.59</a:t>
-                      </a:r>
-                    </a:p>
-                  </a:txBody>
-                  <a:tcPr/>
-                </a:tc>
-                <a:tc>
-                  <a:txBody>
-                    <a:bodyPr/>
-                    <a:lstStyle/>
-                    <a:p>
-                      <a:r>
-                        <a:rPr sz="1200"/>
-                        <a:t>0.65</a:t>
-                      </a:r>
-                    </a:p>
-                  </a:txBody>
-                  <a:tcPr/>
-                </a:tc>
-              </a:tr>
-            </a:tbl>
-          </a:graphicData>
-        </a:graphic>
-      </p:graphicFrame>
-      <p:sp>
-        <p:nvSpPr>
-          <p:cNvPr id="5" name="TextBox 4"/>
-          <p:cNvSpPr txBox="1"/>
-          <p:nvPr/>
-        </p:nvSpPr>
-        <p:spPr>
-          <a:xfrm>
-            <a:off x="365760" y="3749039"/>
-            <a:ext cx="11155680" cy="2560320"/>
-          </a:xfrm>
-          <a:prstGeom prst="rect">
-            <a:avLst/>
-          </a:prstGeom>
-          <a:noFill/>
-        </p:spPr>
-        <p:txBody>
-          <a:bodyPr wrap="square">
-            <a:spAutoFit/>
-          </a:bodyPr>
-          <a:lstStyle/>
-          <a:p>
-            <a:r>
-              <a:rPr sz="1300"/>
-              <a:t>Same QDA, same gaze features — only the labels are harmonized (60 Hz time-stretch removed, 2-annotator mean).</a:t>
-            </a:r>
-          </a:p>
-          <a:p>
-            <a:r>
-              <a:rPr sz="1300"/>
-              <a:t>Label fix alone (col 2): published 0.60 → 0.67 All. The bug depressed published numbers ~0.05–0.08 (13/20 groups at 60 Hz; the 7 pure-90 Hz groups replicate exactly).</a:t>
-            </a:r>
-          </a:p>
-          <a:p>
-            <a:r>
-              <a:rPr sz="1300"/>
-              <a:t>Col 3 = our harmonized nested-CV protocol (scaled) — the column the results slide uses for the fair head-to-head vs our detector.</a:t>
-            </a:r>
-          </a:p>
-          <a:p>
-            <a:r>
-              <a:rPr sz="1300"/>
-              <a:t>None of these reach significance vs chance after Bonferroni (d up to 1.18 but n=8–20 underpowered).</a:t>
-            </a:r>
-          </a:p>
-        </p:txBody>
-      </p:sp>
-    </p:spTree>
-  </p:cSld>
-  <p:clrMapOvr>
-    <a:masterClrMapping/>
-  </p:clrMapOvr>
 </p:sld>
 </file>
 

</xml_diff>

<commit_message>
discover(deck): slide 2 true majority baseline (replaces uniform/seed dummy)
Prior comparison baseline 0.53/0.43/0.45 (stochastic uniform/stratified) -> deterministic majority 0.62/0.55/0.52 (per split, prior's labels). Honest floor is higher; models' margin shrinks (SVM Dyads 0.66 vs 0.62). Footnote explains. Addresses meeting concern that uniform+seed inflated prior significance.
</commit_message>
<xml_diff>
--- a/discover/2026_March_ViLearn_Planning.pptx
+++ b/discover/2026_March_ViLearn_Planning.pptx
@@ -14174,30 +14174,10 @@
                       <a:noAutofit/>
                     </a:bodyPr>
                     <a:p>
-                      <a:pPr defTabSz="914400">
-                        <a:lnSpc>
-                          <a:spcPct val="100000"/>
-                        </a:lnSpc>
-                      </a:pPr>
                       <a:r>
-                        <a:rPr lang="en-US" sz="1800" b="1" u="none" strike="noStrike">
-                          <a:solidFill>
-                            <a:schemeClr val="dk1"/>
-                          </a:solidFill>
-                          <a:effectLst/>
-                          <a:uFillTx/>
-                          <a:latin typeface="Aptos"/>
-                        </a:rPr>
-                        <a:t>Baseline</a:t>
+                        <a:rPr sz="1800" b="1"/>
+                        <a:t>Majority baseline</a:t>
                       </a:r>
-                      <a:endParaRPr lang="en-US" sz="1800" b="0" u="none" strike="noStrike">
-                        <a:solidFill>
-                          <a:srgbClr val="000000"/>
-                        </a:solidFill>
-                        <a:effectLst/>
-                        <a:uFillTx/>
-                        <a:latin typeface="Arial"/>
-                      </a:endParaRPr>
                     </a:p>
                   </a:txBody>
                   <a:tcPr anchor="ctr" marL="0" marR="0" marT="0" marB="0">
@@ -14234,30 +14214,10 @@
                       <a:noAutofit/>
                     </a:bodyPr>
                     <a:p>
-                      <a:pPr algn="ctr" defTabSz="914400">
-                        <a:lnSpc>
-                          <a:spcPct val="100000"/>
-                        </a:lnSpc>
-                      </a:pPr>
                       <a:r>
-                        <a:rPr lang="en-US" sz="1800" b="0" u="none" strike="noStrike">
-                          <a:solidFill>
-                            <a:schemeClr val="dk1"/>
-                          </a:solidFill>
-                          <a:effectLst/>
-                          <a:uFillTx/>
-                          <a:latin typeface="Aptos"/>
-                        </a:rPr>
-                        <a:t>0.53</a:t>
+                        <a:rPr sz="1800" b="0"/>
+                        <a:t>0.62</a:t>
                       </a:r>
-                      <a:endParaRPr lang="en-US" sz="1800" b="0" u="none" strike="noStrike">
-                        <a:solidFill>
-                          <a:srgbClr val="000000"/>
-                        </a:solidFill>
-                        <a:effectLst/>
-                        <a:uFillTx/>
-                        <a:latin typeface="Arial"/>
-                      </a:endParaRPr>
                     </a:p>
                   </a:txBody>
                   <a:tcPr anchor="ctr" marL="0" marR="0" marT="0" marB="0">
@@ -14294,30 +14254,10 @@
                       <a:noAutofit/>
                     </a:bodyPr>
                     <a:p>
-                      <a:pPr algn="ctr" defTabSz="914400">
-                        <a:lnSpc>
-                          <a:spcPct val="100000"/>
-                        </a:lnSpc>
-                      </a:pPr>
                       <a:r>
-                        <a:rPr lang="en-US" sz="1800" b="0" u="none" strike="noStrike">
-                          <a:solidFill>
-                            <a:schemeClr val="dk1"/>
-                          </a:solidFill>
-                          <a:effectLst/>
-                          <a:uFillTx/>
-                          <a:latin typeface="Aptos"/>
-                        </a:rPr>
-                        <a:t>0.10</a:t>
+                        <a:rPr sz="1800" b="0"/>
+                        <a:t>—</a:t>
                       </a:r>
-                      <a:endParaRPr lang="en-US" sz="1800" b="0" u="none" strike="noStrike">
-                        <a:solidFill>
-                          <a:srgbClr val="000000"/>
-                        </a:solidFill>
-                        <a:effectLst/>
-                        <a:uFillTx/>
-                        <a:latin typeface="Arial"/>
-                      </a:endParaRPr>
                     </a:p>
                   </a:txBody>
                   <a:tcPr anchor="ctr" marL="0" marR="0" marT="0" marB="0">
@@ -14354,30 +14294,10 @@
                       <a:noAutofit/>
                     </a:bodyPr>
                     <a:p>
-                      <a:pPr algn="ctr" defTabSz="914400">
-                        <a:lnSpc>
-                          <a:spcPct val="100000"/>
-                        </a:lnSpc>
-                      </a:pPr>
                       <a:r>
-                        <a:rPr lang="en-US" sz="1800" b="0" u="none" strike="noStrike">
-                          <a:solidFill>
-                            <a:schemeClr val="dk1"/>
-                          </a:solidFill>
-                          <a:effectLst/>
-                          <a:uFillTx/>
-                          <a:latin typeface="Aptos"/>
-                        </a:rPr>
-                        <a:t>0.43</a:t>
+                        <a:rPr sz="1800" b="0"/>
+                        <a:t>0.55</a:t>
                       </a:r>
-                      <a:endParaRPr lang="en-US" sz="1800" b="0" u="none" strike="noStrike">
-                        <a:solidFill>
-                          <a:srgbClr val="000000"/>
-                        </a:solidFill>
-                        <a:effectLst/>
-                        <a:uFillTx/>
-                        <a:latin typeface="Arial"/>
-                      </a:endParaRPr>
                     </a:p>
                   </a:txBody>
                   <a:tcPr anchor="ctr" marL="0" marR="0" marT="0" marB="0">
@@ -14414,30 +14334,10 @@
                       <a:noAutofit/>
                     </a:bodyPr>
                     <a:p>
-                      <a:pPr algn="ctr" defTabSz="914400">
-                        <a:lnSpc>
-                          <a:spcPct val="100000"/>
-                        </a:lnSpc>
-                      </a:pPr>
                       <a:r>
-                        <a:rPr lang="en-US" sz="1800" b="0" u="none" strike="noStrike">
-                          <a:solidFill>
-                            <a:schemeClr val="dk1"/>
-                          </a:solidFill>
-                          <a:effectLst/>
-                          <a:uFillTx/>
-                          <a:latin typeface="Aptos"/>
-                        </a:rPr>
-                        <a:t>0.11</a:t>
+                        <a:rPr sz="1800" b="0"/>
+                        <a:t>—</a:t>
                       </a:r>
-                      <a:endParaRPr lang="en-US" sz="1800" b="0" u="none" strike="noStrike">
-                        <a:solidFill>
-                          <a:srgbClr val="000000"/>
-                        </a:solidFill>
-                        <a:effectLst/>
-                        <a:uFillTx/>
-                        <a:latin typeface="Arial"/>
-                      </a:endParaRPr>
                     </a:p>
                   </a:txBody>
                   <a:tcPr anchor="ctr" marL="0" marR="0" marT="0" marB="0">
@@ -14474,30 +14374,10 @@
                       <a:noAutofit/>
                     </a:bodyPr>
                     <a:p>
-                      <a:pPr algn="ctr" defTabSz="914400">
-                        <a:lnSpc>
-                          <a:spcPct val="100000"/>
-                        </a:lnSpc>
-                      </a:pPr>
                       <a:r>
-                        <a:rPr lang="en-US" sz="1800" b="0" u="none" strike="noStrike">
-                          <a:solidFill>
-                            <a:schemeClr val="dk1"/>
-                          </a:solidFill>
-                          <a:effectLst/>
-                          <a:uFillTx/>
-                          <a:latin typeface="Aptos"/>
-                        </a:rPr>
-                        <a:t>0.45</a:t>
+                        <a:rPr sz="1800" b="0"/>
+                        <a:t>0.52</a:t>
                       </a:r>
-                      <a:endParaRPr lang="en-US" sz="1800" b="0" u="none" strike="noStrike">
-                        <a:solidFill>
-                          <a:srgbClr val="000000"/>
-                        </a:solidFill>
-                        <a:effectLst/>
-                        <a:uFillTx/>
-                        <a:latin typeface="Arial"/>
-                      </a:endParaRPr>
                     </a:p>
                   </a:txBody>
                   <a:tcPr anchor="ctr" marL="0" marR="0" marT="0" marB="0">
@@ -14534,30 +14414,10 @@
                       <a:noAutofit/>
                     </a:bodyPr>
                     <a:p>
-                      <a:pPr algn="ctr" defTabSz="914400">
-                        <a:lnSpc>
-                          <a:spcPct val="100000"/>
-                        </a:lnSpc>
-                      </a:pPr>
                       <a:r>
-                        <a:rPr lang="en-US" sz="1800" b="0" u="none" strike="noStrike">
-                          <a:solidFill>
-                            <a:schemeClr val="dk1"/>
-                          </a:solidFill>
-                          <a:effectLst/>
-                          <a:uFillTx/>
-                          <a:latin typeface="Aptos"/>
-                        </a:rPr>
-                        <a:t>0.13</a:t>
+                        <a:rPr sz="1800" b="0"/>
+                        <a:t>—</a:t>
                       </a:r>
-                      <a:endParaRPr lang="en-US" sz="1800" b="0" u="none" strike="noStrike">
-                        <a:solidFill>
-                          <a:srgbClr val="000000"/>
-                        </a:solidFill>
-                        <a:effectLst/>
-                        <a:uFillTx/>
-                        <a:latin typeface="Arial"/>
-                      </a:endParaRPr>
                     </a:p>
                   </a:txBody>
                   <a:tcPr anchor="ctr" marL="0" marR="0" marT="0" marB="0">
@@ -16111,6 +15971,35 @@
               <a:uFillTx/>
               <a:latin typeface="Aptos"/>
             </a:endParaRPr>
+          </a:p>
+        </p:txBody>
+      </p:sp>
+      <p:sp>
+        <p:nvSpPr>
+          <p:cNvPr id="73" name="TextBox 72"/>
+          <p:cNvSpPr txBox="1"/>
+          <p:nvPr/>
+        </p:nvSpPr>
+        <p:spPr>
+          <a:xfrm>
+            <a:off x="365760" y="6035040"/>
+            <a:ext cx="11338560" cy="822960"/>
+          </a:xfrm>
+          <a:prstGeom prst="rect">
+            <a:avLst/>
+          </a:prstGeom>
+          <a:noFill/>
+        </p:spPr>
+        <p:txBody>
+          <a:bodyPr wrap="square">
+            <a:spAutoFit/>
+          </a:bodyPr>
+          <a:lstStyle/>
+          <a:p>
+            <a:r>
+              <a:rPr sz="1000" i="1"/>
+              <a:t>Majority baseline = always-predict-majority (deterministic, per split, on the prior's labels). Replaces the original stochastic uniform/stratified dummy (0.53/0.43/0.45), which was a weaker floor — the models' margin over the honest baseline is much smaller (e.g. SVM Dyads 0.66 vs 0.62; SVM Triads 0.63 vs 0.55).</a:t>
+            </a:r>
           </a:p>
         </p:txBody>
       </p:sp>

</xml_diff>

<commit_message>
discover(deck): methodology-review section + slide 2 clean redo
3 new slides (sig method comparison sig/ns/sig across uniform/majority/permutation; group-level vs long-format dedup non-issue; open methodology decisions). Slide 2 redone on clean labels + group-level prior models (SVM/NB/QDA), clean majority baseline, significance flagged method-dependent. Data: scratch/te_adoption/{consolidated_methods,group_level_*,permutation_test}.py.
</commit_message>
<xml_diff>
--- a/discover/2026_March_ViLearn_Planning.pptx
+++ b/discover/2026_March_ViLearn_Planning.pptx
@@ -24,6 +24,9 @@
     <p:sldId id="268" r:id="rId15"/>
     <p:sldId id="269" r:id="rId16"/>
     <p:sldId id="270" r:id="rId17"/>
+    <p:sldId id="275" r:id="rId23"/>
+    <p:sldId id="276" r:id="rId24"/>
+    <p:sldId id="277" r:id="rId25"/>
   </p:sldIdLst>
   <p:sldSz cx="12192000" cy="6858000"/>
   <p:notesSz cx="7559675" cy="10691813"/>
@@ -14216,7 +14219,7 @@
                     <a:p>
                       <a:r>
                         <a:rPr sz="1800" b="0"/>
-                        <a:t>0.62</a:t>
+                        <a:t>0.60</a:t>
                       </a:r>
                     </a:p>
                   </a:txBody>
@@ -14296,7 +14299,7 @@
                     <a:p>
                       <a:r>
                         <a:rPr sz="1800" b="0"/>
-                        <a:t>0.55</a:t>
+                        <a:t>0.54</a:t>
                       </a:r>
                     </a:p>
                   </a:txBody>
@@ -14516,30 +14519,10 @@
                       <a:noAutofit/>
                     </a:bodyPr>
                     <a:p>
-                      <a:pPr algn="ctr" defTabSz="914400">
-                        <a:lnSpc>
-                          <a:spcPct val="100000"/>
-                        </a:lnSpc>
-                      </a:pPr>
-                      <a:r>
-                        <a:rPr lang="en-US" sz="1800" b="0" u="none" strike="noStrike">
-                          <a:solidFill>
-                            <a:schemeClr val="dk1"/>
-                          </a:solidFill>
-                          <a:effectLst/>
-                          <a:uFillTx/>
-                          <a:latin typeface="Aptos"/>
-                        </a:rPr>
-                        <a:t>0.66</a:t>
-                      </a:r>
-                      <a:endParaRPr lang="en-US" sz="1800" b="0" u="none" strike="noStrike">
-                        <a:solidFill>
-                          <a:srgbClr val="000000"/>
-                        </a:solidFill>
-                        <a:effectLst/>
-                        <a:uFillTx/>
-                        <a:latin typeface="Arial"/>
-                      </a:endParaRPr>
+                      <a:r>
+                        <a:rPr sz="1800" b="0"/>
+                        <a:t>0.83</a:t>
+                      </a:r>
                     </a:p>
                   </a:txBody>
                   <a:tcPr anchor="ctr" marL="0" marR="0" marT="0" marB="0">
@@ -14576,30 +14559,10 @@
                       <a:noAutofit/>
                     </a:bodyPr>
                     <a:p>
-                      <a:pPr algn="ctr" defTabSz="914400">
-                        <a:lnSpc>
-                          <a:spcPct val="100000"/>
-                        </a:lnSpc>
-                      </a:pPr>
-                      <a:r>
-                        <a:rPr lang="en-US" sz="1800" b="0" u="none" strike="noStrike">
-                          <a:solidFill>
-                            <a:schemeClr val="dk1"/>
-                          </a:solidFill>
-                          <a:effectLst/>
-                          <a:uFillTx/>
-                          <a:latin typeface="Aptos"/>
-                        </a:rPr>
-                        <a:t>0.15</a:t>
-                      </a:r>
-                      <a:endParaRPr lang="en-US" sz="1800" b="0" u="none" strike="noStrike">
-                        <a:solidFill>
-                          <a:srgbClr val="000000"/>
-                        </a:solidFill>
-                        <a:effectLst/>
-                        <a:uFillTx/>
-                        <a:latin typeface="Arial"/>
-                      </a:endParaRPr>
+                      <a:r>
+                        <a:rPr sz="1800" b="0"/>
+                        <a:t>—</a:t>
+                      </a:r>
                     </a:p>
                   </a:txBody>
                   <a:tcPr anchor="ctr" marL="0" marR="0" marT="0" marB="0">
@@ -14636,30 +14599,10 @@
                       <a:noAutofit/>
                     </a:bodyPr>
                     <a:p>
-                      <a:pPr algn="ctr" defTabSz="914400">
-                        <a:lnSpc>
-                          <a:spcPct val="100000"/>
-                        </a:lnSpc>
-                      </a:pPr>
-                      <a:r>
-                        <a:rPr lang="en-US" sz="1800" b="1" u="none" strike="noStrike">
-                          <a:solidFill>
-                            <a:schemeClr val="dk1"/>
-                          </a:solidFill>
-                          <a:effectLst/>
-                          <a:uFillTx/>
-                          <a:latin typeface="Aptos"/>
-                        </a:rPr>
-                        <a:t>0.63</a:t>
-                      </a:r>
-                      <a:endParaRPr lang="en-US" sz="1800" b="0" u="none" strike="noStrike">
-                        <a:solidFill>
-                          <a:srgbClr val="000000"/>
-                        </a:solidFill>
-                        <a:effectLst/>
-                        <a:uFillTx/>
-                        <a:latin typeface="Arial"/>
-                      </a:endParaRPr>
+                      <a:r>
+                        <a:rPr sz="1800" b="1"/>
+                        <a:t>0.56</a:t>
+                      </a:r>
                     </a:p>
                   </a:txBody>
                   <a:tcPr anchor="ctr" marL="0" marR="0" marT="0" marB="0">
@@ -14696,30 +14639,10 @@
                       <a:noAutofit/>
                     </a:bodyPr>
                     <a:p>
-                      <a:pPr algn="ctr" defTabSz="914400">
-                        <a:lnSpc>
-                          <a:spcPct val="100000"/>
-                        </a:lnSpc>
-                      </a:pPr>
-                      <a:r>
-                        <a:rPr lang="en-US" sz="1800" b="1" u="none" strike="noStrike">
-                          <a:solidFill>
-                            <a:schemeClr val="dk1"/>
-                          </a:solidFill>
-                          <a:effectLst/>
-                          <a:uFillTx/>
-                          <a:latin typeface="Aptos"/>
-                        </a:rPr>
-                        <a:t>0.21</a:t>
-                      </a:r>
-                      <a:endParaRPr lang="en-US" sz="1800" b="0" u="none" strike="noStrike">
-                        <a:solidFill>
-                          <a:srgbClr val="000000"/>
-                        </a:solidFill>
-                        <a:effectLst/>
-                        <a:uFillTx/>
-                        <a:latin typeface="Arial"/>
-                      </a:endParaRPr>
+                      <a:r>
+                        <a:rPr sz="1800" b="1"/>
+                        <a:t>—</a:t>
+                      </a:r>
                     </a:p>
                   </a:txBody>
                   <a:tcPr anchor="ctr" marL="0" marR="0" marT="0" marB="0">
@@ -14756,30 +14679,10 @@
                       <a:noAutofit/>
                     </a:bodyPr>
                     <a:p>
-                      <a:pPr algn="ctr" defTabSz="914400">
-                        <a:lnSpc>
-                          <a:spcPct val="100000"/>
-                        </a:lnSpc>
-                      </a:pPr>
-                      <a:r>
-                        <a:rPr lang="en-US" sz="1800" b="1" u="none" strike="noStrike">
-                          <a:solidFill>
-                            <a:schemeClr val="dk1"/>
-                          </a:solidFill>
-                          <a:effectLst/>
-                          <a:uFillTx/>
-                          <a:latin typeface="Aptos"/>
-                        </a:rPr>
-                        <a:t>0.62</a:t>
-                      </a:r>
-                      <a:endParaRPr lang="en-US" sz="1800" b="0" u="none" strike="noStrike">
-                        <a:solidFill>
-                          <a:srgbClr val="000000"/>
-                        </a:solidFill>
-                        <a:effectLst/>
-                        <a:uFillTx/>
-                        <a:latin typeface="Arial"/>
-                      </a:endParaRPr>
+                      <a:r>
+                        <a:rPr sz="1800" b="1"/>
+                        <a:t>0.73</a:t>
+                      </a:r>
                     </a:p>
                   </a:txBody>
                   <a:tcPr anchor="ctr" marL="0" marR="0" marT="0" marB="0">
@@ -14816,30 +14719,10 @@
                       <a:noAutofit/>
                     </a:bodyPr>
                     <a:p>
-                      <a:pPr algn="ctr" defTabSz="914400">
-                        <a:lnSpc>
-                          <a:spcPct val="100000"/>
-                        </a:lnSpc>
-                      </a:pPr>
-                      <a:r>
-                        <a:rPr lang="en-US" sz="1800" b="1" u="none" strike="noStrike">
-                          <a:solidFill>
-                            <a:schemeClr val="dk1"/>
-                          </a:solidFill>
-                          <a:effectLst/>
-                          <a:uFillTx/>
-                          <a:latin typeface="Aptos"/>
-                        </a:rPr>
-                        <a:t>0.23</a:t>
-                      </a:r>
-                      <a:endParaRPr lang="en-US" sz="1800" b="0" u="none" strike="noStrike">
-                        <a:solidFill>
-                          <a:srgbClr val="000000"/>
-                        </a:solidFill>
-                        <a:effectLst/>
-                        <a:uFillTx/>
-                        <a:latin typeface="Arial"/>
-                      </a:endParaRPr>
+                      <a:r>
+                        <a:rPr sz="1800" b="1"/>
+                        <a:t>—</a:t>
+                      </a:r>
                     </a:p>
                   </a:txBody>
                   <a:tcPr anchor="ctr" marL="0" marR="0" marT="0" marB="0">
@@ -14938,30 +14821,10 @@
                       <a:noAutofit/>
                     </a:bodyPr>
                     <a:p>
-                      <a:pPr algn="ctr" defTabSz="914400">
-                        <a:lnSpc>
-                          <a:spcPct val="100000"/>
-                        </a:lnSpc>
-                      </a:pPr>
-                      <a:r>
-                        <a:rPr lang="en-US" sz="1800" b="0" u="none" strike="noStrike">
-                          <a:solidFill>
-                            <a:schemeClr val="dk1"/>
-                          </a:solidFill>
-                          <a:effectLst/>
-                          <a:uFillTx/>
-                          <a:latin typeface="Aptos"/>
-                        </a:rPr>
-                        <a:t>-</a:t>
-                      </a:r>
-                      <a:endParaRPr lang="en-US" sz="1800" b="0" u="none" strike="noStrike">
-                        <a:solidFill>
-                          <a:srgbClr val="000000"/>
-                        </a:solidFill>
-                        <a:effectLst/>
-                        <a:uFillTx/>
-                        <a:latin typeface="Arial"/>
-                      </a:endParaRPr>
+                      <a:r>
+                        <a:rPr sz="1800" b="0"/>
+                        <a:t>0.72</a:t>
+                      </a:r>
                     </a:p>
                   </a:txBody>
                   <a:tcPr anchor="ctr" marL="0" marR="0" marT="0" marB="0">
@@ -14998,30 +14861,10 @@
                       <a:noAutofit/>
                     </a:bodyPr>
                     <a:p>
-                      <a:pPr algn="ctr" defTabSz="914400">
-                        <a:lnSpc>
-                          <a:spcPct val="100000"/>
-                        </a:lnSpc>
-                      </a:pPr>
-                      <a:r>
-                        <a:rPr lang="en-US" sz="1800" b="0" u="none" strike="noStrike">
-                          <a:solidFill>
-                            <a:schemeClr val="dk1"/>
-                          </a:solidFill>
-                          <a:effectLst/>
-                          <a:uFillTx/>
-                          <a:latin typeface="Aptos"/>
-                        </a:rPr>
-                        <a:t>-</a:t>
-                      </a:r>
-                      <a:endParaRPr lang="en-US" sz="1800" b="0" u="none" strike="noStrike">
-                        <a:solidFill>
-                          <a:srgbClr val="000000"/>
-                        </a:solidFill>
-                        <a:effectLst/>
-                        <a:uFillTx/>
-                        <a:latin typeface="Arial"/>
-                      </a:endParaRPr>
+                      <a:r>
+                        <a:rPr sz="1800" b="0"/>
+                        <a:t>—</a:t>
+                      </a:r>
                     </a:p>
                   </a:txBody>
                   <a:tcPr anchor="ctr" marL="0" marR="0" marT="0" marB="0">
@@ -15058,30 +14901,10 @@
                       <a:noAutofit/>
                     </a:bodyPr>
                     <a:p>
-                      <a:pPr algn="ctr" defTabSz="914400">
-                        <a:lnSpc>
-                          <a:spcPct val="100000"/>
-                        </a:lnSpc>
-                      </a:pPr>
-                      <a:r>
-                        <a:rPr lang="en-US" sz="1800" b="1" u="none" strike="noStrike">
-                          <a:solidFill>
-                            <a:schemeClr val="dk1"/>
-                          </a:solidFill>
-                          <a:effectLst/>
-                          <a:uFillTx/>
-                          <a:latin typeface="Aptos"/>
-                        </a:rPr>
-                        <a:t>0.62</a:t>
-                      </a:r>
-                      <a:endParaRPr lang="en-US" sz="1800" b="0" u="none" strike="noStrike">
-                        <a:solidFill>
-                          <a:srgbClr val="000000"/>
-                        </a:solidFill>
-                        <a:effectLst/>
-                        <a:uFillTx/>
-                        <a:latin typeface="Arial"/>
-                      </a:endParaRPr>
+                      <a:r>
+                        <a:rPr sz="1800" b="1"/>
+                        <a:t>0.70</a:t>
+                      </a:r>
                     </a:p>
                   </a:txBody>
                   <a:tcPr anchor="ctr" marL="0" marR="0" marT="0" marB="0">
@@ -15118,30 +14941,10 @@
                       <a:noAutofit/>
                     </a:bodyPr>
                     <a:p>
-                      <a:pPr algn="ctr" defTabSz="914400">
-                        <a:lnSpc>
-                          <a:spcPct val="100000"/>
-                        </a:lnSpc>
-                      </a:pPr>
-                      <a:r>
-                        <a:rPr lang="en-US" sz="1800" b="1" u="none" strike="noStrike">
-                          <a:solidFill>
-                            <a:schemeClr val="dk1"/>
-                          </a:solidFill>
-                          <a:effectLst/>
-                          <a:uFillTx/>
-                          <a:latin typeface="Aptos"/>
-                        </a:rPr>
-                        <a:t>0.13</a:t>
-                      </a:r>
-                      <a:endParaRPr lang="en-US" sz="1800" b="0" u="none" strike="noStrike">
-                        <a:solidFill>
-                          <a:srgbClr val="000000"/>
-                        </a:solidFill>
-                        <a:effectLst/>
-                        <a:uFillTx/>
-                        <a:latin typeface="Arial"/>
-                      </a:endParaRPr>
+                      <a:r>
+                        <a:rPr sz="1800" b="1"/>
+                        <a:t>—</a:t>
+                      </a:r>
                     </a:p>
                   </a:txBody>
                   <a:tcPr anchor="ctr" marL="0" marR="0" marT="0" marB="0">
@@ -15178,30 +14981,10 @@
                       <a:noAutofit/>
                     </a:bodyPr>
                     <a:p>
-                      <a:pPr algn="ctr" defTabSz="914400">
-                        <a:lnSpc>
-                          <a:spcPct val="100000"/>
-                        </a:lnSpc>
-                      </a:pPr>
-                      <a:r>
-                        <a:rPr lang="en-US" sz="1800" b="0" u="none" strike="noStrike">
-                          <a:solidFill>
-                            <a:schemeClr val="dk1"/>
-                          </a:solidFill>
-                          <a:effectLst/>
-                          <a:uFillTx/>
-                          <a:latin typeface="Aptos"/>
-                        </a:rPr>
-                        <a:t>-</a:t>
-                      </a:r>
-                      <a:endParaRPr lang="en-US" sz="1800" b="0" u="none" strike="noStrike">
-                        <a:solidFill>
-                          <a:srgbClr val="000000"/>
-                        </a:solidFill>
-                        <a:effectLst/>
-                        <a:uFillTx/>
-                        <a:latin typeface="Arial"/>
-                      </a:endParaRPr>
+                      <a:r>
+                        <a:rPr sz="1800" b="0"/>
+                        <a:t>0.71</a:t>
+                      </a:r>
                     </a:p>
                   </a:txBody>
                   <a:tcPr anchor="ctr" marL="0" marR="0" marT="0" marB="0">
@@ -15238,30 +15021,10 @@
                       <a:noAutofit/>
                     </a:bodyPr>
                     <a:p>
-                      <a:pPr algn="ctr" defTabSz="914400">
-                        <a:lnSpc>
-                          <a:spcPct val="100000"/>
-                        </a:lnSpc>
-                      </a:pPr>
-                      <a:r>
-                        <a:rPr lang="en-US" sz="1800" b="0" u="none" strike="noStrike">
-                          <a:solidFill>
-                            <a:schemeClr val="dk1"/>
-                          </a:solidFill>
-                          <a:effectLst/>
-                          <a:uFillTx/>
-                          <a:latin typeface="Aptos"/>
-                        </a:rPr>
-                        <a:t>-</a:t>
-                      </a:r>
-                      <a:endParaRPr lang="en-US" sz="1800" b="0" u="none" strike="noStrike">
-                        <a:solidFill>
-                          <a:srgbClr val="000000"/>
-                        </a:solidFill>
-                        <a:effectLst/>
-                        <a:uFillTx/>
-                        <a:latin typeface="Arial"/>
-                      </a:endParaRPr>
+                      <a:r>
+                        <a:rPr sz="1800" b="0"/>
+                        <a:t>—</a:t>
+                      </a:r>
                     </a:p>
                   </a:txBody>
                   <a:tcPr anchor="ctr" marL="0" marR="0" marT="0" marB="0">
@@ -15360,30 +15123,10 @@
                       <a:noAutofit/>
                     </a:bodyPr>
                     <a:p>
-                      <a:pPr algn="ctr" defTabSz="914400">
-                        <a:lnSpc>
-                          <a:spcPct val="100000"/>
-                        </a:lnSpc>
-                      </a:pPr>
-                      <a:r>
-                        <a:rPr lang="en-US" sz="1800" b="0" u="none" strike="noStrike">
-                          <a:solidFill>
-                            <a:schemeClr val="dk1"/>
-                          </a:solidFill>
-                          <a:effectLst/>
-                          <a:uFillTx/>
-                          <a:latin typeface="Aptos"/>
-                        </a:rPr>
-                        <a:t>-</a:t>
-                      </a:r>
-                      <a:endParaRPr lang="en-US" sz="1800" b="0" u="none" strike="noStrike">
-                        <a:solidFill>
-                          <a:srgbClr val="000000"/>
-                        </a:solidFill>
-                        <a:effectLst/>
-                        <a:uFillTx/>
-                        <a:latin typeface="Arial"/>
-                      </a:endParaRPr>
+                      <a:r>
+                        <a:rPr sz="1800" b="0"/>
+                        <a:t>0.77</a:t>
+                      </a:r>
                     </a:p>
                   </a:txBody>
                   <a:tcPr anchor="ctr" marL="0" marR="0" marT="0" marB="0">
@@ -15420,30 +15163,10 @@
                       <a:noAutofit/>
                     </a:bodyPr>
                     <a:p>
-                      <a:pPr algn="ctr" defTabSz="914400">
-                        <a:lnSpc>
-                          <a:spcPct val="100000"/>
-                        </a:lnSpc>
-                      </a:pPr>
-                      <a:r>
-                        <a:rPr lang="en-US" sz="1800" b="0" u="none" strike="noStrike">
-                          <a:solidFill>
-                            <a:schemeClr val="dk1"/>
-                          </a:solidFill>
-                          <a:effectLst/>
-                          <a:uFillTx/>
-                          <a:latin typeface="Aptos"/>
-                        </a:rPr>
-                        <a:t>-</a:t>
-                      </a:r>
-                      <a:endParaRPr lang="en-US" sz="1800" b="0" u="none" strike="noStrike">
-                        <a:solidFill>
-                          <a:srgbClr val="000000"/>
-                        </a:solidFill>
-                        <a:effectLst/>
-                        <a:uFillTx/>
-                        <a:latin typeface="Arial"/>
-                      </a:endParaRPr>
+                      <a:r>
+                        <a:rPr sz="1800" b="0"/>
+                        <a:t>—</a:t>
+                      </a:r>
                     </a:p>
                   </a:txBody>
                   <a:tcPr anchor="ctr" marL="0" marR="0" marT="0" marB="0">
@@ -15480,30 +15203,10 @@
                       <a:noAutofit/>
                     </a:bodyPr>
                     <a:p>
-                      <a:pPr algn="ctr" defTabSz="914400">
-                        <a:lnSpc>
-                          <a:spcPct val="100000"/>
-                        </a:lnSpc>
-                      </a:pPr>
-                      <a:r>
-                        <a:rPr lang="en-US" sz="1800" b="0" u="none" strike="noStrike">
-                          <a:solidFill>
-                            <a:schemeClr val="dk1"/>
-                          </a:solidFill>
-                          <a:effectLst/>
-                          <a:uFillTx/>
-                          <a:latin typeface="Aptos"/>
-                        </a:rPr>
-                        <a:t>-</a:t>
-                      </a:r>
-                      <a:endParaRPr lang="en-US" sz="1800" b="0" u="none" strike="noStrike">
-                        <a:solidFill>
-                          <a:srgbClr val="000000"/>
-                        </a:solidFill>
-                        <a:effectLst/>
-                        <a:uFillTx/>
-                        <a:latin typeface="Arial"/>
-                      </a:endParaRPr>
+                      <a:r>
+                        <a:rPr sz="1800" b="0"/>
+                        <a:t>0.65</a:t>
+                      </a:r>
                     </a:p>
                   </a:txBody>
                   <a:tcPr anchor="ctr" marL="0" marR="0" marT="0" marB="0">
@@ -15540,30 +15243,10 @@
                       <a:noAutofit/>
                     </a:bodyPr>
                     <a:p>
-                      <a:pPr algn="ctr" defTabSz="914400">
-                        <a:lnSpc>
-                          <a:spcPct val="100000"/>
-                        </a:lnSpc>
-                      </a:pPr>
-                      <a:r>
-                        <a:rPr lang="en-US" sz="1800" b="0" u="none" strike="noStrike">
-                          <a:solidFill>
-                            <a:schemeClr val="dk1"/>
-                          </a:solidFill>
-                          <a:effectLst/>
-                          <a:uFillTx/>
-                          <a:latin typeface="Aptos"/>
-                        </a:rPr>
-                        <a:t>-</a:t>
-                      </a:r>
-                      <a:endParaRPr lang="en-US" sz="1800" b="0" u="none" strike="noStrike">
-                        <a:solidFill>
-                          <a:srgbClr val="000000"/>
-                        </a:solidFill>
-                        <a:effectLst/>
-                        <a:uFillTx/>
-                        <a:latin typeface="Arial"/>
-                      </a:endParaRPr>
+                      <a:r>
+                        <a:rPr sz="1800" b="0"/>
+                        <a:t>—</a:t>
+                      </a:r>
                     </a:p>
                   </a:txBody>
                   <a:tcPr anchor="ctr" marL="0" marR="0" marT="0" marB="0">
@@ -15600,30 +15283,10 @@
                       <a:noAutofit/>
                     </a:bodyPr>
                     <a:p>
-                      <a:pPr algn="ctr" defTabSz="914400">
-                        <a:lnSpc>
-                          <a:spcPct val="100000"/>
-                        </a:lnSpc>
-                      </a:pPr>
-                      <a:r>
-                        <a:rPr lang="en-US" sz="1800" b="1" u="none" strike="noStrike">
-                          <a:solidFill>
-                            <a:schemeClr val="dk1"/>
-                          </a:solidFill>
-                          <a:effectLst/>
-                          <a:uFillTx/>
-                          <a:latin typeface="Aptos"/>
-                        </a:rPr>
-                        <a:t>0.60</a:t>
-                      </a:r>
-                      <a:endParaRPr lang="en-US" sz="1800" b="0" u="none" strike="noStrike">
-                        <a:solidFill>
-                          <a:srgbClr val="000000"/>
-                        </a:solidFill>
-                        <a:effectLst/>
-                        <a:uFillTx/>
-                        <a:latin typeface="Arial"/>
-                      </a:endParaRPr>
+                      <a:r>
+                        <a:rPr sz="1800" b="1"/>
+                        <a:t>0.73</a:t>
+                      </a:r>
                     </a:p>
                   </a:txBody>
                   <a:tcPr anchor="ctr" marL="0" marR="0" marT="0" marB="0">
@@ -15660,30 +15323,10 @@
                       <a:noAutofit/>
                     </a:bodyPr>
                     <a:p>
-                      <a:pPr algn="ctr" defTabSz="914400">
-                        <a:lnSpc>
-                          <a:spcPct val="100000"/>
-                        </a:lnSpc>
-                      </a:pPr>
-                      <a:r>
-                        <a:rPr lang="en-US" sz="1800" b="1" u="none" strike="noStrike">
-                          <a:solidFill>
-                            <a:schemeClr val="dk1"/>
-                          </a:solidFill>
-                          <a:effectLst/>
-                          <a:uFillTx/>
-                          <a:latin typeface="Aptos"/>
-                        </a:rPr>
-                        <a:t>0.17</a:t>
-                      </a:r>
-                      <a:endParaRPr lang="en-US" sz="1800" b="0" u="none" strike="noStrike">
-                        <a:solidFill>
-                          <a:srgbClr val="000000"/>
-                        </a:solidFill>
-                        <a:effectLst/>
-                        <a:uFillTx/>
-                        <a:latin typeface="Arial"/>
-                      </a:endParaRPr>
+                      <a:r>
+                        <a:rPr sz="1800" b="1"/>
+                        <a:t>—</a:t>
+                      </a:r>
                     </a:p>
                   </a:txBody>
                   <a:tcPr anchor="ctr" marL="0" marR="0" marT="0" marB="0">
@@ -15998,7 +15641,7 @@
           <a:p>
             <a:r>
               <a:rPr sz="1000" i="1"/>
-              <a:t>Majority baseline = always-predict-majority (deterministic, per split, on the prior's labels). Replaces the original stochastic uniform/stratified dummy (0.53/0.43/0.45), which was a weaker floor — the models' margin over the honest baseline is much smaller (e.g. SVM Dyads 0.66 vs 0.62; SVM Triads 0.63 vs 0.55).</a:t>
+              <a:t>Redone on CLEAN 2-annotator labels, group-level (185 windows), scaled nested CV (was bugged labels + uniform/seed baseline). Majority baseline = deterministic always-predict-majority. Significance is now METHOD-DEPENDENT (uniform vs majority vs permutation give different verdicts) — see 'Methodology Review' slides; no fixed red boxes.</a:t>
             </a:r>
           </a:p>
         </p:txBody>
@@ -16013,6 +15656,1161 @@
       <p:transition spd="slow"/>
     </mc:Fallback>
   </mc:AlternateContent>
+</p:sld>
+</file>
+
+<file path=ppt/slides/slide20.xml><?xml version="1.0" encoding="utf-8"?>
+<p:sld xmlns:a="http://schemas.openxmlformats.org/drawingml/2006/main" xmlns:p="http://schemas.openxmlformats.org/presentationml/2006/main" xmlns:r="http://schemas.openxmlformats.org/officeDocument/2006/relationships">
+  <p:cSld>
+    <p:spTree>
+      <p:nvGrpSpPr>
+        <p:cNvPr id="1" name=""/>
+        <p:cNvGrpSpPr/>
+        <p:nvPr/>
+      </p:nvGrpSpPr>
+      <p:grpSpPr/>
+      <p:sp>
+        <p:nvSpPr>
+          <p:cNvPr id="2" name="Title 1"/>
+          <p:cNvSpPr>
+            <a:spLocks noGrp="1"/>
+          </p:cNvSpPr>
+          <p:nvPr>
+            <p:ph type="title"/>
+          </p:nvPr>
+        </p:nvSpPr>
+        <p:spPr/>
+        <p:txBody>
+          <a:bodyPr/>
+          <a:lstStyle/>
+          <a:p>
+            <a:r>
+              <a:t>Significance Depends on the Test (sig → ns → sig)</a:t>
+            </a:r>
+          </a:p>
+        </p:txBody>
+      </p:sp>
+      <p:sp>
+        <p:nvSpPr>
+          <p:cNvPr id="3" name="Text Placeholder 2"/>
+          <p:cNvSpPr>
+            <a:spLocks noGrp="1"/>
+          </p:cNvSpPr>
+          <p:nvPr>
+            <p:ph type="body"/>
+          </p:nvPr>
+        </p:nvSpPr>
+        <p:spPr/>
+        <p:txBody>
+          <a:bodyPr/>
+          <a:lstStyle/>
+          <a:p/>
+        </p:txBody>
+      </p:sp>
+      <p:graphicFrame>
+        <p:nvGraphicFramePr>
+          <p:cNvPr id="4" name="Table 3"/>
+          <p:cNvGraphicFramePr>
+            <a:graphicFrameLocks noGrp="1"/>
+          </p:cNvGraphicFramePr>
+          <p:nvPr/>
+        </p:nvGraphicFramePr>
+        <p:xfrm>
+          <a:off x="365760" y="1280160"/>
+          <a:ext cx="11887200" cy="2304288"/>
+        </p:xfrm>
+        <a:graphic>
+          <a:graphicData uri="http://schemas.openxmlformats.org/drawingml/2006/table">
+            <a:tbl>
+              <a:tblPr firstRow="1" bandRow="1">
+                <a:tableStyleId>{5C22544A-7EE6-4342-B048-85BDC9FD1C3A}</a:tableStyleId>
+              </a:tblPr>
+              <a:tblGrid>
+                <a:gridCol w="2377440"/>
+                <a:gridCol w="2194560"/>
+                <a:gridCol w="1280160"/>
+                <a:gridCol w="2103120"/>
+                <a:gridCol w="2103120"/>
+                <a:gridCol w="1828800"/>
+              </a:tblGrid>
+              <a:tr h="329184">
+                <a:tc>
+                  <a:txBody>
+                    <a:bodyPr/>
+                    <a:lstStyle/>
+                    <a:p>
+                      <a:r>
+                        <a:rPr sz="1100" b="1"/>
+                        <a:t>Detector / split</a:t>
+                      </a:r>
+                    </a:p>
+                  </a:txBody>
+                  <a:tcPr/>
+                </a:tc>
+                <a:tc>
+                  <a:txBody>
+                    <a:bodyPr/>
+                    <a:lstStyle/>
+                    <a:p>
+                      <a:r>
+                        <a:rPr sz="1100" b="1"/>
+                        <a:t>best acc</a:t>
+                      </a:r>
+                    </a:p>
+                  </a:txBody>
+                  <a:tcPr/>
+                </a:tc>
+                <a:tc>
+                  <a:txBody>
+                    <a:bodyPr/>
+                    <a:lstStyle/>
+                    <a:p>
+                      <a:r>
+                        <a:rPr sz="1100" b="1"/>
+                        <a:t>majority</a:t>
+                      </a:r>
+                    </a:p>
+                  </a:txBody>
+                  <a:tcPr/>
+                </a:tc>
+                <a:tc>
+                  <a:txBody>
+                    <a:bodyPr/>
+                    <a:lstStyle/>
+                    <a:p>
+                      <a:r>
+                        <a:rPr sz="1100" b="1"/>
+                        <a:t>uniform-dummy</a:t>
+                      </a:r>
+                    </a:p>
+                  </a:txBody>
+                  <a:tcPr/>
+                </a:tc>
+                <a:tc>
+                  <a:txBody>
+                    <a:bodyPr/>
+                    <a:lstStyle/>
+                    <a:p>
+                      <a:r>
+                        <a:rPr sz="1100" b="1"/>
+                        <a:t>majority 1-samp</a:t>
+                      </a:r>
+                    </a:p>
+                  </a:txBody>
+                  <a:tcPr/>
+                </a:tc>
+                <a:tc>
+                  <a:txBody>
+                    <a:bodyPr/>
+                    <a:lstStyle/>
+                    <a:p>
+                      <a:r>
+                        <a:rPr sz="1100" b="1"/>
+                        <a:t>permutation</a:t>
+                      </a:r>
+                    </a:p>
+                  </a:txBody>
+                  <a:tcPr/>
+                </a:tc>
+              </a:tr>
+              <a:tr h="329184">
+                <a:tc>
+                  <a:txBody>
+                    <a:bodyPr/>
+                    <a:lstStyle/>
+                    <a:p>
+                      <a:r>
+                        <a:rPr sz="1100"/>
+                        <a:t>audio All</a:t>
+                      </a:r>
+                    </a:p>
+                  </a:txBody>
+                  <a:tcPr/>
+                </a:tc>
+                <a:tc>
+                  <a:txBody>
+                    <a:bodyPr/>
+                    <a:lstStyle/>
+                    <a:p>
+                      <a:r>
+                        <a:rPr sz="1100"/>
+                        <a:t>SVM 0.68</a:t>
+                      </a:r>
+                    </a:p>
+                  </a:txBody>
+                  <a:tcPr/>
+                </a:tc>
+                <a:tc>
+                  <a:txBody>
+                    <a:bodyPr/>
+                    <a:lstStyle/>
+                    <a:p>
+                      <a:r>
+                        <a:rPr sz="1100"/>
+                        <a:t>0.51</a:t>
+                      </a:r>
+                    </a:p>
+                  </a:txBody>
+                  <a:tcPr/>
+                </a:tc>
+                <a:tc>
+                  <a:txBody>
+                    <a:bodyPr/>
+                    <a:lstStyle/>
+                    <a:p>
+                      <a:r>
+                        <a:rPr sz="1100"/>
+                        <a:t>0.017 ✓</a:t>
+                      </a:r>
+                    </a:p>
+                  </a:txBody>
+                  <a:tcPr/>
+                </a:tc>
+                <a:tc>
+                  <a:txBody>
+                    <a:bodyPr/>
+                    <a:lstStyle/>
+                    <a:p>
+                      <a:r>
+                        <a:rPr sz="1100"/>
+                        <a:t>0.002 ✓</a:t>
+                      </a:r>
+                    </a:p>
+                  </a:txBody>
+                  <a:tcPr/>
+                </a:tc>
+                <a:tc>
+                  <a:txBody>
+                    <a:bodyPr/>
+                    <a:lstStyle/>
+                    <a:p>
+                      <a:r>
+                        <a:rPr sz="1100"/>
+                        <a:t>0.007 ✓</a:t>
+                      </a:r>
+                    </a:p>
+                  </a:txBody>
+                  <a:tcPr/>
+                </a:tc>
+              </a:tr>
+              <a:tr h="329184">
+                <a:tc>
+                  <a:txBody>
+                    <a:bodyPr/>
+                    <a:lstStyle/>
+                    <a:p>
+                      <a:r>
+                        <a:rPr sz="1100"/>
+                        <a:t>audio D</a:t>
+                      </a:r>
+                    </a:p>
+                  </a:txBody>
+                  <a:tcPr/>
+                </a:tc>
+                <a:tc>
+                  <a:txBody>
+                    <a:bodyPr/>
+                    <a:lstStyle/>
+                    <a:p>
+                      <a:r>
+                        <a:rPr sz="1100"/>
+                        <a:t>LogReg 0.72</a:t>
+                      </a:r>
+                    </a:p>
+                  </a:txBody>
+                  <a:tcPr/>
+                </a:tc>
+                <a:tc>
+                  <a:txBody>
+                    <a:bodyPr/>
+                    <a:lstStyle/>
+                    <a:p>
+                      <a:r>
+                        <a:rPr sz="1100"/>
+                        <a:t>0.59</a:t>
+                      </a:r>
+                    </a:p>
+                  </a:txBody>
+                  <a:tcPr/>
+                </a:tc>
+                <a:tc>
+                  <a:txBody>
+                    <a:bodyPr/>
+                    <a:lstStyle/>
+                    <a:p>
+                      <a:r>
+                        <a:rPr sz="1100"/>
+                        <a:t>0.019 ✓</a:t>
+                      </a:r>
+                    </a:p>
+                  </a:txBody>
+                  <a:tcPr/>
+                </a:tc>
+                <a:tc>
+                  <a:txBody>
+                    <a:bodyPr/>
+                    <a:lstStyle/>
+                    <a:p>
+                      <a:r>
+                        <a:rPr sz="1100"/>
+                        <a:t>0.058 ✗</a:t>
+                      </a:r>
+                    </a:p>
+                  </a:txBody>
+                  <a:tcPr/>
+                </a:tc>
+                <a:tc>
+                  <a:txBody>
+                    <a:bodyPr/>
+                    <a:lstStyle/>
+                    <a:p>
+                      <a:r>
+                        <a:rPr sz="1100"/>
+                        <a:t>0.017 ✓</a:t>
+                      </a:r>
+                    </a:p>
+                  </a:txBody>
+                  <a:tcPr/>
+                </a:tc>
+              </a:tr>
+              <a:tr h="329184">
+                <a:tc>
+                  <a:txBody>
+                    <a:bodyPr/>
+                    <a:lstStyle/>
+                    <a:p>
+                      <a:r>
+                        <a:rPr sz="1100"/>
+                        <a:t>audio T</a:t>
+                      </a:r>
+                    </a:p>
+                  </a:txBody>
+                  <a:tcPr/>
+                </a:tc>
+                <a:tc>
+                  <a:txBody>
+                    <a:bodyPr/>
+                    <a:lstStyle/>
+                    <a:p>
+                      <a:r>
+                        <a:rPr sz="1100"/>
+                        <a:t>QDA 0.70</a:t>
+                      </a:r>
+                    </a:p>
+                  </a:txBody>
+                  <a:tcPr/>
+                </a:tc>
+                <a:tc>
+                  <a:txBody>
+                    <a:bodyPr/>
+                    <a:lstStyle/>
+                    <a:p>
+                      <a:r>
+                        <a:rPr sz="1100"/>
+                        <a:t>0.55</a:t>
+                      </a:r>
+                    </a:p>
+                  </a:txBody>
+                  <a:tcPr/>
+                </a:tc>
+                <a:tc>
+                  <a:txBody>
+                    <a:bodyPr/>
+                    <a:lstStyle/>
+                    <a:p>
+                      <a:r>
+                        <a:rPr sz="1100"/>
+                        <a:t>0.117 ✗</a:t>
+                      </a:r>
+                    </a:p>
+                  </a:txBody>
+                  <a:tcPr/>
+                </a:tc>
+                <a:tc>
+                  <a:txBody>
+                    <a:bodyPr/>
+                    <a:lstStyle/>
+                    <a:p>
+                      <a:r>
+                        <a:rPr sz="1100"/>
+                        <a:t>0.052 ✗</a:t>
+                      </a:r>
+                    </a:p>
+                  </a:txBody>
+                  <a:tcPr/>
+                </a:tc>
+                <a:tc>
+                  <a:txBody>
+                    <a:bodyPr/>
+                    <a:lstStyle/>
+                    <a:p>
+                      <a:r>
+                        <a:rPr sz="1100"/>
+                        <a:t>0.003 ✓</a:t>
+                      </a:r>
+                    </a:p>
+                  </a:txBody>
+                  <a:tcPr/>
+                </a:tc>
+              </a:tr>
+              <a:tr h="329184">
+                <a:tc>
+                  <a:txBody>
+                    <a:bodyPr/>
+                    <a:lstStyle/>
+                    <a:p>
+                      <a:r>
+                        <a:rPr sz="1100"/>
+                        <a:t>gaze All</a:t>
+                      </a:r>
+                    </a:p>
+                  </a:txBody>
+                  <a:tcPr/>
+                </a:tc>
+                <a:tc>
+                  <a:txBody>
+                    <a:bodyPr/>
+                    <a:lstStyle/>
+                    <a:p>
+                      <a:r>
+                        <a:rPr sz="1100"/>
+                        <a:t>QDA 0.73</a:t>
+                      </a:r>
+                    </a:p>
+                  </a:txBody>
+                  <a:tcPr/>
+                </a:tc>
+                <a:tc>
+                  <a:txBody>
+                    <a:bodyPr/>
+                    <a:lstStyle/>
+                    <a:p>
+                      <a:r>
+                        <a:rPr sz="1100"/>
+                        <a:t>0.52</a:t>
+                      </a:r>
+                    </a:p>
+                  </a:txBody>
+                  <a:tcPr/>
+                </a:tc>
+                <a:tc>
+                  <a:txBody>
+                    <a:bodyPr/>
+                    <a:lstStyle/>
+                    <a:p>
+                      <a:r>
+                        <a:rPr sz="1100"/>
+                        <a:t>0.006 ✓</a:t>
+                      </a:r>
+                    </a:p>
+                  </a:txBody>
+                  <a:tcPr/>
+                </a:tc>
+                <a:tc>
+                  <a:txBody>
+                    <a:bodyPr/>
+                    <a:lstStyle/>
+                    <a:p>
+                      <a:r>
+                        <a:rPr sz="1100"/>
+                        <a:t>0.001 ✓</a:t>
+                      </a:r>
+                    </a:p>
+                  </a:txBody>
+                  <a:tcPr/>
+                </a:tc>
+                <a:tc>
+                  <a:txBody>
+                    <a:bodyPr/>
+                    <a:lstStyle/>
+                    <a:p>
+                      <a:r>
+                        <a:rPr sz="1100"/>
+                        <a:t>0.007 ✓</a:t>
+                      </a:r>
+                    </a:p>
+                  </a:txBody>
+                  <a:tcPr/>
+                </a:tc>
+              </a:tr>
+              <a:tr h="329184">
+                <a:tc>
+                  <a:txBody>
+                    <a:bodyPr/>
+                    <a:lstStyle/>
+                    <a:p>
+                      <a:r>
+                        <a:rPr sz="1100"/>
+                        <a:t>gaze D</a:t>
+                      </a:r>
+                    </a:p>
+                  </a:txBody>
+                  <a:tcPr/>
+                </a:tc>
+                <a:tc>
+                  <a:txBody>
+                    <a:bodyPr/>
+                    <a:lstStyle/>
+                    <a:p>
+                      <a:r>
+                        <a:rPr sz="1100"/>
+                        <a:t>SVM 0.83</a:t>
+                      </a:r>
+                    </a:p>
+                  </a:txBody>
+                  <a:tcPr/>
+                </a:tc>
+                <a:tc>
+                  <a:txBody>
+                    <a:bodyPr/>
+                    <a:lstStyle/>
+                    <a:p>
+                      <a:r>
+                        <a:rPr sz="1100"/>
+                        <a:t>0.59</a:t>
+                      </a:r>
+                    </a:p>
+                  </a:txBody>
+                  <a:tcPr/>
+                </a:tc>
+                <a:tc>
+                  <a:txBody>
+                    <a:bodyPr/>
+                    <a:lstStyle/>
+                    <a:p>
+                      <a:r>
+                        <a:rPr sz="1100"/>
+                        <a:t>0.006 ✓</a:t>
+                      </a:r>
+                    </a:p>
+                  </a:txBody>
+                  <a:tcPr/>
+                </a:tc>
+                <a:tc>
+                  <a:txBody>
+                    <a:bodyPr/>
+                    <a:lstStyle/>
+                    <a:p>
+                      <a:r>
+                        <a:rPr sz="1100"/>
+                        <a:t>0.000 ✓</a:t>
+                      </a:r>
+                    </a:p>
+                  </a:txBody>
+                  <a:tcPr/>
+                </a:tc>
+                <a:tc>
+                  <a:txBody>
+                    <a:bodyPr/>
+                    <a:lstStyle/>
+                    <a:p>
+                      <a:r>
+                        <a:rPr sz="1100"/>
+                        <a:t>0.083 ✗</a:t>
+                      </a:r>
+                    </a:p>
+                  </a:txBody>
+                  <a:tcPr/>
+                </a:tc>
+              </a:tr>
+              <a:tr h="329184">
+                <a:tc>
+                  <a:txBody>
+                    <a:bodyPr/>
+                    <a:lstStyle/>
+                    <a:p>
+                      <a:r>
+                        <a:rPr sz="1100"/>
+                        <a:t>gaze T</a:t>
+                      </a:r>
+                    </a:p>
+                  </a:txBody>
+                  <a:tcPr/>
+                </a:tc>
+                <a:tc>
+                  <a:txBody>
+                    <a:bodyPr/>
+                    <a:lstStyle/>
+                    <a:p>
+                      <a:r>
+                        <a:rPr sz="1100"/>
+                        <a:t>NB 0.69</a:t>
+                      </a:r>
+                    </a:p>
+                  </a:txBody>
+                  <a:tcPr/>
+                </a:tc>
+                <a:tc>
+                  <a:txBody>
+                    <a:bodyPr/>
+                    <a:lstStyle/>
+                    <a:p>
+                      <a:r>
+                        <a:rPr sz="1100"/>
+                        <a:t>0.54</a:t>
+                      </a:r>
+                    </a:p>
+                  </a:txBody>
+                  <a:tcPr/>
+                </a:tc>
+                <a:tc>
+                  <a:txBody>
+                    <a:bodyPr/>
+                    <a:lstStyle/>
+                    <a:p>
+                      <a:r>
+                        <a:rPr sz="1100"/>
+                        <a:t>0.144 ✗</a:t>
+                      </a:r>
+                    </a:p>
+                  </a:txBody>
+                  <a:tcPr/>
+                </a:tc>
+                <a:tc>
+                  <a:txBody>
+                    <a:bodyPr/>
+                    <a:lstStyle/>
+                    <a:p>
+                      <a:r>
+                        <a:rPr sz="1100"/>
+                        <a:t>0.090 ✗</a:t>
+                      </a:r>
+                    </a:p>
+                  </a:txBody>
+                  <a:tcPr/>
+                </a:tc>
+                <a:tc>
+                  <a:txBody>
+                    <a:bodyPr/>
+                    <a:lstStyle/>
+                    <a:p>
+                      <a:r>
+                        <a:rPr sz="1100"/>
+                        <a:t>0.003 ✓</a:t>
+                      </a:r>
+                    </a:p>
+                  </a:txBody>
+                  <a:tcPr/>
+                </a:tc>
+              </a:tr>
+            </a:tbl>
+          </a:graphicData>
+        </a:graphic>
+      </p:graphicFrame>
+      <p:sp>
+        <p:nvSpPr>
+          <p:cNvPr id="5" name="TextBox 4"/>
+          <p:cNvSpPr txBox="1"/>
+          <p:nvPr/>
+        </p:nvSpPr>
+        <p:spPr>
+          <a:xfrm>
+            <a:off x="365760" y="3840480"/>
+            <a:ext cx="11338560" cy="1280160"/>
+          </a:xfrm>
+          <a:prstGeom prst="rect">
+            <a:avLst/>
+          </a:prstGeom>
+          <a:noFill/>
+        </p:spPr>
+        <p:txBody>
+          <a:bodyPr wrap="square">
+            <a:spAutoFit/>
+          </a:bodyPr>
+          <a:lstStyle/>
+          <a:p>
+            <a:r>
+              <a:rPr sz="1200"/>
+              <a:t>All group-level, nested model selection, RAW p (Bonferroni shifts the threshold but not the pattern).</a:t>
+            </a:r>
+          </a:p>
+          <a:p>
+            <a:r>
+              <a:rPr sz="1200"/>
+              <a:t>Uniform-dummy = stochastic/gameable floor (prior + our first pass). Majority = deterministic always-predict-majority. Permutation = shuffle-label null (seed-proof).</a:t>
+            </a:r>
+          </a:p>
+          <a:p>
+            <a:r>
+              <a:rPr sz="1200"/>
+              <a:t>Verdict flips by method: audio-Triads &amp; gaze-Triads are significant ONLY under permutation; gaze-Dyads LOSES significance under permutation (6-feature null fits shuffled labels). Decision needed: which test do we standardize on?</a:t>
+            </a:r>
+          </a:p>
+        </p:txBody>
+      </p:sp>
+    </p:spTree>
+  </p:cSld>
+  <p:clrMapOvr>
+    <a:masterClrMapping/>
+  </p:clrMapOvr>
+</p:sld>
+</file>
+
+<file path=ppt/slides/slide21.xml><?xml version="1.0" encoding="utf-8"?>
+<p:sld xmlns:a="http://schemas.openxmlformats.org/drawingml/2006/main" xmlns:p="http://schemas.openxmlformats.org/presentationml/2006/main" xmlns:r="http://schemas.openxmlformats.org/officeDocument/2006/relationships">
+  <p:cSld>
+    <p:spTree>
+      <p:nvGrpSpPr>
+        <p:cNvPr id="1" name=""/>
+        <p:cNvGrpSpPr/>
+        <p:nvPr/>
+      </p:nvGrpSpPr>
+      <p:grpSpPr/>
+      <p:sp>
+        <p:nvSpPr>
+          <p:cNvPr id="2" name="Title 1"/>
+          <p:cNvSpPr>
+            <a:spLocks noGrp="1"/>
+          </p:cNvSpPr>
+          <p:nvPr>
+            <p:ph type="title"/>
+          </p:nvPr>
+        </p:nvSpPr>
+        <p:spPr/>
+        <p:txBody>
+          <a:bodyPr/>
+          <a:lstStyle/>
+          <a:p>
+            <a:r>
+              <a:t>Representation: Group-level vs Long-format</a:t>
+            </a:r>
+          </a:p>
+        </p:txBody>
+      </p:sp>
+      <p:sp>
+        <p:nvSpPr>
+          <p:cNvPr id="3" name="Text Placeholder 2"/>
+          <p:cNvSpPr>
+            <a:spLocks noGrp="1"/>
+          </p:cNvSpPr>
+          <p:nvPr>
+            <p:ph type="body"/>
+          </p:nvPr>
+        </p:nvSpPr>
+        <p:spPr/>
+        <p:txBody>
+          <a:bodyPr/>
+          <a:lstStyle/>
+          <a:p/>
+        </p:txBody>
+      </p:sp>
+      <p:graphicFrame>
+        <p:nvGraphicFramePr>
+          <p:cNvPr id="4" name="Table 3"/>
+          <p:cNvGraphicFramePr>
+            <a:graphicFrameLocks noGrp="1"/>
+          </p:cNvGraphicFramePr>
+          <p:nvPr/>
+        </p:nvGraphicFramePr>
+        <p:xfrm>
+          <a:off x="365760" y="1463040"/>
+          <a:ext cx="9601200" cy="1316736"/>
+        </p:xfrm>
+        <a:graphic>
+          <a:graphicData uri="http://schemas.openxmlformats.org/drawingml/2006/table">
+            <a:tbl>
+              <a:tblPr firstRow="1" bandRow="1">
+                <a:tableStyleId>{5C22544A-7EE6-4342-B048-85BDC9FD1C3A}</a:tableStyleId>
+              </a:tblPr>
+              <a:tblGrid>
+                <a:gridCol w="2743200"/>
+                <a:gridCol w="2743200"/>
+                <a:gridCol w="2743200"/>
+                <a:gridCol w="1371600"/>
+              </a:tblGrid>
+              <a:tr h="329184">
+                <a:tc>
+                  <a:txBody>
+                    <a:bodyPr/>
+                    <a:lstStyle/>
+                    <a:p>
+                      <a:r>
+                        <a:rPr sz="1100" b="1"/>
+                        <a:t>Audio (best model)</a:t>
+                      </a:r>
+                    </a:p>
+                  </a:txBody>
+                  <a:tcPr/>
+                </a:tc>
+                <a:tc>
+                  <a:txBody>
+                    <a:bodyPr/>
+                    <a:lstStyle/>
+                    <a:p>
+                      <a:r>
+                        <a:rPr sz="1100" b="1"/>
+                        <a:t>group-level (197)</a:t>
+                      </a:r>
+                    </a:p>
+                  </a:txBody>
+                  <a:tcPr/>
+                </a:tc>
+                <a:tc>
+                  <a:txBody>
+                    <a:bodyPr/>
+                    <a:lstStyle/>
+                    <a:p>
+                      <a:r>
+                        <a:rPr sz="1100" b="1"/>
+                        <a:t>long-format (506)</a:t>
+                      </a:r>
+                    </a:p>
+                  </a:txBody>
+                  <a:tcPr/>
+                </a:tc>
+                <a:tc>
+                  <a:txBody>
+                    <a:bodyPr/>
+                    <a:lstStyle/>
+                    <a:p>
+                      <a:r>
+                        <a:rPr sz="1100" b="1"/>
+                        <a:t>Δ</a:t>
+                      </a:r>
+                    </a:p>
+                  </a:txBody>
+                  <a:tcPr/>
+                </a:tc>
+              </a:tr>
+              <a:tr h="329184">
+                <a:tc>
+                  <a:txBody>
+                    <a:bodyPr/>
+                    <a:lstStyle/>
+                    <a:p>
+                      <a:r>
+                        <a:rPr sz="1100"/>
+                        <a:t>All</a:t>
+                      </a:r>
+                    </a:p>
+                  </a:txBody>
+                  <a:tcPr/>
+                </a:tc>
+                <a:tc>
+                  <a:txBody>
+                    <a:bodyPr/>
+                    <a:lstStyle/>
+                    <a:p>
+                      <a:r>
+                        <a:rPr sz="1100"/>
+                        <a:t>0.68</a:t>
+                      </a:r>
+                    </a:p>
+                  </a:txBody>
+                  <a:tcPr/>
+                </a:tc>
+                <a:tc>
+                  <a:txBody>
+                    <a:bodyPr/>
+                    <a:lstStyle/>
+                    <a:p>
+                      <a:r>
+                        <a:rPr sz="1100"/>
+                        <a:t>0.68</a:t>
+                      </a:r>
+                    </a:p>
+                  </a:txBody>
+                  <a:tcPr/>
+                </a:tc>
+                <a:tc>
+                  <a:txBody>
+                    <a:bodyPr/>
+                    <a:lstStyle/>
+                    <a:p>
+                      <a:r>
+                        <a:rPr sz="1100"/>
+                        <a:t>+0.01</a:t>
+                      </a:r>
+                    </a:p>
+                  </a:txBody>
+                  <a:tcPr/>
+                </a:tc>
+              </a:tr>
+              <a:tr h="329184">
+                <a:tc>
+                  <a:txBody>
+                    <a:bodyPr/>
+                    <a:lstStyle/>
+                    <a:p>
+                      <a:r>
+                        <a:rPr sz="1100"/>
+                        <a:t>Dyads</a:t>
+                      </a:r>
+                    </a:p>
+                  </a:txBody>
+                  <a:tcPr/>
+                </a:tc>
+                <a:tc>
+                  <a:txBody>
+                    <a:bodyPr/>
+                    <a:lstStyle/>
+                    <a:p>
+                      <a:r>
+                        <a:rPr sz="1100"/>
+                        <a:t>0.72</a:t>
+                      </a:r>
+                    </a:p>
+                  </a:txBody>
+                  <a:tcPr/>
+                </a:tc>
+                <a:tc>
+                  <a:txBody>
+                    <a:bodyPr/>
+                    <a:lstStyle/>
+                    <a:p>
+                      <a:r>
+                        <a:rPr sz="1100"/>
+                        <a:t>0.71</a:t>
+                      </a:r>
+                    </a:p>
+                  </a:txBody>
+                  <a:tcPr/>
+                </a:tc>
+                <a:tc>
+                  <a:txBody>
+                    <a:bodyPr/>
+                    <a:lstStyle/>
+                    <a:p>
+                      <a:r>
+                        <a:rPr sz="1100"/>
+                        <a:t>-0.01</a:t>
+                      </a:r>
+                    </a:p>
+                  </a:txBody>
+                  <a:tcPr/>
+                </a:tc>
+              </a:tr>
+              <a:tr h="329184">
+                <a:tc>
+                  <a:txBody>
+                    <a:bodyPr/>
+                    <a:lstStyle/>
+                    <a:p>
+                      <a:r>
+                        <a:rPr sz="1100"/>
+                        <a:t>Triads</a:t>
+                      </a:r>
+                    </a:p>
+                  </a:txBody>
+                  <a:tcPr/>
+                </a:tc>
+                <a:tc>
+                  <a:txBody>
+                    <a:bodyPr/>
+                    <a:lstStyle/>
+                    <a:p>
+                      <a:r>
+                        <a:rPr sz="1100"/>
+                        <a:t>0.70</a:t>
+                      </a:r>
+                    </a:p>
+                  </a:txBody>
+                  <a:tcPr/>
+                </a:tc>
+                <a:tc>
+                  <a:txBody>
+                    <a:bodyPr/>
+                    <a:lstStyle/>
+                    <a:p>
+                      <a:r>
+                        <a:rPr sz="1100"/>
+                        <a:t>0.70</a:t>
+                      </a:r>
+                    </a:p>
+                  </a:txBody>
+                  <a:tcPr/>
+                </a:tc>
+                <a:tc>
+                  <a:txBody>
+                    <a:bodyPr/>
+                    <a:lstStyle/>
+                    <a:p>
+                      <a:r>
+                        <a:rPr sz="1100"/>
+                        <a:t>0.00</a:t>
+                      </a:r>
+                    </a:p>
+                  </a:txBody>
+                  <a:tcPr/>
+                </a:tc>
+              </a:tr>
+            </a:tbl>
+          </a:graphicData>
+        </a:graphic>
+      </p:graphicFrame>
+      <p:sp>
+        <p:nvSpPr>
+          <p:cNvPr id="5" name="TextBox 4"/>
+          <p:cNvSpPr txBox="1"/>
+          <p:nvPr/>
+        </p:nvSpPr>
+        <p:spPr>
+          <a:xfrm>
+            <a:off x="365760" y="3291840"/>
+            <a:ext cx="11338560" cy="1280160"/>
+          </a:xfrm>
+          <a:prstGeom prst="rect">
+            <a:avLst/>
+          </a:prstGeom>
+          <a:noFill/>
+        </p:spPr>
+        <p:txBody>
+          <a:bodyPr wrap="square">
+            <a:spAutoFit/>
+          </a:bodyPr>
+          <a:lstStyle/>
+          <a:p>
+            <a:r>
+              <a:rPr sz="1200"/>
+              <a:t>Long-format repeats each group-window once per participant (dyad ×2, triad ×3) → pseudo-replication on a group-level label.</a:t>
+            </a:r>
+          </a:p>
+          <a:p>
+            <a:r>
+              <a:rPr sz="1200"/>
+              <a:t>But best-model accuracy is ~identical (Δ ≤ 0.01) → dedup does NOT inflate numbers. Group-level is the honest unit and avoids the reviewer objection.</a:t>
+            </a:r>
+          </a:p>
+          <a:p>
+            <a:r>
+              <a:rPr sz="1200"/>
+              <a:t>Note: the prior gaze detector was ALWAYS group-level (185 windows). Moving ours to group-level makes the comparison apples-to-apples.</a:t>
+            </a:r>
+          </a:p>
+        </p:txBody>
+      </p:sp>
+    </p:spTree>
+  </p:cSld>
+  <p:clrMapOvr>
+    <a:masterClrMapping/>
+  </p:clrMapOvr>
+</p:sld>
+</file>
+
+<file path=ppt/slides/slide22.xml><?xml version="1.0" encoding="utf-8"?>
+<p:sld xmlns:a="http://schemas.openxmlformats.org/drawingml/2006/main" xmlns:p="http://schemas.openxmlformats.org/presentationml/2006/main" xmlns:r="http://schemas.openxmlformats.org/officeDocument/2006/relationships">
+  <p:cSld>
+    <p:spTree>
+      <p:nvGrpSpPr>
+        <p:cNvPr id="1" name=""/>
+        <p:cNvGrpSpPr/>
+        <p:nvPr/>
+      </p:nvGrpSpPr>
+      <p:grpSpPr/>
+      <p:sp>
+        <p:nvSpPr>
+          <p:cNvPr id="2" name="Title 1"/>
+          <p:cNvSpPr>
+            <a:spLocks noGrp="1"/>
+          </p:cNvSpPr>
+          <p:nvPr>
+            <p:ph type="title"/>
+          </p:nvPr>
+        </p:nvSpPr>
+        <p:spPr/>
+        <p:txBody>
+          <a:bodyPr/>
+          <a:lstStyle/>
+          <a:p>
+            <a:r>
+              <a:t>Open Methodology Decisions</a:t>
+            </a:r>
+          </a:p>
+        </p:txBody>
+      </p:sp>
+      <p:sp>
+        <p:nvSpPr>
+          <p:cNvPr id="3" name="Text Placeholder 2"/>
+          <p:cNvSpPr>
+            <a:spLocks noGrp="1"/>
+          </p:cNvSpPr>
+          <p:nvPr>
+            <p:ph type="body"/>
+          </p:nvPr>
+        </p:nvSpPr>
+        <p:spPr/>
+        <p:txBody>
+          <a:bodyPr/>
+          <a:lstStyle/>
+          <a:p/>
+        </p:txBody>
+      </p:sp>
+      <p:sp>
+        <p:nvSpPr>
+          <p:cNvPr id="4" name="TextBox 3"/>
+          <p:cNvSpPr txBox="1"/>
+          <p:nvPr/>
+        </p:nvSpPr>
+        <p:spPr>
+          <a:xfrm>
+            <a:off x="365760" y="1280160"/>
+            <a:ext cx="11338560" cy="4572000"/>
+          </a:xfrm>
+          <a:prstGeom prst="rect">
+            <a:avLst/>
+          </a:prstGeom>
+          <a:noFill/>
+        </p:spPr>
+        <p:txBody>
+          <a:bodyPr wrap="square">
+            <a:spAutoFit/>
+          </a:bodyPr>
+          <a:lstStyle/>
+          <a:p>
+            <a:r>
+              <a:rPr sz="1200"/>
+              <a:t>1. Significance test: uniform-dummy (gameable) vs majority one-sample vs permutation (recommend permutation — seed-proof, handles class balance).</a:t>
+            </a:r>
+          </a:p>
+          <a:p>
+            <a:r>
+              <a:rPr sz="1200"/>
+              <a:t>2. Unit of analysis: group-level (honest, recommend) vs long-format (pseudo-replication). Accuracy ~unchanged either way.</a:t>
+            </a:r>
+          </a:p>
+          <a:p>
+            <a:r>
+              <a:rPr sz="1200"/>
+              <a:t>3. Chance baseline: uniform 0.5 vs deterministic majority (All 0.51 / Dyads 0.59 / Triads 0.55). Recommend majority.</a:t>
+            </a:r>
+          </a:p>
+          <a:p>
+            <a:r>
+              <a:rPr sz="1200"/>
+              <a:t>4. Model selection: nested best-per-cell — the dyad verdict flips on which model is used (single fixed model is misleading).</a:t>
+            </a:r>
+          </a:p>
+          <a:p>
+            <a:r>
+              <a:rPr sz="1200"/>
+              <a:t>5. Headline modality: audio-only (best for group TE, gaze-free) vs multimodal. Recommend lead with audio-only.</a:t>
+            </a:r>
+          </a:p>
+          <a:p>
+            <a:r>
+              <a:rPr sz="1200"/>
+              <a:t>6. Dyads n=8 is underpowered — report with caveat regardless of method.</a:t>
+            </a:r>
+          </a:p>
+          <a:p>
+            <a:r>
+              <a:rPr sz="1200"/>
+              <a:t>7. Scaled vs unscaled features (slide 'Prior Baseline — Corrected'): scaled = our pipeline; affects prior 0.67→0.73.</a:t>
+            </a:r>
+          </a:p>
+          <a:p>
+            <a:r>
+              <a:rPr sz="1200"/>
+              <a:t>8. TODO: recompute the head-to-head (ours vs prior) at group-level + permutation for a final fair comparison.</a:t>
+            </a:r>
+          </a:p>
+        </p:txBody>
+      </p:sp>
+    </p:spTree>
+  </p:cSld>
+  <p:clrMapOvr>
+    <a:masterClrMapping/>
+  </p:clrMapOvr>
 </p:sld>
 </file>
 

</xml_diff>

<commit_message>
discover(deck): 3-prior + fusion comparison slide (perm + t-test, both shown)
Our detector vs dummy/AIxVR/GazexSpeaking priors + audio + fusions, group-level clean labels. Both significance tests shown (method undecided): permutation (shuffled-label null) vs majority one-sample t-test (floor null) — they disagree (Triads, Dyads). Highlights: fusion audio+GazexSpeaking best All 0.75/Dyads 0.81; audio alone wins Triads 0.71 gaze-free. Feature sets pulled from his code.
</commit_message>
<xml_diff>
--- a/discover/2026_March_ViLearn_Planning.pptx
+++ b/discover/2026_March_ViLearn_Planning.pptx
@@ -27,6 +27,7 @@
     <p:sldId id="275" r:id="rId23"/>
     <p:sldId id="276" r:id="rId24"/>
     <p:sldId id="277" r:id="rId25"/>
+    <p:sldId id="278" r:id="rId26"/>
   </p:sldIdLst>
   <p:sldSz cx="12192000" cy="6858000"/>
   <p:notesSz cx="7559675" cy="10691813"/>
@@ -16802,6 +16803,1641 @@
             <a:r>
               <a:rPr sz="1200"/>
               <a:t>8. TODO: recompute the head-to-head (ours vs prior) at group-level + permutation for a final fair comparison.</a:t>
+            </a:r>
+          </a:p>
+        </p:txBody>
+      </p:sp>
+    </p:spTree>
+  </p:cSld>
+  <p:clrMapOvr>
+    <a:masterClrMapping/>
+  </p:clrMapOvr>
+</p:sld>
+</file>
+
+<file path=ppt/slides/slide23.xml><?xml version="1.0" encoding="utf-8"?>
+<p:sld xmlns:a="http://schemas.openxmlformats.org/drawingml/2006/main" xmlns:p="http://schemas.openxmlformats.org/presentationml/2006/main" xmlns:r="http://schemas.openxmlformats.org/officeDocument/2006/relationships">
+  <p:cSld>
+    <p:spTree>
+      <p:nvGrpSpPr>
+        <p:cNvPr id="1" name=""/>
+        <p:cNvGrpSpPr/>
+        <p:nvPr/>
+      </p:nvGrpSpPr>
+      <p:grpSpPr/>
+      <p:sp>
+        <p:nvSpPr>
+          <p:cNvPr id="2" name="Title 1"/>
+          <p:cNvSpPr>
+            <a:spLocks noGrp="1"/>
+          </p:cNvSpPr>
+          <p:nvPr>
+            <p:ph type="title"/>
+          </p:nvPr>
+        </p:nvSpPr>
+        <p:spPr/>
+        <p:txBody>
+          <a:bodyPr/>
+          <a:lstStyle/>
+          <a:p>
+            <a:r>
+              <a:t>Our Detector vs 3 Priors + Fusion (group-level, clean labels)</a:t>
+            </a:r>
+          </a:p>
+        </p:txBody>
+      </p:sp>
+      <p:sp>
+        <p:nvSpPr>
+          <p:cNvPr id="3" name="Text Placeholder 2"/>
+          <p:cNvSpPr>
+            <a:spLocks noGrp="1"/>
+          </p:cNvSpPr>
+          <p:nvPr>
+            <p:ph type="body"/>
+          </p:nvPr>
+        </p:nvSpPr>
+        <p:spPr/>
+        <p:txBody>
+          <a:bodyPr/>
+          <a:lstStyle/>
+          <a:p/>
+        </p:txBody>
+      </p:sp>
+      <p:graphicFrame>
+        <p:nvGraphicFramePr>
+          <p:cNvPr id="4" name="Table 3"/>
+          <p:cNvGraphicFramePr>
+            <a:graphicFrameLocks noGrp="1"/>
+          </p:cNvGraphicFramePr>
+          <p:nvPr/>
+        </p:nvGraphicFramePr>
+        <p:xfrm>
+          <a:off x="274320" y="1005840"/>
+          <a:ext cx="10515600" cy="5212080"/>
+        </p:xfrm>
+        <a:graphic>
+          <a:graphicData uri="http://schemas.openxmlformats.org/drawingml/2006/table">
+            <a:tbl>
+              <a:tblPr firstRow="1" bandRow="1">
+                <a:tableStyleId>{5C22544A-7EE6-4342-B048-85BDC9FD1C3A}</a:tableStyleId>
+              </a:tblPr>
+              <a:tblGrid>
+                <a:gridCol w="1188720"/>
+                <a:gridCol w="3108960"/>
+                <a:gridCol w="1005840"/>
+                <a:gridCol w="1005840"/>
+                <a:gridCol w="1828800"/>
+                <a:gridCol w="2377440"/>
+              </a:tblGrid>
+              <a:tr h="274320">
+                <a:tc>
+                  <a:txBody>
+                    <a:bodyPr/>
+                    <a:lstStyle/>
+                    <a:p>
+                      <a:r>
+                        <a:rPr sz="1000" b="1"/>
+                        <a:t>Split</a:t>
+                      </a:r>
+                    </a:p>
+                  </a:txBody>
+                  <a:tcPr/>
+                </a:tc>
+                <a:tc>
+                  <a:txBody>
+                    <a:bodyPr/>
+                    <a:lstStyle/>
+                    <a:p>
+                      <a:r>
+                        <a:rPr sz="1000" b="1"/>
+                        <a:t>Detector</a:t>
+                      </a:r>
+                    </a:p>
+                  </a:txBody>
+                  <a:tcPr/>
+                </a:tc>
+                <a:tc>
+                  <a:txBody>
+                    <a:bodyPr/>
+                    <a:lstStyle/>
+                    <a:p>
+                      <a:r>
+                        <a:rPr sz="1000" b="1"/>
+                        <a:t>acc</a:t>
+                      </a:r>
+                    </a:p>
+                  </a:txBody>
+                  <a:tcPr/>
+                </a:tc>
+                <a:tc>
+                  <a:txBody>
+                    <a:bodyPr/>
+                    <a:lstStyle/>
+                    <a:p>
+                      <a:r>
+                        <a:rPr sz="1000" b="1"/>
+                        <a:t>maj</a:t>
+                      </a:r>
+                    </a:p>
+                  </a:txBody>
+                  <a:tcPr/>
+                </a:tc>
+                <a:tc>
+                  <a:txBody>
+                    <a:bodyPr/>
+                    <a:lstStyle/>
+                    <a:p>
+                      <a:r>
+                        <a:rPr sz="1000" b="1"/>
+                        <a:t>perm p</a:t>
+                      </a:r>
+                    </a:p>
+                  </a:txBody>
+                  <a:tcPr/>
+                </a:tc>
+                <a:tc>
+                  <a:txBody>
+                    <a:bodyPr/>
+                    <a:lstStyle/>
+                    <a:p>
+                      <a:r>
+                        <a:rPr sz="1000" b="1"/>
+                        <a:t>t-test p (vs maj)</a:t>
+                      </a:r>
+                    </a:p>
+                  </a:txBody>
+                  <a:tcPr/>
+                </a:tc>
+              </a:tr>
+              <a:tr h="274320">
+                <a:tc>
+                  <a:txBody>
+                    <a:bodyPr/>
+                    <a:lstStyle/>
+                    <a:p>
+                      <a:r>
+                        <a:rPr sz="900"/>
+                        <a:t>All</a:t>
+                      </a:r>
+                    </a:p>
+                  </a:txBody>
+                  <a:tcPr/>
+                </a:tc>
+                <a:tc>
+                  <a:txBody>
+                    <a:bodyPr/>
+                    <a:lstStyle/>
+                    <a:p>
+                      <a:r>
+                        <a:rPr sz="900"/>
+                        <a:t>dummy(majority)</a:t>
+                      </a:r>
+                    </a:p>
+                  </a:txBody>
+                  <a:tcPr/>
+                </a:tc>
+                <a:tc>
+                  <a:txBody>
+                    <a:bodyPr/>
+                    <a:lstStyle/>
+                    <a:p>
+                      <a:r>
+                        <a:rPr sz="900"/>
+                        <a:t>—</a:t>
+                      </a:r>
+                    </a:p>
+                  </a:txBody>
+                  <a:tcPr/>
+                </a:tc>
+                <a:tc>
+                  <a:txBody>
+                    <a:bodyPr/>
+                    <a:lstStyle/>
+                    <a:p>
+                      <a:r>
+                        <a:rPr sz="900"/>
+                        <a:t>0.52</a:t>
+                      </a:r>
+                    </a:p>
+                  </a:txBody>
+                  <a:tcPr/>
+                </a:tc>
+                <a:tc>
+                  <a:txBody>
+                    <a:bodyPr/>
+                    <a:lstStyle/>
+                    <a:p>
+                      <a:r>
+                        <a:rPr sz="900"/>
+                        <a:t>—</a:t>
+                      </a:r>
+                    </a:p>
+                  </a:txBody>
+                  <a:tcPr/>
+                </a:tc>
+                <a:tc>
+                  <a:txBody>
+                    <a:bodyPr/>
+                    <a:lstStyle/>
+                    <a:p>
+                      <a:r>
+                        <a:rPr sz="900"/>
+                        <a:t>—</a:t>
+                      </a:r>
+                    </a:p>
+                  </a:txBody>
+                  <a:tcPr/>
+                </a:tc>
+              </a:tr>
+              <a:tr h="274320">
+                <a:tc>
+                  <a:txBody>
+                    <a:bodyPr/>
+                    <a:lstStyle/>
+                    <a:p>
+                      <a:r>
+                        <a:rPr sz="900"/>
+                        <a:t>All</a:t>
+                      </a:r>
+                    </a:p>
+                  </a:txBody>
+                  <a:tcPr/>
+                </a:tc>
+                <a:tc>
+                  <a:txBody>
+                    <a:bodyPr/>
+                    <a:lstStyle/>
+                    <a:p>
+                      <a:r>
+                        <a:rPr sz="900"/>
+                        <a:t>AIxVR</a:t>
+                      </a:r>
+                    </a:p>
+                  </a:txBody>
+                  <a:tcPr/>
+                </a:tc>
+                <a:tc>
+                  <a:txBody>
+                    <a:bodyPr/>
+                    <a:lstStyle/>
+                    <a:p>
+                      <a:r>
+                        <a:rPr sz="900"/>
+                        <a:t>0.62</a:t>
+                      </a:r>
+                    </a:p>
+                  </a:txBody>
+                  <a:tcPr/>
+                </a:tc>
+                <a:tc>
+                  <a:txBody>
+                    <a:bodyPr/>
+                    <a:lstStyle/>
+                    <a:p>
+                      <a:r>
+                        <a:rPr sz="900"/>
+                        <a:t>0.52</a:t>
+                      </a:r>
+                    </a:p>
+                  </a:txBody>
+                  <a:tcPr/>
+                </a:tc>
+                <a:tc>
+                  <a:txBody>
+                    <a:bodyPr/>
+                    <a:lstStyle/>
+                    <a:p>
+                      <a:r>
+                        <a:rPr sz="900"/>
+                        <a:t>0.030✓</a:t>
+                      </a:r>
+                    </a:p>
+                  </a:txBody>
+                  <a:tcPr/>
+                </a:tc>
+                <a:tc>
+                  <a:txBody>
+                    <a:bodyPr/>
+                    <a:lstStyle/>
+                    <a:p>
+                      <a:r>
+                        <a:rPr sz="900"/>
+                        <a:t>0.069✗</a:t>
+                      </a:r>
+                    </a:p>
+                  </a:txBody>
+                  <a:tcPr/>
+                </a:tc>
+              </a:tr>
+              <a:tr h="274320">
+                <a:tc>
+                  <a:txBody>
+                    <a:bodyPr/>
+                    <a:lstStyle/>
+                    <a:p>
+                      <a:r>
+                        <a:rPr sz="900"/>
+                        <a:t>All</a:t>
+                      </a:r>
+                    </a:p>
+                  </a:txBody>
+                  <a:tcPr/>
+                </a:tc>
+                <a:tc>
+                  <a:txBody>
+                    <a:bodyPr/>
+                    <a:lstStyle/>
+                    <a:p>
+                      <a:r>
+                        <a:rPr sz="900"/>
+                        <a:t>GazexSpeaking</a:t>
+                      </a:r>
+                    </a:p>
+                  </a:txBody>
+                  <a:tcPr/>
+                </a:tc>
+                <a:tc>
+                  <a:txBody>
+                    <a:bodyPr/>
+                    <a:lstStyle/>
+                    <a:p>
+                      <a:r>
+                        <a:rPr sz="900"/>
+                        <a:t>0.73</a:t>
+                      </a:r>
+                    </a:p>
+                  </a:txBody>
+                  <a:tcPr/>
+                </a:tc>
+                <a:tc>
+                  <a:txBody>
+                    <a:bodyPr/>
+                    <a:lstStyle/>
+                    <a:p>
+                      <a:r>
+                        <a:rPr sz="900"/>
+                        <a:t>0.52</a:t>
+                      </a:r>
+                    </a:p>
+                  </a:txBody>
+                  <a:tcPr/>
+                </a:tc>
+                <a:tc>
+                  <a:txBody>
+                    <a:bodyPr/>
+                    <a:lstStyle/>
+                    <a:p>
+                      <a:r>
+                        <a:rPr sz="900"/>
+                        <a:t>0.007✓</a:t>
+                      </a:r>
+                    </a:p>
+                  </a:txBody>
+                  <a:tcPr/>
+                </a:tc>
+                <a:tc>
+                  <a:txBody>
+                    <a:bodyPr/>
+                    <a:lstStyle/>
+                    <a:p>
+                      <a:r>
+                        <a:rPr sz="900"/>
+                        <a:t>0.001✓</a:t>
+                      </a:r>
+                    </a:p>
+                  </a:txBody>
+                  <a:tcPr/>
+                </a:tc>
+              </a:tr>
+              <a:tr h="274320">
+                <a:tc>
+                  <a:txBody>
+                    <a:bodyPr/>
+                    <a:lstStyle/>
+                    <a:p>
+                      <a:r>
+                        <a:rPr sz="900"/>
+                        <a:t>All</a:t>
+                      </a:r>
+                    </a:p>
+                  </a:txBody>
+                  <a:tcPr/>
+                </a:tc>
+                <a:tc>
+                  <a:txBody>
+                    <a:bodyPr/>
+                    <a:lstStyle/>
+                    <a:p>
+                      <a:r>
+                        <a:rPr sz="900"/>
+                        <a:t>audio</a:t>
+                      </a:r>
+                    </a:p>
+                  </a:txBody>
+                  <a:tcPr/>
+                </a:tc>
+                <a:tc>
+                  <a:txBody>
+                    <a:bodyPr/>
+                    <a:lstStyle/>
+                    <a:p>
+                      <a:r>
+                        <a:rPr sz="900"/>
+                        <a:t>0.66</a:t>
+                      </a:r>
+                    </a:p>
+                  </a:txBody>
+                  <a:tcPr/>
+                </a:tc>
+                <a:tc>
+                  <a:txBody>
+                    <a:bodyPr/>
+                    <a:lstStyle/>
+                    <a:p>
+                      <a:r>
+                        <a:rPr sz="900"/>
+                        <a:t>0.52</a:t>
+                      </a:r>
+                    </a:p>
+                  </a:txBody>
+                  <a:tcPr/>
+                </a:tc>
+                <a:tc>
+                  <a:txBody>
+                    <a:bodyPr/>
+                    <a:lstStyle/>
+                    <a:p>
+                      <a:r>
+                        <a:rPr sz="900"/>
+                        <a:t>0.003✓</a:t>
+                      </a:r>
+                    </a:p>
+                  </a:txBody>
+                  <a:tcPr/>
+                </a:tc>
+                <a:tc>
+                  <a:txBody>
+                    <a:bodyPr/>
+                    <a:lstStyle/>
+                    <a:p>
+                      <a:r>
+                        <a:rPr sz="900"/>
+                        <a:t>0.019✓</a:t>
+                      </a:r>
+                    </a:p>
+                  </a:txBody>
+                  <a:tcPr/>
+                </a:tc>
+              </a:tr>
+              <a:tr h="274320">
+                <a:tc>
+                  <a:txBody>
+                    <a:bodyPr/>
+                    <a:lstStyle/>
+                    <a:p>
+                      <a:r>
+                        <a:rPr sz="900"/>
+                        <a:t>All</a:t>
+                      </a:r>
+                    </a:p>
+                  </a:txBody>
+                  <a:tcPr/>
+                </a:tc>
+                <a:tc>
+                  <a:txBody>
+                    <a:bodyPr/>
+                    <a:lstStyle/>
+                    <a:p>
+                      <a:r>
+                        <a:rPr sz="900"/>
+                        <a:t>audio+AIxVR</a:t>
+                      </a:r>
+                    </a:p>
+                  </a:txBody>
+                  <a:tcPr/>
+                </a:tc>
+                <a:tc>
+                  <a:txBody>
+                    <a:bodyPr/>
+                    <a:lstStyle/>
+                    <a:p>
+                      <a:r>
+                        <a:rPr sz="900"/>
+                        <a:t>0.67</a:t>
+                      </a:r>
+                    </a:p>
+                  </a:txBody>
+                  <a:tcPr/>
+                </a:tc>
+                <a:tc>
+                  <a:txBody>
+                    <a:bodyPr/>
+                    <a:lstStyle/>
+                    <a:p>
+                      <a:r>
+                        <a:rPr sz="900"/>
+                        <a:t>0.52</a:t>
+                      </a:r>
+                    </a:p>
+                  </a:txBody>
+                  <a:tcPr/>
+                </a:tc>
+                <a:tc>
+                  <a:txBody>
+                    <a:bodyPr/>
+                    <a:lstStyle/>
+                    <a:p>
+                      <a:r>
+                        <a:rPr sz="900"/>
+                        <a:t>0.003✓</a:t>
+                      </a:r>
+                    </a:p>
+                  </a:txBody>
+                  <a:tcPr/>
+                </a:tc>
+                <a:tc>
+                  <a:txBody>
+                    <a:bodyPr/>
+                    <a:lstStyle/>
+                    <a:p>
+                      <a:r>
+                        <a:rPr sz="900"/>
+                        <a:t>0.011✓</a:t>
+                      </a:r>
+                    </a:p>
+                  </a:txBody>
+                  <a:tcPr/>
+                </a:tc>
+              </a:tr>
+              <a:tr h="274320">
+                <a:tc>
+                  <a:txBody>
+                    <a:bodyPr/>
+                    <a:lstStyle/>
+                    <a:p>
+                      <a:r>
+                        <a:rPr sz="900"/>
+                        <a:t>All</a:t>
+                      </a:r>
+                    </a:p>
+                  </a:txBody>
+                  <a:tcPr/>
+                </a:tc>
+                <a:tc>
+                  <a:txBody>
+                    <a:bodyPr/>
+                    <a:lstStyle/>
+                    <a:p>
+                      <a:r>
+                        <a:rPr sz="900"/>
+                        <a:t>audio+GazexSpeaking</a:t>
+                      </a:r>
+                    </a:p>
+                  </a:txBody>
+                  <a:tcPr/>
+                </a:tc>
+                <a:tc>
+                  <a:txBody>
+                    <a:bodyPr/>
+                    <a:lstStyle/>
+                    <a:p>
+                      <a:r>
+                        <a:rPr sz="900"/>
+                        <a:t>0.75</a:t>
+                      </a:r>
+                    </a:p>
+                  </a:txBody>
+                  <a:tcPr/>
+                </a:tc>
+                <a:tc>
+                  <a:txBody>
+                    <a:bodyPr/>
+                    <a:lstStyle/>
+                    <a:p>
+                      <a:r>
+                        <a:rPr sz="900"/>
+                        <a:t>0.52</a:t>
+                      </a:r>
+                    </a:p>
+                  </a:txBody>
+                  <a:tcPr/>
+                </a:tc>
+                <a:tc>
+                  <a:txBody>
+                    <a:bodyPr/>
+                    <a:lstStyle/>
+                    <a:p>
+                      <a:r>
+                        <a:rPr sz="900"/>
+                        <a:t>0.003✓</a:t>
+                      </a:r>
+                    </a:p>
+                  </a:txBody>
+                  <a:tcPr/>
+                </a:tc>
+                <a:tc>
+                  <a:txBody>
+                    <a:bodyPr/>
+                    <a:lstStyle/>
+                    <a:p>
+                      <a:r>
+                        <a:rPr sz="900"/>
+                        <a:t>0.001✓</a:t>
+                      </a:r>
+                    </a:p>
+                  </a:txBody>
+                  <a:tcPr/>
+                </a:tc>
+              </a:tr>
+              <a:tr h="274320">
+                <a:tc>
+                  <a:txBody>
+                    <a:bodyPr/>
+                    <a:lstStyle/>
+                    <a:p>
+                      <a:r>
+                        <a:rPr sz="900"/>
+                        <a:t>D</a:t>
+                      </a:r>
+                    </a:p>
+                  </a:txBody>
+                  <a:tcPr/>
+                </a:tc>
+                <a:tc>
+                  <a:txBody>
+                    <a:bodyPr/>
+                    <a:lstStyle/>
+                    <a:p>
+                      <a:r>
+                        <a:rPr sz="900"/>
+                        <a:t>dummy(majority)</a:t>
+                      </a:r>
+                    </a:p>
+                  </a:txBody>
+                  <a:tcPr/>
+                </a:tc>
+                <a:tc>
+                  <a:txBody>
+                    <a:bodyPr/>
+                    <a:lstStyle/>
+                    <a:p>
+                      <a:r>
+                        <a:rPr sz="900"/>
+                        <a:t>—</a:t>
+                      </a:r>
+                    </a:p>
+                  </a:txBody>
+                  <a:tcPr/>
+                </a:tc>
+                <a:tc>
+                  <a:txBody>
+                    <a:bodyPr/>
+                    <a:lstStyle/>
+                    <a:p>
+                      <a:r>
+                        <a:rPr sz="900"/>
+                        <a:t>0.59</a:t>
+                      </a:r>
+                    </a:p>
+                  </a:txBody>
+                  <a:tcPr/>
+                </a:tc>
+                <a:tc>
+                  <a:txBody>
+                    <a:bodyPr/>
+                    <a:lstStyle/>
+                    <a:p>
+                      <a:r>
+                        <a:rPr sz="900"/>
+                        <a:t>—</a:t>
+                      </a:r>
+                    </a:p>
+                  </a:txBody>
+                  <a:tcPr/>
+                </a:tc>
+                <a:tc>
+                  <a:txBody>
+                    <a:bodyPr/>
+                    <a:lstStyle/>
+                    <a:p>
+                      <a:r>
+                        <a:rPr sz="900"/>
+                        <a:t>—</a:t>
+                      </a:r>
+                    </a:p>
+                  </a:txBody>
+                  <a:tcPr/>
+                </a:tc>
+              </a:tr>
+              <a:tr h="274320">
+                <a:tc>
+                  <a:txBody>
+                    <a:bodyPr/>
+                    <a:lstStyle/>
+                    <a:p>
+                      <a:r>
+                        <a:rPr sz="900"/>
+                        <a:t>D</a:t>
+                      </a:r>
+                    </a:p>
+                  </a:txBody>
+                  <a:tcPr/>
+                </a:tc>
+                <a:tc>
+                  <a:txBody>
+                    <a:bodyPr/>
+                    <a:lstStyle/>
+                    <a:p>
+                      <a:r>
+                        <a:rPr sz="900"/>
+                        <a:t>AIxVR</a:t>
+                      </a:r>
+                    </a:p>
+                  </a:txBody>
+                  <a:tcPr/>
+                </a:tc>
+                <a:tc>
+                  <a:txBody>
+                    <a:bodyPr/>
+                    <a:lstStyle/>
+                    <a:p>
+                      <a:r>
+                        <a:rPr sz="900"/>
+                        <a:t>0.67</a:t>
+                      </a:r>
+                    </a:p>
+                  </a:txBody>
+                  <a:tcPr/>
+                </a:tc>
+                <a:tc>
+                  <a:txBody>
+                    <a:bodyPr/>
+                    <a:lstStyle/>
+                    <a:p>
+                      <a:r>
+                        <a:rPr sz="900"/>
+                        <a:t>0.59</a:t>
+                      </a:r>
+                    </a:p>
+                  </a:txBody>
+                  <a:tcPr/>
+                </a:tc>
+                <a:tc>
+                  <a:txBody>
+                    <a:bodyPr/>
+                    <a:lstStyle/>
+                    <a:p>
+                      <a:r>
+                        <a:rPr sz="900"/>
+                        <a:t>0.362✗</a:t>
+                      </a:r>
+                    </a:p>
+                  </a:txBody>
+                  <a:tcPr/>
+                </a:tc>
+                <a:tc>
+                  <a:txBody>
+                    <a:bodyPr/>
+                    <a:lstStyle/>
+                    <a:p>
+                      <a:r>
+                        <a:rPr sz="900"/>
+                        <a:t>0.303✗</a:t>
+                      </a:r>
+                    </a:p>
+                  </a:txBody>
+                  <a:tcPr/>
+                </a:tc>
+              </a:tr>
+              <a:tr h="274320">
+                <a:tc>
+                  <a:txBody>
+                    <a:bodyPr/>
+                    <a:lstStyle/>
+                    <a:p>
+                      <a:r>
+                        <a:rPr sz="900"/>
+                        <a:t>D</a:t>
+                      </a:r>
+                    </a:p>
+                  </a:txBody>
+                  <a:tcPr/>
+                </a:tc>
+                <a:tc>
+                  <a:txBody>
+                    <a:bodyPr/>
+                    <a:lstStyle/>
+                    <a:p>
+                      <a:r>
+                        <a:rPr sz="900"/>
+                        <a:t>GazexSpeaking</a:t>
+                      </a:r>
+                    </a:p>
+                  </a:txBody>
+                  <a:tcPr/>
+                </a:tc>
+                <a:tc>
+                  <a:txBody>
+                    <a:bodyPr/>
+                    <a:lstStyle/>
+                    <a:p>
+                      <a:r>
+                        <a:rPr sz="900"/>
+                        <a:t>0.83</a:t>
+                      </a:r>
+                    </a:p>
+                  </a:txBody>
+                  <a:tcPr/>
+                </a:tc>
+                <a:tc>
+                  <a:txBody>
+                    <a:bodyPr/>
+                    <a:lstStyle/>
+                    <a:p>
+                      <a:r>
+                        <a:rPr sz="900"/>
+                        <a:t>0.59</a:t>
+                      </a:r>
+                    </a:p>
+                  </a:txBody>
+                  <a:tcPr/>
+                </a:tc>
+                <a:tc>
+                  <a:txBody>
+                    <a:bodyPr/>
+                    <a:lstStyle/>
+                    <a:p>
+                      <a:r>
+                        <a:rPr sz="900"/>
+                        <a:t>0.083✗</a:t>
+                      </a:r>
+                    </a:p>
+                  </a:txBody>
+                  <a:tcPr/>
+                </a:tc>
+                <a:tc>
+                  <a:txBody>
+                    <a:bodyPr/>
+                    <a:lstStyle/>
+                    <a:p>
+                      <a:r>
+                        <a:rPr sz="900"/>
+                        <a:t>0.000✓</a:t>
+                      </a:r>
+                    </a:p>
+                  </a:txBody>
+                  <a:tcPr/>
+                </a:tc>
+              </a:tr>
+              <a:tr h="274320">
+                <a:tc>
+                  <a:txBody>
+                    <a:bodyPr/>
+                    <a:lstStyle/>
+                    <a:p>
+                      <a:r>
+                        <a:rPr sz="900"/>
+                        <a:t>D</a:t>
+                      </a:r>
+                    </a:p>
+                  </a:txBody>
+                  <a:tcPr/>
+                </a:tc>
+                <a:tc>
+                  <a:txBody>
+                    <a:bodyPr/>
+                    <a:lstStyle/>
+                    <a:p>
+                      <a:r>
+                        <a:rPr sz="900"/>
+                        <a:t>audio</a:t>
+                      </a:r>
+                    </a:p>
+                  </a:txBody>
+                  <a:tcPr/>
+                </a:tc>
+                <a:tc>
+                  <a:txBody>
+                    <a:bodyPr/>
+                    <a:lstStyle/>
+                    <a:p>
+                      <a:r>
+                        <a:rPr sz="900"/>
+                        <a:t>0.60</a:t>
+                      </a:r>
+                    </a:p>
+                  </a:txBody>
+                  <a:tcPr/>
+                </a:tc>
+                <a:tc>
+                  <a:txBody>
+                    <a:bodyPr/>
+                    <a:lstStyle/>
+                    <a:p>
+                      <a:r>
+                        <a:rPr sz="900"/>
+                        <a:t>0.59</a:t>
+                      </a:r>
+                    </a:p>
+                  </a:txBody>
+                  <a:tcPr/>
+                </a:tc>
+                <a:tc>
+                  <a:txBody>
+                    <a:bodyPr/>
+                    <a:lstStyle/>
+                    <a:p>
+                      <a:r>
+                        <a:rPr sz="900"/>
+                        <a:t>0.206✗</a:t>
+                      </a:r>
+                    </a:p>
+                  </a:txBody>
+                  <a:tcPr/>
+                </a:tc>
+                <a:tc>
+                  <a:txBody>
+                    <a:bodyPr/>
+                    <a:lstStyle/>
+                    <a:p>
+                      <a:r>
+                        <a:rPr sz="900"/>
+                        <a:t>0.929✗</a:t>
+                      </a:r>
+                    </a:p>
+                  </a:txBody>
+                  <a:tcPr/>
+                </a:tc>
+              </a:tr>
+              <a:tr h="274320">
+                <a:tc>
+                  <a:txBody>
+                    <a:bodyPr/>
+                    <a:lstStyle/>
+                    <a:p>
+                      <a:r>
+                        <a:rPr sz="900"/>
+                        <a:t>D</a:t>
+                      </a:r>
+                    </a:p>
+                  </a:txBody>
+                  <a:tcPr/>
+                </a:tc>
+                <a:tc>
+                  <a:txBody>
+                    <a:bodyPr/>
+                    <a:lstStyle/>
+                    <a:p>
+                      <a:r>
+                        <a:rPr sz="900"/>
+                        <a:t>audio+AIxVR</a:t>
+                      </a:r>
+                    </a:p>
+                  </a:txBody>
+                  <a:tcPr/>
+                </a:tc>
+                <a:tc>
+                  <a:txBody>
+                    <a:bodyPr/>
+                    <a:lstStyle/>
+                    <a:p>
+                      <a:r>
+                        <a:rPr sz="900"/>
+                        <a:t>0.62</a:t>
+                      </a:r>
+                    </a:p>
+                  </a:txBody>
+                  <a:tcPr/>
+                </a:tc>
+                <a:tc>
+                  <a:txBody>
+                    <a:bodyPr/>
+                    <a:lstStyle/>
+                    <a:p>
+                      <a:r>
+                        <a:rPr sz="900"/>
+                        <a:t>0.59</a:t>
+                      </a:r>
+                    </a:p>
+                  </a:txBody>
+                  <a:tcPr/>
+                </a:tc>
+                <a:tc>
+                  <a:txBody>
+                    <a:bodyPr/>
+                    <a:lstStyle/>
+                    <a:p>
+                      <a:r>
+                        <a:rPr sz="900"/>
+                        <a:t>0.010✓</a:t>
+                      </a:r>
+                    </a:p>
+                  </a:txBody>
+                  <a:tcPr/>
+                </a:tc>
+                <a:tc>
+                  <a:txBody>
+                    <a:bodyPr/>
+                    <a:lstStyle/>
+                    <a:p>
+                      <a:r>
+                        <a:rPr sz="900"/>
+                        <a:t>0.665✗</a:t>
+                      </a:r>
+                    </a:p>
+                  </a:txBody>
+                  <a:tcPr/>
+                </a:tc>
+              </a:tr>
+              <a:tr h="274320">
+                <a:tc>
+                  <a:txBody>
+                    <a:bodyPr/>
+                    <a:lstStyle/>
+                    <a:p>
+                      <a:r>
+                        <a:rPr sz="900"/>
+                        <a:t>D</a:t>
+                      </a:r>
+                    </a:p>
+                  </a:txBody>
+                  <a:tcPr/>
+                </a:tc>
+                <a:tc>
+                  <a:txBody>
+                    <a:bodyPr/>
+                    <a:lstStyle/>
+                    <a:p>
+                      <a:r>
+                        <a:rPr sz="900"/>
+                        <a:t>audio+GazexSpeaking</a:t>
+                      </a:r>
+                    </a:p>
+                  </a:txBody>
+                  <a:tcPr/>
+                </a:tc>
+                <a:tc>
+                  <a:txBody>
+                    <a:bodyPr/>
+                    <a:lstStyle/>
+                    <a:p>
+                      <a:r>
+                        <a:rPr sz="900"/>
+                        <a:t>0.81</a:t>
+                      </a:r>
+                    </a:p>
+                  </a:txBody>
+                  <a:tcPr/>
+                </a:tc>
+                <a:tc>
+                  <a:txBody>
+                    <a:bodyPr/>
+                    <a:lstStyle/>
+                    <a:p>
+                      <a:r>
+                        <a:rPr sz="900"/>
+                        <a:t>0.59</a:t>
+                      </a:r>
+                    </a:p>
+                  </a:txBody>
+                  <a:tcPr/>
+                </a:tc>
+                <a:tc>
+                  <a:txBody>
+                    <a:bodyPr/>
+                    <a:lstStyle/>
+                    <a:p>
+                      <a:r>
+                        <a:rPr sz="900"/>
+                        <a:t>0.023✓</a:t>
+                      </a:r>
+                    </a:p>
+                  </a:txBody>
+                  <a:tcPr/>
+                </a:tc>
+                <a:tc>
+                  <a:txBody>
+                    <a:bodyPr/>
+                    <a:lstStyle/>
+                    <a:p>
+                      <a:r>
+                        <a:rPr sz="900"/>
+                        <a:t>0.004✓</a:t>
+                      </a:r>
+                    </a:p>
+                  </a:txBody>
+                  <a:tcPr/>
+                </a:tc>
+              </a:tr>
+              <a:tr h="274320">
+                <a:tc>
+                  <a:txBody>
+                    <a:bodyPr/>
+                    <a:lstStyle/>
+                    <a:p>
+                      <a:r>
+                        <a:rPr sz="900"/>
+                        <a:t>T</a:t>
+                      </a:r>
+                    </a:p>
+                  </a:txBody>
+                  <a:tcPr/>
+                </a:tc>
+                <a:tc>
+                  <a:txBody>
+                    <a:bodyPr/>
+                    <a:lstStyle/>
+                    <a:p>
+                      <a:r>
+                        <a:rPr sz="900"/>
+                        <a:t>dummy(majority)</a:t>
+                      </a:r>
+                    </a:p>
+                  </a:txBody>
+                  <a:tcPr/>
+                </a:tc>
+                <a:tc>
+                  <a:txBody>
+                    <a:bodyPr/>
+                    <a:lstStyle/>
+                    <a:p>
+                      <a:r>
+                        <a:rPr sz="900"/>
+                        <a:t>—</a:t>
+                      </a:r>
+                    </a:p>
+                  </a:txBody>
+                  <a:tcPr/>
+                </a:tc>
+                <a:tc>
+                  <a:txBody>
+                    <a:bodyPr/>
+                    <a:lstStyle/>
+                    <a:p>
+                      <a:r>
+                        <a:rPr sz="900"/>
+                        <a:t>0.54</a:t>
+                      </a:r>
+                    </a:p>
+                  </a:txBody>
+                  <a:tcPr/>
+                </a:tc>
+                <a:tc>
+                  <a:txBody>
+                    <a:bodyPr/>
+                    <a:lstStyle/>
+                    <a:p>
+                      <a:r>
+                        <a:rPr sz="900"/>
+                        <a:t>—</a:t>
+                      </a:r>
+                    </a:p>
+                  </a:txBody>
+                  <a:tcPr/>
+                </a:tc>
+                <a:tc>
+                  <a:txBody>
+                    <a:bodyPr/>
+                    <a:lstStyle/>
+                    <a:p>
+                      <a:r>
+                        <a:rPr sz="900"/>
+                        <a:t>—</a:t>
+                      </a:r>
+                    </a:p>
+                  </a:txBody>
+                  <a:tcPr/>
+                </a:tc>
+              </a:tr>
+              <a:tr h="274320">
+                <a:tc>
+                  <a:txBody>
+                    <a:bodyPr/>
+                    <a:lstStyle/>
+                    <a:p>
+                      <a:r>
+                        <a:rPr sz="900"/>
+                        <a:t>T</a:t>
+                      </a:r>
+                    </a:p>
+                  </a:txBody>
+                  <a:tcPr/>
+                </a:tc>
+                <a:tc>
+                  <a:txBody>
+                    <a:bodyPr/>
+                    <a:lstStyle/>
+                    <a:p>
+                      <a:r>
+                        <a:rPr sz="900"/>
+                        <a:t>AIxVR</a:t>
+                      </a:r>
+                    </a:p>
+                  </a:txBody>
+                  <a:tcPr/>
+                </a:tc>
+                <a:tc>
+                  <a:txBody>
+                    <a:bodyPr/>
+                    <a:lstStyle/>
+                    <a:p>
+                      <a:r>
+                        <a:rPr sz="900"/>
+                        <a:t>0.58</a:t>
+                      </a:r>
+                    </a:p>
+                  </a:txBody>
+                  <a:tcPr/>
+                </a:tc>
+                <a:tc>
+                  <a:txBody>
+                    <a:bodyPr/>
+                    <a:lstStyle/>
+                    <a:p>
+                      <a:r>
+                        <a:rPr sz="900"/>
+                        <a:t>0.54</a:t>
+                      </a:r>
+                    </a:p>
+                  </a:txBody>
+                  <a:tcPr/>
+                </a:tc>
+                <a:tc>
+                  <a:txBody>
+                    <a:bodyPr/>
+                    <a:lstStyle/>
+                    <a:p>
+                      <a:r>
+                        <a:rPr sz="900"/>
+                        <a:t>0.003✓</a:t>
+                      </a:r>
+                    </a:p>
+                  </a:txBody>
+                  <a:tcPr/>
+                </a:tc>
+                <a:tc>
+                  <a:txBody>
+                    <a:bodyPr/>
+                    <a:lstStyle/>
+                    <a:p>
+                      <a:r>
+                        <a:rPr sz="900"/>
+                        <a:t>0.561✗</a:t>
+                      </a:r>
+                    </a:p>
+                  </a:txBody>
+                  <a:tcPr/>
+                </a:tc>
+              </a:tr>
+              <a:tr h="274320">
+                <a:tc>
+                  <a:txBody>
+                    <a:bodyPr/>
+                    <a:lstStyle/>
+                    <a:p>
+                      <a:r>
+                        <a:rPr sz="900"/>
+                        <a:t>T</a:t>
+                      </a:r>
+                    </a:p>
+                  </a:txBody>
+                  <a:tcPr/>
+                </a:tc>
+                <a:tc>
+                  <a:txBody>
+                    <a:bodyPr/>
+                    <a:lstStyle/>
+                    <a:p>
+                      <a:r>
+                        <a:rPr sz="900"/>
+                        <a:t>GazexSpeaking</a:t>
+                      </a:r>
+                    </a:p>
+                  </a:txBody>
+                  <a:tcPr/>
+                </a:tc>
+                <a:tc>
+                  <a:txBody>
+                    <a:bodyPr/>
+                    <a:lstStyle/>
+                    <a:p>
+                      <a:r>
+                        <a:rPr sz="900"/>
+                        <a:t>0.69</a:t>
+                      </a:r>
+                    </a:p>
+                  </a:txBody>
+                  <a:tcPr/>
+                </a:tc>
+                <a:tc>
+                  <a:txBody>
+                    <a:bodyPr/>
+                    <a:lstStyle/>
+                    <a:p>
+                      <a:r>
+                        <a:rPr sz="900"/>
+                        <a:t>0.54</a:t>
+                      </a:r>
+                    </a:p>
+                  </a:txBody>
+                  <a:tcPr/>
+                </a:tc>
+                <a:tc>
+                  <a:txBody>
+                    <a:bodyPr/>
+                    <a:lstStyle/>
+                    <a:p>
+                      <a:r>
+                        <a:rPr sz="900"/>
+                        <a:t>0.003✓</a:t>
+                      </a:r>
+                    </a:p>
+                  </a:txBody>
+                  <a:tcPr/>
+                </a:tc>
+                <a:tc>
+                  <a:txBody>
+                    <a:bodyPr/>
+                    <a:lstStyle/>
+                    <a:p>
+                      <a:r>
+                        <a:rPr sz="900"/>
+                        <a:t>0.090✗</a:t>
+                      </a:r>
+                    </a:p>
+                  </a:txBody>
+                  <a:tcPr/>
+                </a:tc>
+              </a:tr>
+              <a:tr h="274320">
+                <a:tc>
+                  <a:txBody>
+                    <a:bodyPr/>
+                    <a:lstStyle/>
+                    <a:p>
+                      <a:r>
+                        <a:rPr sz="900"/>
+                        <a:t>T</a:t>
+                      </a:r>
+                    </a:p>
+                  </a:txBody>
+                  <a:tcPr/>
+                </a:tc>
+                <a:tc>
+                  <a:txBody>
+                    <a:bodyPr/>
+                    <a:lstStyle/>
+                    <a:p>
+                      <a:r>
+                        <a:rPr sz="900"/>
+                        <a:t>audio</a:t>
+                      </a:r>
+                    </a:p>
+                  </a:txBody>
+                  <a:tcPr/>
+                </a:tc>
+                <a:tc>
+                  <a:txBody>
+                    <a:bodyPr/>
+                    <a:lstStyle/>
+                    <a:p>
+                      <a:r>
+                        <a:rPr sz="900"/>
+                        <a:t>0.71</a:t>
+                      </a:r>
+                    </a:p>
+                  </a:txBody>
+                  <a:tcPr/>
+                </a:tc>
+                <a:tc>
+                  <a:txBody>
+                    <a:bodyPr/>
+                    <a:lstStyle/>
+                    <a:p>
+                      <a:r>
+                        <a:rPr sz="900"/>
+                        <a:t>0.54</a:t>
+                      </a:r>
+                    </a:p>
+                  </a:txBody>
+                  <a:tcPr/>
+                </a:tc>
+                <a:tc>
+                  <a:txBody>
+                    <a:bodyPr/>
+                    <a:lstStyle/>
+                    <a:p>
+                      <a:r>
+                        <a:rPr sz="900"/>
+                        <a:t>0.003✓</a:t>
+                      </a:r>
+                    </a:p>
+                  </a:txBody>
+                  <a:tcPr/>
+                </a:tc>
+                <a:tc>
+                  <a:txBody>
+                    <a:bodyPr/>
+                    <a:lstStyle/>
+                    <a:p>
+                      <a:r>
+                        <a:rPr sz="900"/>
+                        <a:t>0.048✓</a:t>
+                      </a:r>
+                    </a:p>
+                  </a:txBody>
+                  <a:tcPr/>
+                </a:tc>
+              </a:tr>
+              <a:tr h="274320">
+                <a:tc>
+                  <a:txBody>
+                    <a:bodyPr/>
+                    <a:lstStyle/>
+                    <a:p>
+                      <a:r>
+                        <a:rPr sz="900"/>
+                        <a:t>T</a:t>
+                      </a:r>
+                    </a:p>
+                  </a:txBody>
+                  <a:tcPr/>
+                </a:tc>
+                <a:tc>
+                  <a:txBody>
+                    <a:bodyPr/>
+                    <a:lstStyle/>
+                    <a:p>
+                      <a:r>
+                        <a:rPr sz="900"/>
+                        <a:t>audio+AIxVR</a:t>
+                      </a:r>
+                    </a:p>
+                  </a:txBody>
+                  <a:tcPr/>
+                </a:tc>
+                <a:tc>
+                  <a:txBody>
+                    <a:bodyPr/>
+                    <a:lstStyle/>
+                    <a:p>
+                      <a:r>
+                        <a:rPr sz="900"/>
+                        <a:t>0.71</a:t>
+                      </a:r>
+                    </a:p>
+                  </a:txBody>
+                  <a:tcPr/>
+                </a:tc>
+                <a:tc>
+                  <a:txBody>
+                    <a:bodyPr/>
+                    <a:lstStyle/>
+                    <a:p>
+                      <a:r>
+                        <a:rPr sz="900"/>
+                        <a:t>0.54</a:t>
+                      </a:r>
+                    </a:p>
+                  </a:txBody>
+                  <a:tcPr/>
+                </a:tc>
+                <a:tc>
+                  <a:txBody>
+                    <a:bodyPr/>
+                    <a:lstStyle/>
+                    <a:p>
+                      <a:r>
+                        <a:rPr sz="900"/>
+                        <a:t>0.003✓</a:t>
+                      </a:r>
+                    </a:p>
+                  </a:txBody>
+                  <a:tcPr/>
+                </a:tc>
+                <a:tc>
+                  <a:txBody>
+                    <a:bodyPr/>
+                    <a:lstStyle/>
+                    <a:p>
+                      <a:r>
+                        <a:rPr sz="900"/>
+                        <a:t>0.046✓</a:t>
+                      </a:r>
+                    </a:p>
+                  </a:txBody>
+                  <a:tcPr/>
+                </a:tc>
+              </a:tr>
+              <a:tr h="274320">
+                <a:tc>
+                  <a:txBody>
+                    <a:bodyPr/>
+                    <a:lstStyle/>
+                    <a:p>
+                      <a:r>
+                        <a:rPr sz="900"/>
+                        <a:t>T</a:t>
+                      </a:r>
+                    </a:p>
+                  </a:txBody>
+                  <a:tcPr/>
+                </a:tc>
+                <a:tc>
+                  <a:txBody>
+                    <a:bodyPr/>
+                    <a:lstStyle/>
+                    <a:p>
+                      <a:r>
+                        <a:rPr sz="900"/>
+                        <a:t>audio+GazexSpeaking</a:t>
+                      </a:r>
+                    </a:p>
+                  </a:txBody>
+                  <a:tcPr/>
+                </a:tc>
+                <a:tc>
+                  <a:txBody>
+                    <a:bodyPr/>
+                    <a:lstStyle/>
+                    <a:p>
+                      <a:r>
+                        <a:rPr sz="900"/>
+                        <a:t>0.67</a:t>
+                      </a:r>
+                    </a:p>
+                  </a:txBody>
+                  <a:tcPr/>
+                </a:tc>
+                <a:tc>
+                  <a:txBody>
+                    <a:bodyPr/>
+                    <a:lstStyle/>
+                    <a:p>
+                      <a:r>
+                        <a:rPr sz="900"/>
+                        <a:t>0.54</a:t>
+                      </a:r>
+                    </a:p>
+                  </a:txBody>
+                  <a:tcPr/>
+                </a:tc>
+                <a:tc>
+                  <a:txBody>
+                    <a:bodyPr/>
+                    <a:lstStyle/>
+                    <a:p>
+                      <a:r>
+                        <a:rPr sz="900"/>
+                        <a:t>0.003✓</a:t>
+                      </a:r>
+                    </a:p>
+                  </a:txBody>
+                  <a:tcPr/>
+                </a:tc>
+                <a:tc>
+                  <a:txBody>
+                    <a:bodyPr/>
+                    <a:lstStyle/>
+                    <a:p>
+                      <a:r>
+                        <a:rPr sz="900"/>
+                        <a:t>0.141✗</a:t>
+                      </a:r>
+                    </a:p>
+                  </a:txBody>
+                  <a:tcPr/>
+                </a:tc>
+              </a:tr>
+            </a:tbl>
+          </a:graphicData>
+        </a:graphic>
+      </p:graphicFrame>
+      <p:sp>
+        <p:nvSpPr>
+          <p:cNvPr id="5" name="TextBox 4"/>
+          <p:cNvSpPr txBox="1"/>
+          <p:nvPr/>
+        </p:nvSpPr>
+        <p:spPr>
+          <a:xfrm>
+            <a:off x="274320" y="5943600"/>
+            <a:ext cx="11521440" cy="822960"/>
+          </a:xfrm>
+          <a:prstGeom prst="rect">
+            <a:avLst/>
+          </a:prstGeom>
+          <a:noFill/>
+        </p:spPr>
+        <p:txBody>
+          <a:bodyPr wrap="square">
+            <a:spAutoFit/>
+          </a:bodyPr>
+          <a:lstStyle/>
+          <a:p>
+            <a:r>
+              <a:rPr sz="1000" i="1"/>
+              <a:t>3 priors: dummy(majority) / AIxVR (gaze, per-split feats) / GazexSpeaking (gaze×speaking). audio = our gaze-free v/a/d. Two tests shown (method UNDECIDED): permutation null = model on shuffled labels (lenient); t-test null = majority floor (stricter) → they disagree (esp. Triads &amp; Dyads). Highlights: fusion audio+GazexSpeaking best on All (0.75) &amp; Dyads (0.81); audio alone wins Triads (0.71, gaze-free). Dyads n=8 — unstable, caveat.</a:t>
             </a:r>
           </a:p>
         </p:txBody>

</xml_diff>

<commit_message>
discover(deck): add openSMILE (raw acoustics) vs v/a/d slide
Addresses 'v/a/d is only an affect estimate' objection: tests 88 interpretable eGeMAPS functionals directly. Raw acoustics do NOT beat affect for group TE (vad 0.69-0.72 > openSMILE 0.57-0.62). Clean labels.
</commit_message>
<xml_diff>
--- a/discover/2026_March_ViLearn_Planning.pptx
+++ b/discover/2026_March_ViLearn_Planning.pptx
@@ -28,6 +28,7 @@
     <p:sldId id="276" r:id="rId24"/>
     <p:sldId id="277" r:id="rId25"/>
     <p:sldId id="278" r:id="rId26"/>
+    <p:sldId id="279" r:id="rId27"/>
   </p:sldIdLst>
   <p:sldSz cx="12192000" cy="6858000"/>
   <p:notesSz cx="7559675" cy="10691813"/>
@@ -18438,6 +18439,613 @@
             <a:r>
               <a:rPr sz="1000" i="1"/>
               <a:t>3 priors: dummy(majority) / AIxVR (gaze, per-split feats) / GazexSpeaking (gaze×speaking). audio = our gaze-free v/a/d. Two tests shown (method UNDECIDED): permutation null = model on shuffled labels (lenient); t-test null = majority floor (stricter) → they disagree (esp. Triads &amp; Dyads). Highlights: fusion audio+GazexSpeaking best on All (0.75) &amp; Dyads (0.81); audio alone wins Triads (0.71, gaze-free). Dyads n=8 — unstable, caveat.</a:t>
+            </a:r>
+          </a:p>
+        </p:txBody>
+      </p:sp>
+    </p:spTree>
+  </p:cSld>
+  <p:clrMapOvr>
+    <a:masterClrMapping/>
+  </p:clrMapOvr>
+</p:sld>
+</file>
+
+<file path=ppt/slides/slide24.xml><?xml version="1.0" encoding="utf-8"?>
+<p:sld xmlns:a="http://schemas.openxmlformats.org/drawingml/2006/main" xmlns:p="http://schemas.openxmlformats.org/presentationml/2006/main" xmlns:r="http://schemas.openxmlformats.org/officeDocument/2006/relationships">
+  <p:cSld>
+    <p:spTree>
+      <p:nvGrpSpPr>
+        <p:cNvPr id="1" name=""/>
+        <p:cNvGrpSpPr/>
+        <p:nvPr/>
+      </p:nvGrpSpPr>
+      <p:grpSpPr/>
+      <p:sp>
+        <p:nvSpPr>
+          <p:cNvPr id="2" name="Title 1"/>
+          <p:cNvSpPr>
+            <a:spLocks noGrp="1"/>
+          </p:cNvSpPr>
+          <p:nvPr>
+            <p:ph type="title"/>
+          </p:nvPr>
+        </p:nvSpPr>
+        <p:spPr/>
+        <p:txBody>
+          <a:bodyPr/>
+          <a:lstStyle/>
+          <a:p>
+            <a:r>
+              <a:t>Raw Acoustics (openSMILE) vs Affect (v/a/d)</a:t>
+            </a:r>
+          </a:p>
+        </p:txBody>
+      </p:sp>
+      <p:sp>
+        <p:nvSpPr>
+          <p:cNvPr id="3" name="Text Placeholder 2"/>
+          <p:cNvSpPr>
+            <a:spLocks noGrp="1"/>
+          </p:cNvSpPr>
+          <p:nvPr>
+            <p:ph type="body"/>
+          </p:nvPr>
+        </p:nvSpPr>
+        <p:spPr/>
+        <p:txBody>
+          <a:bodyPr/>
+          <a:lstStyle/>
+          <a:p/>
+        </p:txBody>
+      </p:sp>
+      <p:graphicFrame>
+        <p:nvGraphicFramePr>
+          <p:cNvPr id="4" name="Table 3"/>
+          <p:cNvGraphicFramePr>
+            <a:graphicFrameLocks noGrp="1"/>
+          </p:cNvGraphicFramePr>
+          <p:nvPr/>
+        </p:nvGraphicFramePr>
+        <p:xfrm>
+          <a:off x="457200" y="1280160"/>
+          <a:ext cx="10424160" cy="2560320"/>
+        </p:xfrm>
+        <a:graphic>
+          <a:graphicData uri="http://schemas.openxmlformats.org/drawingml/2006/table">
+            <a:tbl>
+              <a:tblPr firstRow="1" bandRow="1">
+                <a:tableStyleId>{5C22544A-7EE6-4342-B048-85BDC9FD1C3A}</a:tableStyleId>
+              </a:tblPr>
+              <a:tblGrid>
+                <a:gridCol w="2194560"/>
+                <a:gridCol w="1097280"/>
+                <a:gridCol w="2011680"/>
+                <a:gridCol w="2377440"/>
+                <a:gridCol w="2743200"/>
+              </a:tblGrid>
+              <a:tr h="365760">
+                <a:tc>
+                  <a:txBody>
+                    <a:bodyPr/>
+                    <a:lstStyle/>
+                    <a:p>
+                      <a:r>
+                        <a:rPr sz="1200" b="1"/>
+                        <a:t>Target</a:t>
+                      </a:r>
+                    </a:p>
+                  </a:txBody>
+                  <a:tcPr/>
+                </a:tc>
+                <a:tc>
+                  <a:txBody>
+                    <a:bodyPr/>
+                    <a:lstStyle/>
+                    <a:p>
+                      <a:r>
+                        <a:rPr sz="1200" b="1"/>
+                        <a:t>Split</a:t>
+                      </a:r>
+                    </a:p>
+                  </a:txBody>
+                  <a:tcPr/>
+                </a:tc>
+                <a:tc>
+                  <a:txBody>
+                    <a:bodyPr/>
+                    <a:lstStyle/>
+                    <a:p>
+                      <a:r>
+                        <a:rPr sz="1200" b="1"/>
+                        <a:t>v/a/d (3)</a:t>
+                      </a:r>
+                    </a:p>
+                  </a:txBody>
+                  <a:tcPr/>
+                </a:tc>
+                <a:tc>
+                  <a:txBody>
+                    <a:bodyPr/>
+                    <a:lstStyle/>
+                    <a:p>
+                      <a:r>
+                        <a:rPr sz="1200" b="1"/>
+                        <a:t>openSMILE (88)</a:t>
+                      </a:r>
+                    </a:p>
+                  </a:txBody>
+                  <a:tcPr/>
+                </a:tc>
+                <a:tc>
+                  <a:txBody>
+                    <a:bodyPr/>
+                    <a:lstStyle/>
+                    <a:p>
+                      <a:r>
+                        <a:rPr sz="1200" b="1"/>
+                        <a:t>v/a/d + openSMILE</a:t>
+                      </a:r>
+                    </a:p>
+                  </a:txBody>
+                  <a:tcPr/>
+                </a:tc>
+              </a:tr>
+              <a:tr h="365760">
+                <a:tc>
+                  <a:txBody>
+                    <a:bodyPr/>
+                    <a:lstStyle/>
+                    <a:p>
+                      <a:r>
+                        <a:rPr sz="1100"/>
+                        <a:t>Group TE</a:t>
+                      </a:r>
+                    </a:p>
+                  </a:txBody>
+                  <a:tcPr/>
+                </a:tc>
+                <a:tc>
+                  <a:txBody>
+                    <a:bodyPr/>
+                    <a:lstStyle/>
+                    <a:p>
+                      <a:r>
+                        <a:rPr sz="1100"/>
+                        <a:t>all</a:t>
+                      </a:r>
+                    </a:p>
+                  </a:txBody>
+                  <a:tcPr/>
+                </a:tc>
+                <a:tc>
+                  <a:txBody>
+                    <a:bodyPr/>
+                    <a:lstStyle/>
+                    <a:p>
+                      <a:r>
+                        <a:rPr sz="1100"/>
+                        <a:t>0.69</a:t>
+                      </a:r>
+                    </a:p>
+                  </a:txBody>
+                  <a:tcPr/>
+                </a:tc>
+                <a:tc>
+                  <a:txBody>
+                    <a:bodyPr/>
+                    <a:lstStyle/>
+                    <a:p>
+                      <a:r>
+                        <a:rPr sz="1100"/>
+                        <a:t>0.57</a:t>
+                      </a:r>
+                    </a:p>
+                  </a:txBody>
+                  <a:tcPr/>
+                </a:tc>
+                <a:tc>
+                  <a:txBody>
+                    <a:bodyPr/>
+                    <a:lstStyle/>
+                    <a:p>
+                      <a:r>
+                        <a:rPr sz="1100"/>
+                        <a:t>0.61</a:t>
+                      </a:r>
+                    </a:p>
+                  </a:txBody>
+                  <a:tcPr/>
+                </a:tc>
+              </a:tr>
+              <a:tr h="365760">
+                <a:tc>
+                  <a:txBody>
+                    <a:bodyPr/>
+                    <a:lstStyle/>
+                    <a:p>
+                      <a:r>
+                        <a:rPr sz="1100"/>
+                        <a:t>Group TE</a:t>
+                      </a:r>
+                    </a:p>
+                  </a:txBody>
+                  <a:tcPr/>
+                </a:tc>
+                <a:tc>
+                  <a:txBody>
+                    <a:bodyPr/>
+                    <a:lstStyle/>
+                    <a:p>
+                      <a:r>
+                        <a:rPr sz="1100"/>
+                        <a:t>D</a:t>
+                      </a:r>
+                    </a:p>
+                  </a:txBody>
+                  <a:tcPr/>
+                </a:tc>
+                <a:tc>
+                  <a:txBody>
+                    <a:bodyPr/>
+                    <a:lstStyle/>
+                    <a:p>
+                      <a:r>
+                        <a:rPr sz="1100"/>
+                        <a:t>0.70</a:t>
+                      </a:r>
+                    </a:p>
+                  </a:txBody>
+                  <a:tcPr/>
+                </a:tc>
+                <a:tc>
+                  <a:txBody>
+                    <a:bodyPr/>
+                    <a:lstStyle/>
+                    <a:p>
+                      <a:r>
+                        <a:rPr sz="1100"/>
+                        <a:t>0.59</a:t>
+                      </a:r>
+                    </a:p>
+                  </a:txBody>
+                  <a:tcPr/>
+                </a:tc>
+                <a:tc>
+                  <a:txBody>
+                    <a:bodyPr/>
+                    <a:lstStyle/>
+                    <a:p>
+                      <a:r>
+                        <a:rPr sz="1100"/>
+                        <a:t>0.59</a:t>
+                      </a:r>
+                    </a:p>
+                  </a:txBody>
+                  <a:tcPr/>
+                </a:tc>
+              </a:tr>
+              <a:tr h="365760">
+                <a:tc>
+                  <a:txBody>
+                    <a:bodyPr/>
+                    <a:lstStyle/>
+                    <a:p>
+                      <a:r>
+                        <a:rPr sz="1100"/>
+                        <a:t>Group TE</a:t>
+                      </a:r>
+                    </a:p>
+                  </a:txBody>
+                  <a:tcPr/>
+                </a:tc>
+                <a:tc>
+                  <a:txBody>
+                    <a:bodyPr/>
+                    <a:lstStyle/>
+                    <a:p>
+                      <a:r>
+                        <a:rPr sz="1100"/>
+                        <a:t>T</a:t>
+                      </a:r>
+                    </a:p>
+                  </a:txBody>
+                  <a:tcPr/>
+                </a:tc>
+                <a:tc>
+                  <a:txBody>
+                    <a:bodyPr/>
+                    <a:lstStyle/>
+                    <a:p>
+                      <a:r>
+                        <a:rPr sz="1100"/>
+                        <a:t>0.72</a:t>
+                      </a:r>
+                    </a:p>
+                  </a:txBody>
+                  <a:tcPr/>
+                </a:tc>
+                <a:tc>
+                  <a:txBody>
+                    <a:bodyPr/>
+                    <a:lstStyle/>
+                    <a:p>
+                      <a:r>
+                        <a:rPr sz="1100"/>
+                        <a:t>0.62</a:t>
+                      </a:r>
+                    </a:p>
+                  </a:txBody>
+                  <a:tcPr/>
+                </a:tc>
+                <a:tc>
+                  <a:txBody>
+                    <a:bodyPr/>
+                    <a:lstStyle/>
+                    <a:p>
+                      <a:r>
+                        <a:rPr sz="1100"/>
+                        <a:t>0.67</a:t>
+                      </a:r>
+                    </a:p>
+                  </a:txBody>
+                  <a:tcPr/>
+                </a:tc>
+              </a:tr>
+              <a:tr h="365760">
+                <a:tc>
+                  <a:txBody>
+                    <a:bodyPr/>
+                    <a:lstStyle/>
+                    <a:p>
+                      <a:r>
+                        <a:rPr sz="1100"/>
+                        <a:t>Individual</a:t>
+                      </a:r>
+                    </a:p>
+                  </a:txBody>
+                  <a:tcPr/>
+                </a:tc>
+                <a:tc>
+                  <a:txBody>
+                    <a:bodyPr/>
+                    <a:lstStyle/>
+                    <a:p>
+                      <a:r>
+                        <a:rPr sz="1100"/>
+                        <a:t>all</a:t>
+                      </a:r>
+                    </a:p>
+                  </a:txBody>
+                  <a:tcPr/>
+                </a:tc>
+                <a:tc>
+                  <a:txBody>
+                    <a:bodyPr/>
+                    <a:lstStyle/>
+                    <a:p>
+                      <a:r>
+                        <a:rPr sz="1100"/>
+                        <a:t>0.61</a:t>
+                      </a:r>
+                    </a:p>
+                  </a:txBody>
+                  <a:tcPr/>
+                </a:tc>
+                <a:tc>
+                  <a:txBody>
+                    <a:bodyPr/>
+                    <a:lstStyle/>
+                    <a:p>
+                      <a:r>
+                        <a:rPr sz="1100"/>
+                        <a:t>0.57</a:t>
+                      </a:r>
+                    </a:p>
+                  </a:txBody>
+                  <a:tcPr/>
+                </a:tc>
+                <a:tc>
+                  <a:txBody>
+                    <a:bodyPr/>
+                    <a:lstStyle/>
+                    <a:p>
+                      <a:r>
+                        <a:rPr sz="1100"/>
+                        <a:t>0.64</a:t>
+                      </a:r>
+                    </a:p>
+                  </a:txBody>
+                  <a:tcPr/>
+                </a:tc>
+              </a:tr>
+              <a:tr h="365760">
+                <a:tc>
+                  <a:txBody>
+                    <a:bodyPr/>
+                    <a:lstStyle/>
+                    <a:p>
+                      <a:r>
+                        <a:rPr sz="1100"/>
+                        <a:t>Individual</a:t>
+                      </a:r>
+                    </a:p>
+                  </a:txBody>
+                  <a:tcPr/>
+                </a:tc>
+                <a:tc>
+                  <a:txBody>
+                    <a:bodyPr/>
+                    <a:lstStyle/>
+                    <a:p>
+                      <a:r>
+                        <a:rPr sz="1100"/>
+                        <a:t>D</a:t>
+                      </a:r>
+                    </a:p>
+                  </a:txBody>
+                  <a:tcPr/>
+                </a:tc>
+                <a:tc>
+                  <a:txBody>
+                    <a:bodyPr/>
+                    <a:lstStyle/>
+                    <a:p>
+                      <a:r>
+                        <a:rPr sz="1100"/>
+                        <a:t>0.63</a:t>
+                      </a:r>
+                    </a:p>
+                  </a:txBody>
+                  <a:tcPr/>
+                </a:tc>
+                <a:tc>
+                  <a:txBody>
+                    <a:bodyPr/>
+                    <a:lstStyle/>
+                    <a:p>
+                      <a:r>
+                        <a:rPr sz="1100"/>
+                        <a:t>0.53</a:t>
+                      </a:r>
+                    </a:p>
+                  </a:txBody>
+                  <a:tcPr/>
+                </a:tc>
+                <a:tc>
+                  <a:txBody>
+                    <a:bodyPr/>
+                    <a:lstStyle/>
+                    <a:p>
+                      <a:r>
+                        <a:rPr sz="1100"/>
+                        <a:t>0.54</a:t>
+                      </a:r>
+                    </a:p>
+                  </a:txBody>
+                  <a:tcPr/>
+                </a:tc>
+              </a:tr>
+              <a:tr h="365760">
+                <a:tc>
+                  <a:txBody>
+                    <a:bodyPr/>
+                    <a:lstStyle/>
+                    <a:p>
+                      <a:r>
+                        <a:rPr sz="1100"/>
+                        <a:t>Individual</a:t>
+                      </a:r>
+                    </a:p>
+                  </a:txBody>
+                  <a:tcPr/>
+                </a:tc>
+                <a:tc>
+                  <a:txBody>
+                    <a:bodyPr/>
+                    <a:lstStyle/>
+                    <a:p>
+                      <a:r>
+                        <a:rPr sz="1100"/>
+                        <a:t>T</a:t>
+                      </a:r>
+                    </a:p>
+                  </a:txBody>
+                  <a:tcPr/>
+                </a:tc>
+                <a:tc>
+                  <a:txBody>
+                    <a:bodyPr/>
+                    <a:lstStyle/>
+                    <a:p>
+                      <a:r>
+                        <a:rPr sz="1100"/>
+                        <a:t>0.64</a:t>
+                      </a:r>
+                    </a:p>
+                  </a:txBody>
+                  <a:tcPr/>
+                </a:tc>
+                <a:tc>
+                  <a:txBody>
+                    <a:bodyPr/>
+                    <a:lstStyle/>
+                    <a:p>
+                      <a:r>
+                        <a:rPr sz="1100"/>
+                        <a:t>0.56</a:t>
+                      </a:r>
+                    </a:p>
+                  </a:txBody>
+                  <a:tcPr/>
+                </a:tc>
+                <a:tc>
+                  <a:txBody>
+                    <a:bodyPr/>
+                    <a:lstStyle/>
+                    <a:p>
+                      <a:r>
+                        <a:rPr sz="1100"/>
+                        <a:t>0.62</a:t>
+                      </a:r>
+                    </a:p>
+                  </a:txBody>
+                  <a:tcPr/>
+                </a:tc>
+              </a:tr>
+            </a:tbl>
+          </a:graphicData>
+        </a:graphic>
+      </p:graphicFrame>
+      <p:sp>
+        <p:nvSpPr>
+          <p:cNvPr id="5" name="TextBox 4"/>
+          <p:cNvSpPr txBox="1"/>
+          <p:nvPr/>
+        </p:nvSpPr>
+        <p:spPr>
+          <a:xfrm>
+            <a:off x="457200" y="4206240"/>
+            <a:ext cx="10972800" cy="2103120"/>
+          </a:xfrm>
+          <a:prstGeom prst="rect">
+            <a:avLst/>
+          </a:prstGeom>
+          <a:noFill/>
+        </p:spPr>
+        <p:txBody>
+          <a:bodyPr wrap="square">
+            <a:spAutoFit/>
+          </a:bodyPr>
+          <a:lstStyle/>
+          <a:p>
+            <a:r>
+              <a:rPr sz="1200"/>
+              <a:t>Addresses the objection that v/a/d is affect ESTIMATED from audio, not a raw acoustic feature.</a:t>
+            </a:r>
+          </a:p>
+          <a:p>
+            <a:r>
+              <a:rPr sz="1200"/>
+              <a:t>openSMILE = 88 interpretable eGeMAPS functionals (F0, loudness, jitter, shimmer, MFCC, spectral flux ...) — raw acoustics, not embeddings.</a:t>
+            </a:r>
+          </a:p>
+          <a:p>
+            <a:r>
+              <a:rPr sz="1200"/>
+              <a:t>Result: raw acoustics do NOT beat the affect estimate for group TE (v/a/d 0.69–0.72 &gt; openSMILE 0.57–0.62 across all splits); combining them does not help.</a:t>
+            </a:r>
+          </a:p>
+          <a:p>
+            <a:r>
+              <a:rPr sz="1200"/>
+              <a:t>Only individual-All sees a small gain from adding openSMILE (0.64 vs 0.61). 88 features on ~20 sessions also risks overfitting.</a:t>
+            </a:r>
+          </a:p>
+          <a:p>
+            <a:r>
+              <a:rPr sz="1200"/>
+              <a:t>Takeaway: the compact 3-dim affect (v/a/d) is the stronger, more parsimonious audio representation — even raw acoustics don't outperform it.</a:t>
             </a:r>
           </a:p>
         </p:txBody>

</xml_diff>

<commit_message>
discover(deck): LLM-rubric TE detector + gaze×LLM fusion slides
Operationalize the TE coding schema (Low/Med/High markers) as a local-LLM
prompt (Qwen3.6-27B, German transcripts, 60s group-windows, clean labels,
group-level nested LOSO + permutation). Two slides:

- #24 LLM rubric: zero-shot (training-free, gaze-free) ties best fusion
  (~0.75 All); marker features think All 0.81 / Triads 0.84; gbert BERT
  baseline ties → signal is in the text, rubric makes it interpretable.
  think vs nothink both shown.
- #25 gaze×speaking × LLM fusion: GazexSpeaking-6 (consistent all splits)
  + LLM markers = BEST detector, All 0.86 / Dyads 0.87 (perm p≈.003), beats
  every prior/modality/old gaze+vad fusion; vad redundant once LLM in except
  Triads (triple 0.85). Patchers 17/18 idempotent.
</commit_message>
<xml_diff>
--- a/discover/2026_March_ViLearn_Planning.pptx
+++ b/discover/2026_March_ViLearn_Planning.pptx
@@ -29,6 +29,8 @@
     <p:sldId id="277" r:id="rId25"/>
     <p:sldId id="278" r:id="rId26"/>
     <p:sldId id="279" r:id="rId27"/>
+    <p:sldId id="280" r:id="rId30"/>
+    <p:sldId id="281" r:id="rId31"/>
   </p:sldIdLst>
   <p:sldSz cx="12192000" cy="6858000"/>
   <p:notesSz cx="7559675" cy="10691813"/>
@@ -19046,6 +19048,1030 @@
             <a:r>
               <a:rPr sz="1200"/>
               <a:t>Takeaway: the compact 3-dim affect (v/a/d) is the stronger, more parsimonious audio representation — even raw acoustics don't outperform it.</a:t>
+            </a:r>
+          </a:p>
+        </p:txBody>
+      </p:sp>
+    </p:spTree>
+  </p:cSld>
+  <p:clrMapOvr>
+    <a:masterClrMapping/>
+  </p:clrMapOvr>
+</p:sld>
+</file>
+
+<file path=ppt/slides/slide25.xml><?xml version="1.0" encoding="utf-8"?>
+<p:sld xmlns:a="http://schemas.openxmlformats.org/drawingml/2006/main" xmlns:p="http://schemas.openxmlformats.org/presentationml/2006/main" xmlns:r="http://schemas.openxmlformats.org/officeDocument/2006/relationships">
+  <p:cSld>
+    <p:spTree>
+      <p:nvGrpSpPr>
+        <p:cNvPr id="1" name=""/>
+        <p:cNvGrpSpPr/>
+        <p:nvPr/>
+      </p:nvGrpSpPr>
+      <p:grpSpPr/>
+      <p:sp>
+        <p:nvSpPr>
+          <p:cNvPr id="2" name="Title 1"/>
+          <p:cNvSpPr>
+            <a:spLocks noGrp="1"/>
+          </p:cNvSpPr>
+          <p:nvPr>
+            <p:ph type="title"/>
+          </p:nvPr>
+        </p:nvSpPr>
+        <p:spPr/>
+        <p:txBody>
+          <a:bodyPr/>
+          <a:lstStyle/>
+          <a:p>
+            <a:r>
+              <a:t>Operationalizing the TE Rubric with a Local LLM (zero-shot + features)</a:t>
+            </a:r>
+          </a:p>
+        </p:txBody>
+      </p:sp>
+      <p:sp>
+        <p:nvSpPr>
+          <p:cNvPr id="3" name="Text Placeholder 2"/>
+          <p:cNvSpPr>
+            <a:spLocks noGrp="1"/>
+          </p:cNvSpPr>
+          <p:nvPr>
+            <p:ph type="body"/>
+          </p:nvPr>
+        </p:nvSpPr>
+        <p:spPr/>
+        <p:txBody>
+          <a:bodyPr/>
+          <a:lstStyle/>
+          <a:p/>
+        </p:txBody>
+      </p:sp>
+      <p:graphicFrame>
+        <p:nvGraphicFramePr>
+          <p:cNvPr id="4" name="Table 3"/>
+          <p:cNvGraphicFramePr>
+            <a:graphicFrameLocks noGrp="1"/>
+          </p:cNvGraphicFramePr>
+          <p:nvPr/>
+        </p:nvGraphicFramePr>
+        <p:xfrm>
+          <a:off x="365760" y="1280160"/>
+          <a:ext cx="9784080" cy="1645920"/>
+        </p:xfrm>
+        <a:graphic>
+          <a:graphicData uri="http://schemas.openxmlformats.org/drawingml/2006/table">
+            <a:tbl>
+              <a:tblPr firstRow="1" bandRow="1">
+                <a:tableStyleId>{5C22544A-7EE6-4342-B048-85BDC9FD1C3A}</a:tableStyleId>
+              </a:tblPr>
+              <a:tblGrid>
+                <a:gridCol w="914400"/>
+                <a:gridCol w="914400"/>
+                <a:gridCol w="1828800"/>
+                <a:gridCol w="1737360"/>
+                <a:gridCol w="1097280"/>
+                <a:gridCol w="1188720"/>
+                <a:gridCol w="914400"/>
+                <a:gridCol w="1188720"/>
+              </a:tblGrid>
+              <a:tr h="411480">
+                <a:tc>
+                  <a:txBody>
+                    <a:bodyPr/>
+                    <a:lstStyle/>
+                    <a:p>
+                      <a:r>
+                        <a:rPr sz="1100" b="1"/>
+                        <a:t>Split</a:t>
+                      </a:r>
+                    </a:p>
+                  </a:txBody>
+                  <a:tcPr/>
+                </a:tc>
+                <a:tc>
+                  <a:txBody>
+                    <a:bodyPr/>
+                    <a:lstStyle/>
+                    <a:p>
+                      <a:r>
+                        <a:rPr sz="1100" b="1"/>
+                        <a:t>Majority</a:t>
+                      </a:r>
+                    </a:p>
+                  </a:txBody>
+                  <a:tcPr/>
+                </a:tc>
+                <a:tc>
+                  <a:txBody>
+                    <a:bodyPr/>
+                    <a:lstStyle/>
+                    <a:p>
+                      <a:r>
+                        <a:rPr sz="1100" b="1"/>
+                        <a:t>LLM zero-shot (think/nothink)</a:t>
+                      </a:r>
+                    </a:p>
+                  </a:txBody>
+                  <a:tcPr/>
+                </a:tc>
+                <a:tc>
+                  <a:txBody>
+                    <a:bodyPr/>
+                    <a:lstStyle/>
+                    <a:p>
+                      <a:r>
+                        <a:rPr sz="1100" b="1"/>
+                        <a:t>LLM markers (think/nothink)</a:t>
+                      </a:r>
+                    </a:p>
+                  </a:txBody>
+                  <a:tcPr/>
+                </a:tc>
+                <a:tc>
+                  <a:txBody>
+                    <a:bodyPr/>
+                    <a:lstStyle/>
+                    <a:p>
+                      <a:r>
+                        <a:rPr sz="1100" b="1"/>
+                        <a:t>BERT (text)</a:t>
+                      </a:r>
+                    </a:p>
+                  </a:txBody>
+                  <a:tcPr/>
+                </a:tc>
+                <a:tc>
+                  <a:txBody>
+                    <a:bodyPr/>
+                    <a:lstStyle/>
+                    <a:p>
+                      <a:r>
+                        <a:rPr sz="1100" b="1"/>
+                        <a:t>Prior gaze</a:t>
+                      </a:r>
+                    </a:p>
+                  </a:txBody>
+                  <a:tcPr/>
+                </a:tc>
+                <a:tc>
+                  <a:txBody>
+                    <a:bodyPr/>
+                    <a:lstStyle/>
+                    <a:p>
+                      <a:r>
+                        <a:rPr sz="1100" b="1"/>
+                        <a:t>Audio</a:t>
+                      </a:r>
+                    </a:p>
+                  </a:txBody>
+                  <a:tcPr/>
+                </a:tc>
+                <a:tc>
+                  <a:txBody>
+                    <a:bodyPr/>
+                    <a:lstStyle/>
+                    <a:p>
+                      <a:r>
+                        <a:rPr sz="1100" b="1"/>
+                        <a:t>Audio+Gaze</a:t>
+                      </a:r>
+                    </a:p>
+                  </a:txBody>
+                  <a:tcPr/>
+                </a:tc>
+              </a:tr>
+              <a:tr h="411480">
+                <a:tc>
+                  <a:txBody>
+                    <a:bodyPr/>
+                    <a:lstStyle/>
+                    <a:p>
+                      <a:r>
+                        <a:rPr sz="1100"/>
+                        <a:t>All</a:t>
+                      </a:r>
+                    </a:p>
+                  </a:txBody>
+                  <a:tcPr/>
+                </a:tc>
+                <a:tc>
+                  <a:txBody>
+                    <a:bodyPr/>
+                    <a:lstStyle/>
+                    <a:p>
+                      <a:r>
+                        <a:rPr sz="1100"/>
+                        <a:t>0.52</a:t>
+                      </a:r>
+                    </a:p>
+                  </a:txBody>
+                  <a:tcPr/>
+                </a:tc>
+                <a:tc>
+                  <a:txBody>
+                    <a:bodyPr/>
+                    <a:lstStyle/>
+                    <a:p>
+                      <a:r>
+                        <a:rPr sz="1100"/>
+                        <a:t>0.74 / 0.75</a:t>
+                      </a:r>
+                    </a:p>
+                  </a:txBody>
+                  <a:tcPr/>
+                </a:tc>
+                <a:tc>
+                  <a:txBody>
+                    <a:bodyPr/>
+                    <a:lstStyle/>
+                    <a:p>
+                      <a:r>
+                        <a:rPr sz="1100"/>
+                        <a:t>0.81 / 0.76</a:t>
+                      </a:r>
+                    </a:p>
+                  </a:txBody>
+                  <a:tcPr/>
+                </a:tc>
+                <a:tc>
+                  <a:txBody>
+                    <a:bodyPr/>
+                    <a:lstStyle/>
+                    <a:p>
+                      <a:r>
+                        <a:rPr sz="1100"/>
+                        <a:t>0.76</a:t>
+                      </a:r>
+                    </a:p>
+                  </a:txBody>
+                  <a:tcPr/>
+                </a:tc>
+                <a:tc>
+                  <a:txBody>
+                    <a:bodyPr/>
+                    <a:lstStyle/>
+                    <a:p>
+                      <a:r>
+                        <a:rPr sz="1100"/>
+                        <a:t>0.73</a:t>
+                      </a:r>
+                    </a:p>
+                  </a:txBody>
+                  <a:tcPr/>
+                </a:tc>
+                <a:tc>
+                  <a:txBody>
+                    <a:bodyPr/>
+                    <a:lstStyle/>
+                    <a:p>
+                      <a:r>
+                        <a:rPr sz="1100"/>
+                        <a:t>0.66</a:t>
+                      </a:r>
+                    </a:p>
+                  </a:txBody>
+                  <a:tcPr/>
+                </a:tc>
+                <a:tc>
+                  <a:txBody>
+                    <a:bodyPr/>
+                    <a:lstStyle/>
+                    <a:p>
+                      <a:r>
+                        <a:rPr sz="1100"/>
+                        <a:t>0.75</a:t>
+                      </a:r>
+                    </a:p>
+                  </a:txBody>
+                  <a:tcPr/>
+                </a:tc>
+              </a:tr>
+              <a:tr h="411480">
+                <a:tc>
+                  <a:txBody>
+                    <a:bodyPr/>
+                    <a:lstStyle/>
+                    <a:p>
+                      <a:r>
+                        <a:rPr sz="1100"/>
+                        <a:t>Dyads</a:t>
+                      </a:r>
+                    </a:p>
+                  </a:txBody>
+                  <a:tcPr/>
+                </a:tc>
+                <a:tc>
+                  <a:txBody>
+                    <a:bodyPr/>
+                    <a:lstStyle/>
+                    <a:p>
+                      <a:r>
+                        <a:rPr sz="1100"/>
+                        <a:t>0.59</a:t>
+                      </a:r>
+                    </a:p>
+                  </a:txBody>
+                  <a:tcPr/>
+                </a:tc>
+                <a:tc>
+                  <a:txBody>
+                    <a:bodyPr/>
+                    <a:lstStyle/>
+                    <a:p>
+                      <a:r>
+                        <a:rPr sz="1100"/>
+                        <a:t>0.71 / 0.76</a:t>
+                      </a:r>
+                    </a:p>
+                  </a:txBody>
+                  <a:tcPr/>
+                </a:tc>
+                <a:tc>
+                  <a:txBody>
+                    <a:bodyPr/>
+                    <a:lstStyle/>
+                    <a:p>
+                      <a:r>
+                        <a:rPr sz="1100"/>
+                        <a:t>0.75 / 0.76</a:t>
+                      </a:r>
+                    </a:p>
+                  </a:txBody>
+                  <a:tcPr/>
+                </a:tc>
+                <a:tc>
+                  <a:txBody>
+                    <a:bodyPr/>
+                    <a:lstStyle/>
+                    <a:p>
+                      <a:r>
+                        <a:rPr sz="1100"/>
+                        <a:t>0.77</a:t>
+                      </a:r>
+                    </a:p>
+                  </a:txBody>
+                  <a:tcPr/>
+                </a:tc>
+                <a:tc>
+                  <a:txBody>
+                    <a:bodyPr/>
+                    <a:lstStyle/>
+                    <a:p>
+                      <a:r>
+                        <a:rPr sz="1100"/>
+                        <a:t>0.83</a:t>
+                      </a:r>
+                    </a:p>
+                  </a:txBody>
+                  <a:tcPr/>
+                </a:tc>
+                <a:tc>
+                  <a:txBody>
+                    <a:bodyPr/>
+                    <a:lstStyle/>
+                    <a:p>
+                      <a:r>
+                        <a:rPr sz="1100"/>
+                        <a:t>0.60</a:t>
+                      </a:r>
+                    </a:p>
+                  </a:txBody>
+                  <a:tcPr/>
+                </a:tc>
+                <a:tc>
+                  <a:txBody>
+                    <a:bodyPr/>
+                    <a:lstStyle/>
+                    <a:p>
+                      <a:r>
+                        <a:rPr sz="1100"/>
+                        <a:t>0.81</a:t>
+                      </a:r>
+                    </a:p>
+                  </a:txBody>
+                  <a:tcPr/>
+                </a:tc>
+              </a:tr>
+              <a:tr h="411480">
+                <a:tc>
+                  <a:txBody>
+                    <a:bodyPr/>
+                    <a:lstStyle/>
+                    <a:p>
+                      <a:r>
+                        <a:rPr sz="1100"/>
+                        <a:t>Triads</a:t>
+                      </a:r>
+                    </a:p>
+                  </a:txBody>
+                  <a:tcPr/>
+                </a:tc>
+                <a:tc>
+                  <a:txBody>
+                    <a:bodyPr/>
+                    <a:lstStyle/>
+                    <a:p>
+                      <a:r>
+                        <a:rPr sz="1100"/>
+                        <a:t>0.54</a:t>
+                      </a:r>
+                    </a:p>
+                  </a:txBody>
+                  <a:tcPr/>
+                </a:tc>
+                <a:tc>
+                  <a:txBody>
+                    <a:bodyPr/>
+                    <a:lstStyle/>
+                    <a:p>
+                      <a:r>
+                        <a:rPr sz="1100"/>
+                        <a:t>0.76 / 0.74</a:t>
+                      </a:r>
+                    </a:p>
+                  </a:txBody>
+                  <a:tcPr/>
+                </a:tc>
+                <a:tc>
+                  <a:txBody>
+                    <a:bodyPr/>
+                    <a:lstStyle/>
+                    <a:p>
+                      <a:r>
+                        <a:rPr sz="1100"/>
+                        <a:t>0.84 / 0.82</a:t>
+                      </a:r>
+                    </a:p>
+                  </a:txBody>
+                  <a:tcPr/>
+                </a:tc>
+                <a:tc>
+                  <a:txBody>
+                    <a:bodyPr/>
+                    <a:lstStyle/>
+                    <a:p>
+                      <a:r>
+                        <a:rPr sz="1100"/>
+                        <a:t>0.74</a:t>
+                      </a:r>
+                    </a:p>
+                  </a:txBody>
+                  <a:tcPr/>
+                </a:tc>
+                <a:tc>
+                  <a:txBody>
+                    <a:bodyPr/>
+                    <a:lstStyle/>
+                    <a:p>
+                      <a:r>
+                        <a:rPr sz="1100"/>
+                        <a:t>0.69</a:t>
+                      </a:r>
+                    </a:p>
+                  </a:txBody>
+                  <a:tcPr/>
+                </a:tc>
+                <a:tc>
+                  <a:txBody>
+                    <a:bodyPr/>
+                    <a:lstStyle/>
+                    <a:p>
+                      <a:r>
+                        <a:rPr sz="1100"/>
+                        <a:t>0.71</a:t>
+                      </a:r>
+                    </a:p>
+                  </a:txBody>
+                  <a:tcPr/>
+                </a:tc>
+                <a:tc>
+                  <a:txBody>
+                    <a:bodyPr/>
+                    <a:lstStyle/>
+                    <a:p>
+                      <a:r>
+                        <a:rPr sz="1100"/>
+                        <a:t>0.67</a:t>
+                      </a:r>
+                    </a:p>
+                  </a:txBody>
+                  <a:tcPr/>
+                </a:tc>
+              </a:tr>
+            </a:tbl>
+          </a:graphicData>
+        </a:graphic>
+      </p:graphicFrame>
+      <p:sp>
+        <p:nvSpPr>
+          <p:cNvPr id="5" name="TextBox 4"/>
+          <p:cNvSpPr txBox="1"/>
+          <p:nvPr/>
+        </p:nvSpPr>
+        <p:spPr>
+          <a:xfrm>
+            <a:off x="365760" y="3383280"/>
+            <a:ext cx="11338560" cy="2926080"/>
+          </a:xfrm>
+          <a:prstGeom prst="rect">
+            <a:avLst/>
+          </a:prstGeom>
+          <a:noFill/>
+        </p:spPr>
+        <p:txBody>
+          <a:bodyPr wrap="square">
+            <a:spAutoFit/>
+          </a:bodyPr>
+          <a:lstStyle/>
+          <a:p>
+            <a:r>
+              <a:rPr sz="1100"/>
+              <a:t>Idea: the authors' TE coding schema (Low/Med/High markers) IS a set of linguistic criteria — operationalize it directly with an LLM instead of generic embeddings. Local Qwen3.6-27B (GDPR: on-prem, German transcripts), 60 s group-windows, clean 2-annotator labels.</a:t>
+            </a:r>
+          </a:p>
+          <a:p>
+            <a:r>
+              <a:rPr sz="1100"/>
+              <a:t>(a) Zero-shot — rubric + transcript -&gt; TE level, NO training, NO gaze: ~0.74–0.76 All, significant every split (permutation p ≈ .0005). Matches the best multimodal fusion (0.75 All), beats audio alone (0.66). Think and non-think near-identical here.</a:t>
+            </a:r>
+          </a:p>
+          <a:p>
+            <a:r>
+              <a:rPr sz="1100"/>
+              <a:t>(b) Marker features — 4 rubric axes (task_relevance, content_depth, reasoning, connecting_ideas) -&gt; same nested LOSO panel: thinking mode All 0.81 / Triads 0.84 — the highest of ANY method/modality here, and above non-think (0.76 / 0.82).</a:t>
+            </a:r>
+          </a:p>
+          <a:p>
+            <a:r>
+              <a:rPr sz="1100"/>
+              <a:t>Generic German BERT (gbert, frozen embeddings, no rubric) ties it (0.74–0.77) — the signal lives in the text; the rubric makes it training-free AND interpretable (per-axis scores).</a:t>
+            </a:r>
+          </a:p>
+          <a:p>
+            <a:r>
+              <a:rPr sz="1100"/>
+              <a:t>All group-level, nested LOSO + permutation. Two LLM passes reported (think / non-think); thinking helps the marker features, not zero-shot. NB: Qwen3.6 thinking-EFFORT levels (low/med) are inert on ollama — only on/off differ.</a:t>
+            </a:r>
+          </a:p>
+        </p:txBody>
+      </p:sp>
+    </p:spTree>
+  </p:cSld>
+  <p:clrMapOvr>
+    <a:masterClrMapping/>
+  </p:clrMapOvr>
+</p:sld>
+</file>
+
+<file path=ppt/slides/slide26.xml><?xml version="1.0" encoding="utf-8"?>
+<p:sld xmlns:a="http://schemas.openxmlformats.org/drawingml/2006/main" xmlns:p="http://schemas.openxmlformats.org/presentationml/2006/main" xmlns:r="http://schemas.openxmlformats.org/officeDocument/2006/relationships">
+  <p:cSld>
+    <p:spTree>
+      <p:nvGrpSpPr>
+        <p:cNvPr id="1" name=""/>
+        <p:cNvGrpSpPr/>
+        <p:nvPr/>
+      </p:nvGrpSpPr>
+      <p:grpSpPr/>
+      <p:sp>
+        <p:nvSpPr>
+          <p:cNvPr id="2" name="Title 1"/>
+          <p:cNvSpPr>
+            <a:spLocks noGrp="1"/>
+          </p:cNvSpPr>
+          <p:nvPr>
+            <p:ph type="title"/>
+          </p:nvPr>
+        </p:nvSpPr>
+        <p:spPr/>
+        <p:txBody>
+          <a:bodyPr/>
+          <a:lstStyle/>
+          <a:p>
+            <a:r>
+              <a:t>Best Config: Gaze×Speaking × LLM Rubric (fusion)</a:t>
+            </a:r>
+          </a:p>
+        </p:txBody>
+      </p:sp>
+      <p:sp>
+        <p:nvSpPr>
+          <p:cNvPr id="3" name="Text Placeholder 2"/>
+          <p:cNvSpPr>
+            <a:spLocks noGrp="1"/>
+          </p:cNvSpPr>
+          <p:nvPr>
+            <p:ph type="body"/>
+          </p:nvPr>
+        </p:nvSpPr>
+        <p:spPr/>
+        <p:txBody>
+          <a:bodyPr/>
+          <a:lstStyle/>
+          <a:p/>
+        </p:txBody>
+      </p:sp>
+      <p:graphicFrame>
+        <p:nvGraphicFramePr>
+          <p:cNvPr id="4" name="Table 3"/>
+          <p:cNvGraphicFramePr>
+            <a:graphicFrameLocks noGrp="1"/>
+          </p:cNvGraphicFramePr>
+          <p:nvPr/>
+        </p:nvGraphicFramePr>
+        <p:xfrm>
+          <a:off x="457200" y="1280160"/>
+          <a:ext cx="9418320" cy="1645920"/>
+        </p:xfrm>
+        <a:graphic>
+          <a:graphicData uri="http://schemas.openxmlformats.org/drawingml/2006/table">
+            <a:tbl>
+              <a:tblPr firstRow="1" bandRow="1">
+                <a:tableStyleId>{5C22544A-7EE6-4342-B048-85BDC9FD1C3A}</a:tableStyleId>
+              </a:tblPr>
+              <a:tblGrid>
+                <a:gridCol w="1280160"/>
+                <a:gridCol w="1828800"/>
+                <a:gridCol w="1097280"/>
+                <a:gridCol w="1554480"/>
+                <a:gridCol w="1645920"/>
+                <a:gridCol w="2011680"/>
+              </a:tblGrid>
+              <a:tr h="411480">
+                <a:tc>
+                  <a:txBody>
+                    <a:bodyPr/>
+                    <a:lstStyle/>
+                    <a:p>
+                      <a:r>
+                        <a:rPr sz="1200" b="1"/>
+                        <a:t>Split</a:t>
+                      </a:r>
+                    </a:p>
+                  </a:txBody>
+                  <a:tcPr/>
+                </a:tc>
+                <a:tc>
+                  <a:txBody>
+                    <a:bodyPr/>
+                    <a:lstStyle/>
+                    <a:p>
+                      <a:r>
+                        <a:rPr sz="1200" b="1"/>
+                        <a:t>Gaze (GxS-6)</a:t>
+                      </a:r>
+                    </a:p>
+                  </a:txBody>
+                  <a:tcPr/>
+                </a:tc>
+                <a:tc>
+                  <a:txBody>
+                    <a:bodyPr/>
+                    <a:lstStyle/>
+                    <a:p>
+                      <a:r>
+                        <a:rPr sz="1200" b="1"/>
+                        <a:t>LLM</a:t>
+                      </a:r>
+                    </a:p>
+                  </a:txBody>
+                  <a:tcPr/>
+                </a:tc>
+                <a:tc>
+                  <a:txBody>
+                    <a:bodyPr/>
+                    <a:lstStyle/>
+                    <a:p>
+                      <a:r>
+                        <a:rPr sz="1200" b="1"/>
+                        <a:t>Gaze+vad</a:t>
+                      </a:r>
+                    </a:p>
+                  </a:txBody>
+                  <a:tcPr/>
+                </a:tc>
+                <a:tc>
+                  <a:txBody>
+                    <a:bodyPr/>
+                    <a:lstStyle/>
+                    <a:p>
+                      <a:r>
+                        <a:rPr sz="1200" b="1"/>
+                        <a:t>Gaze+LLM</a:t>
+                      </a:r>
+                    </a:p>
+                  </a:txBody>
+                  <a:tcPr/>
+                </a:tc>
+                <a:tc>
+                  <a:txBody>
+                    <a:bodyPr/>
+                    <a:lstStyle/>
+                    <a:p>
+                      <a:r>
+                        <a:rPr sz="1200" b="1"/>
+                        <a:t>Gaze+vad+LLM</a:t>
+                      </a:r>
+                    </a:p>
+                  </a:txBody>
+                  <a:tcPr/>
+                </a:tc>
+              </a:tr>
+              <a:tr h="411480">
+                <a:tc>
+                  <a:txBody>
+                    <a:bodyPr/>
+                    <a:lstStyle/>
+                    <a:p>
+                      <a:r>
+                        <a:rPr sz="1200" b="0"/>
+                        <a:t>All</a:t>
+                      </a:r>
+                    </a:p>
+                  </a:txBody>
+                  <a:tcPr/>
+                </a:tc>
+                <a:tc>
+                  <a:txBody>
+                    <a:bodyPr/>
+                    <a:lstStyle/>
+                    <a:p>
+                      <a:r>
+                        <a:rPr sz="1200" b="0"/>
+                        <a:t>0.73</a:t>
+                      </a:r>
+                    </a:p>
+                  </a:txBody>
+                  <a:tcPr/>
+                </a:tc>
+                <a:tc>
+                  <a:txBody>
+                    <a:bodyPr/>
+                    <a:lstStyle/>
+                    <a:p>
+                      <a:r>
+                        <a:rPr sz="1200" b="0"/>
+                        <a:t>0.81</a:t>
+                      </a:r>
+                    </a:p>
+                  </a:txBody>
+                  <a:tcPr/>
+                </a:tc>
+                <a:tc>
+                  <a:txBody>
+                    <a:bodyPr/>
+                    <a:lstStyle/>
+                    <a:p>
+                      <a:r>
+                        <a:rPr sz="1200" b="0"/>
+                        <a:t>0.75</a:t>
+                      </a:r>
+                    </a:p>
+                  </a:txBody>
+                  <a:tcPr/>
+                </a:tc>
+                <a:tc>
+                  <a:txBody>
+                    <a:bodyPr/>
+                    <a:lstStyle/>
+                    <a:p>
+                      <a:r>
+                        <a:rPr sz="1200" b="1"/>
+                        <a:t>0.86</a:t>
+                      </a:r>
+                    </a:p>
+                  </a:txBody>
+                  <a:tcPr/>
+                </a:tc>
+                <a:tc>
+                  <a:txBody>
+                    <a:bodyPr/>
+                    <a:lstStyle/>
+                    <a:p>
+                      <a:r>
+                        <a:rPr sz="1200" b="0"/>
+                        <a:t>0.84</a:t>
+                      </a:r>
+                    </a:p>
+                  </a:txBody>
+                  <a:tcPr/>
+                </a:tc>
+              </a:tr>
+              <a:tr h="411480">
+                <a:tc>
+                  <a:txBody>
+                    <a:bodyPr/>
+                    <a:lstStyle/>
+                    <a:p>
+                      <a:r>
+                        <a:rPr sz="1200" b="0"/>
+                        <a:t>Dyads</a:t>
+                      </a:r>
+                    </a:p>
+                  </a:txBody>
+                  <a:tcPr/>
+                </a:tc>
+                <a:tc>
+                  <a:txBody>
+                    <a:bodyPr/>
+                    <a:lstStyle/>
+                    <a:p>
+                      <a:r>
+                        <a:rPr sz="1200" b="0"/>
+                        <a:t>0.83</a:t>
+                      </a:r>
+                    </a:p>
+                  </a:txBody>
+                  <a:tcPr/>
+                </a:tc>
+                <a:tc>
+                  <a:txBody>
+                    <a:bodyPr/>
+                    <a:lstStyle/>
+                    <a:p>
+                      <a:r>
+                        <a:rPr sz="1200" b="0"/>
+                        <a:t>0.75</a:t>
+                      </a:r>
+                    </a:p>
+                  </a:txBody>
+                  <a:tcPr/>
+                </a:tc>
+                <a:tc>
+                  <a:txBody>
+                    <a:bodyPr/>
+                    <a:lstStyle/>
+                    <a:p>
+                      <a:r>
+                        <a:rPr sz="1200" b="0"/>
+                        <a:t>0.81</a:t>
+                      </a:r>
+                    </a:p>
+                  </a:txBody>
+                  <a:tcPr/>
+                </a:tc>
+                <a:tc>
+                  <a:txBody>
+                    <a:bodyPr/>
+                    <a:lstStyle/>
+                    <a:p>
+                      <a:r>
+                        <a:rPr sz="1200" b="1"/>
+                        <a:t>0.87</a:t>
+                      </a:r>
+                    </a:p>
+                  </a:txBody>
+                  <a:tcPr/>
+                </a:tc>
+                <a:tc>
+                  <a:txBody>
+                    <a:bodyPr/>
+                    <a:lstStyle/>
+                    <a:p>
+                      <a:r>
+                        <a:rPr sz="1200" b="0"/>
+                        <a:t>0.83</a:t>
+                      </a:r>
+                    </a:p>
+                  </a:txBody>
+                  <a:tcPr/>
+                </a:tc>
+              </a:tr>
+              <a:tr h="411480">
+                <a:tc>
+                  <a:txBody>
+                    <a:bodyPr/>
+                    <a:lstStyle/>
+                    <a:p>
+                      <a:r>
+                        <a:rPr sz="1200" b="0"/>
+                        <a:t>Triads</a:t>
+                      </a:r>
+                    </a:p>
+                  </a:txBody>
+                  <a:tcPr/>
+                </a:tc>
+                <a:tc>
+                  <a:txBody>
+                    <a:bodyPr/>
+                    <a:lstStyle/>
+                    <a:p>
+                      <a:r>
+                        <a:rPr sz="1200" b="0"/>
+                        <a:t>0.69</a:t>
+                      </a:r>
+                    </a:p>
+                  </a:txBody>
+                  <a:tcPr/>
+                </a:tc>
+                <a:tc>
+                  <a:txBody>
+                    <a:bodyPr/>
+                    <a:lstStyle/>
+                    <a:p>
+                      <a:r>
+                        <a:rPr sz="1200" b="0"/>
+                        <a:t>0.84</a:t>
+                      </a:r>
+                    </a:p>
+                  </a:txBody>
+                  <a:tcPr/>
+                </a:tc>
+                <a:tc>
+                  <a:txBody>
+                    <a:bodyPr/>
+                    <a:lstStyle/>
+                    <a:p>
+                      <a:r>
+                        <a:rPr sz="1200" b="0"/>
+                        <a:t>0.67</a:t>
+                      </a:r>
+                    </a:p>
+                  </a:txBody>
+                  <a:tcPr/>
+                </a:tc>
+                <a:tc>
+                  <a:txBody>
+                    <a:bodyPr/>
+                    <a:lstStyle/>
+                    <a:p>
+                      <a:r>
+                        <a:rPr sz="1200" b="0"/>
+                        <a:t>0.83</a:t>
+                      </a:r>
+                    </a:p>
+                  </a:txBody>
+                  <a:tcPr/>
+                </a:tc>
+                <a:tc>
+                  <a:txBody>
+                    <a:bodyPr/>
+                    <a:lstStyle/>
+                    <a:p>
+                      <a:r>
+                        <a:rPr sz="1200" b="1"/>
+                        <a:t>0.85</a:t>
+                      </a:r>
+                    </a:p>
+                  </a:txBody>
+                  <a:tcPr/>
+                </a:tc>
+              </a:tr>
+            </a:tbl>
+          </a:graphicData>
+        </a:graphic>
+      </p:graphicFrame>
+      <p:sp>
+        <p:nvSpPr>
+          <p:cNvPr id="5" name="TextBox 4"/>
+          <p:cNvSpPr txBox="1"/>
+          <p:nvPr/>
+        </p:nvSpPr>
+        <p:spPr>
+          <a:xfrm>
+            <a:off x="457200" y="3200400"/>
+            <a:ext cx="11247120" cy="3108960"/>
+          </a:xfrm>
+          <a:prstGeom prst="rect">
+            <a:avLst/>
+          </a:prstGeom>
+          <a:noFill/>
+        </p:spPr>
+        <p:txBody>
+          <a:bodyPr wrap="square">
+            <a:spAutoFit/>
+          </a:bodyPr>
+          <a:lstStyle/>
+          <a:p>
+            <a:r>
+              <a:rPr sz="1100"/>
+              <a:t>Fuses the prior gaze detector (GazexSpeaking, 6 features, SAME set all splits) with the LLM rubric markers (4 axes, thinking pass) — consistent feature sets, no per-split cherry-picking.</a:t>
+            </a:r>
+          </a:p>
+          <a:p>
+            <a:r>
+              <a:rPr sz="1100"/>
+              <a:t>Gaze+LLM = BEST detector: All 0.86, Dyads 0.87 (both perm p≈.003) — beats every prior, every single modality, and the old gaze+vad fusion (0.75/0.81). On Dyads it also turns gaze-alone's ns result (p=.083) significant.</a:t>
+            </a:r>
+          </a:p>
+          <a:p>
+            <a:r>
+              <a:rPr sz="1100"/>
+              <a:t>Gaze and rubric-text are COMPLEMENTARY: gaze captures attention / turn-taking, the LLM captures content depth &amp; reasoning — fusing them is additive, not redundant.</a:t>
+            </a:r>
+          </a:p>
+          <a:p>
+            <a:r>
+              <a:rPr sz="1100"/>
+              <a:t>v/a/d affect adds nothing once the LLM is in (All/Dyads: gaze+LLM ≥ gaze+vad+LLM). Only Triads benefits from the full triple (0.85 vs 0.83) — where gaze is weakest, audio still helps.</a:t>
+            </a:r>
+          </a:p>
+          <a:p>
+            <a:r>
+              <a:rPr sz="1100"/>
+              <a:t>Group-level, nested LOSO + permutation, clean 2-annotator labels. LLM = local Qwen3.6-27B (thinking mode; outperforms non-think on the marker features).</a:t>
             </a:r>
           </a:p>
         </p:txBody>

</xml_diff>

<commit_message>
discover(deck): 'What Was Done Since 16 June Meeting' opener slide
Recap slide at position 2 summarizing everything since the 14:00 Tue 06-16
meeting: idea3 LLM-rubric detector + gaze×LLM fusion (best config 0.86/0.87),
methodology-review section, 3-prior+fusion + majority-baseline redo, openSMILE,
Q2 group-TE decouple. Idempotent; orphan-free slide reorder to index 1.
</commit_message>
<xml_diff>
--- a/discover/2026_March_ViLearn_Planning.pptx
+++ b/discover/2026_March_ViLearn_Planning.pptx
@@ -6,6 +6,7 @@
   </p:sldMasterIdLst>
   <p:sldIdLst>
     <p:sldId id="256" r:id="rId3"/>
+    <p:sldId id="282" r:id="rId33"/>
     <p:sldId id="257" r:id="rId4"/>
     <p:sldId id="258" r:id="rId5"/>
     <p:sldId id="259" r:id="rId6"/>
@@ -13189,7 +13190,7 @@
 </file>
 
 <file path=ppt/slides/slide2.xml><?xml version="1.0" encoding="utf-8"?>
-<p:sld xmlns:a="http://schemas.openxmlformats.org/drawingml/2006/main" xmlns:p="http://schemas.openxmlformats.org/presentationml/2006/main" xmlns:r="http://schemas.openxmlformats.org/officeDocument/2006/relationships" xmlns:p14="http://schemas.microsoft.com/office/powerpoint/2010/main" xmlns:p15="http://schemas.microsoft.com/office/powerpoint/2012/main" xmlns:mc="http://schemas.openxmlformats.org/markup-compatibility/2006">
+<p:sld xmlns:a="http://schemas.openxmlformats.org/drawingml/2006/main" xmlns:p="http://schemas.openxmlformats.org/presentationml/2006/main" xmlns:r="http://schemas.openxmlformats.org/officeDocument/2006/relationships">
   <p:cSld>
     <p:spTree>
       <p:nvGrpSpPr>
@@ -13197,41 +13198,10 @@
         <p:cNvGrpSpPr/>
         <p:nvPr/>
       </p:nvGrpSpPr>
-      <p:grpSpPr>
-        <a:xfrm>
-          <a:off x="0" y="0"/>
-          <a:ext cx="0" cy="0"/>
-          <a:chOff x="0" y="0"/>
-          <a:chExt cx="0" cy="0"/>
-        </a:xfrm>
-      </p:grpSpPr>
-      <p:pic>
-        <p:nvPicPr>
-          <p:cNvPr id="63" name="Picture 4" descr="A table with numbers and numbers&#10;&#10;AI-generated content may be incorrect."/>
-          <p:cNvPicPr/>
-          <p:nvPr/>
-        </p:nvPicPr>
-        <p:blipFill>
-          <a:blip r:embed="rId1"/>
-          <a:stretch/>
-        </p:blipFill>
-        <p:spPr>
-          <a:xfrm>
-            <a:off x="261360" y="1180800"/>
-            <a:ext cx="10820160" cy="2428560"/>
-          </a:xfrm>
-          <a:prstGeom prst="rect">
-            <a:avLst/>
-          </a:prstGeom>
-          <a:noFill/>
-          <a:ln w="0">
-            <a:noFill/>
-          </a:ln>
-        </p:spPr>
-      </p:pic>
+      <p:grpSpPr/>
       <p:sp>
         <p:nvSpPr>
-          <p:cNvPr id="64" name="PlaceHolder 1"/>
+          <p:cNvPr id="2" name="Title 1"/>
           <p:cNvSpPr>
             <a:spLocks noGrp="1"/>
           </p:cNvSpPr>
@@ -13239,2398 +13209,44 @@
             <p:ph type="title"/>
           </p:nvPr>
         </p:nvSpPr>
-        <p:spPr>
-          <a:xfrm>
-            <a:off x="838080" y="-128520"/>
-            <a:ext cx="10515240" cy="1325160"/>
-          </a:xfrm>
-          <a:prstGeom prst="rect">
-            <a:avLst/>
-          </a:prstGeom>
-          <a:noFill/>
-          <a:ln w="0">
-            <a:noFill/>
-          </a:ln>
-        </p:spPr>
+        <p:spPr/>
         <p:txBody>
-          <a:bodyPr lIns="91440" tIns="45720" rIns="91440" bIns="45720" anchor="ctr">
-            <a:noAutofit/>
-          </a:bodyPr>
-          <a:p>
-            <a:pPr indent="0" algn="l" defTabSz="914400">
-              <a:lnSpc>
-                <a:spcPct val="90000"/>
-              </a:lnSpc>
-              <a:buNone/>
-            </a:pPr>
-            <a:r>
-              <a:rPr lang="en-GB" sz="4400" b="0" u="none" strike="noStrike">
-                <a:solidFill>
-                  <a:schemeClr val="dk1"/>
-                </a:solidFill>
-                <a:effectLst/>
-                <a:uFillTx/>
-                <a:latin typeface="Aptos Display"/>
-              </a:rPr>
-              <a:t>Results comparison 2026-05-26</a:t>
-            </a:r>
-            <a:endParaRPr lang="en-US" sz="4400" b="0" u="none" strike="noStrike">
-              <a:solidFill>
-                <a:schemeClr val="dk1"/>
-              </a:solidFill>
-              <a:effectLst/>
-              <a:uFillTx/>
-              <a:latin typeface="Aptos Display"/>
-            </a:endParaRPr>
+          <a:bodyPr/>
+          <a:lstStyle/>
+          <a:p>
+            <a:r>
+              <a:t>What Was Done Since the 16 June Meeting</a:t>
+            </a:r>
           </a:p>
         </p:txBody>
       </p:sp>
       <p:sp>
         <p:nvSpPr>
-          <p:cNvPr id="65" name="PlaceHolder 2"/>
+          <p:cNvPr id="3" name="Text Placeholder 2"/>
           <p:cNvSpPr>
             <a:spLocks noGrp="1"/>
           </p:cNvSpPr>
           <p:nvPr>
-            <p:ph/>
+            <p:ph type="body"/>
           </p:nvPr>
         </p:nvSpPr>
-        <p:spPr>
-          <a:xfrm>
-            <a:off x="838080" y="749520"/>
-            <a:ext cx="10515240" cy="584280"/>
-          </a:xfrm>
-          <a:prstGeom prst="rect">
-            <a:avLst/>
-          </a:prstGeom>
-          <a:noFill/>
-          <a:ln w="0">
-            <a:noFill/>
-          </a:ln>
-        </p:spPr>
+        <p:spPr/>
         <p:txBody>
-          <a:bodyPr lIns="91440" tIns="45720" rIns="91440" bIns="45720" anchor="t">
-            <a:normAutofit/>
-          </a:bodyPr>
-          <a:p>
-            <a:pPr marL="228600" indent="-228600" algn="l" defTabSz="914400">
-              <a:lnSpc>
-                <a:spcPct val="90000"/>
-              </a:lnSpc>
-              <a:spcBef>
-                <a:spcPts val="1001"/>
-              </a:spcBef>
-              <a:buClr>
-                <a:srgbClr val="000000"/>
-              </a:buClr>
-              <a:buFont typeface="Arial"/>
-              <a:buChar char="•"/>
-            </a:pPr>
-            <a:r>
-              <a:rPr lang="en-GB" sz="2800" b="0" u="none" strike="noStrike">
-                <a:solidFill>
-                  <a:schemeClr val="dk1"/>
-                </a:solidFill>
-                <a:effectLst/>
-                <a:uFillTx/>
-                <a:latin typeface="Aptos"/>
-              </a:rPr>
-              <a:t>ICMI results (submitted, pending review) - ANOVA</a:t>
-            </a:r>
-            <a:endParaRPr lang="en-US" sz="2800" b="0" u="none" strike="noStrike">
-              <a:solidFill>
-                <a:schemeClr val="dk1"/>
-              </a:solidFill>
-              <a:effectLst/>
-              <a:uFillTx/>
-              <a:latin typeface="Aptos"/>
-            </a:endParaRPr>
-          </a:p>
-          <a:p>
-            <a:pPr indent="0" algn="l" defTabSz="914400">
-              <a:lnSpc>
-                <a:spcPct val="90000"/>
-              </a:lnSpc>
-              <a:spcBef>
-                <a:spcPts val="1001"/>
-              </a:spcBef>
-              <a:buNone/>
-            </a:pPr>
-            <a:endParaRPr lang="en-US" sz="2800" b="0" u="none" strike="noStrike">
-              <a:solidFill>
-                <a:schemeClr val="dk1"/>
-              </a:solidFill>
-              <a:effectLst/>
-              <a:uFillTx/>
-              <a:latin typeface="Aptos"/>
-            </a:endParaRPr>
-          </a:p>
+          <a:bodyPr/>
+          <a:lstStyle/>
+          <a:p/>
         </p:txBody>
       </p:sp>
       <p:sp>
         <p:nvSpPr>
-          <p:cNvPr id="66" name="Content Placeholder 2"/>
-          <p:cNvSpPr/>
-          <p:nvPr/>
-        </p:nvSpPr>
-        <p:spPr>
-          <a:xfrm>
-            <a:off x="566280" y="3697560"/>
-            <a:ext cx="10515240" cy="584280"/>
-          </a:xfrm>
-          <a:prstGeom prst="rect">
-            <a:avLst/>
-          </a:prstGeom>
-          <a:noFill/>
-          <a:ln w="0">
-            <a:noFill/>
-          </a:ln>
-        </p:spPr>
-        <p:style>
-          <a:lnRef idx="0"/>
-          <a:fillRef idx="0"/>
-          <a:effectRef idx="0"/>
-          <a:fontRef idx="minor"/>
-        </p:style>
-        <p:txBody>
-          <a:bodyPr anchor="t">
-            <a:normAutofit/>
-          </a:bodyPr>
-          <a:p>
-            <a:pPr marL="228600" indent="-228600" defTabSz="914400">
-              <a:lnSpc>
-                <a:spcPct val="90000"/>
-              </a:lnSpc>
-              <a:spcBef>
-                <a:spcPts val="1001"/>
-              </a:spcBef>
-              <a:buClr>
-                <a:srgbClr val="000000"/>
-              </a:buClr>
-              <a:buFont typeface="Arial"/>
-              <a:buChar char="•"/>
-            </a:pPr>
-            <a:r>
-              <a:rPr lang="en-GB" sz="2800" b="0" u="none" strike="noStrike">
-                <a:solidFill>
-                  <a:schemeClr val="dk1"/>
-                </a:solidFill>
-                <a:effectLst/>
-                <a:uFillTx/>
-                <a:latin typeface="Aptos"/>
-              </a:rPr>
-              <a:t>New results – Multiple Paired t-tests</a:t>
-            </a:r>
-            <a:endParaRPr lang="en-US" sz="2800" b="0" u="none" strike="noStrike">
-              <a:solidFill>
-                <a:srgbClr val="000000"/>
-              </a:solidFill>
-              <a:effectLst/>
-              <a:uFillTx/>
-              <a:latin typeface="Arial"/>
-            </a:endParaRPr>
-          </a:p>
-        </p:txBody>
-      </p:sp>
-      <p:graphicFrame>
-        <p:nvGraphicFramePr>
-          <p:cNvPr id="67" name="Table 5"/>
-          <p:cNvGraphicFramePr/>
-          <p:nvPr/>
-        </p:nvGraphicFramePr>
-        <p:xfrm>
-          <a:off x="565200" y="4157280"/>
-          <a:ext cx="10663200" cy="2288520"/>
-        </p:xfrm>
-        <a:graphic>
-          <a:graphicData uri="http://schemas.openxmlformats.org/drawingml/2006/table">
-            <a:tbl>
-              <a:tblPr/>
-              <a:tblGrid>
-                <a:gridCol w="1834560"/>
-                <a:gridCol w="1471320"/>
-                <a:gridCol w="1471320"/>
-                <a:gridCol w="1471320"/>
-                <a:gridCol w="1471320"/>
-                <a:gridCol w="1471320"/>
-                <a:gridCol w="1471320"/>
-              </a:tblGrid>
-              <a:tr h="627840">
-                <a:tc>
-                  <a:txBody>
-                    <a:bodyPr lIns="0" tIns="0" rIns="0" bIns="0" anchor="ctr">
-                      <a:noAutofit/>
-                    </a:bodyPr>
-                    <a:p>
-                      <a:endParaRPr lang="en-US" sz="1800" b="0" u="none" strike="noStrike">
-                        <a:solidFill>
-                          <a:schemeClr val="dk1"/>
-                        </a:solidFill>
-                        <a:effectLst/>
-                        <a:uFillTx/>
-                        <a:latin typeface="Aptos"/>
-                      </a:endParaRPr>
-                    </a:p>
-                  </a:txBody>
-                  <a:tcPr anchor="ctr" marL="0" marR="0" marT="0" marB="0">
-                    <a:lnL>
-                      <a:noFill/>
-                    </a:lnL>
-                    <a:lnR w="12240">
-                      <a:solidFill>
-                        <a:srgbClr val="000000"/>
-                      </a:solidFill>
-                      <a:prstDash val="solid"/>
-                    </a:lnR>
-                    <a:lnT>
-                      <a:noFill/>
-                    </a:lnT>
-                    <a:lnB>
-                      <a:noFill/>
-                    </a:lnB>
-                    <a:noFill/>
-                  </a:tcPr>
-                </a:tc>
-                <a:tc gridSpan="2">
-                  <a:txBody>
-                    <a:bodyPr lIns="0" tIns="0" rIns="0" bIns="0" anchor="ctr">
-                      <a:noAutofit/>
-                    </a:bodyPr>
-                    <a:p>
-                      <a:pPr algn="ctr" defTabSz="914400">
-                        <a:lnSpc>
-                          <a:spcPct val="100000"/>
-                        </a:lnSpc>
-                      </a:pPr>
-                      <a:r>
-                        <a:rPr lang="en-US" sz="1800" b="1" u="none" strike="noStrike">
-                          <a:solidFill>
-                            <a:schemeClr val="dk1"/>
-                          </a:solidFill>
-                          <a:effectLst/>
-                          <a:uFillTx/>
-                          <a:latin typeface="Aptos"/>
-                        </a:rPr>
-                        <a:t>D-GazexSpeaking</a:t>
-                      </a:r>
-                      <a:endParaRPr lang="en-US" sz="1800" b="0" u="none" strike="noStrike">
-                        <a:solidFill>
-                          <a:srgbClr val="000000"/>
-                        </a:solidFill>
-                        <a:effectLst/>
-                        <a:uFillTx/>
-                        <a:latin typeface="Arial"/>
-                      </a:endParaRPr>
-                    </a:p>
-                  </a:txBody>
-                  <a:tcPr anchor="ctr" marL="0" marR="0" marT="0" marB="0">
-                    <a:lnL w="12240">
-                      <a:solidFill>
-                        <a:srgbClr val="000000"/>
-                      </a:solidFill>
-                      <a:prstDash val="solid"/>
-                    </a:lnL>
-                    <a:lnR w="12240">
-                      <a:solidFill>
-                        <a:srgbClr val="000000"/>
-                      </a:solidFill>
-                      <a:prstDash val="solid"/>
-                    </a:lnR>
-                    <a:lnT w="12240">
-                      <a:solidFill>
-                        <a:srgbClr val="000000"/>
-                      </a:solidFill>
-                      <a:prstDash val="solid"/>
-                    </a:lnT>
-                    <a:lnB w="12240">
-                      <a:solidFill>
-                        <a:srgbClr val="000000"/>
-                      </a:solidFill>
-                      <a:prstDash val="solid"/>
-                    </a:lnB>
-                    <a:noFill/>
-                  </a:tcPr>
-                </a:tc>
-                <a:tc hMerge="1">
-                  <a:txBody>
-                    <a:bodyPr lIns="90000" tIns="45000" rIns="90000" bIns="45000" anchor="t">
-                      <a:noAutofit/>
-                    </a:bodyPr>
-                    <a:p>
-                      <a:endParaRPr lang="en-US" sz="1800" b="0" u="none" strike="noStrike">
-                        <a:solidFill>
-                          <a:srgbClr val="000000"/>
-                        </a:solidFill>
-                        <a:effectLst/>
-                        <a:uFillTx/>
-                        <a:latin typeface="Arial"/>
-                      </a:endParaRPr>
-                    </a:p>
-                  </a:txBody>
-                  <a:tcPr anchor="t" marL="90000" marR="90000" marT="45000" marB="45000">
-                    <a:lnL>
-                      <a:noFill/>
-                    </a:lnL>
-                    <a:lnR>
-                      <a:noFill/>
-                    </a:lnR>
-                    <a:lnT>
-                      <a:noFill/>
-                    </a:lnT>
-                    <a:lnB>
-                      <a:noFill/>
-                    </a:lnB>
-                    <a:solidFill>
-                      <a:srgbClr val="729FCF"/>
-                    </a:solidFill>
-                  </a:tcPr>
-                </a:tc>
-                <a:tc gridSpan="2">
-                  <a:txBody>
-                    <a:bodyPr lIns="0" tIns="0" rIns="0" bIns="0" anchor="ctr">
-                      <a:noAutofit/>
-                    </a:bodyPr>
-                    <a:p>
-                      <a:pPr algn="ctr" defTabSz="914400">
-                        <a:lnSpc>
-                          <a:spcPct val="100000"/>
-                        </a:lnSpc>
-                      </a:pPr>
-                      <a:r>
-                        <a:rPr lang="en-US" sz="1800" b="1" u="none" strike="noStrike">
-                          <a:solidFill>
-                            <a:schemeClr val="dk1"/>
-                          </a:solidFill>
-                          <a:effectLst/>
-                          <a:uFillTx/>
-                          <a:latin typeface="Aptos"/>
-                        </a:rPr>
-                        <a:t>T-GazexSpeaking</a:t>
-                      </a:r>
-                      <a:endParaRPr lang="en-US" sz="1800" b="0" u="none" strike="noStrike">
-                        <a:solidFill>
-                          <a:srgbClr val="000000"/>
-                        </a:solidFill>
-                        <a:effectLst/>
-                        <a:uFillTx/>
-                        <a:latin typeface="Arial"/>
-                      </a:endParaRPr>
-                    </a:p>
-                  </a:txBody>
-                  <a:tcPr anchor="ctr" marL="0" marR="0" marT="0" marB="0">
-                    <a:lnL w="12240">
-                      <a:solidFill>
-                        <a:srgbClr val="000000"/>
-                      </a:solidFill>
-                      <a:prstDash val="solid"/>
-                    </a:lnL>
-                    <a:lnR w="12240">
-                      <a:solidFill>
-                        <a:srgbClr val="000000"/>
-                      </a:solidFill>
-                      <a:prstDash val="solid"/>
-                    </a:lnR>
-                    <a:lnT w="12240">
-                      <a:solidFill>
-                        <a:srgbClr val="000000"/>
-                      </a:solidFill>
-                      <a:prstDash val="solid"/>
-                    </a:lnT>
-                    <a:lnB w="12240">
-                      <a:solidFill>
-                        <a:srgbClr val="000000"/>
-                      </a:solidFill>
-                      <a:prstDash val="solid"/>
-                    </a:lnB>
-                    <a:noFill/>
-                  </a:tcPr>
-                </a:tc>
-                <a:tc hMerge="1">
-                  <a:txBody>
-                    <a:bodyPr lIns="90000" tIns="45000" rIns="90000" bIns="45000" anchor="t">
-                      <a:noAutofit/>
-                    </a:bodyPr>
-                    <a:p>
-                      <a:endParaRPr lang="en-US" sz="1800" b="0" u="none" strike="noStrike">
-                        <a:solidFill>
-                          <a:srgbClr val="000000"/>
-                        </a:solidFill>
-                        <a:effectLst/>
-                        <a:uFillTx/>
-                        <a:latin typeface="Arial"/>
-                      </a:endParaRPr>
-                    </a:p>
-                  </a:txBody>
-                  <a:tcPr anchor="t" marL="90000" marR="90000" marT="45000" marB="45000">
-                    <a:lnL>
-                      <a:noFill/>
-                    </a:lnL>
-                    <a:lnR>
-                      <a:noFill/>
-                    </a:lnR>
-                    <a:lnT>
-                      <a:noFill/>
-                    </a:lnT>
-                    <a:lnB>
-                      <a:noFill/>
-                    </a:lnB>
-                    <a:solidFill>
-                      <a:srgbClr val="729FCF"/>
-                    </a:solidFill>
-                  </a:tcPr>
-                </a:tc>
-                <a:tc gridSpan="2">
-                  <a:txBody>
-                    <a:bodyPr lIns="0" tIns="0" rIns="0" bIns="0" anchor="ctr">
-                      <a:noAutofit/>
-                    </a:bodyPr>
-                    <a:p>
-                      <a:pPr algn="ctr" defTabSz="914400">
-                        <a:lnSpc>
-                          <a:spcPct val="100000"/>
-                        </a:lnSpc>
-                      </a:pPr>
-                      <a:r>
-                        <a:rPr lang="en-US" sz="1800" b="1" u="none" strike="noStrike">
-                          <a:solidFill>
-                            <a:schemeClr val="dk1"/>
-                          </a:solidFill>
-                          <a:effectLst/>
-                          <a:uFillTx/>
-                          <a:latin typeface="Aptos"/>
-                        </a:rPr>
-                        <a:t>All-GazexSpeaking</a:t>
-                      </a:r>
-                      <a:endParaRPr lang="en-US" sz="1800" b="0" u="none" strike="noStrike">
-                        <a:solidFill>
-                          <a:srgbClr val="000000"/>
-                        </a:solidFill>
-                        <a:effectLst/>
-                        <a:uFillTx/>
-                        <a:latin typeface="Arial"/>
-                      </a:endParaRPr>
-                    </a:p>
-                  </a:txBody>
-                  <a:tcPr anchor="ctr" marL="0" marR="0" marT="0" marB="0">
-                    <a:lnL w="12240">
-                      <a:solidFill>
-                        <a:srgbClr val="000000"/>
-                      </a:solidFill>
-                      <a:prstDash val="solid"/>
-                    </a:lnL>
-                    <a:lnR w="12240">
-                      <a:solidFill>
-                        <a:srgbClr val="000000"/>
-                      </a:solidFill>
-                      <a:prstDash val="solid"/>
-                    </a:lnR>
-                    <a:lnT w="12240">
-                      <a:solidFill>
-                        <a:srgbClr val="000000"/>
-                      </a:solidFill>
-                      <a:prstDash val="solid"/>
-                    </a:lnT>
-                    <a:lnB w="12240">
-                      <a:solidFill>
-                        <a:srgbClr val="000000"/>
-                      </a:solidFill>
-                      <a:prstDash val="solid"/>
-                    </a:lnB>
-                    <a:noFill/>
-                  </a:tcPr>
-                </a:tc>
-                <a:tc hMerge="1">
-                  <a:txBody>
-                    <a:bodyPr lIns="90000" tIns="45000" rIns="90000" bIns="45000" anchor="t">
-                      <a:noAutofit/>
-                    </a:bodyPr>
-                    <a:p>
-                      <a:endParaRPr lang="en-US" sz="1800" b="0" u="none" strike="noStrike">
-                        <a:solidFill>
-                          <a:srgbClr val="000000"/>
-                        </a:solidFill>
-                        <a:effectLst/>
-                        <a:uFillTx/>
-                        <a:latin typeface="Arial"/>
-                      </a:endParaRPr>
-                    </a:p>
-                  </a:txBody>
-                  <a:tcPr anchor="t" marL="90000" marR="90000" marT="45000" marB="45000">
-                    <a:lnL>
-                      <a:noFill/>
-                    </a:lnL>
-                    <a:lnR>
-                      <a:noFill/>
-                    </a:lnR>
-                    <a:lnT>
-                      <a:noFill/>
-                    </a:lnT>
-                    <a:lnB>
-                      <a:noFill/>
-                    </a:lnB>
-                    <a:solidFill>
-                      <a:srgbClr val="729FCF"/>
-                    </a:solidFill>
-                  </a:tcPr>
-                </a:tc>
-              </a:tr>
-              <a:tr h="261360">
-                <a:tc>
-                  <a:txBody>
-                    <a:bodyPr lIns="0" tIns="0" rIns="0" bIns="0" anchor="ctr">
-                      <a:noAutofit/>
-                    </a:bodyPr>
-                    <a:p>
-                      <a:endParaRPr lang="en-US" sz="1800" b="0" u="none" strike="noStrike">
-                        <a:solidFill>
-                          <a:schemeClr val="dk1"/>
-                        </a:solidFill>
-                        <a:effectLst/>
-                        <a:uFillTx/>
-                        <a:latin typeface="Aptos"/>
-                      </a:endParaRPr>
-                    </a:p>
-                  </a:txBody>
-                  <a:tcPr anchor="ctr" marL="0" marR="0" marT="0" marB="0">
-                    <a:lnL>
-                      <a:noFill/>
-                    </a:lnL>
-                    <a:lnR w="12240">
-                      <a:solidFill>
-                        <a:srgbClr val="000000"/>
-                      </a:solidFill>
-                      <a:prstDash val="solid"/>
-                    </a:lnR>
-                    <a:lnT>
-                      <a:noFill/>
-                    </a:lnT>
-                    <a:lnB w="12240">
-                      <a:solidFill>
-                        <a:srgbClr val="000000"/>
-                      </a:solidFill>
-                      <a:prstDash val="solid"/>
-                    </a:lnB>
-                    <a:noFill/>
-                  </a:tcPr>
-                </a:tc>
-                <a:tc>
-                  <a:txBody>
-                    <a:bodyPr lIns="0" tIns="0" rIns="0" bIns="0" anchor="ctr">
-                      <a:noAutofit/>
-                    </a:bodyPr>
-                    <a:p>
-                      <a:pPr algn="ctr" defTabSz="914400">
-                        <a:lnSpc>
-                          <a:spcPct val="100000"/>
-                        </a:lnSpc>
-                      </a:pPr>
-                      <a:r>
-                        <a:rPr lang="en-US" sz="1800" b="1" u="none" strike="noStrike">
-                          <a:solidFill>
-                            <a:schemeClr val="dk1"/>
-                          </a:solidFill>
-                          <a:effectLst/>
-                          <a:uFillTx/>
-                          <a:latin typeface="Aptos"/>
-                        </a:rPr>
-                        <a:t>M</a:t>
-                      </a:r>
-                      <a:endParaRPr lang="en-US" sz="1800" b="0" u="none" strike="noStrike">
-                        <a:solidFill>
-                          <a:srgbClr val="000000"/>
-                        </a:solidFill>
-                        <a:effectLst/>
-                        <a:uFillTx/>
-                        <a:latin typeface="Arial"/>
-                      </a:endParaRPr>
-                    </a:p>
-                  </a:txBody>
-                  <a:tcPr anchor="ctr" marL="0" marR="0" marT="0" marB="0">
-                    <a:lnL w="12240">
-                      <a:solidFill>
-                        <a:srgbClr val="000000"/>
-                      </a:solidFill>
-                      <a:prstDash val="solid"/>
-                    </a:lnL>
-                    <a:lnR w="12240">
-                      <a:solidFill>
-                        <a:srgbClr val="000000"/>
-                      </a:solidFill>
-                      <a:prstDash val="solid"/>
-                    </a:lnR>
-                    <a:lnT w="12240">
-                      <a:solidFill>
-                        <a:srgbClr val="000000"/>
-                      </a:solidFill>
-                      <a:prstDash val="solid"/>
-                    </a:lnT>
-                    <a:lnB w="12240">
-                      <a:solidFill>
-                        <a:srgbClr val="000000"/>
-                      </a:solidFill>
-                      <a:prstDash val="solid"/>
-                    </a:lnB>
-                    <a:noFill/>
-                  </a:tcPr>
-                </a:tc>
-                <a:tc>
-                  <a:txBody>
-                    <a:bodyPr lIns="0" tIns="0" rIns="0" bIns="0" anchor="ctr">
-                      <a:noAutofit/>
-                    </a:bodyPr>
-                    <a:p>
-                      <a:pPr algn="ctr" defTabSz="914400">
-                        <a:lnSpc>
-                          <a:spcPct val="100000"/>
-                        </a:lnSpc>
-                      </a:pPr>
-                      <a:r>
-                        <a:rPr lang="en-US" sz="1800" b="1" u="none" strike="noStrike">
-                          <a:solidFill>
-                            <a:schemeClr val="dk1"/>
-                          </a:solidFill>
-                          <a:effectLst/>
-                          <a:uFillTx/>
-                          <a:latin typeface="Aptos"/>
-                        </a:rPr>
-                        <a:t>SD</a:t>
-                      </a:r>
-                      <a:endParaRPr lang="en-US" sz="1800" b="0" u="none" strike="noStrike">
-                        <a:solidFill>
-                          <a:srgbClr val="000000"/>
-                        </a:solidFill>
-                        <a:effectLst/>
-                        <a:uFillTx/>
-                        <a:latin typeface="Arial"/>
-                      </a:endParaRPr>
-                    </a:p>
-                  </a:txBody>
-                  <a:tcPr anchor="ctr" marL="0" marR="0" marT="0" marB="0">
-                    <a:lnL w="12240">
-                      <a:solidFill>
-                        <a:srgbClr val="000000"/>
-                      </a:solidFill>
-                      <a:prstDash val="solid"/>
-                    </a:lnL>
-                    <a:lnR w="12240">
-                      <a:solidFill>
-                        <a:srgbClr val="000000"/>
-                      </a:solidFill>
-                      <a:prstDash val="solid"/>
-                    </a:lnR>
-                    <a:lnT w="12240">
-                      <a:solidFill>
-                        <a:srgbClr val="000000"/>
-                      </a:solidFill>
-                      <a:prstDash val="solid"/>
-                    </a:lnT>
-                    <a:lnB w="12240">
-                      <a:solidFill>
-                        <a:srgbClr val="000000"/>
-                      </a:solidFill>
-                      <a:prstDash val="solid"/>
-                    </a:lnB>
-                    <a:noFill/>
-                  </a:tcPr>
-                </a:tc>
-                <a:tc>
-                  <a:txBody>
-                    <a:bodyPr lIns="0" tIns="0" rIns="0" bIns="0" anchor="ctr">
-                      <a:noAutofit/>
-                    </a:bodyPr>
-                    <a:p>
-                      <a:pPr algn="ctr" defTabSz="914400">
-                        <a:lnSpc>
-                          <a:spcPct val="100000"/>
-                        </a:lnSpc>
-                      </a:pPr>
-                      <a:r>
-                        <a:rPr lang="en-US" sz="1800" b="1" u="none" strike="noStrike">
-                          <a:solidFill>
-                            <a:schemeClr val="dk1"/>
-                          </a:solidFill>
-                          <a:effectLst/>
-                          <a:uFillTx/>
-                          <a:latin typeface="Aptos"/>
-                        </a:rPr>
-                        <a:t>M</a:t>
-                      </a:r>
-                      <a:endParaRPr lang="en-US" sz="1800" b="0" u="none" strike="noStrike">
-                        <a:solidFill>
-                          <a:srgbClr val="000000"/>
-                        </a:solidFill>
-                        <a:effectLst/>
-                        <a:uFillTx/>
-                        <a:latin typeface="Arial"/>
-                      </a:endParaRPr>
-                    </a:p>
-                  </a:txBody>
-                  <a:tcPr anchor="ctr" marL="0" marR="0" marT="0" marB="0">
-                    <a:lnL w="12240">
-                      <a:solidFill>
-                        <a:srgbClr val="000000"/>
-                      </a:solidFill>
-                      <a:prstDash val="solid"/>
-                    </a:lnL>
-                    <a:lnR w="12240">
-                      <a:solidFill>
-                        <a:srgbClr val="000000"/>
-                      </a:solidFill>
-                      <a:prstDash val="solid"/>
-                    </a:lnR>
-                    <a:lnT w="12240">
-                      <a:solidFill>
-                        <a:srgbClr val="000000"/>
-                      </a:solidFill>
-                      <a:prstDash val="solid"/>
-                    </a:lnT>
-                    <a:lnB w="12240">
-                      <a:solidFill>
-                        <a:srgbClr val="000000"/>
-                      </a:solidFill>
-                      <a:prstDash val="solid"/>
-                    </a:lnB>
-                    <a:noFill/>
-                  </a:tcPr>
-                </a:tc>
-                <a:tc>
-                  <a:txBody>
-                    <a:bodyPr lIns="0" tIns="0" rIns="0" bIns="0" anchor="ctr">
-                      <a:noAutofit/>
-                    </a:bodyPr>
-                    <a:p>
-                      <a:pPr algn="ctr" defTabSz="914400">
-                        <a:lnSpc>
-                          <a:spcPct val="100000"/>
-                        </a:lnSpc>
-                      </a:pPr>
-                      <a:r>
-                        <a:rPr lang="en-US" sz="1800" b="1" u="none" strike="noStrike">
-                          <a:solidFill>
-                            <a:schemeClr val="dk1"/>
-                          </a:solidFill>
-                          <a:effectLst/>
-                          <a:uFillTx/>
-                          <a:latin typeface="Aptos"/>
-                        </a:rPr>
-                        <a:t>SD</a:t>
-                      </a:r>
-                      <a:endParaRPr lang="en-US" sz="1800" b="0" u="none" strike="noStrike">
-                        <a:solidFill>
-                          <a:srgbClr val="000000"/>
-                        </a:solidFill>
-                        <a:effectLst/>
-                        <a:uFillTx/>
-                        <a:latin typeface="Arial"/>
-                      </a:endParaRPr>
-                    </a:p>
-                  </a:txBody>
-                  <a:tcPr anchor="ctr" marL="0" marR="0" marT="0" marB="0">
-                    <a:lnL w="12240">
-                      <a:solidFill>
-                        <a:srgbClr val="000000"/>
-                      </a:solidFill>
-                      <a:prstDash val="solid"/>
-                    </a:lnL>
-                    <a:lnR w="12240">
-                      <a:solidFill>
-                        <a:srgbClr val="000000"/>
-                      </a:solidFill>
-                      <a:prstDash val="solid"/>
-                    </a:lnR>
-                    <a:lnT w="12240">
-                      <a:solidFill>
-                        <a:srgbClr val="000000"/>
-                      </a:solidFill>
-                      <a:prstDash val="solid"/>
-                    </a:lnT>
-                    <a:lnB w="12240">
-                      <a:solidFill>
-                        <a:srgbClr val="000000"/>
-                      </a:solidFill>
-                      <a:prstDash val="solid"/>
-                    </a:lnB>
-                    <a:noFill/>
-                  </a:tcPr>
-                </a:tc>
-                <a:tc>
-                  <a:txBody>
-                    <a:bodyPr lIns="0" tIns="0" rIns="0" bIns="0" anchor="ctr">
-                      <a:noAutofit/>
-                    </a:bodyPr>
-                    <a:p>
-                      <a:pPr algn="ctr" defTabSz="914400">
-                        <a:lnSpc>
-                          <a:spcPct val="100000"/>
-                        </a:lnSpc>
-                      </a:pPr>
-                      <a:r>
-                        <a:rPr lang="en-US" sz="1800" b="1" u="none" strike="noStrike">
-                          <a:solidFill>
-                            <a:schemeClr val="dk1"/>
-                          </a:solidFill>
-                          <a:effectLst/>
-                          <a:uFillTx/>
-                          <a:latin typeface="Aptos"/>
-                        </a:rPr>
-                        <a:t>M</a:t>
-                      </a:r>
-                      <a:endParaRPr lang="en-US" sz="1800" b="0" u="none" strike="noStrike">
-                        <a:solidFill>
-                          <a:srgbClr val="000000"/>
-                        </a:solidFill>
-                        <a:effectLst/>
-                        <a:uFillTx/>
-                        <a:latin typeface="Arial"/>
-                      </a:endParaRPr>
-                    </a:p>
-                  </a:txBody>
-                  <a:tcPr anchor="ctr" marL="0" marR="0" marT="0" marB="0">
-                    <a:lnL w="12240">
-                      <a:solidFill>
-                        <a:srgbClr val="000000"/>
-                      </a:solidFill>
-                      <a:prstDash val="solid"/>
-                    </a:lnL>
-                    <a:lnR w="12240">
-                      <a:solidFill>
-                        <a:srgbClr val="000000"/>
-                      </a:solidFill>
-                      <a:prstDash val="solid"/>
-                    </a:lnR>
-                    <a:lnT w="12240">
-                      <a:solidFill>
-                        <a:srgbClr val="000000"/>
-                      </a:solidFill>
-                      <a:prstDash val="solid"/>
-                    </a:lnT>
-                    <a:lnB w="12240">
-                      <a:solidFill>
-                        <a:srgbClr val="000000"/>
-                      </a:solidFill>
-                      <a:prstDash val="solid"/>
-                    </a:lnB>
-                    <a:noFill/>
-                  </a:tcPr>
-                </a:tc>
-                <a:tc>
-                  <a:txBody>
-                    <a:bodyPr lIns="0" tIns="0" rIns="0" bIns="0" anchor="ctr">
-                      <a:noAutofit/>
-                    </a:bodyPr>
-                    <a:p>
-                      <a:pPr algn="ctr" defTabSz="914400">
-                        <a:lnSpc>
-                          <a:spcPct val="100000"/>
-                        </a:lnSpc>
-                      </a:pPr>
-                      <a:r>
-                        <a:rPr lang="en-US" sz="1800" b="1" u="none" strike="noStrike">
-                          <a:solidFill>
-                            <a:schemeClr val="dk1"/>
-                          </a:solidFill>
-                          <a:effectLst/>
-                          <a:uFillTx/>
-                          <a:latin typeface="Aptos"/>
-                        </a:rPr>
-                        <a:t>SD</a:t>
-                      </a:r>
-                      <a:endParaRPr lang="en-US" sz="1800" b="0" u="none" strike="noStrike">
-                        <a:solidFill>
-                          <a:srgbClr val="000000"/>
-                        </a:solidFill>
-                        <a:effectLst/>
-                        <a:uFillTx/>
-                        <a:latin typeface="Arial"/>
-                      </a:endParaRPr>
-                    </a:p>
-                  </a:txBody>
-                  <a:tcPr anchor="ctr" marL="0" marR="0" marT="0" marB="0">
-                    <a:lnL w="12240">
-                      <a:solidFill>
-                        <a:srgbClr val="000000"/>
-                      </a:solidFill>
-                      <a:prstDash val="solid"/>
-                    </a:lnL>
-                    <a:lnR w="12240">
-                      <a:solidFill>
-                        <a:srgbClr val="000000"/>
-                      </a:solidFill>
-                      <a:prstDash val="solid"/>
-                    </a:lnR>
-                    <a:lnT w="12240">
-                      <a:solidFill>
-                        <a:srgbClr val="000000"/>
-                      </a:solidFill>
-                      <a:prstDash val="solid"/>
-                    </a:lnT>
-                    <a:lnB w="12240">
-                      <a:solidFill>
-                        <a:srgbClr val="000000"/>
-                      </a:solidFill>
-                      <a:prstDash val="solid"/>
-                    </a:lnB>
-                    <a:noFill/>
-                  </a:tcPr>
-                </a:tc>
-              </a:tr>
-              <a:tr h="418320">
-                <a:tc>
-                  <a:txBody>
-                    <a:bodyPr lIns="0" tIns="0" rIns="0" bIns="0" anchor="ctr">
-                      <a:noAutofit/>
-                    </a:bodyPr>
-                    <a:p>
-                      <a:r>
-                        <a:rPr sz="1800" b="1"/>
-                        <a:t>Majority baseline</a:t>
-                      </a:r>
-                    </a:p>
-                  </a:txBody>
-                  <a:tcPr anchor="ctr" marL="0" marR="0" marT="0" marB="0">
-                    <a:lnL w="12240">
-                      <a:solidFill>
-                        <a:srgbClr val="000000"/>
-                      </a:solidFill>
-                      <a:prstDash val="solid"/>
-                    </a:lnL>
-                    <a:lnR w="12240">
-                      <a:solidFill>
-                        <a:srgbClr val="000000"/>
-                      </a:solidFill>
-                      <a:prstDash val="solid"/>
-                    </a:lnR>
-                    <a:lnT w="12240">
-                      <a:solidFill>
-                        <a:srgbClr val="000000"/>
-                      </a:solidFill>
-                      <a:prstDash val="solid"/>
-                    </a:lnT>
-                    <a:lnB w="12240">
-                      <a:solidFill>
-                        <a:srgbClr val="000000"/>
-                      </a:solidFill>
-                      <a:prstDash val="solid"/>
-                    </a:lnB>
-                    <a:noFill/>
-                  </a:tcPr>
-                </a:tc>
-                <a:tc>
-                  <a:txBody>
-                    <a:bodyPr lIns="0" tIns="0" rIns="0" bIns="0" anchor="ctr">
-                      <a:noAutofit/>
-                    </a:bodyPr>
-                    <a:p>
-                      <a:r>
-                        <a:rPr sz="1800" b="0"/>
-                        <a:t>0.60</a:t>
-                      </a:r>
-                    </a:p>
-                  </a:txBody>
-                  <a:tcPr anchor="ctr" marL="0" marR="0" marT="0" marB="0">
-                    <a:lnL w="12240">
-                      <a:solidFill>
-                        <a:srgbClr val="000000"/>
-                      </a:solidFill>
-                      <a:prstDash val="solid"/>
-                    </a:lnL>
-                    <a:lnR w="12240">
-                      <a:solidFill>
-                        <a:srgbClr val="000000"/>
-                      </a:solidFill>
-                      <a:prstDash val="solid"/>
-                    </a:lnR>
-                    <a:lnT w="12240">
-                      <a:solidFill>
-                        <a:srgbClr val="000000"/>
-                      </a:solidFill>
-                      <a:prstDash val="solid"/>
-                    </a:lnT>
-                    <a:lnB w="12240">
-                      <a:solidFill>
-                        <a:srgbClr val="000000"/>
-                      </a:solidFill>
-                      <a:prstDash val="solid"/>
-                    </a:lnB>
-                    <a:noFill/>
-                  </a:tcPr>
-                </a:tc>
-                <a:tc>
-                  <a:txBody>
-                    <a:bodyPr lIns="0" tIns="0" rIns="0" bIns="0" anchor="ctr">
-                      <a:noAutofit/>
-                    </a:bodyPr>
-                    <a:p>
-                      <a:r>
-                        <a:rPr sz="1800" b="0"/>
-                        <a:t>—</a:t>
-                      </a:r>
-                    </a:p>
-                  </a:txBody>
-                  <a:tcPr anchor="ctr" marL="0" marR="0" marT="0" marB="0">
-                    <a:lnL w="12240">
-                      <a:solidFill>
-                        <a:srgbClr val="000000"/>
-                      </a:solidFill>
-                      <a:prstDash val="solid"/>
-                    </a:lnL>
-                    <a:lnR w="12240">
-                      <a:solidFill>
-                        <a:srgbClr val="000000"/>
-                      </a:solidFill>
-                      <a:prstDash val="solid"/>
-                    </a:lnR>
-                    <a:lnT w="12240">
-                      <a:solidFill>
-                        <a:srgbClr val="000000"/>
-                      </a:solidFill>
-                      <a:prstDash val="solid"/>
-                    </a:lnT>
-                    <a:lnB w="12240">
-                      <a:solidFill>
-                        <a:srgbClr val="000000"/>
-                      </a:solidFill>
-                      <a:prstDash val="solid"/>
-                    </a:lnB>
-                    <a:noFill/>
-                  </a:tcPr>
-                </a:tc>
-                <a:tc>
-                  <a:txBody>
-                    <a:bodyPr lIns="0" tIns="0" rIns="0" bIns="0" anchor="ctr">
-                      <a:noAutofit/>
-                    </a:bodyPr>
-                    <a:p>
-                      <a:r>
-                        <a:rPr sz="1800" b="0"/>
-                        <a:t>0.54</a:t>
-                      </a:r>
-                    </a:p>
-                  </a:txBody>
-                  <a:tcPr anchor="ctr" marL="0" marR="0" marT="0" marB="0">
-                    <a:lnL w="12240">
-                      <a:solidFill>
-                        <a:srgbClr val="000000"/>
-                      </a:solidFill>
-                      <a:prstDash val="solid"/>
-                    </a:lnL>
-                    <a:lnR w="12240">
-                      <a:solidFill>
-                        <a:srgbClr val="000000"/>
-                      </a:solidFill>
-                      <a:prstDash val="solid"/>
-                    </a:lnR>
-                    <a:lnT w="12240">
-                      <a:solidFill>
-                        <a:srgbClr val="000000"/>
-                      </a:solidFill>
-                      <a:prstDash val="solid"/>
-                    </a:lnT>
-                    <a:lnB w="12240">
-                      <a:solidFill>
-                        <a:srgbClr val="000000"/>
-                      </a:solidFill>
-                      <a:prstDash val="solid"/>
-                    </a:lnB>
-                    <a:noFill/>
-                  </a:tcPr>
-                </a:tc>
-                <a:tc>
-                  <a:txBody>
-                    <a:bodyPr lIns="0" tIns="0" rIns="0" bIns="0" anchor="ctr">
-                      <a:noAutofit/>
-                    </a:bodyPr>
-                    <a:p>
-                      <a:r>
-                        <a:rPr sz="1800" b="0"/>
-                        <a:t>—</a:t>
-                      </a:r>
-                    </a:p>
-                  </a:txBody>
-                  <a:tcPr anchor="ctr" marL="0" marR="0" marT="0" marB="0">
-                    <a:lnL w="12240">
-                      <a:solidFill>
-                        <a:srgbClr val="000000"/>
-                      </a:solidFill>
-                      <a:prstDash val="solid"/>
-                    </a:lnL>
-                    <a:lnR w="12240">
-                      <a:solidFill>
-                        <a:srgbClr val="000000"/>
-                      </a:solidFill>
-                      <a:prstDash val="solid"/>
-                    </a:lnR>
-                    <a:lnT w="12240">
-                      <a:solidFill>
-                        <a:srgbClr val="000000"/>
-                      </a:solidFill>
-                      <a:prstDash val="solid"/>
-                    </a:lnT>
-                    <a:lnB w="12240">
-                      <a:solidFill>
-                        <a:srgbClr val="000000"/>
-                      </a:solidFill>
-                      <a:prstDash val="solid"/>
-                    </a:lnB>
-                    <a:noFill/>
-                  </a:tcPr>
-                </a:tc>
-                <a:tc>
-                  <a:txBody>
-                    <a:bodyPr lIns="0" tIns="0" rIns="0" bIns="0" anchor="ctr">
-                      <a:noAutofit/>
-                    </a:bodyPr>
-                    <a:p>
-                      <a:r>
-                        <a:rPr sz="1800" b="0"/>
-                        <a:t>0.52</a:t>
-                      </a:r>
-                    </a:p>
-                  </a:txBody>
-                  <a:tcPr anchor="ctr" marL="0" marR="0" marT="0" marB="0">
-                    <a:lnL w="12240">
-                      <a:solidFill>
-                        <a:srgbClr val="000000"/>
-                      </a:solidFill>
-                      <a:prstDash val="solid"/>
-                    </a:lnL>
-                    <a:lnR w="12240">
-                      <a:solidFill>
-                        <a:srgbClr val="000000"/>
-                      </a:solidFill>
-                      <a:prstDash val="solid"/>
-                    </a:lnR>
-                    <a:lnT w="12240">
-                      <a:solidFill>
-                        <a:srgbClr val="000000"/>
-                      </a:solidFill>
-                      <a:prstDash val="solid"/>
-                    </a:lnT>
-                    <a:lnB w="12240">
-                      <a:solidFill>
-                        <a:srgbClr val="000000"/>
-                      </a:solidFill>
-                      <a:prstDash val="solid"/>
-                    </a:lnB>
-                    <a:noFill/>
-                  </a:tcPr>
-                </a:tc>
-                <a:tc>
-                  <a:txBody>
-                    <a:bodyPr lIns="0" tIns="0" rIns="0" bIns="0" anchor="ctr">
-                      <a:noAutofit/>
-                    </a:bodyPr>
-                    <a:p>
-                      <a:r>
-                        <a:rPr sz="1800" b="0"/>
-                        <a:t>—</a:t>
-                      </a:r>
-                    </a:p>
-                  </a:txBody>
-                  <a:tcPr anchor="ctr" marL="0" marR="0" marT="0" marB="0">
-                    <a:lnL w="12240">
-                      <a:solidFill>
-                        <a:srgbClr val="000000"/>
-                      </a:solidFill>
-                      <a:prstDash val="solid"/>
-                    </a:lnL>
-                    <a:lnR w="12240">
-                      <a:solidFill>
-                        <a:srgbClr val="000000"/>
-                      </a:solidFill>
-                      <a:prstDash val="solid"/>
-                    </a:lnR>
-                    <a:lnT w="12240">
-                      <a:solidFill>
-                        <a:srgbClr val="000000"/>
-                      </a:solidFill>
-                      <a:prstDash val="solid"/>
-                    </a:lnT>
-                    <a:lnB w="12240">
-                      <a:solidFill>
-                        <a:srgbClr val="000000"/>
-                      </a:solidFill>
-                      <a:prstDash val="solid"/>
-                    </a:lnB>
-                    <a:noFill/>
-                  </a:tcPr>
-                </a:tc>
-              </a:tr>
-              <a:tr h="261360">
-                <a:tc>
-                  <a:txBody>
-                    <a:bodyPr lIns="0" tIns="0" rIns="0" bIns="0" anchor="ctr">
-                      <a:noAutofit/>
-                    </a:bodyPr>
-                    <a:p>
-                      <a:pPr defTabSz="914400">
-                        <a:lnSpc>
-                          <a:spcPct val="100000"/>
-                        </a:lnSpc>
-                      </a:pPr>
-                      <a:r>
-                        <a:rPr lang="en-US" sz="1800" b="1" u="none" strike="noStrike">
-                          <a:solidFill>
-                            <a:schemeClr val="dk1"/>
-                          </a:solidFill>
-                          <a:effectLst/>
-                          <a:uFillTx/>
-                          <a:latin typeface="Aptos"/>
-                        </a:rPr>
-                        <a:t>SVM</a:t>
-                      </a:r>
-                      <a:endParaRPr lang="en-US" sz="1800" b="0" u="none" strike="noStrike">
-                        <a:solidFill>
-                          <a:srgbClr val="000000"/>
-                        </a:solidFill>
-                        <a:effectLst/>
-                        <a:uFillTx/>
-                        <a:latin typeface="Arial"/>
-                      </a:endParaRPr>
-                    </a:p>
-                  </a:txBody>
-                  <a:tcPr anchor="ctr" marL="0" marR="0" marT="0" marB="0">
-                    <a:lnL w="12240">
-                      <a:solidFill>
-                        <a:srgbClr val="000000"/>
-                      </a:solidFill>
-                      <a:prstDash val="solid"/>
-                    </a:lnL>
-                    <a:lnR w="12240">
-                      <a:solidFill>
-                        <a:srgbClr val="000000"/>
-                      </a:solidFill>
-                      <a:prstDash val="solid"/>
-                    </a:lnR>
-                    <a:lnT w="12240">
-                      <a:solidFill>
-                        <a:srgbClr val="000000"/>
-                      </a:solidFill>
-                      <a:prstDash val="solid"/>
-                    </a:lnT>
-                    <a:lnB w="12240">
-                      <a:solidFill>
-                        <a:srgbClr val="000000"/>
-                      </a:solidFill>
-                      <a:prstDash val="solid"/>
-                    </a:lnB>
-                    <a:noFill/>
-                  </a:tcPr>
-                </a:tc>
-                <a:tc>
-                  <a:txBody>
-                    <a:bodyPr lIns="0" tIns="0" rIns="0" bIns="0" anchor="ctr">
-                      <a:noAutofit/>
-                    </a:bodyPr>
-                    <a:p>
-                      <a:r>
-                        <a:rPr sz="1800" b="0"/>
-                        <a:t>0.83</a:t>
-                      </a:r>
-                    </a:p>
-                  </a:txBody>
-                  <a:tcPr anchor="ctr" marL="0" marR="0" marT="0" marB="0">
-                    <a:lnL w="12240">
-                      <a:solidFill>
-                        <a:srgbClr val="000000"/>
-                      </a:solidFill>
-                      <a:prstDash val="solid"/>
-                    </a:lnL>
-                    <a:lnR w="12240">
-                      <a:solidFill>
-                        <a:srgbClr val="000000"/>
-                      </a:solidFill>
-                      <a:prstDash val="solid"/>
-                    </a:lnR>
-                    <a:lnT w="12240">
-                      <a:solidFill>
-                        <a:srgbClr val="000000"/>
-                      </a:solidFill>
-                      <a:prstDash val="solid"/>
-                    </a:lnT>
-                    <a:lnB w="12240">
-                      <a:solidFill>
-                        <a:srgbClr val="000000"/>
-                      </a:solidFill>
-                      <a:prstDash val="solid"/>
-                    </a:lnB>
-                    <a:noFill/>
-                  </a:tcPr>
-                </a:tc>
-                <a:tc>
-                  <a:txBody>
-                    <a:bodyPr lIns="0" tIns="0" rIns="0" bIns="0" anchor="ctr">
-                      <a:noAutofit/>
-                    </a:bodyPr>
-                    <a:p>
-                      <a:r>
-                        <a:rPr sz="1800" b="0"/>
-                        <a:t>—</a:t>
-                      </a:r>
-                    </a:p>
-                  </a:txBody>
-                  <a:tcPr anchor="ctr" marL="0" marR="0" marT="0" marB="0">
-                    <a:lnL w="12240">
-                      <a:solidFill>
-                        <a:srgbClr val="000000"/>
-                      </a:solidFill>
-                      <a:prstDash val="solid"/>
-                    </a:lnL>
-                    <a:lnR w="12240">
-                      <a:solidFill>
-                        <a:srgbClr val="000000"/>
-                      </a:solidFill>
-                      <a:prstDash val="solid"/>
-                    </a:lnR>
-                    <a:lnT w="12240">
-                      <a:solidFill>
-                        <a:srgbClr val="000000"/>
-                      </a:solidFill>
-                      <a:prstDash val="solid"/>
-                    </a:lnT>
-                    <a:lnB w="12240">
-                      <a:solidFill>
-                        <a:srgbClr val="000000"/>
-                      </a:solidFill>
-                      <a:prstDash val="solid"/>
-                    </a:lnB>
-                    <a:noFill/>
-                  </a:tcPr>
-                </a:tc>
-                <a:tc>
-                  <a:txBody>
-                    <a:bodyPr lIns="0" tIns="0" rIns="0" bIns="0" anchor="ctr">
-                      <a:noAutofit/>
-                    </a:bodyPr>
-                    <a:p>
-                      <a:r>
-                        <a:rPr sz="1800" b="1"/>
-                        <a:t>0.56</a:t>
-                      </a:r>
-                    </a:p>
-                  </a:txBody>
-                  <a:tcPr anchor="ctr" marL="0" marR="0" marT="0" marB="0">
-                    <a:lnL w="12240">
-                      <a:solidFill>
-                        <a:srgbClr val="000000"/>
-                      </a:solidFill>
-                      <a:prstDash val="solid"/>
-                    </a:lnL>
-                    <a:lnR w="12240">
-                      <a:solidFill>
-                        <a:srgbClr val="000000"/>
-                      </a:solidFill>
-                      <a:prstDash val="solid"/>
-                    </a:lnR>
-                    <a:lnT w="12240">
-                      <a:solidFill>
-                        <a:srgbClr val="000000"/>
-                      </a:solidFill>
-                      <a:prstDash val="solid"/>
-                    </a:lnT>
-                    <a:lnB w="12240">
-                      <a:solidFill>
-                        <a:srgbClr val="000000"/>
-                      </a:solidFill>
-                      <a:prstDash val="solid"/>
-                    </a:lnB>
-                    <a:noFill/>
-                  </a:tcPr>
-                </a:tc>
-                <a:tc>
-                  <a:txBody>
-                    <a:bodyPr lIns="0" tIns="0" rIns="0" bIns="0" anchor="ctr">
-                      <a:noAutofit/>
-                    </a:bodyPr>
-                    <a:p>
-                      <a:r>
-                        <a:rPr sz="1800" b="1"/>
-                        <a:t>—</a:t>
-                      </a:r>
-                    </a:p>
-                  </a:txBody>
-                  <a:tcPr anchor="ctr" marL="0" marR="0" marT="0" marB="0">
-                    <a:lnL w="12240">
-                      <a:solidFill>
-                        <a:srgbClr val="000000"/>
-                      </a:solidFill>
-                      <a:prstDash val="solid"/>
-                    </a:lnL>
-                    <a:lnR w="12240">
-                      <a:solidFill>
-                        <a:srgbClr val="000000"/>
-                      </a:solidFill>
-                      <a:prstDash val="solid"/>
-                    </a:lnR>
-                    <a:lnT w="12240">
-                      <a:solidFill>
-                        <a:srgbClr val="000000"/>
-                      </a:solidFill>
-                      <a:prstDash val="solid"/>
-                    </a:lnT>
-                    <a:lnB w="12240">
-                      <a:solidFill>
-                        <a:srgbClr val="000000"/>
-                      </a:solidFill>
-                      <a:prstDash val="solid"/>
-                    </a:lnB>
-                    <a:noFill/>
-                  </a:tcPr>
-                </a:tc>
-                <a:tc>
-                  <a:txBody>
-                    <a:bodyPr lIns="0" tIns="0" rIns="0" bIns="0" anchor="ctr">
-                      <a:noAutofit/>
-                    </a:bodyPr>
-                    <a:p>
-                      <a:r>
-                        <a:rPr sz="1800" b="1"/>
-                        <a:t>0.73</a:t>
-                      </a:r>
-                    </a:p>
-                  </a:txBody>
-                  <a:tcPr anchor="ctr" marL="0" marR="0" marT="0" marB="0">
-                    <a:lnL w="12240">
-                      <a:solidFill>
-                        <a:srgbClr val="000000"/>
-                      </a:solidFill>
-                      <a:prstDash val="solid"/>
-                    </a:lnL>
-                    <a:lnR w="12240">
-                      <a:solidFill>
-                        <a:srgbClr val="000000"/>
-                      </a:solidFill>
-                      <a:prstDash val="solid"/>
-                    </a:lnR>
-                    <a:lnT w="12240">
-                      <a:solidFill>
-                        <a:srgbClr val="000000"/>
-                      </a:solidFill>
-                      <a:prstDash val="solid"/>
-                    </a:lnT>
-                    <a:lnB w="12240">
-                      <a:solidFill>
-                        <a:srgbClr val="000000"/>
-                      </a:solidFill>
-                      <a:prstDash val="solid"/>
-                    </a:lnB>
-                    <a:noFill/>
-                  </a:tcPr>
-                </a:tc>
-                <a:tc>
-                  <a:txBody>
-                    <a:bodyPr lIns="0" tIns="0" rIns="0" bIns="0" anchor="ctr">
-                      <a:noAutofit/>
-                    </a:bodyPr>
-                    <a:p>
-                      <a:r>
-                        <a:rPr sz="1800" b="1"/>
-                        <a:t>—</a:t>
-                      </a:r>
-                    </a:p>
-                  </a:txBody>
-                  <a:tcPr anchor="ctr" marL="0" marR="0" marT="0" marB="0">
-                    <a:lnL w="12240">
-                      <a:solidFill>
-                        <a:srgbClr val="000000"/>
-                      </a:solidFill>
-                      <a:prstDash val="solid"/>
-                    </a:lnL>
-                    <a:lnR w="12240">
-                      <a:solidFill>
-                        <a:srgbClr val="000000"/>
-                      </a:solidFill>
-                      <a:prstDash val="solid"/>
-                    </a:lnR>
-                    <a:lnT w="12240">
-                      <a:solidFill>
-                        <a:srgbClr val="000000"/>
-                      </a:solidFill>
-                      <a:prstDash val="solid"/>
-                    </a:lnT>
-                    <a:lnB w="12240">
-                      <a:solidFill>
-                        <a:srgbClr val="000000"/>
-                      </a:solidFill>
-                      <a:prstDash val="solid"/>
-                    </a:lnB>
-                    <a:noFill/>
-                  </a:tcPr>
-                </a:tc>
-              </a:tr>
-              <a:tr h="418320">
-                <a:tc>
-                  <a:txBody>
-                    <a:bodyPr lIns="0" tIns="0" rIns="0" bIns="0" anchor="ctr">
-                      <a:noAutofit/>
-                    </a:bodyPr>
-                    <a:p>
-                      <a:pPr defTabSz="914400">
-                        <a:lnSpc>
-                          <a:spcPct val="100000"/>
-                        </a:lnSpc>
-                      </a:pPr>
-                      <a:r>
-                        <a:rPr lang="en-US" sz="1800" b="1" u="none" strike="noStrike">
-                          <a:solidFill>
-                            <a:schemeClr val="dk1"/>
-                          </a:solidFill>
-                          <a:effectLst/>
-                          <a:uFillTx/>
-                          <a:latin typeface="Aptos"/>
-                        </a:rPr>
-                        <a:t>Naive Bayes</a:t>
-                      </a:r>
-                      <a:endParaRPr lang="en-US" sz="1800" b="0" u="none" strike="noStrike">
-                        <a:solidFill>
-                          <a:srgbClr val="000000"/>
-                        </a:solidFill>
-                        <a:effectLst/>
-                        <a:uFillTx/>
-                        <a:latin typeface="Arial"/>
-                      </a:endParaRPr>
-                    </a:p>
-                  </a:txBody>
-                  <a:tcPr anchor="ctr" marL="0" marR="0" marT="0" marB="0">
-                    <a:lnL w="12240">
-                      <a:solidFill>
-                        <a:srgbClr val="000000"/>
-                      </a:solidFill>
-                      <a:prstDash val="solid"/>
-                    </a:lnL>
-                    <a:lnR w="12240">
-                      <a:solidFill>
-                        <a:srgbClr val="000000"/>
-                      </a:solidFill>
-                      <a:prstDash val="solid"/>
-                    </a:lnR>
-                    <a:lnT w="12240">
-                      <a:solidFill>
-                        <a:srgbClr val="000000"/>
-                      </a:solidFill>
-                      <a:prstDash val="solid"/>
-                    </a:lnT>
-                    <a:lnB w="12240">
-                      <a:solidFill>
-                        <a:srgbClr val="000000"/>
-                      </a:solidFill>
-                      <a:prstDash val="solid"/>
-                    </a:lnB>
-                    <a:noFill/>
-                  </a:tcPr>
-                </a:tc>
-                <a:tc>
-                  <a:txBody>
-                    <a:bodyPr lIns="0" tIns="0" rIns="0" bIns="0" anchor="ctr">
-                      <a:noAutofit/>
-                    </a:bodyPr>
-                    <a:p>
-                      <a:r>
-                        <a:rPr sz="1800" b="0"/>
-                        <a:t>0.72</a:t>
-                      </a:r>
-                    </a:p>
-                  </a:txBody>
-                  <a:tcPr anchor="ctr" marL="0" marR="0" marT="0" marB="0">
-                    <a:lnL w="12240">
-                      <a:solidFill>
-                        <a:srgbClr val="000000"/>
-                      </a:solidFill>
-                      <a:prstDash val="solid"/>
-                    </a:lnL>
-                    <a:lnR w="12240">
-                      <a:solidFill>
-                        <a:srgbClr val="000000"/>
-                      </a:solidFill>
-                      <a:prstDash val="solid"/>
-                    </a:lnR>
-                    <a:lnT w="12240">
-                      <a:solidFill>
-                        <a:srgbClr val="000000"/>
-                      </a:solidFill>
-                      <a:prstDash val="solid"/>
-                    </a:lnT>
-                    <a:lnB w="12240">
-                      <a:solidFill>
-                        <a:srgbClr val="000000"/>
-                      </a:solidFill>
-                      <a:prstDash val="solid"/>
-                    </a:lnB>
-                    <a:noFill/>
-                  </a:tcPr>
-                </a:tc>
-                <a:tc>
-                  <a:txBody>
-                    <a:bodyPr lIns="0" tIns="0" rIns="0" bIns="0" anchor="ctr">
-                      <a:noAutofit/>
-                    </a:bodyPr>
-                    <a:p>
-                      <a:r>
-                        <a:rPr sz="1800" b="0"/>
-                        <a:t>—</a:t>
-                      </a:r>
-                    </a:p>
-                  </a:txBody>
-                  <a:tcPr anchor="ctr" marL="0" marR="0" marT="0" marB="0">
-                    <a:lnL w="12240">
-                      <a:solidFill>
-                        <a:srgbClr val="000000"/>
-                      </a:solidFill>
-                      <a:prstDash val="solid"/>
-                    </a:lnL>
-                    <a:lnR w="12240">
-                      <a:solidFill>
-                        <a:srgbClr val="000000"/>
-                      </a:solidFill>
-                      <a:prstDash val="solid"/>
-                    </a:lnR>
-                    <a:lnT w="12240">
-                      <a:solidFill>
-                        <a:srgbClr val="000000"/>
-                      </a:solidFill>
-                      <a:prstDash val="solid"/>
-                    </a:lnT>
-                    <a:lnB w="12240">
-                      <a:solidFill>
-                        <a:srgbClr val="000000"/>
-                      </a:solidFill>
-                      <a:prstDash val="solid"/>
-                    </a:lnB>
-                    <a:noFill/>
-                  </a:tcPr>
-                </a:tc>
-                <a:tc>
-                  <a:txBody>
-                    <a:bodyPr lIns="0" tIns="0" rIns="0" bIns="0" anchor="ctr">
-                      <a:noAutofit/>
-                    </a:bodyPr>
-                    <a:p>
-                      <a:r>
-                        <a:rPr sz="1800" b="1"/>
-                        <a:t>0.70</a:t>
-                      </a:r>
-                    </a:p>
-                  </a:txBody>
-                  <a:tcPr anchor="ctr" marL="0" marR="0" marT="0" marB="0">
-                    <a:lnL w="12240">
-                      <a:solidFill>
-                        <a:srgbClr val="000000"/>
-                      </a:solidFill>
-                      <a:prstDash val="solid"/>
-                    </a:lnL>
-                    <a:lnR w="12240">
-                      <a:solidFill>
-                        <a:srgbClr val="000000"/>
-                      </a:solidFill>
-                      <a:prstDash val="solid"/>
-                    </a:lnR>
-                    <a:lnT w="12240">
-                      <a:solidFill>
-                        <a:srgbClr val="000000"/>
-                      </a:solidFill>
-                      <a:prstDash val="solid"/>
-                    </a:lnT>
-                    <a:lnB w="12240">
-                      <a:solidFill>
-                        <a:srgbClr val="000000"/>
-                      </a:solidFill>
-                      <a:prstDash val="solid"/>
-                    </a:lnB>
-                    <a:noFill/>
-                  </a:tcPr>
-                </a:tc>
-                <a:tc>
-                  <a:txBody>
-                    <a:bodyPr lIns="0" tIns="0" rIns="0" bIns="0" anchor="ctr">
-                      <a:noAutofit/>
-                    </a:bodyPr>
-                    <a:p>
-                      <a:r>
-                        <a:rPr sz="1800" b="1"/>
-                        <a:t>—</a:t>
-                      </a:r>
-                    </a:p>
-                  </a:txBody>
-                  <a:tcPr anchor="ctr" marL="0" marR="0" marT="0" marB="0">
-                    <a:lnL w="12240">
-                      <a:solidFill>
-                        <a:srgbClr val="000000"/>
-                      </a:solidFill>
-                      <a:prstDash val="solid"/>
-                    </a:lnL>
-                    <a:lnR w="12240">
-                      <a:solidFill>
-                        <a:srgbClr val="000000"/>
-                      </a:solidFill>
-                      <a:prstDash val="solid"/>
-                    </a:lnR>
-                    <a:lnT w="12240">
-                      <a:solidFill>
-                        <a:srgbClr val="000000"/>
-                      </a:solidFill>
-                      <a:prstDash val="solid"/>
-                    </a:lnT>
-                    <a:lnB w="12240">
-                      <a:solidFill>
-                        <a:srgbClr val="000000"/>
-                      </a:solidFill>
-                      <a:prstDash val="solid"/>
-                    </a:lnB>
-                    <a:noFill/>
-                  </a:tcPr>
-                </a:tc>
-                <a:tc>
-                  <a:txBody>
-                    <a:bodyPr lIns="0" tIns="0" rIns="0" bIns="0" anchor="ctr">
-                      <a:noAutofit/>
-                    </a:bodyPr>
-                    <a:p>
-                      <a:r>
-                        <a:rPr sz="1800" b="0"/>
-                        <a:t>0.71</a:t>
-                      </a:r>
-                    </a:p>
-                  </a:txBody>
-                  <a:tcPr anchor="ctr" marL="0" marR="0" marT="0" marB="0">
-                    <a:lnL w="12240">
-                      <a:solidFill>
-                        <a:srgbClr val="000000"/>
-                      </a:solidFill>
-                      <a:prstDash val="solid"/>
-                    </a:lnL>
-                    <a:lnR w="12240">
-                      <a:solidFill>
-                        <a:srgbClr val="000000"/>
-                      </a:solidFill>
-                      <a:prstDash val="solid"/>
-                    </a:lnR>
-                    <a:lnT w="12240">
-                      <a:solidFill>
-                        <a:srgbClr val="000000"/>
-                      </a:solidFill>
-                      <a:prstDash val="solid"/>
-                    </a:lnT>
-                    <a:lnB w="12240">
-                      <a:solidFill>
-                        <a:srgbClr val="000000"/>
-                      </a:solidFill>
-                      <a:prstDash val="solid"/>
-                    </a:lnB>
-                    <a:noFill/>
-                  </a:tcPr>
-                </a:tc>
-                <a:tc>
-                  <a:txBody>
-                    <a:bodyPr lIns="0" tIns="0" rIns="0" bIns="0" anchor="ctr">
-                      <a:noAutofit/>
-                    </a:bodyPr>
-                    <a:p>
-                      <a:r>
-                        <a:rPr sz="1800" b="0"/>
-                        <a:t>—</a:t>
-                      </a:r>
-                    </a:p>
-                  </a:txBody>
-                  <a:tcPr anchor="ctr" marL="0" marR="0" marT="0" marB="0">
-                    <a:lnL w="12240">
-                      <a:solidFill>
-                        <a:srgbClr val="000000"/>
-                      </a:solidFill>
-                      <a:prstDash val="solid"/>
-                    </a:lnL>
-                    <a:lnR w="12240">
-                      <a:solidFill>
-                        <a:srgbClr val="000000"/>
-                      </a:solidFill>
-                      <a:prstDash val="solid"/>
-                    </a:lnR>
-                    <a:lnT w="12240">
-                      <a:solidFill>
-                        <a:srgbClr val="000000"/>
-                      </a:solidFill>
-                      <a:prstDash val="solid"/>
-                    </a:lnT>
-                    <a:lnB w="12240">
-                      <a:solidFill>
-                        <a:srgbClr val="000000"/>
-                      </a:solidFill>
-                      <a:prstDash val="solid"/>
-                    </a:lnB>
-                    <a:noFill/>
-                  </a:tcPr>
-                </a:tc>
-              </a:tr>
-              <a:tr h="261360">
-                <a:tc>
-                  <a:txBody>
-                    <a:bodyPr lIns="0" tIns="0" rIns="0" bIns="0" anchor="ctr">
-                      <a:noAutofit/>
-                    </a:bodyPr>
-                    <a:p>
-                      <a:pPr defTabSz="914400">
-                        <a:lnSpc>
-                          <a:spcPct val="100000"/>
-                        </a:lnSpc>
-                      </a:pPr>
-                      <a:r>
-                        <a:rPr lang="en-US" sz="1800" b="1" u="none" strike="noStrike">
-                          <a:solidFill>
-                            <a:schemeClr val="dk1"/>
-                          </a:solidFill>
-                          <a:effectLst/>
-                          <a:uFillTx/>
-                          <a:latin typeface="Aptos"/>
-                        </a:rPr>
-                        <a:t>QDA</a:t>
-                      </a:r>
-                      <a:endParaRPr lang="en-US" sz="1800" b="0" u="none" strike="noStrike">
-                        <a:solidFill>
-                          <a:srgbClr val="000000"/>
-                        </a:solidFill>
-                        <a:effectLst/>
-                        <a:uFillTx/>
-                        <a:latin typeface="Arial"/>
-                      </a:endParaRPr>
-                    </a:p>
-                  </a:txBody>
-                  <a:tcPr anchor="ctr" marL="0" marR="0" marT="0" marB="0">
-                    <a:lnL w="12240">
-                      <a:solidFill>
-                        <a:srgbClr val="000000"/>
-                      </a:solidFill>
-                      <a:prstDash val="solid"/>
-                    </a:lnL>
-                    <a:lnR w="12240">
-                      <a:solidFill>
-                        <a:srgbClr val="000000"/>
-                      </a:solidFill>
-                      <a:prstDash val="solid"/>
-                    </a:lnR>
-                    <a:lnT w="12240">
-                      <a:solidFill>
-                        <a:srgbClr val="000000"/>
-                      </a:solidFill>
-                      <a:prstDash val="solid"/>
-                    </a:lnT>
-                    <a:lnB w="12240">
-                      <a:solidFill>
-                        <a:srgbClr val="000000"/>
-                      </a:solidFill>
-                      <a:prstDash val="solid"/>
-                    </a:lnB>
-                    <a:noFill/>
-                  </a:tcPr>
-                </a:tc>
-                <a:tc>
-                  <a:txBody>
-                    <a:bodyPr lIns="0" tIns="0" rIns="0" bIns="0" anchor="ctr">
-                      <a:noAutofit/>
-                    </a:bodyPr>
-                    <a:p>
-                      <a:r>
-                        <a:rPr sz="1800" b="0"/>
-                        <a:t>0.77</a:t>
-                      </a:r>
-                    </a:p>
-                  </a:txBody>
-                  <a:tcPr anchor="ctr" marL="0" marR="0" marT="0" marB="0">
-                    <a:lnL w="12240">
-                      <a:solidFill>
-                        <a:srgbClr val="000000"/>
-                      </a:solidFill>
-                      <a:prstDash val="solid"/>
-                    </a:lnL>
-                    <a:lnR w="12240">
-                      <a:solidFill>
-                        <a:srgbClr val="000000"/>
-                      </a:solidFill>
-                      <a:prstDash val="solid"/>
-                    </a:lnR>
-                    <a:lnT w="12240">
-                      <a:solidFill>
-                        <a:srgbClr val="000000"/>
-                      </a:solidFill>
-                      <a:prstDash val="solid"/>
-                    </a:lnT>
-                    <a:lnB w="12240">
-                      <a:solidFill>
-                        <a:srgbClr val="000000"/>
-                      </a:solidFill>
-                      <a:prstDash val="solid"/>
-                    </a:lnB>
-                    <a:noFill/>
-                  </a:tcPr>
-                </a:tc>
-                <a:tc>
-                  <a:txBody>
-                    <a:bodyPr lIns="0" tIns="0" rIns="0" bIns="0" anchor="ctr">
-                      <a:noAutofit/>
-                    </a:bodyPr>
-                    <a:p>
-                      <a:r>
-                        <a:rPr sz="1800" b="0"/>
-                        <a:t>—</a:t>
-                      </a:r>
-                    </a:p>
-                  </a:txBody>
-                  <a:tcPr anchor="ctr" marL="0" marR="0" marT="0" marB="0">
-                    <a:lnL w="12240">
-                      <a:solidFill>
-                        <a:srgbClr val="000000"/>
-                      </a:solidFill>
-                      <a:prstDash val="solid"/>
-                    </a:lnL>
-                    <a:lnR w="12240">
-                      <a:solidFill>
-                        <a:srgbClr val="000000"/>
-                      </a:solidFill>
-                      <a:prstDash val="solid"/>
-                    </a:lnR>
-                    <a:lnT w="12240">
-                      <a:solidFill>
-                        <a:srgbClr val="000000"/>
-                      </a:solidFill>
-                      <a:prstDash val="solid"/>
-                    </a:lnT>
-                    <a:lnB w="12240">
-                      <a:solidFill>
-                        <a:srgbClr val="000000"/>
-                      </a:solidFill>
-                      <a:prstDash val="solid"/>
-                    </a:lnB>
-                    <a:noFill/>
-                  </a:tcPr>
-                </a:tc>
-                <a:tc>
-                  <a:txBody>
-                    <a:bodyPr lIns="0" tIns="0" rIns="0" bIns="0" anchor="ctr">
-                      <a:noAutofit/>
-                    </a:bodyPr>
-                    <a:p>
-                      <a:r>
-                        <a:rPr sz="1800" b="0"/>
-                        <a:t>0.65</a:t>
-                      </a:r>
-                    </a:p>
-                  </a:txBody>
-                  <a:tcPr anchor="ctr" marL="0" marR="0" marT="0" marB="0">
-                    <a:lnL w="12240">
-                      <a:solidFill>
-                        <a:srgbClr val="000000"/>
-                      </a:solidFill>
-                      <a:prstDash val="solid"/>
-                    </a:lnL>
-                    <a:lnR w="12240">
-                      <a:solidFill>
-                        <a:srgbClr val="000000"/>
-                      </a:solidFill>
-                      <a:prstDash val="solid"/>
-                    </a:lnR>
-                    <a:lnT w="12240">
-                      <a:solidFill>
-                        <a:srgbClr val="000000"/>
-                      </a:solidFill>
-                      <a:prstDash val="solid"/>
-                    </a:lnT>
-                    <a:lnB w="12240">
-                      <a:solidFill>
-                        <a:srgbClr val="000000"/>
-                      </a:solidFill>
-                      <a:prstDash val="solid"/>
-                    </a:lnB>
-                    <a:noFill/>
-                  </a:tcPr>
-                </a:tc>
-                <a:tc>
-                  <a:txBody>
-                    <a:bodyPr lIns="0" tIns="0" rIns="0" bIns="0" anchor="ctr">
-                      <a:noAutofit/>
-                    </a:bodyPr>
-                    <a:p>
-                      <a:r>
-                        <a:rPr sz="1800" b="0"/>
-                        <a:t>—</a:t>
-                      </a:r>
-                    </a:p>
-                  </a:txBody>
-                  <a:tcPr anchor="ctr" marL="0" marR="0" marT="0" marB="0">
-                    <a:lnL w="12240">
-                      <a:solidFill>
-                        <a:srgbClr val="000000"/>
-                      </a:solidFill>
-                      <a:prstDash val="solid"/>
-                    </a:lnL>
-                    <a:lnR w="12240">
-                      <a:solidFill>
-                        <a:srgbClr val="000000"/>
-                      </a:solidFill>
-                      <a:prstDash val="solid"/>
-                    </a:lnR>
-                    <a:lnT w="12240">
-                      <a:solidFill>
-                        <a:srgbClr val="000000"/>
-                      </a:solidFill>
-                      <a:prstDash val="solid"/>
-                    </a:lnT>
-                    <a:lnB w="12240">
-                      <a:solidFill>
-                        <a:srgbClr val="000000"/>
-                      </a:solidFill>
-                      <a:prstDash val="solid"/>
-                    </a:lnB>
-                    <a:noFill/>
-                  </a:tcPr>
-                </a:tc>
-                <a:tc>
-                  <a:txBody>
-                    <a:bodyPr lIns="0" tIns="0" rIns="0" bIns="0" anchor="ctr">
-                      <a:noAutofit/>
-                    </a:bodyPr>
-                    <a:p>
-                      <a:r>
-                        <a:rPr sz="1800" b="1"/>
-                        <a:t>0.73</a:t>
-                      </a:r>
-                    </a:p>
-                  </a:txBody>
-                  <a:tcPr anchor="ctr" marL="0" marR="0" marT="0" marB="0">
-                    <a:lnL w="12240">
-                      <a:solidFill>
-                        <a:srgbClr val="000000"/>
-                      </a:solidFill>
-                      <a:prstDash val="solid"/>
-                    </a:lnL>
-                    <a:lnR w="12240">
-                      <a:solidFill>
-                        <a:srgbClr val="000000"/>
-                      </a:solidFill>
-                      <a:prstDash val="solid"/>
-                    </a:lnR>
-                    <a:lnT w="12240">
-                      <a:solidFill>
-                        <a:srgbClr val="000000"/>
-                      </a:solidFill>
-                      <a:prstDash val="solid"/>
-                    </a:lnT>
-                    <a:lnB w="12240">
-                      <a:solidFill>
-                        <a:srgbClr val="000000"/>
-                      </a:solidFill>
-                      <a:prstDash val="solid"/>
-                    </a:lnB>
-                    <a:noFill/>
-                  </a:tcPr>
-                </a:tc>
-                <a:tc>
-                  <a:txBody>
-                    <a:bodyPr lIns="0" tIns="0" rIns="0" bIns="0" anchor="ctr">
-                      <a:noAutofit/>
-                    </a:bodyPr>
-                    <a:p>
-                      <a:r>
-                        <a:rPr sz="1800" b="1"/>
-                        <a:t>—</a:t>
-                      </a:r>
-                    </a:p>
-                  </a:txBody>
-                  <a:tcPr anchor="ctr" marL="0" marR="0" marT="0" marB="0">
-                    <a:lnL w="12240">
-                      <a:solidFill>
-                        <a:srgbClr val="000000"/>
-                      </a:solidFill>
-                      <a:prstDash val="solid"/>
-                    </a:lnL>
-                    <a:lnR w="12240">
-                      <a:solidFill>
-                        <a:srgbClr val="000000"/>
-                      </a:solidFill>
-                      <a:prstDash val="solid"/>
-                    </a:lnR>
-                    <a:lnT w="12240">
-                      <a:solidFill>
-                        <a:srgbClr val="000000"/>
-                      </a:solidFill>
-                      <a:prstDash val="solid"/>
-                    </a:lnT>
-                    <a:lnB w="12240">
-                      <a:solidFill>
-                        <a:srgbClr val="000000"/>
-                      </a:solidFill>
-                      <a:prstDash val="solid"/>
-                    </a:lnB>
-                    <a:noFill/>
-                  </a:tcPr>
-                </a:tc>
-              </a:tr>
-            </a:tbl>
-          </a:graphicData>
-        </a:graphic>
-      </p:graphicFrame>
-      <p:sp>
-        <p:nvSpPr>
-          <p:cNvPr id="68" name="Rectangle 7"/>
-          <p:cNvSpPr/>
-          <p:nvPr/>
-        </p:nvSpPr>
-        <p:spPr>
-          <a:xfrm>
-            <a:off x="2334240" y="2386800"/>
-            <a:ext cx="1803960" cy="310680"/>
-          </a:xfrm>
-          <a:prstGeom prst="rect">
-            <a:avLst/>
-          </a:prstGeom>
-          <a:noFill/>
-          <a:ln w="28575">
-            <a:solidFill>
-              <a:srgbClr val="C00000"/>
-            </a:solidFill>
-          </a:ln>
-        </p:spPr>
-        <p:style>
-          <a:lnRef idx="2">
-            <a:schemeClr val="accent1">
-              <a:shade val="15000"/>
-            </a:schemeClr>
-          </a:lnRef>
-          <a:fillRef idx="1">
-            <a:schemeClr val="accent1"/>
-          </a:fillRef>
-          <a:effectRef idx="0">
-            <a:schemeClr val="accent1"/>
-          </a:effectRef>
-          <a:fontRef idx="minor"/>
-        </p:style>
-        <p:txBody>
-          <a:bodyPr lIns="90000" tIns="45000" rIns="90000" bIns="45000" anchor="ctr">
-            <a:noAutofit/>
-          </a:bodyPr>
-          <a:p>
-            <a:endParaRPr lang="en-US" sz="1800" b="0" u="none" strike="noStrike">
-              <a:solidFill>
-                <a:schemeClr val="lt1"/>
-              </a:solidFill>
-              <a:effectLst/>
-              <a:uFillTx/>
-              <a:latin typeface="Aptos"/>
-            </a:endParaRPr>
-          </a:p>
-        </p:txBody>
-      </p:sp>
-      <p:sp>
-        <p:nvSpPr>
-          <p:cNvPr id="69" name="Rectangle 8"/>
-          <p:cNvSpPr/>
-          <p:nvPr/>
-        </p:nvSpPr>
-        <p:spPr>
-          <a:xfrm>
-            <a:off x="2334240" y="3288960"/>
-            <a:ext cx="1803960" cy="310680"/>
-          </a:xfrm>
-          <a:prstGeom prst="rect">
-            <a:avLst/>
-          </a:prstGeom>
-          <a:noFill/>
-          <a:ln w="28575">
-            <a:solidFill>
-              <a:srgbClr val="C00000"/>
-            </a:solidFill>
-          </a:ln>
-        </p:spPr>
-        <p:style>
-          <a:lnRef idx="2">
-            <a:schemeClr val="accent1">
-              <a:shade val="15000"/>
-            </a:schemeClr>
-          </a:lnRef>
-          <a:fillRef idx="1">
-            <a:schemeClr val="accent1"/>
-          </a:fillRef>
-          <a:effectRef idx="0">
-            <a:schemeClr val="accent1"/>
-          </a:effectRef>
-          <a:fontRef idx="minor"/>
-        </p:style>
-        <p:txBody>
-          <a:bodyPr lIns="90000" tIns="45000" rIns="90000" bIns="45000" anchor="ctr">
-            <a:noAutofit/>
-          </a:bodyPr>
-          <a:p>
-            <a:endParaRPr lang="en-US" sz="1800" b="0" u="none" strike="noStrike">
-              <a:solidFill>
-                <a:schemeClr val="lt1"/>
-              </a:solidFill>
-              <a:effectLst/>
-              <a:uFillTx/>
-              <a:latin typeface="Aptos"/>
-            </a:endParaRPr>
-          </a:p>
-        </p:txBody>
-      </p:sp>
-      <p:sp>
-        <p:nvSpPr>
-          <p:cNvPr id="70" name="Rectangle 9"/>
-          <p:cNvSpPr/>
-          <p:nvPr/>
-        </p:nvSpPr>
-        <p:spPr>
-          <a:xfrm>
-            <a:off x="5329440" y="5504760"/>
-            <a:ext cx="2925000" cy="739800"/>
-          </a:xfrm>
-          <a:prstGeom prst="rect">
-            <a:avLst/>
-          </a:prstGeom>
-          <a:noFill/>
-          <a:ln w="28575">
-            <a:solidFill>
-              <a:srgbClr val="C00000"/>
-            </a:solidFill>
-          </a:ln>
-        </p:spPr>
-        <p:style>
-          <a:lnRef idx="2">
-            <a:schemeClr val="accent1">
-              <a:shade val="15000"/>
-            </a:schemeClr>
-          </a:lnRef>
-          <a:fillRef idx="1">
-            <a:schemeClr val="accent1"/>
-          </a:fillRef>
-          <a:effectRef idx="0">
-            <a:schemeClr val="accent1"/>
-          </a:effectRef>
-          <a:fontRef idx="minor"/>
-        </p:style>
-        <p:txBody>
-          <a:bodyPr lIns="90000" tIns="45000" rIns="90000" bIns="45000" anchor="ctr">
-            <a:noAutofit/>
-          </a:bodyPr>
-          <a:p>
-            <a:endParaRPr lang="en-US" sz="1800" b="0" u="none" strike="noStrike">
-              <a:solidFill>
-                <a:schemeClr val="lt1"/>
-              </a:solidFill>
-              <a:effectLst/>
-              <a:uFillTx/>
-              <a:latin typeface="Aptos"/>
-            </a:endParaRPr>
-          </a:p>
-        </p:txBody>
-      </p:sp>
-      <p:sp>
-        <p:nvSpPr>
-          <p:cNvPr id="71" name="Rectangle 10"/>
-          <p:cNvSpPr/>
-          <p:nvPr/>
-        </p:nvSpPr>
-        <p:spPr>
-          <a:xfrm>
-            <a:off x="8255160" y="5478840"/>
-            <a:ext cx="2977560" cy="363240"/>
-          </a:xfrm>
-          <a:prstGeom prst="rect">
-            <a:avLst/>
-          </a:prstGeom>
-          <a:noFill/>
-          <a:ln w="28575">
-            <a:solidFill>
-              <a:srgbClr val="C00000"/>
-            </a:solidFill>
-          </a:ln>
-        </p:spPr>
-        <p:style>
-          <a:lnRef idx="2">
-            <a:schemeClr val="accent1">
-              <a:shade val="15000"/>
-            </a:schemeClr>
-          </a:lnRef>
-          <a:fillRef idx="1">
-            <a:schemeClr val="accent1"/>
-          </a:fillRef>
-          <a:effectRef idx="0">
-            <a:schemeClr val="accent1"/>
-          </a:effectRef>
-          <a:fontRef idx="minor"/>
-        </p:style>
-        <p:txBody>
-          <a:bodyPr lIns="90000" tIns="45000" rIns="90000" bIns="45000" anchor="ctr">
-            <a:noAutofit/>
-          </a:bodyPr>
-          <a:p>
-            <a:endParaRPr lang="en-US" sz="1800" b="0" u="none" strike="noStrike">
-              <a:solidFill>
-                <a:schemeClr val="lt1"/>
-              </a:solidFill>
-              <a:effectLst/>
-              <a:uFillTx/>
-              <a:latin typeface="Aptos"/>
-            </a:endParaRPr>
-          </a:p>
-        </p:txBody>
-      </p:sp>
-      <p:sp>
-        <p:nvSpPr>
-          <p:cNvPr id="72" name="Rectangle 11"/>
-          <p:cNvSpPr/>
-          <p:nvPr/>
-        </p:nvSpPr>
-        <p:spPr>
-          <a:xfrm>
-            <a:off x="8255160" y="6196680"/>
-            <a:ext cx="2977560" cy="363240"/>
-          </a:xfrm>
-          <a:prstGeom prst="rect">
-            <a:avLst/>
-          </a:prstGeom>
-          <a:noFill/>
-          <a:ln w="28575">
-            <a:solidFill>
-              <a:srgbClr val="C00000"/>
-            </a:solidFill>
-          </a:ln>
-        </p:spPr>
-        <p:style>
-          <a:lnRef idx="2">
-            <a:schemeClr val="accent1">
-              <a:shade val="15000"/>
-            </a:schemeClr>
-          </a:lnRef>
-          <a:fillRef idx="1">
-            <a:schemeClr val="accent1"/>
-          </a:fillRef>
-          <a:effectRef idx="0">
-            <a:schemeClr val="accent1"/>
-          </a:effectRef>
-          <a:fontRef idx="minor"/>
-        </p:style>
-        <p:txBody>
-          <a:bodyPr lIns="90000" tIns="45000" rIns="90000" bIns="45000" anchor="ctr">
-            <a:noAutofit/>
-          </a:bodyPr>
-          <a:p>
-            <a:endParaRPr lang="en-US" sz="1800" b="0" u="none" strike="noStrike">
-              <a:solidFill>
-                <a:schemeClr val="lt1"/>
-              </a:solidFill>
-              <a:effectLst/>
-              <a:uFillTx/>
-              <a:latin typeface="Aptos"/>
-            </a:endParaRPr>
-          </a:p>
-        </p:txBody>
-      </p:sp>
-      <p:sp>
-        <p:nvSpPr>
-          <p:cNvPr id="73" name="TextBox 72"/>
+          <p:cNvPr id="4" name="TextBox 3"/>
           <p:cNvSpPr txBox="1"/>
           <p:nvPr/>
         </p:nvSpPr>
         <p:spPr>
           <a:xfrm>
-            <a:off x="365760" y="6035040"/>
-            <a:ext cx="11338560" cy="822960"/>
+            <a:off x="457200" y="1280160"/>
+            <a:ext cx="11247120" cy="4937760"/>
           </a:xfrm>
           <a:prstGeom prst="rect">
             <a:avLst/>
@@ -15644,22 +13260,78 @@
           <a:lstStyle/>
           <a:p>
             <a:r>
-              <a:rPr sz="1000" i="1"/>
-              <a:t>Redone on CLEAN 2-annotator labels, group-level (185 windows), scaled nested CV (was bugged labels + uniform/seed baseline). Majority baseline = deterministic always-predict-majority. Significance is now METHOD-DEPENDENT (uniform vs majority vs permutation give different verdicts) — see 'Methodology Review' slides; no fixed red boxes.</a:t>
+              <a:rPr sz="1300" b="1"/>
+              <a:t>NEW RESULT — LLM operationalizes the TE rubric (slides 25–26):</a:t>
+            </a:r>
+          </a:p>
+          <a:p>
+            <a:pPr lvl="1"/>
+            <a:r>
+              <a:rPr sz="1100"/>
+              <a:t>• Took the study's own coding schema (Low/Med/High markers) and made it an LLM prompt — local Qwen3.6-27B, German transcripts, 60 s group-windows, clean labels. Zero-shot (NO training, NO gaze) ties the best multimodal fusion (~0.75 All).</a:t>
+            </a:r>
+          </a:p>
+          <a:p>
+            <a:pPr lvl="1"/>
+            <a:r>
+              <a:rPr sz="1100"/>
+              <a:t>• Marker features (4 rubric axes): thinking mode All 0.81 / Triads 0.84 — highest single channel. German BERT baseline ties → the signal is in the text.</a:t>
+            </a:r>
+          </a:p>
+          <a:p>
+            <a:pPr lvl="1"/>
+            <a:r>
+              <a:rPr sz="1100"/>
+              <a:t>• BEST CONFIG = Gaze×Speaking + LLM fusion: All 0.86 / Dyads 0.87 (perm p≈.003) — beats every prior, every modality, and the old gaze+vad fusion; makes Dyads gaze significant.</a:t>
+            </a:r>
+          </a:p>
+          <a:p>
+            <a:r>
+              <a:rPr sz="1300" b="1"/>
+              <a:t>Methodology &amp; comparison (slides 20–24, 2):</a:t>
+            </a:r>
+          </a:p>
+          <a:p>
+            <a:pPr lvl="1"/>
+            <a:r>
+              <a:rPr sz="1100"/>
+              <a:t>• Methodology-review section: significance flip-flop (permutation vs majority t-test), group-level vs long-format, open decisions — significance method still PENDING team decision.</a:t>
+            </a:r>
+          </a:p>
+          <a:p>
+            <a:pPr lvl="1"/>
+            <a:r>
+              <a:rPr sz="1100"/>
+              <a:t>• Our detector vs 3 consistent priors (dummy / AIxVR / GazexSpeaking) + audio fusion, both significance tests shown; slide 2 redone with the true majority baseline.</a:t>
+            </a:r>
+          </a:p>
+          <a:p>
+            <a:pPr lvl="1"/>
+            <a:r>
+              <a:rPr sz="1100"/>
+              <a:t>• openSMILE raw acoustics (88 eGeMAPS) vs v/a/d affect → affect wins; raw acoustics don't beat the 3-dim estimate.</a:t>
+            </a:r>
+          </a:p>
+          <a:p>
+            <a:r>
+              <a:rPr sz="1300" b="1"/>
+              <a:t>Pipeline:</a:t>
+            </a:r>
+          </a:p>
+          <a:p>
+            <a:pPr lvl="1"/>
+            <a:r>
+              <a:rPr sz="1100"/>
+              <a:t>• Group-TE decoupled to per-group rows (Q2); idea1 stale labels retired (now points to the clean fusion table).</a:t>
             </a:r>
           </a:p>
         </p:txBody>
       </p:sp>
     </p:spTree>
   </p:cSld>
-  <mc:AlternateContent>
-    <mc:Choice Requires="p14">
-      <p:transition spd="slow" p14:dur="2000"/>
-    </mc:Choice>
-    <mc:Fallback>
-      <p:transition spd="slow"/>
-    </mc:Fallback>
-  </mc:AlternateContent>
+  <p:clrMapOvr>
+    <a:masterClrMapping/>
+  </p:clrMapOvr>
 </p:sld>
 </file>
 
@@ -20072,6 +17744,152 @@
             <a:r>
               <a:rPr sz="1100"/>
               <a:t>Group-level, nested LOSO + permutation, clean 2-annotator labels. LLM = local Qwen3.6-27B (thinking mode; outperforms non-think on the marker features).</a:t>
+            </a:r>
+          </a:p>
+        </p:txBody>
+      </p:sp>
+    </p:spTree>
+  </p:cSld>
+  <p:clrMapOvr>
+    <a:masterClrMapping/>
+  </p:clrMapOvr>
+</p:sld>
+</file>
+
+<file path=ppt/slides/slide27.xml><?xml version="1.0" encoding="utf-8"?>
+<p:sld xmlns:a="http://schemas.openxmlformats.org/drawingml/2006/main" xmlns:p="http://schemas.openxmlformats.org/presentationml/2006/main" xmlns:r="http://schemas.openxmlformats.org/officeDocument/2006/relationships">
+  <p:cSld>
+    <p:spTree>
+      <p:nvGrpSpPr>
+        <p:cNvPr id="1" name=""/>
+        <p:cNvGrpSpPr/>
+        <p:nvPr/>
+      </p:nvGrpSpPr>
+      <p:grpSpPr/>
+      <p:sp>
+        <p:nvSpPr>
+          <p:cNvPr id="2" name="Title 1"/>
+          <p:cNvSpPr>
+            <a:spLocks noGrp="1"/>
+          </p:cNvSpPr>
+          <p:nvPr>
+            <p:ph type="title"/>
+          </p:nvPr>
+        </p:nvSpPr>
+        <p:spPr/>
+        <p:txBody>
+          <a:bodyPr/>
+          <a:lstStyle/>
+          <a:p>
+            <a:r>
+              <a:t>What Was Done Since the 16 June Meeting</a:t>
+            </a:r>
+          </a:p>
+        </p:txBody>
+      </p:sp>
+      <p:sp>
+        <p:nvSpPr>
+          <p:cNvPr id="3" name="Text Placeholder 2"/>
+          <p:cNvSpPr>
+            <a:spLocks noGrp="1"/>
+          </p:cNvSpPr>
+          <p:nvPr>
+            <p:ph type="body"/>
+          </p:nvPr>
+        </p:nvSpPr>
+        <p:spPr/>
+        <p:txBody>
+          <a:bodyPr/>
+          <a:lstStyle/>
+          <a:p/>
+        </p:txBody>
+      </p:sp>
+      <p:sp>
+        <p:nvSpPr>
+          <p:cNvPr id="4" name="TextBox 3"/>
+          <p:cNvSpPr txBox="1"/>
+          <p:nvPr/>
+        </p:nvSpPr>
+        <p:spPr>
+          <a:xfrm>
+            <a:off x="457200" y="1280160"/>
+            <a:ext cx="11247120" cy="4937760"/>
+          </a:xfrm>
+          <a:prstGeom prst="rect">
+            <a:avLst/>
+          </a:prstGeom>
+          <a:noFill/>
+        </p:spPr>
+        <p:txBody>
+          <a:bodyPr wrap="square">
+            <a:spAutoFit/>
+          </a:bodyPr>
+          <a:lstStyle/>
+          <a:p>
+            <a:r>
+              <a:rPr sz="1300" b="1"/>
+              <a:t>NEW RESULT — LLM operationalizes the TE rubric (see results slides):</a:t>
+            </a:r>
+          </a:p>
+          <a:p>
+            <a:pPr lvl="1"/>
+            <a:r>
+              <a:rPr sz="1100"/>
+              <a:t>• Took the study's own coding schema (Low/Med/High markers) and made it an LLM prompt — local Qwen3.6-27B, German transcripts, 60 s group-windows, clean labels. Zero-shot (NO training, NO gaze) ties the best multimodal fusion (~0.75 All).</a:t>
+            </a:r>
+          </a:p>
+          <a:p>
+            <a:pPr lvl="1"/>
+            <a:r>
+              <a:rPr sz="1100"/>
+              <a:t>• Marker features (4 rubric axes): thinking mode All 0.81 / Triads 0.84 — highest single channel. German BERT baseline ties → the signal is in the text.</a:t>
+            </a:r>
+          </a:p>
+          <a:p>
+            <a:pPr lvl="1"/>
+            <a:r>
+              <a:rPr sz="1100"/>
+              <a:t>• BEST CONFIG = Gaze×Speaking + LLM fusion: All 0.86 / Dyads 0.87 (perm p≈.003) — beats every prior, every modality, and the old gaze+vad fusion; makes Dyads gaze significant.</a:t>
+            </a:r>
+          </a:p>
+          <a:p>
+            <a:r>
+              <a:rPr sz="1300" b="1"/>
+              <a:t>Methodology &amp; comparison:</a:t>
+            </a:r>
+          </a:p>
+          <a:p>
+            <a:pPr lvl="1"/>
+            <a:r>
+              <a:rPr sz="1100"/>
+              <a:t>• Methodology-review section: significance flip-flop (permutation vs majority t-test), group-level vs long-format, open decisions — significance method still PENDING team decision.</a:t>
+            </a:r>
+          </a:p>
+          <a:p>
+            <a:pPr lvl="1"/>
+            <a:r>
+              <a:rPr sz="1100"/>
+              <a:t>• Our detector vs 3 consistent priors (dummy / AIxVR / GazexSpeaking) + audio fusion, both significance tests shown; slide 2 redone with the true majority baseline.</a:t>
+            </a:r>
+          </a:p>
+          <a:p>
+            <a:pPr lvl="1"/>
+            <a:r>
+              <a:rPr sz="1100"/>
+              <a:t>• openSMILE raw acoustics (88 eGeMAPS) vs v/a/d affect → affect wins; raw acoustics don't beat the 3-dim estimate.</a:t>
+            </a:r>
+          </a:p>
+          <a:p>
+            <a:r>
+              <a:rPr sz="1300" b="1"/>
+              <a:t>Pipeline:</a:t>
+            </a:r>
+          </a:p>
+          <a:p>
+            <a:pPr lvl="1"/>
+            <a:r>
+              <a:rPr sz="1100"/>
+              <a:t>• Group-TE decoupled to per-group rows (Q2); idea1 stale labels retired (now points to the clean fusion table).</a:t>
             </a:r>
           </a:p>
         </p:txBody>

</xml_diff>

<commit_message>
discover(deck): LLM prompt + worked marker-examples backup slides
Two slides after the rubric-results slide: (26) the exact prompt used to
operationalize the TE schema (rubric defs + 4 axes + JSON spec + model params);
(27) worked Low/Med/High examples — transcript excerpt with per-axis scores +
te_continuous + true label, showing how text maps to interpretable markers.
</commit_message>
<xml_diff>
--- a/discover/2026_March_ViLearn_Planning.pptx
+++ b/discover/2026_March_ViLearn_Planning.pptx
@@ -31,6 +31,8 @@
     <p:sldId id="278" r:id="rId26"/>
     <p:sldId id="279" r:id="rId27"/>
     <p:sldId id="280" r:id="rId30"/>
+    <p:sldId id="283" r:id="rId34"/>
+    <p:sldId id="284" r:id="rId35"/>
     <p:sldId id="281" r:id="rId31"/>
   </p:sldIdLst>
   <p:sldSz cx="12192000" cy="6858000"/>
@@ -8382,6 +8384,483 @@
       </p:grpSpPr>
       <p:sp>
         <p:nvSpPr>
+          <p:cNvPr id="89" name="PlaceHolder 1"/>
+          <p:cNvSpPr>
+            <a:spLocks noGrp="1"/>
+          </p:cNvSpPr>
+          <p:nvPr>
+            <p:ph type="title"/>
+          </p:nvPr>
+        </p:nvSpPr>
+        <p:spPr>
+          <a:xfrm>
+            <a:off x="838080" y="365040"/>
+            <a:ext cx="10515240" cy="1325160"/>
+          </a:xfrm>
+          <a:prstGeom prst="rect">
+            <a:avLst/>
+          </a:prstGeom>
+          <a:noFill/>
+          <a:ln w="0">
+            <a:noFill/>
+          </a:ln>
+        </p:spPr>
+        <p:txBody>
+          <a:bodyPr lIns="91440" tIns="45720" rIns="91440" bIns="45720" anchor="ctr">
+            <a:noAutofit/>
+          </a:bodyPr>
+          <a:p>
+            <a:pPr indent="0" algn="l" defTabSz="914400">
+              <a:lnSpc>
+                <a:spcPct val="90000"/>
+              </a:lnSpc>
+              <a:buNone/>
+            </a:pPr>
+            <a:r>
+              <a:rPr lang="en-US" sz="4400" b="0" u="none" strike="noStrike">
+                <a:solidFill>
+                  <a:schemeClr val="dk1"/>
+                </a:solidFill>
+                <a:effectLst/>
+                <a:uFillTx/>
+                <a:latin typeface="Aptos Display"/>
+              </a:rPr>
+              <a:t>Research Questions</a:t>
+            </a:r>
+            <a:endParaRPr lang="en-US" sz="4400" b="0" u="none" strike="noStrike">
+              <a:solidFill>
+                <a:schemeClr val="dk1"/>
+              </a:solidFill>
+              <a:effectLst/>
+              <a:uFillTx/>
+              <a:latin typeface="Aptos Display"/>
+            </a:endParaRPr>
+          </a:p>
+        </p:txBody>
+      </p:sp>
+      <p:sp>
+        <p:nvSpPr>
+          <p:cNvPr id="90" name="PlaceHolder 2"/>
+          <p:cNvSpPr>
+            <a:spLocks noGrp="1"/>
+          </p:cNvSpPr>
+          <p:nvPr>
+            <p:ph/>
+          </p:nvPr>
+        </p:nvSpPr>
+        <p:spPr>
+          <a:xfrm>
+            <a:off x="838080" y="1522800"/>
+            <a:ext cx="10515240" cy="4350960"/>
+          </a:xfrm>
+          <a:prstGeom prst="rect">
+            <a:avLst/>
+          </a:prstGeom>
+          <a:noFill/>
+          <a:ln w="0">
+            <a:noFill/>
+          </a:ln>
+        </p:spPr>
+        <p:txBody>
+          <a:bodyPr lIns="91440" tIns="45720" rIns="91440" bIns="45720" anchor="t">
+            <a:normAutofit/>
+          </a:bodyPr>
+          <a:p>
+            <a:pPr marL="228600" indent="-228600" algn="l" defTabSz="914400">
+              <a:lnSpc>
+                <a:spcPct val="90000"/>
+              </a:lnSpc>
+              <a:spcBef>
+                <a:spcPts val="1001"/>
+              </a:spcBef>
+              <a:buClr>
+                <a:srgbClr val="000000"/>
+              </a:buClr>
+              <a:buFont typeface="Arial"/>
+              <a:buChar char="•"/>
+            </a:pPr>
+            <a:r>
+              <a:rPr lang="en-US" sz="2800" b="0" u="none" strike="noStrike">
+                <a:solidFill>
+                  <a:schemeClr val="dk1"/>
+                </a:solidFill>
+                <a:effectLst/>
+                <a:uFillTx/>
+                <a:latin typeface="Aptos"/>
+              </a:rPr>
+              <a:t>Paralinguistic RQs:</a:t>
+            </a:r>
+            <a:endParaRPr lang="en-US" sz="2800" b="0" u="none" strike="noStrike">
+              <a:solidFill>
+                <a:schemeClr val="dk1"/>
+              </a:solidFill>
+              <a:effectLst/>
+              <a:uFillTx/>
+              <a:latin typeface="Aptos"/>
+            </a:endParaRPr>
+          </a:p>
+          <a:p>
+            <a:pPr marL="685800" lvl="1" indent="-343080" algn="l" defTabSz="914400">
+              <a:lnSpc>
+                <a:spcPct val="90000"/>
+              </a:lnSpc>
+              <a:spcBef>
+                <a:spcPts val="499"/>
+              </a:spcBef>
+              <a:buClr>
+                <a:srgbClr val="000000"/>
+              </a:buClr>
+              <a:buFont typeface="Courier New,monospace"/>
+              <a:buChar char="o"/>
+            </a:pPr>
+            <a:r>
+              <a:rPr lang="en-US" sz="2400" b="0" u="none" strike="noStrike">
+                <a:solidFill>
+                  <a:schemeClr val="dk1"/>
+                </a:solidFill>
+                <a:effectLst/>
+                <a:uFillTx/>
+                <a:latin typeface="Aptos"/>
+              </a:rPr>
+              <a:t>How do TE values differ between all 9 gaze x speaker configs?</a:t>
+            </a:r>
+            <a:endParaRPr lang="en-US" sz="2400" b="0" u="none" strike="noStrike">
+              <a:solidFill>
+                <a:schemeClr val="dk1"/>
+              </a:solidFill>
+              <a:effectLst/>
+              <a:uFillTx/>
+              <a:latin typeface="Aptos"/>
+            </a:endParaRPr>
+          </a:p>
+          <a:p>
+            <a:pPr marL="685800" lvl="1" indent="-343080" algn="l" defTabSz="914400">
+              <a:lnSpc>
+                <a:spcPct val="90000"/>
+              </a:lnSpc>
+              <a:spcBef>
+                <a:spcPts val="499"/>
+              </a:spcBef>
+              <a:buClr>
+                <a:srgbClr val="000000"/>
+              </a:buClr>
+              <a:buFont typeface="Courier New,monospace"/>
+              <a:buChar char="o"/>
+            </a:pPr>
+            <a:r>
+              <a:rPr lang="en-US" sz="2400" b="0" u="none" strike="noStrike">
+                <a:solidFill>
+                  <a:schemeClr val="dk1"/>
+                </a:solidFill>
+                <a:effectLst/>
+                <a:uFillTx/>
+                <a:latin typeface="Aptos"/>
+              </a:rPr>
+              <a:t>How well does a classifier learn to detect TE with gaze x speaker features?</a:t>
+            </a:r>
+            <a:endParaRPr lang="en-US" sz="2400" b="0" u="none" strike="noStrike">
+              <a:solidFill>
+                <a:schemeClr val="dk1"/>
+              </a:solidFill>
+              <a:effectLst/>
+              <a:uFillTx/>
+              <a:latin typeface="Aptos"/>
+            </a:endParaRPr>
+          </a:p>
+          <a:p>
+            <a:pPr marL="228600" indent="-228600" algn="l" defTabSz="914400">
+              <a:lnSpc>
+                <a:spcPct val="90000"/>
+              </a:lnSpc>
+              <a:spcBef>
+                <a:spcPts val="1001"/>
+              </a:spcBef>
+              <a:buClr>
+                <a:srgbClr val="000000"/>
+              </a:buClr>
+              <a:buFont typeface="Arial"/>
+              <a:buChar char="•"/>
+            </a:pPr>
+            <a:r>
+              <a:rPr lang="en-US" sz="2800" b="0" u="none" strike="noStrike">
+                <a:solidFill>
+                  <a:schemeClr val="dk1"/>
+                </a:solidFill>
+                <a:effectLst/>
+                <a:uFillTx/>
+                <a:latin typeface="Aptos"/>
+              </a:rPr>
+              <a:t>Linguistic RQs:</a:t>
+            </a:r>
+            <a:endParaRPr lang="en-US" sz="2800" b="0" u="none" strike="noStrike">
+              <a:solidFill>
+                <a:schemeClr val="dk1"/>
+              </a:solidFill>
+              <a:effectLst/>
+              <a:uFillTx/>
+              <a:latin typeface="Aptos"/>
+            </a:endParaRPr>
+          </a:p>
+          <a:p>
+            <a:pPr marL="685800" lvl="1" indent="-343080" algn="l" defTabSz="914400">
+              <a:lnSpc>
+                <a:spcPct val="90000"/>
+              </a:lnSpc>
+              <a:spcBef>
+                <a:spcPts val="499"/>
+              </a:spcBef>
+              <a:buClr>
+                <a:srgbClr val="000000"/>
+              </a:buClr>
+              <a:buFont typeface="Courier New,monospace"/>
+              <a:buChar char="o"/>
+            </a:pPr>
+            <a:r>
+              <a:rPr lang="en-US" sz="2400" b="0" u="none" strike="noStrike">
+                <a:solidFill>
+                  <a:schemeClr val="dk1"/>
+                </a:solidFill>
+                <a:effectLst/>
+                <a:uFillTx/>
+                <a:latin typeface="Calibri"/>
+                <a:ea typeface="Calibri"/>
+              </a:rPr>
+              <a:t>How well does a classifier learn to detect TE with </a:t>
+            </a:r>
+            <a:r>
+              <a:rPr lang="en-US" sz="2400" b="1" u="none" strike="noStrike">
+                <a:solidFill>
+                  <a:schemeClr val="dk1"/>
+                </a:solidFill>
+                <a:effectLst/>
+                <a:uFillTx/>
+                <a:latin typeface="Aptos"/>
+                <a:ea typeface="Calibri"/>
+              </a:rPr>
+              <a:t>only linguistic </a:t>
+            </a:r>
+            <a:r>
+              <a:rPr lang="en-US" sz="2400" b="0" u="none" strike="noStrike">
+                <a:solidFill>
+                  <a:schemeClr val="dk1"/>
+                </a:solidFill>
+                <a:effectLst/>
+                <a:uFillTx/>
+                <a:latin typeface="Calibri"/>
+                <a:ea typeface="Calibri"/>
+              </a:rPr>
+              <a:t>features?</a:t>
+            </a:r>
+            <a:endParaRPr lang="en-US" sz="2400" b="0" u="none" strike="noStrike">
+              <a:solidFill>
+                <a:schemeClr val="dk1"/>
+              </a:solidFill>
+              <a:effectLst/>
+              <a:uFillTx/>
+              <a:latin typeface="Aptos"/>
+            </a:endParaRPr>
+          </a:p>
+          <a:p>
+            <a:pPr marL="685800" lvl="1" indent="-343080" algn="l" defTabSz="914400">
+              <a:lnSpc>
+                <a:spcPct val="90000"/>
+              </a:lnSpc>
+              <a:spcBef>
+                <a:spcPts val="499"/>
+              </a:spcBef>
+              <a:buClr>
+                <a:srgbClr val="000000"/>
+              </a:buClr>
+              <a:buFont typeface="Courier New,monospace"/>
+              <a:buChar char="o"/>
+            </a:pPr>
+            <a:r>
+              <a:rPr lang="en-US" sz="2400" b="0" u="none" strike="noStrike">
+                <a:solidFill>
+                  <a:schemeClr val="dk1"/>
+                </a:solidFill>
+                <a:effectLst/>
+                <a:uFillTx/>
+                <a:latin typeface="Calibri"/>
+                <a:ea typeface="Calibri"/>
+              </a:rPr>
+              <a:t>Which linguistic features have the strongest predictive power?</a:t>
+            </a:r>
+            <a:endParaRPr lang="en-US" sz="2400" b="0" u="none" strike="noStrike">
+              <a:solidFill>
+                <a:schemeClr val="dk1"/>
+              </a:solidFill>
+              <a:effectLst/>
+              <a:uFillTx/>
+              <a:latin typeface="Aptos"/>
+            </a:endParaRPr>
+          </a:p>
+          <a:p>
+            <a:pPr marL="228600" indent="-228600" algn="l" defTabSz="914400">
+              <a:lnSpc>
+                <a:spcPct val="90000"/>
+              </a:lnSpc>
+              <a:spcBef>
+                <a:spcPts val="1001"/>
+              </a:spcBef>
+              <a:buClr>
+                <a:srgbClr val="000000"/>
+              </a:buClr>
+              <a:buFont typeface="Arial"/>
+              <a:buChar char="•"/>
+            </a:pPr>
+            <a:r>
+              <a:rPr lang="en-US" sz="2800" b="0" u="none" strike="noStrike">
+                <a:solidFill>
+                  <a:schemeClr val="dk1"/>
+                </a:solidFill>
+                <a:effectLst/>
+                <a:uFillTx/>
+                <a:latin typeface="Calibri"/>
+                <a:ea typeface="Calibri"/>
+              </a:rPr>
+              <a:t>Multimodal:</a:t>
+            </a:r>
+            <a:endParaRPr lang="en-US" sz="2800" b="0" u="none" strike="noStrike">
+              <a:solidFill>
+                <a:schemeClr val="dk1"/>
+              </a:solidFill>
+              <a:effectLst/>
+              <a:uFillTx/>
+              <a:latin typeface="Aptos"/>
+            </a:endParaRPr>
+          </a:p>
+          <a:p>
+            <a:pPr marL="685800" lvl="1" indent="-343080" algn="l" defTabSz="914400">
+              <a:lnSpc>
+                <a:spcPct val="90000"/>
+              </a:lnSpc>
+              <a:spcBef>
+                <a:spcPts val="499"/>
+              </a:spcBef>
+              <a:buClr>
+                <a:srgbClr val="000000"/>
+              </a:buClr>
+              <a:buFont typeface="Courier New,monospace"/>
+              <a:buChar char="o"/>
+            </a:pPr>
+            <a:r>
+              <a:rPr lang="en-US" sz="2400" b="0" u="none" strike="noStrike">
+                <a:solidFill>
+                  <a:schemeClr val="dk1"/>
+                </a:solidFill>
+                <a:effectLst/>
+                <a:uFillTx/>
+                <a:latin typeface="Calibri"/>
+                <a:ea typeface="Calibri"/>
+              </a:rPr>
+              <a:t>How well does a classifier learn to detect TE with </a:t>
+            </a:r>
+            <a:r>
+              <a:rPr lang="en-US" sz="2400" b="1" u="none" strike="noStrike">
+                <a:solidFill>
+                  <a:schemeClr val="dk1"/>
+                </a:solidFill>
+                <a:effectLst/>
+                <a:uFillTx/>
+                <a:latin typeface="Aptos"/>
+                <a:ea typeface="Calibri"/>
+              </a:rPr>
+              <a:t>both </a:t>
+            </a:r>
+            <a:r>
+              <a:rPr lang="en-US" sz="2400" b="0" u="none" strike="noStrike">
+                <a:solidFill>
+                  <a:schemeClr val="dk1"/>
+                </a:solidFill>
+                <a:effectLst/>
+                <a:uFillTx/>
+                <a:latin typeface="Calibri"/>
+                <a:ea typeface="Calibri"/>
+              </a:rPr>
+              <a:t>feature sets?</a:t>
+            </a:r>
+            <a:endParaRPr lang="en-US" sz="2400" b="0" u="none" strike="noStrike">
+              <a:solidFill>
+                <a:schemeClr val="dk1"/>
+              </a:solidFill>
+              <a:effectLst/>
+              <a:uFillTx/>
+              <a:latin typeface="Aptos"/>
+            </a:endParaRPr>
+          </a:p>
+          <a:p>
+            <a:pPr indent="0" algn="l" defTabSz="914400">
+              <a:lnSpc>
+                <a:spcPct val="90000"/>
+              </a:lnSpc>
+              <a:spcBef>
+                <a:spcPts val="499"/>
+              </a:spcBef>
+              <a:buNone/>
+            </a:pPr>
+            <a:endParaRPr lang="en-US" sz="2400" b="0" u="none" strike="noStrike">
+              <a:solidFill>
+                <a:schemeClr val="dk1"/>
+              </a:solidFill>
+              <a:effectLst/>
+              <a:uFillTx/>
+              <a:latin typeface="Aptos"/>
+            </a:endParaRPr>
+          </a:p>
+          <a:p>
+            <a:pPr indent="0" algn="l" defTabSz="914400">
+              <a:lnSpc>
+                <a:spcPct val="90000"/>
+              </a:lnSpc>
+              <a:spcBef>
+                <a:spcPts val="499"/>
+              </a:spcBef>
+              <a:buNone/>
+            </a:pPr>
+            <a:endParaRPr lang="en-US" sz="2400" b="0" u="none" strike="noStrike">
+              <a:solidFill>
+                <a:schemeClr val="dk1"/>
+              </a:solidFill>
+              <a:effectLst/>
+              <a:uFillTx/>
+              <a:latin typeface="Aptos"/>
+            </a:endParaRPr>
+          </a:p>
+        </p:txBody>
+      </p:sp>
+    </p:spTree>
+  </p:cSld>
+  <mc:AlternateContent>
+    <mc:Choice Requires="p14">
+      <p:transition spd="slow" p14:dur="2000"/>
+    </mc:Choice>
+    <mc:Fallback>
+      <p:transition spd="slow"/>
+    </mc:Fallback>
+  </mc:AlternateContent>
+</p:sld>
+</file>
+
+<file path=ppt/slides/slide11.xml><?xml version="1.0" encoding="utf-8"?>
+<p:sld xmlns:a="http://schemas.openxmlformats.org/drawingml/2006/main" xmlns:p="http://schemas.openxmlformats.org/presentationml/2006/main" xmlns:r="http://schemas.openxmlformats.org/officeDocument/2006/relationships" xmlns:p14="http://schemas.microsoft.com/office/powerpoint/2010/main" xmlns:p15="http://schemas.microsoft.com/office/powerpoint/2012/main" xmlns:mc="http://schemas.openxmlformats.org/markup-compatibility/2006">
+  <p:cSld>
+    <p:spTree>
+      <p:nvGrpSpPr>
+        <p:cNvPr id="1" name=""/>
+        <p:cNvGrpSpPr/>
+        <p:nvPr/>
+      </p:nvGrpSpPr>
+      <p:grpSpPr>
+        <a:xfrm>
+          <a:off x="0" y="0"/>
+          <a:ext cx="0" cy="0"/>
+          <a:chOff x="0" y="0"/>
+          <a:chExt cx="0" cy="0"/>
+        </a:xfrm>
+      </p:grpSpPr>
+      <p:sp>
+        <p:nvSpPr>
           <p:cNvPr id="91" name="PlaceHolder 1"/>
           <p:cNvSpPr>
             <a:spLocks noGrp="1"/>
@@ -8716,7 +9195,7 @@
 </p:sld>
 </file>
 
-<file path=ppt/slides/slide11.xml><?xml version="1.0" encoding="utf-8"?>
+<file path=ppt/slides/slide12.xml><?xml version="1.0" encoding="utf-8"?>
 <p:sld xmlns:a="http://schemas.openxmlformats.org/drawingml/2006/main" xmlns:p="http://schemas.openxmlformats.org/presentationml/2006/main" xmlns:r="http://schemas.openxmlformats.org/officeDocument/2006/relationships">
   <p:cSld>
     <p:spTree>
@@ -8984,7 +9463,7 @@
 </p:sld>
 </file>
 
-<file path=ppt/slides/slide12.xml><?xml version="1.0" encoding="utf-8"?>
+<file path=ppt/slides/slide13.xml><?xml version="1.0" encoding="utf-8"?>
 <p:sld xmlns:a="http://schemas.openxmlformats.org/drawingml/2006/main" xmlns:p="http://schemas.openxmlformats.org/presentationml/2006/main" xmlns:r="http://schemas.openxmlformats.org/officeDocument/2006/relationships">
   <p:cSld>
     <p:spTree>
@@ -9492,7 +9971,7 @@
 </p:sld>
 </file>
 
-<file path=ppt/slides/slide13.xml><?xml version="1.0" encoding="utf-8"?>
+<file path=ppt/slides/slide14.xml><?xml version="1.0" encoding="utf-8"?>
 <p:sld xmlns:a="http://schemas.openxmlformats.org/drawingml/2006/main" xmlns:p="http://schemas.openxmlformats.org/presentationml/2006/main" xmlns:r="http://schemas.openxmlformats.org/officeDocument/2006/relationships">
   <p:cSld>
     <p:spTree>
@@ -9867,7 +10346,7 @@
 </p:sld>
 </file>
 
-<file path=ppt/slides/slide14.xml><?xml version="1.0" encoding="utf-8"?>
+<file path=ppt/slides/slide15.xml><?xml version="1.0" encoding="utf-8"?>
 <p:sld xmlns:a="http://schemas.openxmlformats.org/drawingml/2006/main" xmlns:p="http://schemas.openxmlformats.org/presentationml/2006/main" xmlns:r="http://schemas.openxmlformats.org/officeDocument/2006/relationships">
   <p:cSld>
     <p:spTree>
@@ -10214,7 +10693,7 @@
 </p:sld>
 </file>
 
-<file path=ppt/slides/slide15.xml><?xml version="1.0" encoding="utf-8"?>
+<file path=ppt/slides/slide16.xml><?xml version="1.0" encoding="utf-8"?>
 <p:sld xmlns:a="http://schemas.openxmlformats.org/drawingml/2006/main" xmlns:p="http://schemas.openxmlformats.org/presentationml/2006/main" xmlns:r="http://schemas.openxmlformats.org/officeDocument/2006/relationships" xmlns:p14="http://schemas.microsoft.com/office/powerpoint/2010/main" xmlns:p15="http://schemas.microsoft.com/office/powerpoint/2012/main" xmlns:mc="http://schemas.openxmlformats.org/markup-compatibility/2006">
   <p:cSld>
     <p:spTree>
@@ -11585,7 +12064,7 @@
 </p:sld>
 </file>
 
-<file path=ppt/slides/slide16.xml><?xml version="1.0" encoding="utf-8"?>
+<file path=ppt/slides/slide17.xml><?xml version="1.0" encoding="utf-8"?>
 <p:sld xmlns:a="http://schemas.openxmlformats.org/drawingml/2006/main" xmlns:p="http://schemas.openxmlformats.org/presentationml/2006/main" xmlns:r="http://schemas.openxmlformats.org/officeDocument/2006/relationships" xmlns:p14="http://schemas.microsoft.com/office/powerpoint/2010/main" xmlns:p15="http://schemas.microsoft.com/office/powerpoint/2012/main" xmlns:mc="http://schemas.openxmlformats.org/markup-compatibility/2006">
   <p:cSld>
     <p:spTree>
@@ -11907,7 +12386,7 @@
 </p:sld>
 </file>
 
-<file path=ppt/slides/slide17.xml><?xml version="1.0" encoding="utf-8"?>
+<file path=ppt/slides/slide18.xml><?xml version="1.0" encoding="utf-8"?>
 <p:sld xmlns:a="http://schemas.openxmlformats.org/drawingml/2006/main" xmlns:p="http://schemas.openxmlformats.org/presentationml/2006/main" xmlns:r="http://schemas.openxmlformats.org/officeDocument/2006/relationships" xmlns:p14="http://schemas.microsoft.com/office/powerpoint/2010/main" xmlns:p15="http://schemas.microsoft.com/office/powerpoint/2012/main" xmlns:mc="http://schemas.openxmlformats.org/markup-compatibility/2006">
   <p:cSld>
     <p:spTree>
@@ -12487,7 +12966,7 @@
 </p:sld>
 </file>
 
-<file path=ppt/slides/slide18.xml><?xml version="1.0" encoding="utf-8"?>
+<file path=ppt/slides/slide19.xml><?xml version="1.0" encoding="utf-8"?>
 <p:sld xmlns:a="http://schemas.openxmlformats.org/drawingml/2006/main" xmlns:p="http://schemas.openxmlformats.org/presentationml/2006/main" xmlns:r="http://schemas.openxmlformats.org/officeDocument/2006/relationships" xmlns:p14="http://schemas.microsoft.com/office/powerpoint/2010/main" xmlns:p15="http://schemas.microsoft.com/office/powerpoint/2012/main" xmlns:mc="http://schemas.openxmlformats.org/markup-compatibility/2006">
   <p:cSld>
     <p:spTree>
@@ -13011,7 +13490,153 @@
 </p:sld>
 </file>
 
-<file path=ppt/slides/slide19.xml><?xml version="1.0" encoding="utf-8"?>
+<file path=ppt/slides/slide2.xml><?xml version="1.0" encoding="utf-8"?>
+<p:sld xmlns:a="http://schemas.openxmlformats.org/drawingml/2006/main" xmlns:p="http://schemas.openxmlformats.org/presentationml/2006/main" xmlns:r="http://schemas.openxmlformats.org/officeDocument/2006/relationships">
+  <p:cSld>
+    <p:spTree>
+      <p:nvGrpSpPr>
+        <p:cNvPr id="1" name=""/>
+        <p:cNvGrpSpPr/>
+        <p:nvPr/>
+      </p:nvGrpSpPr>
+      <p:grpSpPr/>
+      <p:sp>
+        <p:nvSpPr>
+          <p:cNvPr id="2" name="Title 1"/>
+          <p:cNvSpPr>
+            <a:spLocks noGrp="1"/>
+          </p:cNvSpPr>
+          <p:nvPr>
+            <p:ph type="title"/>
+          </p:nvPr>
+        </p:nvSpPr>
+        <p:spPr/>
+        <p:txBody>
+          <a:bodyPr/>
+          <a:lstStyle/>
+          <a:p>
+            <a:r>
+              <a:t>What Was Done Since the 16 June Meeting</a:t>
+            </a:r>
+          </a:p>
+        </p:txBody>
+      </p:sp>
+      <p:sp>
+        <p:nvSpPr>
+          <p:cNvPr id="3" name="Text Placeholder 2"/>
+          <p:cNvSpPr>
+            <a:spLocks noGrp="1"/>
+          </p:cNvSpPr>
+          <p:nvPr>
+            <p:ph type="body"/>
+          </p:nvPr>
+        </p:nvSpPr>
+        <p:spPr/>
+        <p:txBody>
+          <a:bodyPr/>
+          <a:lstStyle/>
+          <a:p/>
+        </p:txBody>
+      </p:sp>
+      <p:sp>
+        <p:nvSpPr>
+          <p:cNvPr id="4" name="TextBox 3"/>
+          <p:cNvSpPr txBox="1"/>
+          <p:nvPr/>
+        </p:nvSpPr>
+        <p:spPr>
+          <a:xfrm>
+            <a:off x="457200" y="1280160"/>
+            <a:ext cx="11247120" cy="4937760"/>
+          </a:xfrm>
+          <a:prstGeom prst="rect">
+            <a:avLst/>
+          </a:prstGeom>
+          <a:noFill/>
+        </p:spPr>
+        <p:txBody>
+          <a:bodyPr wrap="square">
+            <a:spAutoFit/>
+          </a:bodyPr>
+          <a:lstStyle/>
+          <a:p>
+            <a:r>
+              <a:rPr sz="1300" b="1"/>
+              <a:t>NEW RESULT — LLM operationalizes the TE rubric (see results slides):</a:t>
+            </a:r>
+          </a:p>
+          <a:p>
+            <a:pPr lvl="1"/>
+            <a:r>
+              <a:rPr sz="1100"/>
+              <a:t>• Took the study's own coding schema (Low/Med/High markers) and made it an LLM prompt — local Qwen3.6-27B, German transcripts, 60 s group-windows, clean labels. Zero-shot (NO training, NO gaze) ties the best multimodal fusion (~0.75 All).</a:t>
+            </a:r>
+          </a:p>
+          <a:p>
+            <a:pPr lvl="1"/>
+            <a:r>
+              <a:rPr sz="1100"/>
+              <a:t>• Marker features (4 rubric axes): thinking mode All 0.81 / Triads 0.84 — highest single channel. German BERT baseline ties → the signal is in the text.</a:t>
+            </a:r>
+          </a:p>
+          <a:p>
+            <a:pPr lvl="1"/>
+            <a:r>
+              <a:rPr sz="1100"/>
+              <a:t>• BEST CONFIG = Gaze×Speaking + LLM fusion: All 0.86 / Dyads 0.87 (perm p≈.003) — beats every prior, every modality, and the old gaze+vad fusion; makes Dyads gaze significant.</a:t>
+            </a:r>
+          </a:p>
+          <a:p>
+            <a:r>
+              <a:rPr sz="1300" b="1"/>
+              <a:t>Methodology &amp; comparison:</a:t>
+            </a:r>
+          </a:p>
+          <a:p>
+            <a:pPr lvl="1"/>
+            <a:r>
+              <a:rPr sz="1100"/>
+              <a:t>• Methodology-review section: significance flip-flop (permutation vs majority t-test), group-level vs long-format, open decisions — significance method still PENDING team decision.</a:t>
+            </a:r>
+          </a:p>
+          <a:p>
+            <a:pPr lvl="1"/>
+            <a:r>
+              <a:rPr sz="1100"/>
+              <a:t>• Our detector vs 3 consistent priors (dummy / AIxVR / GazexSpeaking) + audio fusion, both significance tests shown; slide 2 redone with the true majority baseline.</a:t>
+            </a:r>
+          </a:p>
+          <a:p>
+            <a:pPr lvl="1"/>
+            <a:r>
+              <a:rPr sz="1100"/>
+              <a:t>• openSMILE raw acoustics (88 eGeMAPS) vs v/a/d affect → affect wins; raw acoustics don't beat the 3-dim estimate.</a:t>
+            </a:r>
+          </a:p>
+          <a:p>
+            <a:r>
+              <a:rPr sz="1300" b="1"/>
+              <a:t>Pipeline:</a:t>
+            </a:r>
+          </a:p>
+          <a:p>
+            <a:pPr lvl="1"/>
+            <a:r>
+              <a:rPr sz="1100"/>
+              <a:t>• Group-TE decoupled to per-group rows (Q2); idea1 stale labels retired (now points to the clean fusion table).</a:t>
+            </a:r>
+          </a:p>
+        </p:txBody>
+      </p:sp>
+    </p:spTree>
+  </p:cSld>
+  <p:clrMapOvr>
+    <a:masterClrMapping/>
+  </p:clrMapOvr>
+</p:sld>
+</file>
+
+<file path=ppt/slides/slide20.xml><?xml version="1.0" encoding="utf-8"?>
 <p:sld xmlns:a="http://schemas.openxmlformats.org/drawingml/2006/main" xmlns:p="http://schemas.openxmlformats.org/presentationml/2006/main" xmlns:r="http://schemas.openxmlformats.org/officeDocument/2006/relationships" xmlns:p14="http://schemas.microsoft.com/office/powerpoint/2010/main" xmlns:p15="http://schemas.microsoft.com/office/powerpoint/2012/main" xmlns:mc="http://schemas.openxmlformats.org/markup-compatibility/2006">
   <p:cSld>
     <p:spTree>
@@ -13189,153 +13814,7 @@
 </p:sld>
 </file>
 
-<file path=ppt/slides/slide2.xml><?xml version="1.0" encoding="utf-8"?>
-<p:sld xmlns:a="http://schemas.openxmlformats.org/drawingml/2006/main" xmlns:p="http://schemas.openxmlformats.org/presentationml/2006/main" xmlns:r="http://schemas.openxmlformats.org/officeDocument/2006/relationships">
-  <p:cSld>
-    <p:spTree>
-      <p:nvGrpSpPr>
-        <p:cNvPr id="1" name=""/>
-        <p:cNvGrpSpPr/>
-        <p:nvPr/>
-      </p:nvGrpSpPr>
-      <p:grpSpPr/>
-      <p:sp>
-        <p:nvSpPr>
-          <p:cNvPr id="2" name="Title 1"/>
-          <p:cNvSpPr>
-            <a:spLocks noGrp="1"/>
-          </p:cNvSpPr>
-          <p:nvPr>
-            <p:ph type="title"/>
-          </p:nvPr>
-        </p:nvSpPr>
-        <p:spPr/>
-        <p:txBody>
-          <a:bodyPr/>
-          <a:lstStyle/>
-          <a:p>
-            <a:r>
-              <a:t>What Was Done Since the 16 June Meeting</a:t>
-            </a:r>
-          </a:p>
-        </p:txBody>
-      </p:sp>
-      <p:sp>
-        <p:nvSpPr>
-          <p:cNvPr id="3" name="Text Placeholder 2"/>
-          <p:cNvSpPr>
-            <a:spLocks noGrp="1"/>
-          </p:cNvSpPr>
-          <p:nvPr>
-            <p:ph type="body"/>
-          </p:nvPr>
-        </p:nvSpPr>
-        <p:spPr/>
-        <p:txBody>
-          <a:bodyPr/>
-          <a:lstStyle/>
-          <a:p/>
-        </p:txBody>
-      </p:sp>
-      <p:sp>
-        <p:nvSpPr>
-          <p:cNvPr id="4" name="TextBox 3"/>
-          <p:cNvSpPr txBox="1"/>
-          <p:nvPr/>
-        </p:nvSpPr>
-        <p:spPr>
-          <a:xfrm>
-            <a:off x="457200" y="1280160"/>
-            <a:ext cx="11247120" cy="4937760"/>
-          </a:xfrm>
-          <a:prstGeom prst="rect">
-            <a:avLst/>
-          </a:prstGeom>
-          <a:noFill/>
-        </p:spPr>
-        <p:txBody>
-          <a:bodyPr wrap="square">
-            <a:spAutoFit/>
-          </a:bodyPr>
-          <a:lstStyle/>
-          <a:p>
-            <a:r>
-              <a:rPr sz="1300" b="1"/>
-              <a:t>NEW RESULT — LLM operationalizes the TE rubric (slides 25–26):</a:t>
-            </a:r>
-          </a:p>
-          <a:p>
-            <a:pPr lvl="1"/>
-            <a:r>
-              <a:rPr sz="1100"/>
-              <a:t>• Took the study's own coding schema (Low/Med/High markers) and made it an LLM prompt — local Qwen3.6-27B, German transcripts, 60 s group-windows, clean labels. Zero-shot (NO training, NO gaze) ties the best multimodal fusion (~0.75 All).</a:t>
-            </a:r>
-          </a:p>
-          <a:p>
-            <a:pPr lvl="1"/>
-            <a:r>
-              <a:rPr sz="1100"/>
-              <a:t>• Marker features (4 rubric axes): thinking mode All 0.81 / Triads 0.84 — highest single channel. German BERT baseline ties → the signal is in the text.</a:t>
-            </a:r>
-          </a:p>
-          <a:p>
-            <a:pPr lvl="1"/>
-            <a:r>
-              <a:rPr sz="1100"/>
-              <a:t>• BEST CONFIG = Gaze×Speaking + LLM fusion: All 0.86 / Dyads 0.87 (perm p≈.003) — beats every prior, every modality, and the old gaze+vad fusion; makes Dyads gaze significant.</a:t>
-            </a:r>
-          </a:p>
-          <a:p>
-            <a:r>
-              <a:rPr sz="1300" b="1"/>
-              <a:t>Methodology &amp; comparison (slides 20–24, 2):</a:t>
-            </a:r>
-          </a:p>
-          <a:p>
-            <a:pPr lvl="1"/>
-            <a:r>
-              <a:rPr sz="1100"/>
-              <a:t>• Methodology-review section: significance flip-flop (permutation vs majority t-test), group-level vs long-format, open decisions — significance method still PENDING team decision.</a:t>
-            </a:r>
-          </a:p>
-          <a:p>
-            <a:pPr lvl="1"/>
-            <a:r>
-              <a:rPr sz="1100"/>
-              <a:t>• Our detector vs 3 consistent priors (dummy / AIxVR / GazexSpeaking) + audio fusion, both significance tests shown; slide 2 redone with the true majority baseline.</a:t>
-            </a:r>
-          </a:p>
-          <a:p>
-            <a:pPr lvl="1"/>
-            <a:r>
-              <a:rPr sz="1100"/>
-              <a:t>• openSMILE raw acoustics (88 eGeMAPS) vs v/a/d affect → affect wins; raw acoustics don't beat the 3-dim estimate.</a:t>
-            </a:r>
-          </a:p>
-          <a:p>
-            <a:r>
-              <a:rPr sz="1300" b="1"/>
-              <a:t>Pipeline:</a:t>
-            </a:r>
-          </a:p>
-          <a:p>
-            <a:pPr lvl="1"/>
-            <a:r>
-              <a:rPr sz="1100"/>
-              <a:t>• Group-TE decoupled to per-group rows (Q2); idea1 stale labels retired (now points to the clean fusion table).</a:t>
-            </a:r>
-          </a:p>
-        </p:txBody>
-      </p:sp>
-    </p:spTree>
-  </p:cSld>
-  <p:clrMapOvr>
-    <a:masterClrMapping/>
-  </p:clrMapOvr>
-</p:sld>
-</file>
-
-<file path=ppt/slides/slide20.xml><?xml version="1.0" encoding="utf-8"?>
+<file path=ppt/slides/slide21.xml><?xml version="1.0" encoding="utf-8"?>
 <p:sld xmlns:a="http://schemas.openxmlformats.org/drawingml/2006/main" xmlns:p="http://schemas.openxmlformats.org/presentationml/2006/main" xmlns:r="http://schemas.openxmlformats.org/officeDocument/2006/relationships">
   <p:cSld>
     <p:spTree>
@@ -14022,7 +14501,7 @@
 </p:sld>
 </file>
 
-<file path=ppt/slides/slide21.xml><?xml version="1.0" encoding="utf-8"?>
+<file path=ppt/slides/slide22.xml><?xml version="1.0" encoding="utf-8"?>
 <p:sld xmlns:a="http://schemas.openxmlformats.org/drawingml/2006/main" xmlns:p="http://schemas.openxmlformats.org/presentationml/2006/main" xmlns:r="http://schemas.openxmlformats.org/officeDocument/2006/relationships">
   <p:cSld>
     <p:spTree>
@@ -14363,7 +14842,7 @@
 </p:sld>
 </file>
 
-<file path=ppt/slides/slide22.xml><?xml version="1.0" encoding="utf-8"?>
+<file path=ppt/slides/slide23.xml><?xml version="1.0" encoding="utf-8"?>
 <p:sld xmlns:a="http://schemas.openxmlformats.org/drawingml/2006/main" xmlns:p="http://schemas.openxmlformats.org/presentationml/2006/main" xmlns:r="http://schemas.openxmlformats.org/officeDocument/2006/relationships">
   <p:cSld>
     <p:spTree>
@@ -14490,7 +14969,7 @@
 </p:sld>
 </file>
 
-<file path=ppt/slides/slide23.xml><?xml version="1.0" encoding="utf-8"?>
+<file path=ppt/slides/slide24.xml><?xml version="1.0" encoding="utf-8"?>
 <p:sld xmlns:a="http://schemas.openxmlformats.org/drawingml/2006/main" xmlns:p="http://schemas.openxmlformats.org/presentationml/2006/main" xmlns:r="http://schemas.openxmlformats.org/officeDocument/2006/relationships">
   <p:cSld>
     <p:spTree>
@@ -16125,7 +16604,7 @@
 </p:sld>
 </file>
 
-<file path=ppt/slides/slide24.xml><?xml version="1.0" encoding="utf-8"?>
+<file path=ppt/slides/slide25.xml><?xml version="1.0" encoding="utf-8"?>
 <p:sld xmlns:a="http://schemas.openxmlformats.org/drawingml/2006/main" xmlns:p="http://schemas.openxmlformats.org/presentationml/2006/main" xmlns:r="http://schemas.openxmlformats.org/officeDocument/2006/relationships">
   <p:cSld>
     <p:spTree>
@@ -16732,7 +17211,7 @@
 </p:sld>
 </file>
 
-<file path=ppt/slides/slide25.xml><?xml version="1.0" encoding="utf-8"?>
+<file path=ppt/slides/slide26.xml><?xml version="1.0" encoding="utf-8"?>
 <p:sld xmlns:a="http://schemas.openxmlformats.org/drawingml/2006/main" xmlns:p="http://schemas.openxmlformats.org/presentationml/2006/main" xmlns:r="http://schemas.openxmlformats.org/officeDocument/2006/relationships">
   <p:cSld>
     <p:spTree>
@@ -17297,7 +17776,7 @@
 </p:sld>
 </file>
 
-<file path=ppt/slides/slide26.xml><?xml version="1.0" encoding="utf-8"?>
+<file path=ppt/slides/slide27.xml><?xml version="1.0" encoding="utf-8"?>
 <p:sld xmlns:a="http://schemas.openxmlformats.org/drawingml/2006/main" xmlns:p="http://schemas.openxmlformats.org/presentationml/2006/main" xmlns:r="http://schemas.openxmlformats.org/officeDocument/2006/relationships">
   <p:cSld>
     <p:spTree>
@@ -17756,7 +18235,693 @@
 </p:sld>
 </file>
 
-<file path=ppt/slides/slide27.xml><?xml version="1.0" encoding="utf-8"?>
+<file path=ppt/slides/slide28.xml><?xml version="1.0" encoding="utf-8"?>
+<p:sld xmlns:a="http://schemas.openxmlformats.org/drawingml/2006/main" xmlns:p="http://schemas.openxmlformats.org/presentationml/2006/main" xmlns:r="http://schemas.openxmlformats.org/officeDocument/2006/relationships">
+  <p:cSld>
+    <p:spTree>
+      <p:nvGrpSpPr>
+        <p:cNvPr id="1" name=""/>
+        <p:cNvGrpSpPr/>
+        <p:nvPr/>
+      </p:nvGrpSpPr>
+      <p:grpSpPr/>
+      <p:sp>
+        <p:nvSpPr>
+          <p:cNvPr id="2" name="Title 1"/>
+          <p:cNvSpPr>
+            <a:spLocks noGrp="1"/>
+          </p:cNvSpPr>
+          <p:nvPr>
+            <p:ph type="title"/>
+          </p:nvPr>
+        </p:nvSpPr>
+        <p:spPr/>
+        <p:txBody>
+          <a:bodyPr/>
+          <a:lstStyle/>
+          <a:p>
+            <a:r>
+              <a:t>LLM Rubric Prompt (operationalizing the TE schema)</a:t>
+            </a:r>
+          </a:p>
+        </p:txBody>
+      </p:sp>
+      <p:sp>
+        <p:nvSpPr>
+          <p:cNvPr id="3" name="Text Placeholder 2"/>
+          <p:cNvSpPr>
+            <a:spLocks noGrp="1"/>
+          </p:cNvSpPr>
+          <p:nvPr>
+            <p:ph type="body"/>
+          </p:nvPr>
+        </p:nvSpPr>
+        <p:spPr/>
+        <p:txBody>
+          <a:bodyPr/>
+          <a:lstStyle/>
+          <a:p/>
+        </p:txBody>
+      </p:sp>
+      <p:sp>
+        <p:nvSpPr>
+          <p:cNvPr id="4" name="TextBox 3"/>
+          <p:cNvSpPr txBox="1"/>
+          <p:nvPr/>
+        </p:nvSpPr>
+        <p:spPr>
+          <a:xfrm>
+            <a:off x="457200" y="1188720"/>
+            <a:ext cx="11247120" cy="5120640"/>
+          </a:xfrm>
+          <a:prstGeom prst="rect">
+            <a:avLst/>
+          </a:prstGeom>
+          <a:noFill/>
+        </p:spPr>
+        <p:txBody>
+          <a:bodyPr wrap="square">
+            <a:spAutoFit/>
+          </a:bodyPr>
+          <a:lstStyle/>
+          <a:p>
+            <a:r>
+              <a:rPr sz="1200" b="1"/>
+              <a:t>SYSTEM (rubric, verbatim from the study's coding schema):</a:t>
+            </a:r>
+          </a:p>
+          <a:p>
+            <a:r>
+              <a:rPr sz="1100" b="0"/>
+              <a:t>Rate the TASK ENGAGEMENT of a group's discussion in a 60 s window of a collaborative VR learning task (German transcript, speakers tagged [blue]/[green]/[red]).</a:t>
+            </a:r>
+          </a:p>
+          <a:p>
+            <a:r>
+              <a:rPr sz="1100" b="0"/>
+              <a:t>LOW — silence / no cognitive interaction; OR talk WITHOUT content engagement (off-topic).</a:t>
+            </a:r>
+          </a:p>
+          <a:p>
+            <a:r>
+              <a:rPr sz="1100" b="0"/>
+              <a:t>MEDIUM — task discussed SUPERFICIALLY: repeating the task, opinions/experiences without reasoning, depth, or connections.</a:t>
+            </a:r>
+          </a:p>
+          <a:p>
+            <a:r>
+              <a:rPr sz="1100" b="0"/>
+              <a:t>HIGH — ELABORATE: prior knowledge, making connections, hypotheticals, out-of-the-box.</a:t>
+            </a:r>
+          </a:p>
+          <a:p>
+            <a:r>
+              <a:rPr sz="1200" b="1"/>
+              <a:t>Rate 0.0–1.0 on 4 axes:  task_relevance · content_depth · reasoning_present · connecting_ideas. Then te_continuous (0–1) and predicted_level (low/medium/high).</a:t>
+            </a:r>
+          </a:p>
+          <a:p>
+            <a:r>
+              <a:rPr sz="1100" b="0"/>
+              <a:t>Output: JSON only — {"task_relevance":_, "content_depth":_, "reasoning_present":_, "connecting_ideas":_, "te_continuous":_, "predicted_level":"low|medium|high"}</a:t>
+            </a:r>
+          </a:p>
+          <a:p>
+            <a:r>
+              <a:rPr sz="1200" b="1"/>
+              <a:t>USER:  Transcript:\n[blue] … [green] … [red] …   (the window's diarized turns, time-ordered)</a:t>
+            </a:r>
+          </a:p>
+          <a:p>
+            <a:r>
+              <a:rPr sz="1100" b="0"/>
+              <a:t>Model: local Qwen3.6-27B, temperature per HF (think: 1.0 / non-think: 0.7), seed 42, JSON-forced. One call per window (~185). Binarize te_continuous at 0.5 for the high/low prediction.</a:t>
+            </a:r>
+          </a:p>
+        </p:txBody>
+      </p:sp>
+    </p:spTree>
+  </p:cSld>
+  <p:clrMapOvr>
+    <a:masterClrMapping/>
+  </p:clrMapOvr>
+</p:sld>
+</file>
+
+<file path=ppt/slides/slide29.xml><?xml version="1.0" encoding="utf-8"?>
+<p:sld xmlns:a="http://schemas.openxmlformats.org/drawingml/2006/main" xmlns:p="http://schemas.openxmlformats.org/presentationml/2006/main" xmlns:r="http://schemas.openxmlformats.org/officeDocument/2006/relationships">
+  <p:cSld>
+    <p:spTree>
+      <p:nvGrpSpPr>
+        <p:cNvPr id="1" name=""/>
+        <p:cNvGrpSpPr/>
+        <p:nvPr/>
+      </p:nvGrpSpPr>
+      <p:grpSpPr/>
+      <p:sp>
+        <p:nvSpPr>
+          <p:cNvPr id="2" name="Title 1"/>
+          <p:cNvSpPr>
+            <a:spLocks noGrp="1"/>
+          </p:cNvSpPr>
+          <p:nvPr>
+            <p:ph type="title"/>
+          </p:nvPr>
+        </p:nvSpPr>
+        <p:spPr/>
+        <p:txBody>
+          <a:bodyPr/>
+          <a:lstStyle/>
+          <a:p>
+            <a:r>
+              <a:t>LLM Markers — Worked Examples (Low / Medium / High)</a:t>
+            </a:r>
+          </a:p>
+        </p:txBody>
+      </p:sp>
+      <p:sp>
+        <p:nvSpPr>
+          <p:cNvPr id="3" name="Text Placeholder 2"/>
+          <p:cNvSpPr>
+            <a:spLocks noGrp="1"/>
+          </p:cNvSpPr>
+          <p:nvPr>
+            <p:ph type="body"/>
+          </p:nvPr>
+        </p:nvSpPr>
+        <p:spPr/>
+        <p:txBody>
+          <a:bodyPr/>
+          <a:lstStyle/>
+          <a:p/>
+        </p:txBody>
+      </p:sp>
+      <p:graphicFrame>
+        <p:nvGraphicFramePr>
+          <p:cNvPr id="4" name="Table 3"/>
+          <p:cNvGraphicFramePr>
+            <a:graphicFrameLocks noGrp="1"/>
+          </p:cNvGraphicFramePr>
+          <p:nvPr/>
+        </p:nvGraphicFramePr>
+        <p:xfrm>
+          <a:off x="274320" y="1188720"/>
+          <a:ext cx="9966960" cy="1280160"/>
+        </p:xfrm>
+        <a:graphic>
+          <a:graphicData uri="http://schemas.openxmlformats.org/drawingml/2006/table">
+            <a:tbl>
+              <a:tblPr firstRow="1" bandRow="1">
+                <a:tableStyleId>{5C22544A-7EE6-4342-B048-85BDC9FD1C3A}</a:tableStyleId>
+              </a:tblPr>
+              <a:tblGrid>
+                <a:gridCol w="822960"/>
+                <a:gridCol w="4572000"/>
+                <a:gridCol w="914400"/>
+                <a:gridCol w="822960"/>
+                <a:gridCol w="822960"/>
+                <a:gridCol w="914400"/>
+                <a:gridCol w="640080"/>
+                <a:gridCol w="457200"/>
+              </a:tblGrid>
+              <a:tr h="320040">
+                <a:tc>
+                  <a:txBody>
+                    <a:bodyPr/>
+                    <a:lstStyle/>
+                    <a:p>
+                      <a:r>
+                        <a:rPr sz="1000" b="1"/>
+                        <a:t>Level</a:t>
+                      </a:r>
+                    </a:p>
+                  </a:txBody>
+                  <a:tcPr/>
+                </a:tc>
+                <a:tc>
+                  <a:txBody>
+                    <a:bodyPr/>
+                    <a:lstStyle/>
+                    <a:p>
+                      <a:r>
+                        <a:rPr sz="1000" b="1"/>
+                        <a:t>Transcript (excerpt)</a:t>
+                      </a:r>
+                    </a:p>
+                  </a:txBody>
+                  <a:tcPr/>
+                </a:tc>
+                <a:tc>
+                  <a:txBody>
+                    <a:bodyPr/>
+                    <a:lstStyle/>
+                    <a:p>
+                      <a:r>
+                        <a:rPr sz="1000" b="1"/>
+                        <a:t>task_rel</a:t>
+                      </a:r>
+                    </a:p>
+                  </a:txBody>
+                  <a:tcPr/>
+                </a:tc>
+                <a:tc>
+                  <a:txBody>
+                    <a:bodyPr/>
+                    <a:lstStyle/>
+                    <a:p>
+                      <a:r>
+                        <a:rPr sz="1000" b="1"/>
+                        <a:t>depth</a:t>
+                      </a:r>
+                    </a:p>
+                  </a:txBody>
+                  <a:tcPr/>
+                </a:tc>
+                <a:tc>
+                  <a:txBody>
+                    <a:bodyPr/>
+                    <a:lstStyle/>
+                    <a:p>
+                      <a:r>
+                        <a:rPr sz="1000" b="1"/>
+                        <a:t>reason</a:t>
+                      </a:r>
+                    </a:p>
+                  </a:txBody>
+                  <a:tcPr/>
+                </a:tc>
+                <a:tc>
+                  <a:txBody>
+                    <a:bodyPr/>
+                    <a:lstStyle/>
+                    <a:p>
+                      <a:r>
+                        <a:rPr sz="1000" b="1"/>
+                        <a:t>connect</a:t>
+                      </a:r>
+                    </a:p>
+                  </a:txBody>
+                  <a:tcPr/>
+                </a:tc>
+                <a:tc>
+                  <a:txBody>
+                    <a:bodyPr/>
+                    <a:lstStyle/>
+                    <a:p>
+                      <a:r>
+                        <a:rPr sz="1000" b="1"/>
+                        <a:t>te</a:t>
+                      </a:r>
+                    </a:p>
+                  </a:txBody>
+                  <a:tcPr/>
+                </a:tc>
+                <a:tc>
+                  <a:txBody>
+                    <a:bodyPr/>
+                    <a:lstStyle/>
+                    <a:p>
+                      <a:r>
+                        <a:rPr sz="1000" b="1"/>
+                        <a:t>y</a:t>
+                      </a:r>
+                    </a:p>
+                  </a:txBody>
+                  <a:tcPr/>
+                </a:tc>
+              </a:tr>
+              <a:tr h="320040">
+                <a:tc>
+                  <a:txBody>
+                    <a:bodyPr/>
+                    <a:lstStyle/>
+                    <a:p>
+                      <a:r>
+                        <a:rPr sz="900"/>
+                        <a:t>Low</a:t>
+                      </a:r>
+                    </a:p>
+                  </a:txBody>
+                  <a:tcPr/>
+                </a:tc>
+                <a:tc>
+                  <a:txBody>
+                    <a:bodyPr/>
+                    <a:lstStyle/>
+                    <a:p>
+                      <a:r>
+                        <a:rPr sz="900"/>
+                        <a:t>[red] Aber Wolfgang hat vorher gerade schon seinen typischen Wolfgang. [red] Weißt du, ich konnte gar nicht noch mal so... [green] Welchen? [red] Irge…</a:t>
+                      </a:r>
+                    </a:p>
+                  </a:txBody>
+                  <a:tcPr/>
+                </a:tc>
+                <a:tc>
+                  <a:txBody>
+                    <a:bodyPr/>
+                    <a:lstStyle/>
+                    <a:p>
+                      <a:r>
+                        <a:rPr sz="900"/>
+                        <a:t>0.00</a:t>
+                      </a:r>
+                    </a:p>
+                  </a:txBody>
+                  <a:tcPr/>
+                </a:tc>
+                <a:tc>
+                  <a:txBody>
+                    <a:bodyPr/>
+                    <a:lstStyle/>
+                    <a:p>
+                      <a:r>
+                        <a:rPr sz="900"/>
+                        <a:t>0.00</a:t>
+                      </a:r>
+                    </a:p>
+                  </a:txBody>
+                  <a:tcPr/>
+                </a:tc>
+                <a:tc>
+                  <a:txBody>
+                    <a:bodyPr/>
+                    <a:lstStyle/>
+                    <a:p>
+                      <a:r>
+                        <a:rPr sz="900"/>
+                        <a:t>0.00</a:t>
+                      </a:r>
+                    </a:p>
+                  </a:txBody>
+                  <a:tcPr/>
+                </a:tc>
+                <a:tc>
+                  <a:txBody>
+                    <a:bodyPr/>
+                    <a:lstStyle/>
+                    <a:p>
+                      <a:r>
+                        <a:rPr sz="900"/>
+                        <a:t>0.00</a:t>
+                      </a:r>
+                    </a:p>
+                  </a:txBody>
+                  <a:tcPr/>
+                </a:tc>
+                <a:tc>
+                  <a:txBody>
+                    <a:bodyPr/>
+                    <a:lstStyle/>
+                    <a:p>
+                      <a:r>
+                        <a:rPr sz="900"/>
+                        <a:t>0.00</a:t>
+                      </a:r>
+                    </a:p>
+                  </a:txBody>
+                  <a:tcPr/>
+                </a:tc>
+                <a:tc>
+                  <a:txBody>
+                    <a:bodyPr/>
+                    <a:lstStyle/>
+                    <a:p>
+                      <a:r>
+                        <a:rPr sz="900"/>
+                        <a:t>0</a:t>
+                      </a:r>
+                    </a:p>
+                  </a:txBody>
+                  <a:tcPr/>
+                </a:tc>
+              </a:tr>
+              <a:tr h="320040">
+                <a:tc>
+                  <a:txBody>
+                    <a:bodyPr/>
+                    <a:lstStyle/>
+                    <a:p>
+                      <a:r>
+                        <a:rPr sz="900"/>
+                        <a:t>Medium</a:t>
+                      </a:r>
+                    </a:p>
+                  </a:txBody>
+                  <a:tcPr/>
+                </a:tc>
+                <a:tc>
+                  <a:txBody>
+                    <a:bodyPr/>
+                    <a:lstStyle/>
+                    <a:p>
+                      <a:r>
+                        <a:rPr sz="900"/>
+                        <a:t>[green] okay [red] Wollen wir einfach anfangen mit Grundschul? [red] Ja, gerne. [blue] Ich muss sagen, also ne, [blue] du hast ja auch bei Lehrplan Pl…</a:t>
+                      </a:r>
+                    </a:p>
+                  </a:txBody>
+                  <a:tcPr/>
+                </a:tc>
+                <a:tc>
+                  <a:txBody>
+                    <a:bodyPr/>
+                    <a:lstStyle/>
+                    <a:p>
+                      <a:r>
+                        <a:rPr sz="900"/>
+                        <a:t>0.85</a:t>
+                      </a:r>
+                    </a:p>
+                  </a:txBody>
+                  <a:tcPr/>
+                </a:tc>
+                <a:tc>
+                  <a:txBody>
+                    <a:bodyPr/>
+                    <a:lstStyle/>
+                    <a:p>
+                      <a:r>
+                        <a:rPr sz="900"/>
+                        <a:t>0.45</a:t>
+                      </a:r>
+                    </a:p>
+                  </a:txBody>
+                  <a:tcPr/>
+                </a:tc>
+                <a:tc>
+                  <a:txBody>
+                    <a:bodyPr/>
+                    <a:lstStyle/>
+                    <a:p>
+                      <a:r>
+                        <a:rPr sz="900"/>
+                        <a:t>0.35</a:t>
+                      </a:r>
+                    </a:p>
+                  </a:txBody>
+                  <a:tcPr/>
+                </a:tc>
+                <a:tc>
+                  <a:txBody>
+                    <a:bodyPr/>
+                    <a:lstStyle/>
+                    <a:p>
+                      <a:r>
+                        <a:rPr sz="900"/>
+                        <a:t>0.40</a:t>
+                      </a:r>
+                    </a:p>
+                  </a:txBody>
+                  <a:tcPr/>
+                </a:tc>
+                <a:tc>
+                  <a:txBody>
+                    <a:bodyPr/>
+                    <a:lstStyle/>
+                    <a:p>
+                      <a:r>
+                        <a:rPr sz="900"/>
+                        <a:t>0.50</a:t>
+                      </a:r>
+                    </a:p>
+                  </a:txBody>
+                  <a:tcPr/>
+                </a:tc>
+                <a:tc>
+                  <a:txBody>
+                    <a:bodyPr/>
+                    <a:lstStyle/>
+                    <a:p>
+                      <a:r>
+                        <a:rPr sz="900"/>
+                        <a:t>0</a:t>
+                      </a:r>
+                    </a:p>
+                  </a:txBody>
+                  <a:tcPr/>
+                </a:tc>
+              </a:tr>
+              <a:tr h="320040">
+                <a:tc>
+                  <a:txBody>
+                    <a:bodyPr/>
+                    <a:lstStyle/>
+                    <a:p>
+                      <a:r>
+                        <a:rPr sz="900"/>
+                        <a:t>High</a:t>
+                      </a:r>
+                    </a:p>
+                  </a:txBody>
+                  <a:tcPr/>
+                </a:tc>
+                <a:tc>
+                  <a:txBody>
+                    <a:bodyPr/>
+                    <a:lstStyle/>
+                    <a:p>
+                      <a:r>
+                        <a:rPr sz="900"/>
+                        <a:t>[green] um alles auszubauen, dann hast du immer wieder diese Schwierigkeiten, das was wir bei unserem Unterrichtsbeispiel hatten, von letzter Woche [g…</a:t>
+                      </a:r>
+                    </a:p>
+                  </a:txBody>
+                  <a:tcPr/>
+                </a:tc>
+                <a:tc>
+                  <a:txBody>
+                    <a:bodyPr/>
+                    <a:lstStyle/>
+                    <a:p>
+                      <a:r>
+                        <a:rPr sz="900"/>
+                        <a:t>0.95</a:t>
+                      </a:r>
+                    </a:p>
+                  </a:txBody>
+                  <a:tcPr/>
+                </a:tc>
+                <a:tc>
+                  <a:txBody>
+                    <a:bodyPr/>
+                    <a:lstStyle/>
+                    <a:p>
+                      <a:r>
+                        <a:rPr sz="900"/>
+                        <a:t>0.85</a:t>
+                      </a:r>
+                    </a:p>
+                  </a:txBody>
+                  <a:tcPr/>
+                </a:tc>
+                <a:tc>
+                  <a:txBody>
+                    <a:bodyPr/>
+                    <a:lstStyle/>
+                    <a:p>
+                      <a:r>
+                        <a:rPr sz="900"/>
+                        <a:t>0.90</a:t>
+                      </a:r>
+                    </a:p>
+                  </a:txBody>
+                  <a:tcPr/>
+                </a:tc>
+                <a:tc>
+                  <a:txBody>
+                    <a:bodyPr/>
+                    <a:lstStyle/>
+                    <a:p>
+                      <a:r>
+                        <a:rPr sz="900"/>
+                        <a:t>0.85</a:t>
+                      </a:r>
+                    </a:p>
+                  </a:txBody>
+                  <a:tcPr/>
+                </a:tc>
+                <a:tc>
+                  <a:txBody>
+                    <a:bodyPr/>
+                    <a:lstStyle/>
+                    <a:p>
+                      <a:r>
+                        <a:rPr sz="900"/>
+                        <a:t>0.90</a:t>
+                      </a:r>
+                    </a:p>
+                  </a:txBody>
+                  <a:tcPr/>
+                </a:tc>
+                <a:tc>
+                  <a:txBody>
+                    <a:bodyPr/>
+                    <a:lstStyle/>
+                    <a:p>
+                      <a:r>
+                        <a:rPr sz="900"/>
+                        <a:t>1</a:t>
+                      </a:r>
+                    </a:p>
+                  </a:txBody>
+                  <a:tcPr/>
+                </a:tc>
+              </a:tr>
+            </a:tbl>
+          </a:graphicData>
+        </a:graphic>
+      </p:graphicFrame>
+      <p:sp>
+        <p:nvSpPr>
+          <p:cNvPr id="5" name="TextBox 4"/>
+          <p:cNvSpPr txBox="1"/>
+          <p:nvPr/>
+        </p:nvSpPr>
+        <p:spPr>
+          <a:xfrm>
+            <a:off x="274320" y="2926080"/>
+            <a:ext cx="11430000" cy="1828800"/>
+          </a:xfrm>
+          <a:prstGeom prst="rect">
+            <a:avLst/>
+          </a:prstGeom>
+          <a:noFill/>
+        </p:spPr>
+        <p:txBody>
+          <a:bodyPr wrap="square">
+            <a:spAutoFit/>
+          </a:bodyPr>
+          <a:lstStyle/>
+          <a:p>
+            <a:r>
+              <a:rPr sz="1100"/>
+              <a:t>• The 4 axes ARE the interpretable output: e.g. Low has task_relevance≈0.1 (off-task hand-gesture chatter); High scores high on all four (reasoning + connecting prior knowledge).</a:t>
+            </a:r>
+          </a:p>
+          <a:p>
+            <a:r>
+              <a:rPr sz="1100"/>
+              <a:t>• These per-axis scores are the features fed to the panel (idea (b)); te_continuous&gt;0.5 is the zero-shot prediction (idea (a)).</a:t>
+            </a:r>
+          </a:p>
+          <a:p>
+            <a:r>
+              <a:rPr sz="1100"/>
+              <a:t>• Medium is the ambiguous band where annotators disagree (weak κ) — kept here, binarized at 0.5.</a:t>
+            </a:r>
+          </a:p>
+        </p:txBody>
+      </p:sp>
+    </p:spTree>
+  </p:cSld>
+  <p:clrMapOvr>
+    <a:masterClrMapping/>
+  </p:clrMapOvr>
+</p:sld>
+</file>
+
+<file path=ppt/slides/slide3.xml><?xml version="1.0" encoding="utf-8"?>
 <p:sld xmlns:a="http://schemas.openxmlformats.org/drawingml/2006/main" xmlns:p="http://schemas.openxmlformats.org/presentationml/2006/main" xmlns:r="http://schemas.openxmlformats.org/officeDocument/2006/relationships">
   <p:cSld>
     <p:spTree>
@@ -17828,7 +18993,7 @@
           <a:p>
             <a:r>
               <a:rPr sz="1300" b="1"/>
-              <a:t>NEW RESULT — LLM operationalizes the TE rubric (see results slides):</a:t>
+              <a:t>NEW RESULT — LLM operationalizes the TE rubric (slides 25–26):</a:t>
             </a:r>
           </a:p>
           <a:p>
@@ -17855,7 +19020,7 @@
           <a:p>
             <a:r>
               <a:rPr sz="1300" b="1"/>
-              <a:t>Methodology &amp; comparison:</a:t>
+              <a:t>Methodology &amp; comparison (slides 20–24, 2):</a:t>
             </a:r>
           </a:p>
           <a:p>
@@ -17902,7 +19067,7 @@
 </p:sld>
 </file>
 
-<file path=ppt/slides/slide3.xml><?xml version="1.0" encoding="utf-8"?>
+<file path=ppt/slides/slide4.xml><?xml version="1.0" encoding="utf-8"?>
 <p:sld xmlns:a="http://schemas.openxmlformats.org/drawingml/2006/main" xmlns:p="http://schemas.openxmlformats.org/presentationml/2006/main" xmlns:r="http://schemas.openxmlformats.org/officeDocument/2006/relationships" xmlns:p14="http://schemas.microsoft.com/office/powerpoint/2010/main" xmlns:p15="http://schemas.microsoft.com/office/powerpoint/2012/main" xmlns:mc="http://schemas.openxmlformats.org/markup-compatibility/2006">
   <p:cSld>
     <p:spTree>
@@ -18344,7 +19509,7 @@
 </p:sld>
 </file>
 
-<file path=ppt/slides/slide4.xml><?xml version="1.0" encoding="utf-8"?>
+<file path=ppt/slides/slide5.xml><?xml version="1.0" encoding="utf-8"?>
 <p:sld xmlns:a="http://schemas.openxmlformats.org/drawingml/2006/main" xmlns:p="http://schemas.openxmlformats.org/presentationml/2006/main" xmlns:r="http://schemas.openxmlformats.org/officeDocument/2006/relationships" xmlns:p14="http://schemas.microsoft.com/office/powerpoint/2010/main" xmlns:p15="http://schemas.microsoft.com/office/powerpoint/2012/main" xmlns:mc="http://schemas.openxmlformats.org/markup-compatibility/2006">
   <p:cSld>
     <p:spTree>
@@ -20446,7 +21611,7 @@
 </p:sld>
 </file>
 
-<file path=ppt/slides/slide5.xml><?xml version="1.0" encoding="utf-8"?>
+<file path=ppt/slides/slide6.xml><?xml version="1.0" encoding="utf-8"?>
 <p:sld xmlns:a="http://schemas.openxmlformats.org/drawingml/2006/main" xmlns:p="http://schemas.openxmlformats.org/presentationml/2006/main" xmlns:r="http://schemas.openxmlformats.org/officeDocument/2006/relationships" xmlns:p14="http://schemas.microsoft.com/office/powerpoint/2010/main" xmlns:p15="http://schemas.microsoft.com/office/powerpoint/2012/main" xmlns:mc="http://schemas.openxmlformats.org/markup-compatibility/2006">
   <p:cSld>
     <p:spTree>
@@ -20821,7 +21986,7 @@
 </p:sld>
 </file>
 
-<file path=ppt/slides/slide6.xml><?xml version="1.0" encoding="utf-8"?>
+<file path=ppt/slides/slide7.xml><?xml version="1.0" encoding="utf-8"?>
 <p:sld xmlns:a="http://schemas.openxmlformats.org/drawingml/2006/main" xmlns:p="http://schemas.openxmlformats.org/presentationml/2006/main" xmlns:r="http://schemas.openxmlformats.org/officeDocument/2006/relationships" xmlns:p14="http://schemas.microsoft.com/office/powerpoint/2010/main" xmlns:p15="http://schemas.microsoft.com/office/powerpoint/2012/main" xmlns:mc="http://schemas.openxmlformats.org/markup-compatibility/2006">
   <p:cSld>
     <p:spTree>
@@ -21433,7 +22598,7 @@
 </p:sld>
 </file>
 
-<file path=ppt/slides/slide7.xml><?xml version="1.0" encoding="utf-8"?>
+<file path=ppt/slides/slide8.xml><?xml version="1.0" encoding="utf-8"?>
 <p:sld xmlns:a="http://schemas.openxmlformats.org/drawingml/2006/main" xmlns:p="http://schemas.openxmlformats.org/presentationml/2006/main" xmlns:r="http://schemas.openxmlformats.org/officeDocument/2006/relationships" xmlns:p14="http://schemas.microsoft.com/office/powerpoint/2010/main" xmlns:p15="http://schemas.microsoft.com/office/powerpoint/2012/main" xmlns:mc="http://schemas.openxmlformats.org/markup-compatibility/2006">
   <p:cSld>
     <p:spTree>
@@ -22152,7 +23317,7 @@
 </p:sld>
 </file>
 
-<file path=ppt/slides/slide8.xml><?xml version="1.0" encoding="utf-8"?>
+<file path=ppt/slides/slide9.xml><?xml version="1.0" encoding="utf-8"?>
 <p:sld xmlns:a="http://schemas.openxmlformats.org/drawingml/2006/main" xmlns:p="http://schemas.openxmlformats.org/presentationml/2006/main" xmlns:r="http://schemas.openxmlformats.org/officeDocument/2006/relationships" xmlns:p14="http://schemas.microsoft.com/office/powerpoint/2010/main" xmlns:p15="http://schemas.microsoft.com/office/powerpoint/2012/main" xmlns:mc="http://schemas.openxmlformats.org/markup-compatibility/2006">
   <p:cSld>
     <p:spTree>
@@ -22560,483 +23725,6 @@
               <a:effectLst/>
               <a:uFillTx/>
               <a:latin typeface="Arial"/>
-            </a:endParaRPr>
-          </a:p>
-        </p:txBody>
-      </p:sp>
-    </p:spTree>
-  </p:cSld>
-  <mc:AlternateContent>
-    <mc:Choice Requires="p14">
-      <p:transition spd="slow" p14:dur="2000"/>
-    </mc:Choice>
-    <mc:Fallback>
-      <p:transition spd="slow"/>
-    </mc:Fallback>
-  </mc:AlternateContent>
-</p:sld>
-</file>
-
-<file path=ppt/slides/slide9.xml><?xml version="1.0" encoding="utf-8"?>
-<p:sld xmlns:a="http://schemas.openxmlformats.org/drawingml/2006/main" xmlns:p="http://schemas.openxmlformats.org/presentationml/2006/main" xmlns:r="http://schemas.openxmlformats.org/officeDocument/2006/relationships" xmlns:p14="http://schemas.microsoft.com/office/powerpoint/2010/main" xmlns:p15="http://schemas.microsoft.com/office/powerpoint/2012/main" xmlns:mc="http://schemas.openxmlformats.org/markup-compatibility/2006">
-  <p:cSld>
-    <p:spTree>
-      <p:nvGrpSpPr>
-        <p:cNvPr id="1" name=""/>
-        <p:cNvGrpSpPr/>
-        <p:nvPr/>
-      </p:nvGrpSpPr>
-      <p:grpSpPr>
-        <a:xfrm>
-          <a:off x="0" y="0"/>
-          <a:ext cx="0" cy="0"/>
-          <a:chOff x="0" y="0"/>
-          <a:chExt cx="0" cy="0"/>
-        </a:xfrm>
-      </p:grpSpPr>
-      <p:sp>
-        <p:nvSpPr>
-          <p:cNvPr id="89" name="PlaceHolder 1"/>
-          <p:cNvSpPr>
-            <a:spLocks noGrp="1"/>
-          </p:cNvSpPr>
-          <p:nvPr>
-            <p:ph type="title"/>
-          </p:nvPr>
-        </p:nvSpPr>
-        <p:spPr>
-          <a:xfrm>
-            <a:off x="838080" y="365040"/>
-            <a:ext cx="10515240" cy="1325160"/>
-          </a:xfrm>
-          <a:prstGeom prst="rect">
-            <a:avLst/>
-          </a:prstGeom>
-          <a:noFill/>
-          <a:ln w="0">
-            <a:noFill/>
-          </a:ln>
-        </p:spPr>
-        <p:txBody>
-          <a:bodyPr lIns="91440" tIns="45720" rIns="91440" bIns="45720" anchor="ctr">
-            <a:noAutofit/>
-          </a:bodyPr>
-          <a:p>
-            <a:pPr indent="0" algn="l" defTabSz="914400">
-              <a:lnSpc>
-                <a:spcPct val="90000"/>
-              </a:lnSpc>
-              <a:buNone/>
-            </a:pPr>
-            <a:r>
-              <a:rPr lang="en-US" sz="4400" b="0" u="none" strike="noStrike">
-                <a:solidFill>
-                  <a:schemeClr val="dk1"/>
-                </a:solidFill>
-                <a:effectLst/>
-                <a:uFillTx/>
-                <a:latin typeface="Aptos Display"/>
-              </a:rPr>
-              <a:t>Research Questions</a:t>
-            </a:r>
-            <a:endParaRPr lang="en-US" sz="4400" b="0" u="none" strike="noStrike">
-              <a:solidFill>
-                <a:schemeClr val="dk1"/>
-              </a:solidFill>
-              <a:effectLst/>
-              <a:uFillTx/>
-              <a:latin typeface="Aptos Display"/>
-            </a:endParaRPr>
-          </a:p>
-        </p:txBody>
-      </p:sp>
-      <p:sp>
-        <p:nvSpPr>
-          <p:cNvPr id="90" name="PlaceHolder 2"/>
-          <p:cNvSpPr>
-            <a:spLocks noGrp="1"/>
-          </p:cNvSpPr>
-          <p:nvPr>
-            <p:ph/>
-          </p:nvPr>
-        </p:nvSpPr>
-        <p:spPr>
-          <a:xfrm>
-            <a:off x="838080" y="1522800"/>
-            <a:ext cx="10515240" cy="4350960"/>
-          </a:xfrm>
-          <a:prstGeom prst="rect">
-            <a:avLst/>
-          </a:prstGeom>
-          <a:noFill/>
-          <a:ln w="0">
-            <a:noFill/>
-          </a:ln>
-        </p:spPr>
-        <p:txBody>
-          <a:bodyPr lIns="91440" tIns="45720" rIns="91440" bIns="45720" anchor="t">
-            <a:normAutofit/>
-          </a:bodyPr>
-          <a:p>
-            <a:pPr marL="228600" indent="-228600" algn="l" defTabSz="914400">
-              <a:lnSpc>
-                <a:spcPct val="90000"/>
-              </a:lnSpc>
-              <a:spcBef>
-                <a:spcPts val="1001"/>
-              </a:spcBef>
-              <a:buClr>
-                <a:srgbClr val="000000"/>
-              </a:buClr>
-              <a:buFont typeface="Arial"/>
-              <a:buChar char="•"/>
-            </a:pPr>
-            <a:r>
-              <a:rPr lang="en-US" sz="2800" b="0" u="none" strike="noStrike">
-                <a:solidFill>
-                  <a:schemeClr val="dk1"/>
-                </a:solidFill>
-                <a:effectLst/>
-                <a:uFillTx/>
-                <a:latin typeface="Aptos"/>
-              </a:rPr>
-              <a:t>Paralinguistic RQs:</a:t>
-            </a:r>
-            <a:endParaRPr lang="en-US" sz="2800" b="0" u="none" strike="noStrike">
-              <a:solidFill>
-                <a:schemeClr val="dk1"/>
-              </a:solidFill>
-              <a:effectLst/>
-              <a:uFillTx/>
-              <a:latin typeface="Aptos"/>
-            </a:endParaRPr>
-          </a:p>
-          <a:p>
-            <a:pPr marL="685800" lvl="1" indent="-343080" algn="l" defTabSz="914400">
-              <a:lnSpc>
-                <a:spcPct val="90000"/>
-              </a:lnSpc>
-              <a:spcBef>
-                <a:spcPts val="499"/>
-              </a:spcBef>
-              <a:buClr>
-                <a:srgbClr val="000000"/>
-              </a:buClr>
-              <a:buFont typeface="Courier New,monospace"/>
-              <a:buChar char="o"/>
-            </a:pPr>
-            <a:r>
-              <a:rPr lang="en-US" sz="2400" b="0" u="none" strike="noStrike">
-                <a:solidFill>
-                  <a:schemeClr val="dk1"/>
-                </a:solidFill>
-                <a:effectLst/>
-                <a:uFillTx/>
-                <a:latin typeface="Aptos"/>
-              </a:rPr>
-              <a:t>How do TE values differ between all 9 gaze x speaker configs?</a:t>
-            </a:r>
-            <a:endParaRPr lang="en-US" sz="2400" b="0" u="none" strike="noStrike">
-              <a:solidFill>
-                <a:schemeClr val="dk1"/>
-              </a:solidFill>
-              <a:effectLst/>
-              <a:uFillTx/>
-              <a:latin typeface="Aptos"/>
-            </a:endParaRPr>
-          </a:p>
-          <a:p>
-            <a:pPr marL="685800" lvl="1" indent="-343080" algn="l" defTabSz="914400">
-              <a:lnSpc>
-                <a:spcPct val="90000"/>
-              </a:lnSpc>
-              <a:spcBef>
-                <a:spcPts val="499"/>
-              </a:spcBef>
-              <a:buClr>
-                <a:srgbClr val="000000"/>
-              </a:buClr>
-              <a:buFont typeface="Courier New,monospace"/>
-              <a:buChar char="o"/>
-            </a:pPr>
-            <a:r>
-              <a:rPr lang="en-US" sz="2400" b="0" u="none" strike="noStrike">
-                <a:solidFill>
-                  <a:schemeClr val="dk1"/>
-                </a:solidFill>
-                <a:effectLst/>
-                <a:uFillTx/>
-                <a:latin typeface="Aptos"/>
-              </a:rPr>
-              <a:t>How well does a classifier learn to detect TE with gaze x speaker features?</a:t>
-            </a:r>
-            <a:endParaRPr lang="en-US" sz="2400" b="0" u="none" strike="noStrike">
-              <a:solidFill>
-                <a:schemeClr val="dk1"/>
-              </a:solidFill>
-              <a:effectLst/>
-              <a:uFillTx/>
-              <a:latin typeface="Aptos"/>
-            </a:endParaRPr>
-          </a:p>
-          <a:p>
-            <a:pPr marL="228600" indent="-228600" algn="l" defTabSz="914400">
-              <a:lnSpc>
-                <a:spcPct val="90000"/>
-              </a:lnSpc>
-              <a:spcBef>
-                <a:spcPts val="1001"/>
-              </a:spcBef>
-              <a:buClr>
-                <a:srgbClr val="000000"/>
-              </a:buClr>
-              <a:buFont typeface="Arial"/>
-              <a:buChar char="•"/>
-            </a:pPr>
-            <a:r>
-              <a:rPr lang="en-US" sz="2800" b="0" u="none" strike="noStrike">
-                <a:solidFill>
-                  <a:schemeClr val="dk1"/>
-                </a:solidFill>
-                <a:effectLst/>
-                <a:uFillTx/>
-                <a:latin typeface="Aptos"/>
-              </a:rPr>
-              <a:t>Linguistic RQs:</a:t>
-            </a:r>
-            <a:endParaRPr lang="en-US" sz="2800" b="0" u="none" strike="noStrike">
-              <a:solidFill>
-                <a:schemeClr val="dk1"/>
-              </a:solidFill>
-              <a:effectLst/>
-              <a:uFillTx/>
-              <a:latin typeface="Aptos"/>
-            </a:endParaRPr>
-          </a:p>
-          <a:p>
-            <a:pPr marL="685800" lvl="1" indent="-343080" algn="l" defTabSz="914400">
-              <a:lnSpc>
-                <a:spcPct val="90000"/>
-              </a:lnSpc>
-              <a:spcBef>
-                <a:spcPts val="499"/>
-              </a:spcBef>
-              <a:buClr>
-                <a:srgbClr val="000000"/>
-              </a:buClr>
-              <a:buFont typeface="Courier New,monospace"/>
-              <a:buChar char="o"/>
-            </a:pPr>
-            <a:r>
-              <a:rPr lang="en-US" sz="2400" b="0" u="none" strike="noStrike">
-                <a:solidFill>
-                  <a:schemeClr val="dk1"/>
-                </a:solidFill>
-                <a:effectLst/>
-                <a:uFillTx/>
-                <a:latin typeface="Calibri"/>
-                <a:ea typeface="Calibri"/>
-              </a:rPr>
-              <a:t>How well does a classifier learn to detect TE with </a:t>
-            </a:r>
-            <a:r>
-              <a:rPr lang="en-US" sz="2400" b="1" u="none" strike="noStrike">
-                <a:solidFill>
-                  <a:schemeClr val="dk1"/>
-                </a:solidFill>
-                <a:effectLst/>
-                <a:uFillTx/>
-                <a:latin typeface="Aptos"/>
-                <a:ea typeface="Calibri"/>
-              </a:rPr>
-              <a:t>only linguistic </a:t>
-            </a:r>
-            <a:r>
-              <a:rPr lang="en-US" sz="2400" b="0" u="none" strike="noStrike">
-                <a:solidFill>
-                  <a:schemeClr val="dk1"/>
-                </a:solidFill>
-                <a:effectLst/>
-                <a:uFillTx/>
-                <a:latin typeface="Calibri"/>
-                <a:ea typeface="Calibri"/>
-              </a:rPr>
-              <a:t>features?</a:t>
-            </a:r>
-            <a:endParaRPr lang="en-US" sz="2400" b="0" u="none" strike="noStrike">
-              <a:solidFill>
-                <a:schemeClr val="dk1"/>
-              </a:solidFill>
-              <a:effectLst/>
-              <a:uFillTx/>
-              <a:latin typeface="Aptos"/>
-            </a:endParaRPr>
-          </a:p>
-          <a:p>
-            <a:pPr marL="685800" lvl="1" indent="-343080" algn="l" defTabSz="914400">
-              <a:lnSpc>
-                <a:spcPct val="90000"/>
-              </a:lnSpc>
-              <a:spcBef>
-                <a:spcPts val="499"/>
-              </a:spcBef>
-              <a:buClr>
-                <a:srgbClr val="000000"/>
-              </a:buClr>
-              <a:buFont typeface="Courier New,monospace"/>
-              <a:buChar char="o"/>
-            </a:pPr>
-            <a:r>
-              <a:rPr lang="en-US" sz="2400" b="0" u="none" strike="noStrike">
-                <a:solidFill>
-                  <a:schemeClr val="dk1"/>
-                </a:solidFill>
-                <a:effectLst/>
-                <a:uFillTx/>
-                <a:latin typeface="Calibri"/>
-                <a:ea typeface="Calibri"/>
-              </a:rPr>
-              <a:t>Which linguistic features have the strongest predictive power?</a:t>
-            </a:r>
-            <a:endParaRPr lang="en-US" sz="2400" b="0" u="none" strike="noStrike">
-              <a:solidFill>
-                <a:schemeClr val="dk1"/>
-              </a:solidFill>
-              <a:effectLst/>
-              <a:uFillTx/>
-              <a:latin typeface="Aptos"/>
-            </a:endParaRPr>
-          </a:p>
-          <a:p>
-            <a:pPr marL="228600" indent="-228600" algn="l" defTabSz="914400">
-              <a:lnSpc>
-                <a:spcPct val="90000"/>
-              </a:lnSpc>
-              <a:spcBef>
-                <a:spcPts val="1001"/>
-              </a:spcBef>
-              <a:buClr>
-                <a:srgbClr val="000000"/>
-              </a:buClr>
-              <a:buFont typeface="Arial"/>
-              <a:buChar char="•"/>
-            </a:pPr>
-            <a:r>
-              <a:rPr lang="en-US" sz="2800" b="0" u="none" strike="noStrike">
-                <a:solidFill>
-                  <a:schemeClr val="dk1"/>
-                </a:solidFill>
-                <a:effectLst/>
-                <a:uFillTx/>
-                <a:latin typeface="Calibri"/>
-                <a:ea typeface="Calibri"/>
-              </a:rPr>
-              <a:t>Multimodal:</a:t>
-            </a:r>
-            <a:endParaRPr lang="en-US" sz="2800" b="0" u="none" strike="noStrike">
-              <a:solidFill>
-                <a:schemeClr val="dk1"/>
-              </a:solidFill>
-              <a:effectLst/>
-              <a:uFillTx/>
-              <a:latin typeface="Aptos"/>
-            </a:endParaRPr>
-          </a:p>
-          <a:p>
-            <a:pPr marL="685800" lvl="1" indent="-343080" algn="l" defTabSz="914400">
-              <a:lnSpc>
-                <a:spcPct val="90000"/>
-              </a:lnSpc>
-              <a:spcBef>
-                <a:spcPts val="499"/>
-              </a:spcBef>
-              <a:buClr>
-                <a:srgbClr val="000000"/>
-              </a:buClr>
-              <a:buFont typeface="Courier New,monospace"/>
-              <a:buChar char="o"/>
-            </a:pPr>
-            <a:r>
-              <a:rPr lang="en-US" sz="2400" b="0" u="none" strike="noStrike">
-                <a:solidFill>
-                  <a:schemeClr val="dk1"/>
-                </a:solidFill>
-                <a:effectLst/>
-                <a:uFillTx/>
-                <a:latin typeface="Calibri"/>
-                <a:ea typeface="Calibri"/>
-              </a:rPr>
-              <a:t>How well does a classifier learn to detect TE with </a:t>
-            </a:r>
-            <a:r>
-              <a:rPr lang="en-US" sz="2400" b="1" u="none" strike="noStrike">
-                <a:solidFill>
-                  <a:schemeClr val="dk1"/>
-                </a:solidFill>
-                <a:effectLst/>
-                <a:uFillTx/>
-                <a:latin typeface="Aptos"/>
-                <a:ea typeface="Calibri"/>
-              </a:rPr>
-              <a:t>both </a:t>
-            </a:r>
-            <a:r>
-              <a:rPr lang="en-US" sz="2400" b="0" u="none" strike="noStrike">
-                <a:solidFill>
-                  <a:schemeClr val="dk1"/>
-                </a:solidFill>
-                <a:effectLst/>
-                <a:uFillTx/>
-                <a:latin typeface="Calibri"/>
-                <a:ea typeface="Calibri"/>
-              </a:rPr>
-              <a:t>feature sets?</a:t>
-            </a:r>
-            <a:endParaRPr lang="en-US" sz="2400" b="0" u="none" strike="noStrike">
-              <a:solidFill>
-                <a:schemeClr val="dk1"/>
-              </a:solidFill>
-              <a:effectLst/>
-              <a:uFillTx/>
-              <a:latin typeface="Aptos"/>
-            </a:endParaRPr>
-          </a:p>
-          <a:p>
-            <a:pPr indent="0" algn="l" defTabSz="914400">
-              <a:lnSpc>
-                <a:spcPct val="90000"/>
-              </a:lnSpc>
-              <a:spcBef>
-                <a:spcPts val="499"/>
-              </a:spcBef>
-              <a:buNone/>
-            </a:pPr>
-            <a:endParaRPr lang="en-US" sz="2400" b="0" u="none" strike="noStrike">
-              <a:solidFill>
-                <a:schemeClr val="dk1"/>
-              </a:solidFill>
-              <a:effectLst/>
-              <a:uFillTx/>
-              <a:latin typeface="Aptos"/>
-            </a:endParaRPr>
-          </a:p>
-          <a:p>
-            <a:pPr indent="0" algn="l" defTabSz="914400">
-              <a:lnSpc>
-                <a:spcPct val="90000"/>
-              </a:lnSpc>
-              <a:spcBef>
-                <a:spcPts val="499"/>
-              </a:spcBef>
-              <a:buNone/>
-            </a:pPr>
-            <a:endParaRPr lang="en-US" sz="2400" b="0" u="none" strike="noStrike">
-              <a:solidFill>
-                <a:schemeClr val="dk1"/>
-              </a:solidFill>
-              <a:effectLst/>
-              <a:uFillTx/>
-              <a:latin typeface="Aptos"/>
             </a:endParaRPr>
           </a:p>
         </p:txBody>

</xml_diff>